<commit_message>
Thesis slides: split thesis 2 into economic and finance aspects
Thesis 2 now argues why the AI-hardware theme should be owned through a
protected autocall: an economic half (structural growth but violent,
concentrated, already-priced path; reforms support recovery) and a finance
half (rates make protection cheap, volatility funds the coupon, the autocall
only needs a recovery). The former thesis 3 becomes its supporting evidence.

Co-Authored-By: Claude Opus 5.5 <noreply@anthropic.com>
Claude-Session: https://claude.ai/code/session_01Rwoh8cFDQqLD8JWT3mee6y
</commit_message>
<xml_diff>
--- a/deck/Investment-Thesis-Slides.pptx
+++ b/deck/Investment-Thesis-Slides.pptx
@@ -400,7 +400,7 @@
           <a:lstStyle/>
           <a:p>
             <a:pPr>
-              <a:defRPr sz="1100" b="0" i="0" u="none" strike="noStrike">
+              <a:defRPr sz="950" b="0" i="0" u="none" strike="noStrike">
                 <a:solidFill>
                   <a:srgbClr val="262626"/>
                 </a:solidFill>
@@ -408,13 +408,13 @@
               </a:defRPr>
             </a:pPr>
             <a:r>
-              <a:rPr sz="1100" b="0" i="0" u="none" strike="noStrike">
+              <a:rPr sz="950" b="0" i="0" u="none" strike="noStrike">
                 <a:solidFill>
                   <a:srgbClr val="262626"/>
                 </a:solidFill>
                 <a:latin typeface="Arial"/>
               </a:rPr>
-              <a:t>2022 decline</a:t>
+              <a:t>Last down-cycle: 2022 fall</a:t>
             </a:r>
           </a:p>
         </c:rich>
@@ -451,13 +451,13 @@
           </c:spPr>
           <c:invertIfNegative val="0"/>
           <c:dLbls>
-            <c:numFmt formatCode="0.0&quot;%&quot;" sourceLinked="0"/>
+            <c:numFmt formatCode="0&quot;%&quot;" sourceLinked="0"/>
             <c:txPr>
               <a:bodyPr/>
               <a:lstStyle/>
               <a:p>
                 <a:pPr>
-                  <a:defRPr b="0" i="0" strike="noStrike" sz="1000" u="none">
+                  <a:defRPr b="0" i="0" strike="noStrike" sz="900" u="none">
                     <a:solidFill>
                       <a:srgbClr val="262626"/>
                     </a:solidFill>
@@ -481,13 +481,13 @@
                 <c:ptCount val="3"/>
                 <c:lvl>
                   <c:pt idx="0">
-                    <c:v>TAIEX (peak to trough)</c:v>
+                    <c:v>TAIEX</c:v>
                   </c:pt>
                   <c:pt idx="1">
-                    <c:v>KOSPI (calendar year)</c:v>
+                    <c:v>KOSPI</c:v>
                   </c:pt>
                   <c:pt idx="2">
-                    <c:v>Global chip index SOX (calendar year)</c:v>
+                    <c:v>Global chip index</c:v>
                   </c:pt>
                 </c:lvl>
               </c:multiLvlStrCache>
@@ -513,13 +513,13 @@
           </c:val>
         </c:ser>
         <c:dLbls>
-          <c:numFmt formatCode="0.0&quot;%&quot;" sourceLinked="0"/>
+          <c:numFmt formatCode="0&quot;%&quot;" sourceLinked="0"/>
           <c:txPr>
             <a:bodyPr/>
             <a:lstStyle/>
             <a:p>
               <a:pPr>
-                <a:defRPr b="0" i="0" strike="noStrike" sz="1000" u="none">
+                <a:defRPr b="0" i="0" strike="noStrike" sz="900" u="none">
                   <a:solidFill>
                     <a:srgbClr val="262626"/>
                   </a:solidFill>
@@ -567,7 +567,7 @@
           <a:lstStyle/>
           <a:p>
             <a:pPr>
-              <a:defRPr sz="900" b="0" i="0" u="none" strike="noStrike">
+              <a:defRPr sz="800" b="0" i="0" u="none" strike="noStrike">
                 <a:solidFill>
                   <a:srgbClr val="595959"/>
                 </a:solidFill>
@@ -590,20 +590,9 @@
           <c:max val="0"/>
           <c:min val="-45"/>
         </c:scaling>
-        <c:delete val="0"/>
+        <c:delete val="1"/>
         <c:axPos val="l"/>
-        <c:majorGridlines>
-          <c:spPr>
-            <a:ln w="6350" cap="flat">
-              <a:solidFill>
-                <a:srgbClr val="E3E3E3"/>
-              </a:solidFill>
-              <a:prstDash val="solid"/>
-              <a:round/>
-            </a:ln>
-          </c:spPr>
-        </c:majorGridlines>
-        <c:numFmt formatCode="0&quot;%&quot;" sourceLinked="0"/>
+        <c:numFmt formatCode="General" sourceLinked="0"/>
         <c:majorTickMark val="out"/>
         <c:minorTickMark val="none"/>
         <c:tickLblPos val="nextTo"/>
@@ -660,6 +649,413 @@
 </file>
 
 <file path=ppt/charts/chart3.xml><?xml version="1.0" encoding="utf-8"?>
+<c:chartSpace xmlns:c="http://schemas.openxmlformats.org/drawingml/2006/chart" xmlns:a="http://schemas.openxmlformats.org/drawingml/2006/main" xmlns:r="http://schemas.openxmlformats.org/officeDocument/2006/relationships">
+  <c:date1904 val="0"/>
+  <c:roundedCorners val="1"/>
+  <c:chart>
+    <c:title>
+      <c:tx>
+        <c:rich>
+          <a:bodyPr/>
+          <a:lstStyle/>
+          <a:p>
+            <a:pPr>
+              <a:defRPr sz="950" b="0" i="0" u="none" strike="noStrike">
+                <a:solidFill>
+                  <a:srgbClr val="262626"/>
+                </a:solidFill>
+                <a:latin typeface="Arial"/>
+              </a:defRPr>
+            </a:pPr>
+            <a:r>
+              <a:rPr sz="950" b="0" i="0" u="none" strike="noStrike">
+                <a:solidFill>
+                  <a:srgbClr val="262626"/>
+                </a:solidFill>
+                <a:latin typeface="Arial"/>
+              </a:rPr>
+              <a:t>Where the client's 100% goes (fair value, % of notional)</a:t>
+            </a:r>
+          </a:p>
+        </c:rich>
+      </c:tx>
+      <c:layout/>
+      <c:overlay val="0"/>
+    </c:title>
+    <c:autoTitleDeleted val="0"/>
+    <c:plotArea>
+      <c:layout/>
+      <c:barChart>
+        <c:barDir val="bar"/>
+        <c:grouping val="stacked"/>
+        <c:varyColors val="0"/>
+        <c:ser>
+          <c:idx val="0"/>
+          <c:order val="0"/>
+          <c:tx>
+            <c:strRef>
+              <c:f>Sheet1!$B$1</c:f>
+              <c:strCache>
+                <c:ptCount val="1"/>
+                <c:pt idx="0">
+                  <c:v>Protected principal: 89.9%</c:v>
+                </c:pt>
+              </c:strCache>
+            </c:strRef>
+          </c:tx>
+          <c:spPr>
+            <a:solidFill>
+              <a:srgbClr val="2C5F82"/>
+            </a:solidFill>
+            <a:effectLst/>
+          </c:spPr>
+          <c:invertIfNegative val="0"/>
+          <c:dLbls>
+            <c:numFmt formatCode="#,##0" sourceLinked="0"/>
+            <c:txPr>
+              <a:bodyPr/>
+              <a:lstStyle/>
+              <a:p>
+                <a:pPr>
+                  <a:defRPr b="0" i="0" strike="noStrike" sz="1200" u="none">
+                    <a:solidFill>
+                      <a:srgbClr val="000000"/>
+                    </a:solidFill>
+                    <a:latin typeface="Arial"/>
+                  </a:defRPr>
+                </a:pPr>
+              </a:p>
+            </c:txPr>
+            <c:showLegendKey val="0"/>
+            <c:showVal val="0"/>
+            <c:showCatName val="0"/>
+            <c:showSerName val="0"/>
+            <c:showPercent val="0"/>
+            <c:showBubbleSize val="0"/>
+            <c:showLeaderLines val="0"/>
+          </c:dLbls>
+          <c:cat>
+            <c:multiLvlStrRef>
+              <c:f>Sheet1!$A$2:$A$2</c:f>
+              <c:multiLvlStrCache>
+                <c:ptCount val="1"/>
+                <c:lvl>
+                  <c:pt idx="0">
+                    <c:v>100% issue price</c:v>
+                  </c:pt>
+                </c:lvl>
+              </c:multiLvlStrCache>
+            </c:multiLvlStrRef>
+          </c:cat>
+          <c:val>
+            <c:numRef>
+              <c:f>Sheet1!$B$2:$B$2</c:f>
+              <c:numCache>
+                <c:formatCode>General</c:formatCode>
+                <c:ptCount val="1"/>
+                <c:pt idx="0">
+                  <c:v>89.9</c:v>
+                </c:pt>
+              </c:numCache>
+            </c:numRef>
+          </c:val>
+        </c:ser>
+        <c:ser>
+          <c:idx val="1"/>
+          <c:order val="1"/>
+          <c:tx>
+            <c:strRef>
+              <c:f>Sheet1!$C$1</c:f>
+              <c:strCache>
+                <c:ptCount val="1"/>
+                <c:pt idx="0">
+                  <c:v>Coupons (net of autocall): 7.6%</c:v>
+                </c:pt>
+              </c:strCache>
+            </c:strRef>
+          </c:tx>
+          <c:spPr>
+            <a:solidFill>
+              <a:srgbClr val="8DB3D1"/>
+            </a:solidFill>
+            <a:effectLst/>
+          </c:spPr>
+          <c:invertIfNegative val="0"/>
+          <c:dLbls>
+            <c:numFmt formatCode="#,##0" sourceLinked="0"/>
+            <c:txPr>
+              <a:bodyPr/>
+              <a:lstStyle/>
+              <a:p>
+                <a:pPr>
+                  <a:defRPr b="0" i="0" strike="noStrike" sz="1200" u="none">
+                    <a:solidFill>
+                      <a:srgbClr val="000000"/>
+                    </a:solidFill>
+                    <a:latin typeface="Arial"/>
+                  </a:defRPr>
+                </a:pPr>
+              </a:p>
+            </c:txPr>
+            <c:showLegendKey val="0"/>
+            <c:showVal val="0"/>
+            <c:showCatName val="0"/>
+            <c:showSerName val="0"/>
+            <c:showPercent val="0"/>
+            <c:showBubbleSize val="0"/>
+            <c:showLeaderLines val="0"/>
+          </c:dLbls>
+          <c:cat>
+            <c:multiLvlStrRef>
+              <c:f>Sheet1!$A$2:$A$2</c:f>
+              <c:multiLvlStrCache>
+                <c:ptCount val="1"/>
+                <c:lvl>
+                  <c:pt idx="0">
+                    <c:v>100% issue price</c:v>
+                  </c:pt>
+                </c:lvl>
+              </c:multiLvlStrCache>
+            </c:multiLvlStrRef>
+          </c:cat>
+          <c:val>
+            <c:numRef>
+              <c:f>Sheet1!$C$2:$C$2</c:f>
+              <c:numCache>
+                <c:formatCode>General</c:formatCode>
+                <c:ptCount val="1"/>
+                <c:pt idx="0">
+                  <c:v>7.6</c:v>
+                </c:pt>
+              </c:numCache>
+            </c:numRef>
+          </c:val>
+        </c:ser>
+        <c:ser>
+          <c:idx val="2"/>
+          <c:order val="2"/>
+          <c:tx>
+            <c:strRef>
+              <c:f>Sheet1!$D$1</c:f>
+              <c:strCache>
+                <c:ptCount val="1"/>
+                <c:pt idx="0">
+                  <c:v>Natixis hedging &amp; margin: 2.4%</c:v>
+                </c:pt>
+              </c:strCache>
+            </c:strRef>
+          </c:tx>
+          <c:spPr>
+            <a:solidFill>
+              <a:srgbClr val="A6A6A6"/>
+            </a:solidFill>
+            <a:effectLst/>
+          </c:spPr>
+          <c:invertIfNegative val="0"/>
+          <c:dLbls>
+            <c:numFmt formatCode="#,##0" sourceLinked="0"/>
+            <c:txPr>
+              <a:bodyPr/>
+              <a:lstStyle/>
+              <a:p>
+                <a:pPr>
+                  <a:defRPr b="0" i="0" strike="noStrike" sz="1200" u="none">
+                    <a:solidFill>
+                      <a:srgbClr val="000000"/>
+                    </a:solidFill>
+                    <a:latin typeface="Arial"/>
+                  </a:defRPr>
+                </a:pPr>
+              </a:p>
+            </c:txPr>
+            <c:showLegendKey val="0"/>
+            <c:showVal val="0"/>
+            <c:showCatName val="0"/>
+            <c:showSerName val="0"/>
+            <c:showPercent val="0"/>
+            <c:showBubbleSize val="0"/>
+            <c:showLeaderLines val="0"/>
+          </c:dLbls>
+          <c:cat>
+            <c:multiLvlStrRef>
+              <c:f>Sheet1!$A$2:$A$2</c:f>
+              <c:multiLvlStrCache>
+                <c:ptCount val="1"/>
+                <c:lvl>
+                  <c:pt idx="0">
+                    <c:v>100% issue price</c:v>
+                  </c:pt>
+                </c:lvl>
+              </c:multiLvlStrCache>
+            </c:multiLvlStrRef>
+          </c:cat>
+          <c:val>
+            <c:numRef>
+              <c:f>Sheet1!$D$2:$D$2</c:f>
+              <c:numCache>
+                <c:formatCode>General</c:formatCode>
+                <c:ptCount val="1"/>
+                <c:pt idx="0">
+                  <c:v>2.4</c:v>
+                </c:pt>
+              </c:numCache>
+            </c:numRef>
+          </c:val>
+        </c:ser>
+        <c:dLbls>
+          <c:numFmt formatCode="#,##0" sourceLinked="0"/>
+          <c:txPr>
+            <a:bodyPr/>
+            <a:lstStyle/>
+            <a:p>
+              <a:pPr>
+                <a:defRPr b="0" i="0" strike="noStrike" sz="1200" u="none">
+                  <a:solidFill>
+                    <a:srgbClr val="000000"/>
+                  </a:solidFill>
+                  <a:latin typeface="Arial"/>
+                </a:defRPr>
+              </a:pPr>
+            </a:p>
+          </c:txPr>
+          <c:showLegendKey val="0"/>
+          <c:showVal val="0"/>
+          <c:showCatName val="0"/>
+          <c:showSerName val="0"/>
+          <c:showPercent val="0"/>
+          <c:showBubbleSize val="0"/>
+          <c:showLeaderLines val="0"/>
+        </c:dLbls>
+        <c:gapWidth val="50"/>
+        <c:overlap val="100"/>
+        <c:axId val="2094734554"/>
+        <c:axId val="2094734552"/>
+        <c:axId val="2094734556"/>
+      </c:barChart>
+      <c:catAx>
+        <c:axId val="2094734554"/>
+        <c:scaling>
+          <c:orientation val="minMax"/>
+        </c:scaling>
+        <c:delete val="1"/>
+        <c:axPos val="l"/>
+        <c:numFmt formatCode="General" sourceLinked="1"/>
+        <c:majorTickMark val="out"/>
+        <c:minorTickMark val="none"/>
+        <c:tickLblPos val="nextTo"/>
+        <c:spPr>
+          <a:ln w="12700" cap="flat">
+            <a:solidFill>
+              <a:srgbClr val="BFBFBF"/>
+            </a:solidFill>
+            <a:prstDash val="solid"/>
+            <a:round/>
+          </a:ln>
+        </c:spPr>
+        <c:txPr>
+          <a:bodyPr/>
+          <a:lstStyle/>
+          <a:p>
+            <a:pPr>
+              <a:defRPr sz="1000" b="0" i="0" u="none" strike="noStrike">
+                <a:solidFill>
+                  <a:srgbClr val="595959"/>
+                </a:solidFill>
+                <a:latin typeface="Arial"/>
+              </a:defRPr>
+            </a:pPr>
+            <a:endParaRPr lang="en-US"/>
+          </a:p>
+        </c:txPr>
+        <c:crossAx val="2094734552"/>
+        <c:crosses val="autoZero"/>
+        <c:auto val="1"/>
+        <c:lblAlgn val="ctr"/>
+        <c:noMultiLvlLbl val="1"/>
+      </c:catAx>
+      <c:valAx>
+        <c:axId val="2094734552"/>
+        <c:scaling>
+          <c:orientation val="minMax"/>
+          <c:max val="100"/>
+          <c:min val="0"/>
+        </c:scaling>
+        <c:delete val="1"/>
+        <c:axPos val="b"/>
+        <c:numFmt formatCode="General" sourceLinked="0"/>
+        <c:majorTickMark val="out"/>
+        <c:minorTickMark val="none"/>
+        <c:tickLblPos val="low"/>
+        <c:spPr>
+          <a:ln w="12700" cap="flat">
+            <a:solidFill>
+              <a:srgbClr val="888888"/>
+            </a:solidFill>
+            <a:prstDash val="solid"/>
+            <a:round/>
+          </a:ln>
+        </c:spPr>
+        <c:txPr>
+          <a:bodyPr/>
+          <a:lstStyle/>
+          <a:p>
+            <a:pPr>
+              <a:defRPr sz="900" b="0" i="0" u="none" strike="noStrike">
+                <a:solidFill>
+                  <a:srgbClr val="595959"/>
+                </a:solidFill>
+                <a:latin typeface="Arial"/>
+              </a:defRPr>
+            </a:pPr>
+            <a:endParaRPr lang="en-US"/>
+          </a:p>
+        </c:txPr>
+        <c:crossAx val="2094734554"/>
+        <c:crosses val="autoZero"/>
+        <c:crossBetween val="between"/>
+      </c:valAx>
+      <c:spPr>
+        <a:noFill/>
+        <a:ln>
+          <a:noFill/>
+        </a:ln>
+        <a:effectLst/>
+      </c:spPr>
+    </c:plotArea>
+    <c:legend>
+      <c:legendPos val="b"/>
+      <c:overlay val="0"/>
+      <c:txPr>
+        <a:bodyPr/>
+        <a:lstStyle/>
+        <a:p>
+          <a:pPr>
+            <a:defRPr sz="900">
+              <a:latin typeface="Arial"/>
+              <a:cs typeface="Arial"/>
+            </a:defRPr>
+          </a:pPr>
+          <a:endParaRPr lang="en-US"/>
+        </a:p>
+      </c:txPr>
+    </c:legend>
+    <c:plotVisOnly val="1"/>
+    <c:dispBlanksAs val="span"/>
+  </c:chart>
+  <c:spPr>
+    <a:noFill/>
+    <a:ln>
+      <a:noFill/>
+    </a:ln>
+    <a:effectLst/>
+  </c:spPr>
+  <c:externalData r:id="rId1">
+    <c:autoUpdate val="0"/>
+  </c:externalData>
+</c:chartSpace>
+</file>
+
+<file path=ppt/charts/chart4.xml><?xml version="1.0" encoding="utf-8"?>
 <c:chartSpace xmlns:c="http://schemas.openxmlformats.org/drawingml/2006/chart" xmlns:a="http://schemas.openxmlformats.org/drawingml/2006/main" xmlns:r="http://schemas.openxmlformats.org/officeDocument/2006/relationships">
   <c:date1904 val="0"/>
   <c:roundedCorners val="1"/>
@@ -1703,7 +2099,7 @@
           <a:p>
             <a:r>
               <a:rPr lang="en-US" dirty="0"/>
-              <a:t>Thesis 2. The growth is real but chip stocks are the most cyclical part of the market: 2022 cost 25–36% in a year. After the 2026 rally the risk is skewed: KOSPI roughly doubled and already had single-day crashes, and the indices are concentrated in a few names. Governance reforms in Japan and Korea are a tailwind that helps the basket recover to 100%, which is all our coupon needs. KOSPI 2026 figures come from one secondary source: check them on Bloomberg before presenting.</a:t>
+              <a:t>Thesis 2 in two halves. Economic: AI hardware demand is structural, but chip stocks move in violent cycles, 2026 prices already reflect a boom, and the indices are concentrated in a few names; governance reforms support a recovery to the starting level. Finance: high USD rates make the 100% protection cheap, Asian volatility makes the 100% coupon trigger likely, and the autocall pays as soon as the basket recovers, with memory catching up missed coupons. Together: the family keeps the theme without the drawdown.</a:t>
             </a:r>
             <a:endParaRPr lang="en-US" dirty="0"/>
           </a:p>
@@ -1791,7 +2187,7 @@
           <a:p>
             <a:r>
               <a:rPr lang="en-US" dirty="0"/>
-              <a:t>Thesis 3. Same simulated paths for all four strategies. The note beats holding the basket in bear and flat markets, ties in moderate ones and lags only in bull markets. It beats the plain principal-protected note in every market except a bull market. Be upfront about the bond: a fixed 5.69% wins in bear markets and on average unless equities return ~8% a year, but a bond gives none of the AI exposure the family asked for.</a:t>
+              <a:t>Thesis 2 evidence. Same simulated paths for all four strategies. The note beats holding the basket in bear and flat markets, ties in moderate ones and lags only in bull markets. It beats the plain principal-protected note in every market except a bull market. Be upfront about the bond: a fixed 5.69% wins in bear markets and on average unless equities return ~8% a year, but a bond gives none of the AI exposure the family asked for.</a:t>
             </a:r>
             <a:endParaRPr lang="en-US" dirty="0"/>
           </a:p>
@@ -3607,7 +4003,7 @@
                 <a:ea typeface="Arial" pitchFamily="34" charset="-122"/>
                 <a:cs typeface="Arial" pitchFamily="34" charset="-120"/>
               </a:rPr>
-              <a:t>Investment thesis 2: Chip cycles are violent, so own the theme with protection</a:t>
+              <a:t>Investment thesis 2: Own the AI-hardware theme through a protected autocall</a:t>
             </a:r>
             <a:endParaRPr lang="en-US" sz="2400" dirty="0"/>
           </a:p>
@@ -3810,7 +4206,7 @@
         <p:spPr>
           <a:xfrm>
             <a:off x="457200" y="1051560"/>
-            <a:ext cx="3657600" cy="384048"/>
+            <a:ext cx="5486400" cy="384048"/>
           </a:xfrm>
           <a:prstGeom prst="rect">
             <a:avLst/>
@@ -3835,7 +4231,7 @@
         <p:spPr>
           <a:xfrm>
             <a:off x="457200" y="1051560"/>
-            <a:ext cx="3657600" cy="384048"/>
+            <a:ext cx="5486400" cy="384048"/>
           </a:xfrm>
           <a:prstGeom prst="rect">
             <a:avLst/>
@@ -3859,21 +4255,60 @@
                 <a:ea typeface="Arial" pitchFamily="34" charset="-122"/>
                 <a:cs typeface="Arial" pitchFamily="34" charset="-120"/>
               </a:rPr>
-              <a:t>The last down-cycle (2022)</a:t>
+              <a:t>Economic aspect: why this theme needs protection</a:t>
             </a:r>
             <a:endParaRPr lang="en-US" sz="1400" dirty="0"/>
           </a:p>
         </p:txBody>
       </p:sp>
+      <p:sp>
+        <p:nvSpPr>
+          <p:cNvPr id="11" name="Text 9"/>
+          <p:cNvSpPr txBox="1"/>
+          <p:nvPr/>
+        </p:nvSpPr>
+        <p:spPr>
+          <a:xfrm>
+            <a:off x="457200" y="1481328"/>
+            <a:ext cx="5486400" cy="274320"/>
+          </a:xfrm>
+          <a:prstGeom prst="rect">
+            <a:avLst/>
+          </a:prstGeom>
+          <a:noFill/>
+          <a:ln/>
+        </p:spPr>
+        <p:txBody>
+          <a:bodyPr wrap="square" lIns="0" tIns="0" rIns="0" bIns="0" rtlCol="0" anchor="t"/>
+          <a:lstStyle/>
+          <a:p>
+            <a:pPr algn="ctr" indent="0" marL="0">
+              <a:buNone/>
+            </a:pPr>
+            <a:r>
+              <a:rPr lang="en-US" sz="1050" i="1" dirty="0">
+                <a:solidFill>
+                  <a:srgbClr val="595959"/>
+                </a:solidFill>
+                <a:latin typeface="Arial" pitchFamily="34" charset="0"/>
+                <a:ea typeface="Arial" pitchFamily="34" charset="-122"/>
+                <a:cs typeface="Arial" pitchFamily="34" charset="-120"/>
+              </a:rPr>
+              <a:t>Structural growth, but a violent and concentrated path</a:t>
+            </a:r>
+            <a:endParaRPr lang="en-US" sz="1050" dirty="0"/>
+          </a:p>
+        </p:txBody>
+      </p:sp>
       <p:graphicFrame>
         <p:nvGraphicFramePr>
-          <p:cNvPr id="11" name="Chart 0" descr=""/>
+          <p:cNvPr id="12" name="Chart 0" descr=""/>
           <p:cNvGraphicFramePr/>
           <p:nvPr/>
         </p:nvGraphicFramePr>
         <p:xfrm>
-          <a:off x="457200" y="1508760"/>
-          <a:ext cx="3657600" cy="2743200"/>
+          <a:off x="457200" y="1783080"/>
+          <a:ext cx="2103120" cy="1600200"/>
         </p:xfrm>
         <a:graphic xmlns:a="http://schemas.openxmlformats.org/drawingml/2006/main">
           <a:graphicData uri="http://schemas.openxmlformats.org/drawingml/2006/chart">
@@ -3883,14 +4318,14 @@
       </p:graphicFrame>
       <p:sp>
         <p:nvSpPr>
-          <p:cNvPr id="12" name="Text 9"/>
+          <p:cNvPr id="13" name="Text 10"/>
           <p:cNvSpPr txBox="1"/>
           <p:nvPr/>
         </p:nvSpPr>
         <p:spPr>
           <a:xfrm>
-            <a:off x="457200" y="4343400"/>
-            <a:ext cx="3657600" cy="914400"/>
+            <a:off x="2697480" y="1828800"/>
+            <a:ext cx="3200400" cy="1508760"/>
           </a:xfrm>
           <a:prstGeom prst="rect">
             <a:avLst/>
@@ -3900,13 +4335,260 @@
         </p:spPr>
         <p:txBody>
           <a:bodyPr wrap="square" lIns="0" tIns="0" rIns="0" bIns="0" rtlCol="0" anchor="t"/>
+          <a:lstStyle/>
+          <a:p>
+            <a:pPr indent="0" marL="0">
+              <a:spcAft>
+                <a:spcPts val="300"/>
+              </a:spcAft>
+              <a:buNone/>
+            </a:pPr>
+            <a:r>
+              <a:rPr lang="en-US" sz="1000" b="1" dirty="0">
+                <a:solidFill>
+                  <a:srgbClr val="2C5F82"/>
+                </a:solidFill>
+                <a:latin typeface="Arial" pitchFamily="34" charset="0"/>
+                <a:ea typeface="Arial" pitchFamily="34" charset="-122"/>
+                <a:cs typeface="Arial" pitchFamily="34" charset="-120"/>
+              </a:rPr>
+              <a:t>Growth is structural…</a:t>
+            </a:r>
+            <a:endParaRPr lang="en-US" sz="1000" dirty="0"/>
+          </a:p>
+          <a:p>
+            <a:pPr indent="0" marL="0">
+              <a:spcAft>
+                <a:spcPts val="300"/>
+              </a:spcAft>
+              <a:buNone/>
+            </a:pPr>
+            <a:r>
+              <a:rPr lang="en-US" sz="1000" dirty="0">
+                <a:solidFill>
+                  <a:srgbClr val="262626"/>
+                </a:solidFill>
+                <a:latin typeface="Arial" pitchFamily="34" charset="0"/>
+                <a:ea typeface="Arial" pitchFamily="34" charset="-122"/>
+                <a:cs typeface="Arial" pitchFamily="34" charset="-120"/>
+              </a:rPr>
+              <a:t>Hyperscaler capex +77% and chip-equipment sales +23% in 2026 (thesis 1).</a:t>
+            </a:r>
+            <a:endParaRPr lang="en-US" sz="1000" dirty="0"/>
+          </a:p>
+          <a:p>
+            <a:pPr indent="0" marL="0">
+              <a:spcAft>
+                <a:spcPts val="300"/>
+              </a:spcAft>
+              <a:buNone/>
+            </a:pPr>
+            <a:r>
+              <a:rPr lang="en-US" sz="1000" b="1" dirty="0">
+                <a:solidFill>
+                  <a:srgbClr val="B23B3B"/>
+                </a:solidFill>
+                <a:latin typeface="Arial" pitchFamily="34" charset="0"/>
+                <a:ea typeface="Arial" pitchFamily="34" charset="-122"/>
+                <a:cs typeface="Arial" pitchFamily="34" charset="-120"/>
+              </a:rPr>
+              <a:t>…but the path is not</a:t>
+            </a:r>
+            <a:endParaRPr lang="en-US" sz="1000" dirty="0"/>
+          </a:p>
+          <a:p>
+            <a:pPr indent="0" marL="0">
+              <a:spcAft>
+                <a:spcPts val="300"/>
+              </a:spcAft>
+              <a:buNone/>
+            </a:pPr>
+            <a:r>
+              <a:rPr lang="en-US" sz="1000" dirty="0">
+                <a:solidFill>
+                  <a:srgbClr val="262626"/>
+                </a:solidFill>
+                <a:latin typeface="Arial" pitchFamily="34" charset="0"/>
+                <a:ea typeface="Arial" pitchFamily="34" charset="-122"/>
+                <a:cs typeface="Arial" pitchFamily="34" charset="-120"/>
+              </a:rPr>
+              <a:t>Chip stocks fell 25–36% in 2022. A direct investor needed a 33–56% rally just to get back to even.</a:t>
+            </a:r>
+            <a:endParaRPr lang="en-US" sz="1000" dirty="0"/>
+          </a:p>
+        </p:txBody>
+      </p:sp>
+      <p:sp>
+        <p:nvSpPr>
+          <p:cNvPr id="14" name="Shape 11"/>
+          <p:cNvSpPr/>
+          <p:nvPr/>
+        </p:nvSpPr>
+        <p:spPr>
+          <a:xfrm>
+            <a:off x="457200" y="3474720"/>
+            <a:ext cx="5486400" cy="786384"/>
+          </a:xfrm>
+          <a:prstGeom prst="rect">
+            <a:avLst/>
+          </a:prstGeom>
+          <a:solidFill>
+            <a:srgbClr val="F2F2F2"/>
+          </a:solidFill>
+          <a:ln w="12700">
+            <a:solidFill>
+              <a:srgbClr val="F2F2F2"/>
+            </a:solidFill>
+            <a:prstDash val="solid"/>
+          </a:ln>
+        </p:spPr>
+      </p:sp>
+      <p:sp>
+        <p:nvSpPr>
+          <p:cNvPr id="15" name="Shape 12"/>
+          <p:cNvSpPr/>
+          <p:nvPr/>
+        </p:nvSpPr>
+        <p:spPr>
+          <a:xfrm>
+            <a:off x="548640" y="3657600"/>
+            <a:ext cx="384048" cy="384048"/>
+          </a:xfrm>
+          <a:prstGeom prst="ellipse">
+            <a:avLst/>
+          </a:prstGeom>
+          <a:solidFill>
+            <a:srgbClr val="FFFFFF"/>
+          </a:solidFill>
+          <a:ln w="15875">
+            <a:solidFill>
+              <a:srgbClr val="2C5F82"/>
+            </a:solidFill>
+            <a:prstDash val="solid"/>
+          </a:ln>
+        </p:spPr>
+      </p:sp>
+      <p:sp>
+        <p:nvSpPr>
+          <p:cNvPr id="16" name="Text 13"/>
+          <p:cNvSpPr txBox="1"/>
+          <p:nvPr/>
+        </p:nvSpPr>
+        <p:spPr>
+          <a:xfrm>
+            <a:off x="548640" y="3657600"/>
+            <a:ext cx="384048" cy="384048"/>
+          </a:xfrm>
+          <a:prstGeom prst="rect">
+            <a:avLst/>
+          </a:prstGeom>
+          <a:noFill/>
+          <a:ln/>
+        </p:spPr>
+        <p:txBody>
+          <a:bodyPr wrap="square" lIns="0" tIns="0" rIns="0" bIns="0" rtlCol="0" anchor="ctr"/>
+          <a:lstStyle/>
+          <a:p>
+            <a:pPr algn="ctr" indent="0" marL="0">
+              <a:buNone/>
+            </a:pPr>
+            <a:r>
+              <a:rPr lang="en-US" sz="1300" b="1" i="1" dirty="0">
+                <a:solidFill>
+                  <a:srgbClr val="2C5F82"/>
+                </a:solidFill>
+                <a:latin typeface="Arial" pitchFamily="34" charset="0"/>
+                <a:ea typeface="Arial" pitchFamily="34" charset="-122"/>
+                <a:cs typeface="Arial" pitchFamily="34" charset="-120"/>
+              </a:rPr>
+              <a:t>1</a:t>
+            </a:r>
+            <a:endParaRPr lang="en-US" sz="1300" dirty="0"/>
+          </a:p>
+        </p:txBody>
+      </p:sp>
+      <p:sp>
+        <p:nvSpPr>
+          <p:cNvPr id="17" name="Text 14"/>
+          <p:cNvSpPr txBox="1"/>
+          <p:nvPr/>
+        </p:nvSpPr>
+        <p:spPr>
+          <a:xfrm>
+            <a:off x="1024128" y="3474720"/>
+            <a:ext cx="1005840" cy="786384"/>
+          </a:xfrm>
+          <a:prstGeom prst="rect">
+            <a:avLst/>
+          </a:prstGeom>
+          <a:noFill/>
+          <a:ln/>
+        </p:spPr>
+        <p:txBody>
+          <a:bodyPr wrap="square" lIns="0" tIns="0" rIns="0" bIns="0" rtlCol="0" anchor="ctr"/>
+          <a:lstStyle/>
+          <a:p>
+            <a:pPr algn="ctr" indent="0" marL="0">
+              <a:buNone/>
+            </a:pPr>
+            <a:r>
+              <a:rPr lang="en-US" sz="1900" b="1" dirty="0">
+                <a:solidFill>
+                  <a:srgbClr val="B23B3B"/>
+                </a:solidFill>
+                <a:latin typeface="Arial" pitchFamily="34" charset="0"/>
+                <a:ea typeface="Arial" pitchFamily="34" charset="-122"/>
+                <a:cs typeface="Arial" pitchFamily="34" charset="-120"/>
+              </a:rPr>
+              <a:t>~2×</a:t>
+            </a:r>
+            <a:endParaRPr lang="en-US" sz="1900" dirty="0"/>
+          </a:p>
+        </p:txBody>
+      </p:sp>
+      <p:sp>
+        <p:nvSpPr>
+          <p:cNvPr id="18" name="Text 15"/>
+          <p:cNvSpPr txBox="1"/>
+          <p:nvPr/>
+        </p:nvSpPr>
+        <p:spPr>
+          <a:xfrm>
+            <a:off x="2103120" y="3529584"/>
+            <a:ext cx="3749040" cy="713232"/>
+          </a:xfrm>
+          <a:prstGeom prst="rect">
+            <a:avLst/>
+          </a:prstGeom>
+          <a:noFill/>
+          <a:ln/>
+        </p:spPr>
+        <p:txBody>
+          <a:bodyPr wrap="square" lIns="0" tIns="0" rIns="0" bIns="0" rtlCol="0" anchor="ctr"/>
           <a:lstStyle/>
           <a:p>
             <a:pPr indent="0" marL="0">
               <a:buNone/>
             </a:pPr>
             <a:r>
-              <a:rPr lang="en-US" sz="1050" dirty="0">
+              <a:rPr lang="en-US" sz="950" b="1" dirty="0">
+                <a:solidFill>
+                  <a:srgbClr val="262626"/>
+                </a:solidFill>
+                <a:latin typeface="Arial" pitchFamily="34" charset="0"/>
+                <a:ea typeface="Arial" pitchFamily="34" charset="-122"/>
+                <a:cs typeface="Arial" pitchFamily="34" charset="-120"/>
+              </a:rPr>
+              <a:t>The 2026 boom is priced in</a:t>
+            </a:r>
+            <a:endParaRPr lang="en-US" sz="950" dirty="0"/>
+          </a:p>
+          <a:p>
+            <a:pPr indent="0" marL="0">
+              <a:buNone/>
+            </a:pPr>
+            <a:r>
+              <a:rPr lang="en-US" sz="950" dirty="0">
                 <a:solidFill>
                   <a:srgbClr val="595959"/>
                 </a:solidFill>
@@ -3914,22 +4596,390 @@
                 <a:ea typeface="Arial" pitchFamily="34" charset="-122"/>
                 <a:cs typeface="Arial" pitchFamily="34" charset="-120"/>
               </a:rPr>
-              <a:t>Chip stocks fell 25–36% in a single year when the inventory cycle turned. A direct investor would have needed a 33–56% rally just to get back to even.</a:t>
+              <a:t>KOSPI roughly doubled in 2026 and has already had two violent one-day crashes (verify on Bloomberg).</a:t>
             </a:r>
-            <a:endParaRPr lang="en-US" sz="1050" dirty="0"/>
+            <a:endParaRPr lang="en-US" sz="950" dirty="0"/>
           </a:p>
         </p:txBody>
       </p:sp>
       <p:sp>
         <p:nvSpPr>
-          <p:cNvPr id="13" name="Shape 10"/>
+          <p:cNvPr id="19" name="Shape 16"/>
           <p:cNvSpPr/>
           <p:nvPr/>
         </p:nvSpPr>
         <p:spPr>
           <a:xfrm>
-            <a:off x="4343400" y="1051560"/>
-            <a:ext cx="3657600" cy="384048"/>
+            <a:off x="457200" y="4261104"/>
+            <a:ext cx="5486400" cy="786384"/>
+          </a:xfrm>
+          <a:prstGeom prst="rect">
+            <a:avLst/>
+          </a:prstGeom>
+          <a:solidFill>
+            <a:srgbClr val="FFFFFF"/>
+          </a:solidFill>
+          <a:ln w="12700">
+            <a:solidFill>
+              <a:srgbClr val="F2F2F2"/>
+            </a:solidFill>
+            <a:prstDash val="solid"/>
+          </a:ln>
+        </p:spPr>
+      </p:sp>
+      <p:sp>
+        <p:nvSpPr>
+          <p:cNvPr id="20" name="Shape 17"/>
+          <p:cNvSpPr/>
+          <p:nvPr/>
+        </p:nvSpPr>
+        <p:spPr>
+          <a:xfrm>
+            <a:off x="548640" y="4443984"/>
+            <a:ext cx="384048" cy="384048"/>
+          </a:xfrm>
+          <a:prstGeom prst="ellipse">
+            <a:avLst/>
+          </a:prstGeom>
+          <a:solidFill>
+            <a:srgbClr val="FFFFFF"/>
+          </a:solidFill>
+          <a:ln w="15875">
+            <a:solidFill>
+              <a:srgbClr val="2C5F82"/>
+            </a:solidFill>
+            <a:prstDash val="solid"/>
+          </a:ln>
+        </p:spPr>
+      </p:sp>
+      <p:sp>
+        <p:nvSpPr>
+          <p:cNvPr id="21" name="Text 18"/>
+          <p:cNvSpPr txBox="1"/>
+          <p:nvPr/>
+        </p:nvSpPr>
+        <p:spPr>
+          <a:xfrm>
+            <a:off x="548640" y="4443984"/>
+            <a:ext cx="384048" cy="384048"/>
+          </a:xfrm>
+          <a:prstGeom prst="rect">
+            <a:avLst/>
+          </a:prstGeom>
+          <a:noFill/>
+          <a:ln/>
+        </p:spPr>
+        <p:txBody>
+          <a:bodyPr wrap="square" lIns="0" tIns="0" rIns="0" bIns="0" rtlCol="0" anchor="ctr"/>
+          <a:lstStyle/>
+          <a:p>
+            <a:pPr algn="ctr" indent="0" marL="0">
+              <a:buNone/>
+            </a:pPr>
+            <a:r>
+              <a:rPr lang="en-US" sz="1300" b="1" i="1" dirty="0">
+                <a:solidFill>
+                  <a:srgbClr val="2C5F82"/>
+                </a:solidFill>
+                <a:latin typeface="Arial" pitchFamily="34" charset="0"/>
+                <a:ea typeface="Arial" pitchFamily="34" charset="-122"/>
+                <a:cs typeface="Arial" pitchFamily="34" charset="-120"/>
+              </a:rPr>
+              <a:t>2</a:t>
+            </a:r>
+            <a:endParaRPr lang="en-US" sz="1300" dirty="0"/>
+          </a:p>
+        </p:txBody>
+      </p:sp>
+      <p:sp>
+        <p:nvSpPr>
+          <p:cNvPr id="22" name="Text 19"/>
+          <p:cNvSpPr txBox="1"/>
+          <p:nvPr/>
+        </p:nvSpPr>
+        <p:spPr>
+          <a:xfrm>
+            <a:off x="1024128" y="4261104"/>
+            <a:ext cx="1005840" cy="786384"/>
+          </a:xfrm>
+          <a:prstGeom prst="rect">
+            <a:avLst/>
+          </a:prstGeom>
+          <a:noFill/>
+          <a:ln/>
+        </p:spPr>
+        <p:txBody>
+          <a:bodyPr wrap="square" lIns="0" tIns="0" rIns="0" bIns="0" rtlCol="0" anchor="ctr"/>
+          <a:lstStyle/>
+          <a:p>
+            <a:pPr algn="ctr" indent="0" marL="0">
+              <a:buNone/>
+            </a:pPr>
+            <a:r>
+              <a:rPr lang="en-US" sz="1900" b="1" dirty="0">
+                <a:solidFill>
+                  <a:srgbClr val="2C5F82"/>
+                </a:solidFill>
+                <a:latin typeface="Arial" pitchFamily="34" charset="0"/>
+                <a:ea typeface="Arial" pitchFamily="34" charset="-122"/>
+                <a:cs typeface="Arial" pitchFamily="34" charset="-120"/>
+              </a:rPr>
+              <a:t>&gt;40%</a:t>
+            </a:r>
+            <a:endParaRPr lang="en-US" sz="1900" dirty="0"/>
+          </a:p>
+        </p:txBody>
+      </p:sp>
+      <p:sp>
+        <p:nvSpPr>
+          <p:cNvPr id="23" name="Text 20"/>
+          <p:cNvSpPr txBox="1"/>
+          <p:nvPr/>
+        </p:nvSpPr>
+        <p:spPr>
+          <a:xfrm>
+            <a:off x="2103120" y="4315968"/>
+            <a:ext cx="3749040" cy="713232"/>
+          </a:xfrm>
+          <a:prstGeom prst="rect">
+            <a:avLst/>
+          </a:prstGeom>
+          <a:noFill/>
+          <a:ln/>
+        </p:spPr>
+        <p:txBody>
+          <a:bodyPr wrap="square" lIns="0" tIns="0" rIns="0" bIns="0" rtlCol="0" anchor="ctr"/>
+          <a:lstStyle/>
+          <a:p>
+            <a:pPr indent="0" marL="0">
+              <a:buNone/>
+            </a:pPr>
+            <a:r>
+              <a:rPr lang="en-US" sz="950" b="1" dirty="0">
+                <a:solidFill>
+                  <a:srgbClr val="262626"/>
+                </a:solidFill>
+                <a:latin typeface="Arial" pitchFamily="34" charset="0"/>
+                <a:ea typeface="Arial" pitchFamily="34" charset="-122"/>
+                <a:cs typeface="Arial" pitchFamily="34" charset="-120"/>
+              </a:rPr>
+              <a:t>Returns hinge on a few names</a:t>
+            </a:r>
+            <a:endParaRPr lang="en-US" sz="950" dirty="0"/>
+          </a:p>
+          <a:p>
+            <a:pPr indent="0" marL="0">
+              <a:buNone/>
+            </a:pPr>
+            <a:r>
+              <a:rPr lang="en-US" sz="950" dirty="0">
+                <a:solidFill>
+                  <a:srgbClr val="595959"/>
+                </a:solidFill>
+                <a:latin typeface="Arial" pitchFamily="34" charset="0"/>
+                <a:ea typeface="Arial" pitchFamily="34" charset="-122"/>
+                <a:cs typeface="Arial" pitchFamily="34" charset="-120"/>
+              </a:rPr>
+              <a:t>TSMC is &gt;40% of the TAIEX; Advantest grew past the Nikkei's 10% weight cap. One stock can move the index.</a:t>
+            </a:r>
+            <a:endParaRPr lang="en-US" sz="950" dirty="0"/>
+          </a:p>
+        </p:txBody>
+      </p:sp>
+      <p:sp>
+        <p:nvSpPr>
+          <p:cNvPr id="24" name="Shape 21"/>
+          <p:cNvSpPr/>
+          <p:nvPr/>
+        </p:nvSpPr>
+        <p:spPr>
+          <a:xfrm>
+            <a:off x="457200" y="5047488"/>
+            <a:ext cx="5486400" cy="786384"/>
+          </a:xfrm>
+          <a:prstGeom prst="rect">
+            <a:avLst/>
+          </a:prstGeom>
+          <a:solidFill>
+            <a:srgbClr val="F2F2F2"/>
+          </a:solidFill>
+          <a:ln w="12700">
+            <a:solidFill>
+              <a:srgbClr val="F2F2F2"/>
+            </a:solidFill>
+            <a:prstDash val="solid"/>
+          </a:ln>
+        </p:spPr>
+      </p:sp>
+      <p:sp>
+        <p:nvSpPr>
+          <p:cNvPr id="25" name="Shape 22"/>
+          <p:cNvSpPr/>
+          <p:nvPr/>
+        </p:nvSpPr>
+        <p:spPr>
+          <a:xfrm>
+            <a:off x="548640" y="5230368"/>
+            <a:ext cx="384048" cy="384048"/>
+          </a:xfrm>
+          <a:prstGeom prst="ellipse">
+            <a:avLst/>
+          </a:prstGeom>
+          <a:solidFill>
+            <a:srgbClr val="FFFFFF"/>
+          </a:solidFill>
+          <a:ln w="15875">
+            <a:solidFill>
+              <a:srgbClr val="2C5F82"/>
+            </a:solidFill>
+            <a:prstDash val="solid"/>
+          </a:ln>
+        </p:spPr>
+      </p:sp>
+      <p:sp>
+        <p:nvSpPr>
+          <p:cNvPr id="26" name="Text 23"/>
+          <p:cNvSpPr txBox="1"/>
+          <p:nvPr/>
+        </p:nvSpPr>
+        <p:spPr>
+          <a:xfrm>
+            <a:off x="548640" y="5230368"/>
+            <a:ext cx="384048" cy="384048"/>
+          </a:xfrm>
+          <a:prstGeom prst="rect">
+            <a:avLst/>
+          </a:prstGeom>
+          <a:noFill/>
+          <a:ln/>
+        </p:spPr>
+        <p:txBody>
+          <a:bodyPr wrap="square" lIns="0" tIns="0" rIns="0" bIns="0" rtlCol="0" anchor="ctr"/>
+          <a:lstStyle/>
+          <a:p>
+            <a:pPr algn="ctr" indent="0" marL="0">
+              <a:buNone/>
+            </a:pPr>
+            <a:r>
+              <a:rPr lang="en-US" sz="1300" b="1" i="1" dirty="0">
+                <a:solidFill>
+                  <a:srgbClr val="2C5F82"/>
+                </a:solidFill>
+                <a:latin typeface="Arial" pitchFamily="34" charset="0"/>
+                <a:ea typeface="Arial" pitchFamily="34" charset="-122"/>
+                <a:cs typeface="Arial" pitchFamily="34" charset="-120"/>
+              </a:rPr>
+              <a:t>3</a:t>
+            </a:r>
+            <a:endParaRPr lang="en-US" sz="1300" dirty="0"/>
+          </a:p>
+        </p:txBody>
+      </p:sp>
+      <p:sp>
+        <p:nvSpPr>
+          <p:cNvPr id="27" name="Text 24"/>
+          <p:cNvSpPr txBox="1"/>
+          <p:nvPr/>
+        </p:nvSpPr>
+        <p:spPr>
+          <a:xfrm>
+            <a:off x="1024128" y="5047488"/>
+            <a:ext cx="1005840" cy="786384"/>
+          </a:xfrm>
+          <a:prstGeom prst="rect">
+            <a:avLst/>
+          </a:prstGeom>
+          <a:noFill/>
+          <a:ln/>
+        </p:spPr>
+        <p:txBody>
+          <a:bodyPr wrap="square" lIns="0" tIns="0" rIns="0" bIns="0" rtlCol="0" anchor="ctr"/>
+          <a:lstStyle/>
+          <a:p>
+            <a:pPr algn="ctr" indent="0" marL="0">
+              <a:buNone/>
+            </a:pPr>
+            <a:r>
+              <a:rPr lang="en-US" sz="1900" b="1" dirty="0">
+                <a:solidFill>
+                  <a:srgbClr val="2C5F82"/>
+                </a:solidFill>
+                <a:latin typeface="Arial" pitchFamily="34" charset="0"/>
+                <a:ea typeface="Arial" pitchFamily="34" charset="-122"/>
+                <a:cs typeface="Arial" pitchFamily="34" charset="-120"/>
+              </a:rPr>
+              <a:t>¥20trn</a:t>
+            </a:r>
+            <a:endParaRPr lang="en-US" sz="1900" dirty="0"/>
+          </a:p>
+        </p:txBody>
+      </p:sp>
+      <p:sp>
+        <p:nvSpPr>
+          <p:cNvPr id="28" name="Text 25"/>
+          <p:cNvSpPr txBox="1"/>
+          <p:nvPr/>
+        </p:nvSpPr>
+        <p:spPr>
+          <a:xfrm>
+            <a:off x="2103120" y="5102352"/>
+            <a:ext cx="3749040" cy="713232"/>
+          </a:xfrm>
+          <a:prstGeom prst="rect">
+            <a:avLst/>
+          </a:prstGeom>
+          <a:noFill/>
+          <a:ln/>
+        </p:spPr>
+        <p:txBody>
+          <a:bodyPr wrap="square" lIns="0" tIns="0" rIns="0" bIns="0" rtlCol="0" anchor="ctr"/>
+          <a:lstStyle/>
+          <a:p>
+            <a:pPr indent="0" marL="0">
+              <a:buNone/>
+            </a:pPr>
+            <a:r>
+              <a:rPr lang="en-US" sz="950" b="1" dirty="0">
+                <a:solidFill>
+                  <a:srgbClr val="262626"/>
+                </a:solidFill>
+                <a:latin typeface="Arial" pitchFamily="34" charset="0"/>
+                <a:ea typeface="Arial" pitchFamily="34" charset="-122"/>
+                <a:cs typeface="Arial" pitchFamily="34" charset="-120"/>
+              </a:rPr>
+              <a:t>Reforms support a recovery to 100%</a:t>
+            </a:r>
+            <a:endParaRPr lang="en-US" sz="950" dirty="0"/>
+          </a:p>
+          <a:p>
+            <a:pPr indent="0" marL="0">
+              <a:buNone/>
+            </a:pPr>
+            <a:r>
+              <a:rPr lang="en-US" sz="950" dirty="0">
+                <a:solidFill>
+                  <a:srgbClr val="595959"/>
+                </a:solidFill>
+                <a:latin typeface="Arial" pitchFamily="34" charset="0"/>
+                <a:ea typeface="Arial" pitchFamily="34" charset="-122"/>
+                <a:cs typeface="Arial" pitchFamily="34" charset="-120"/>
+              </a:rPr>
+              <a:t>Record Japanese buybacks (~¥20trn FY2025 forecast) and Korea's Value-up programme help the basket get back to its start.</a:t>
+            </a:r>
+            <a:endParaRPr lang="en-US" sz="950" dirty="0"/>
+          </a:p>
+        </p:txBody>
+      </p:sp>
+      <p:sp>
+        <p:nvSpPr>
+          <p:cNvPr id="29" name="Shape 26"/>
+          <p:cNvSpPr/>
+          <p:nvPr/>
+        </p:nvSpPr>
+        <p:spPr>
+          <a:xfrm>
+            <a:off x="6245352" y="1051560"/>
+            <a:ext cx="5486400" cy="384048"/>
           </a:xfrm>
           <a:prstGeom prst="rect">
             <a:avLst/>
@@ -3947,14 +4997,14 @@
       </p:sp>
       <p:sp>
         <p:nvSpPr>
-          <p:cNvPr id="14" name="Text 11"/>
+          <p:cNvPr id="30" name="Text 27"/>
           <p:cNvSpPr txBox="1"/>
           <p:nvPr/>
         </p:nvSpPr>
         <p:spPr>
           <a:xfrm>
-            <a:off x="4343400" y="1051560"/>
-            <a:ext cx="3657600" cy="384048"/>
+            <a:off x="6245352" y="1051560"/>
+            <a:ext cx="5486400" cy="384048"/>
           </a:xfrm>
           <a:prstGeom prst="rect">
             <a:avLst/>
@@ -3978,7 +5028,7 @@
                 <a:ea typeface="Arial" pitchFamily="34" charset="-122"/>
                 <a:cs typeface="Arial" pitchFamily="34" charset="-120"/>
               </a:rPr>
-              <a:t>2026: the boom is priced in</a:t>
+              <a:t>Finance aspect: why an autocall with protection</a:t>
             </a:r>
             <a:endParaRPr lang="en-US" sz="1400" dirty="0"/>
           </a:p>
@@ -3986,14 +5036,69 @@
       </p:sp>
       <p:sp>
         <p:nvSpPr>
-          <p:cNvPr id="15" name="Shape 12"/>
+          <p:cNvPr id="31" name="Text 28"/>
+          <p:cNvSpPr txBox="1"/>
+          <p:nvPr/>
+        </p:nvSpPr>
+        <p:spPr>
+          <a:xfrm>
+            <a:off x="6245352" y="1481328"/>
+            <a:ext cx="5486400" cy="274320"/>
+          </a:xfrm>
+          <a:prstGeom prst="rect">
+            <a:avLst/>
+          </a:prstGeom>
+          <a:noFill/>
+          <a:ln/>
+        </p:spPr>
+        <p:txBody>
+          <a:bodyPr wrap="square" lIns="0" tIns="0" rIns="0" bIns="0" rtlCol="0" anchor="t"/>
+          <a:lstStyle/>
+          <a:p>
+            <a:pPr algn="ctr" indent="0" marL="0">
+              <a:buNone/>
+            </a:pPr>
+            <a:r>
+              <a:rPr lang="en-US" sz="1050" i="1" dirty="0">
+                <a:solidFill>
+                  <a:srgbClr val="595959"/>
+                </a:solidFill>
+                <a:latin typeface="Arial" pitchFamily="34" charset="0"/>
+                <a:ea typeface="Arial" pitchFamily="34" charset="-122"/>
+                <a:cs typeface="Arial" pitchFamily="34" charset="-120"/>
+              </a:rPr>
+              <a:t>Today's rates pay for the protection; Asian volatility pays for the coupon</a:t>
+            </a:r>
+            <a:endParaRPr lang="en-US" sz="1050" dirty="0"/>
+          </a:p>
+        </p:txBody>
+      </p:sp>
+      <p:graphicFrame>
+        <p:nvGraphicFramePr>
+          <p:cNvPr id="32" name="Chart 1" descr=""/>
+          <p:cNvGraphicFramePr/>
+          <p:nvPr/>
+        </p:nvGraphicFramePr>
+        <p:xfrm>
+          <a:off x="6245352" y="1783080"/>
+          <a:ext cx="5486400" cy="1600200"/>
+        </p:xfrm>
+        <a:graphic xmlns:a="http://schemas.openxmlformats.org/drawingml/2006/main">
+          <a:graphicData uri="http://schemas.openxmlformats.org/drawingml/2006/chart">
+            <c:chart xmlns:c="http://schemas.openxmlformats.org/drawingml/2006/chart" r:id="rId2"/>
+          </a:graphicData>
+        </a:graphic>
+      </p:graphicFrame>
+      <p:sp>
+        <p:nvSpPr>
+          <p:cNvPr id="33" name="Shape 29"/>
           <p:cNvSpPr/>
           <p:nvPr/>
         </p:nvSpPr>
         <p:spPr>
           <a:xfrm>
-            <a:off x="4343400" y="1554480"/>
-            <a:ext cx="3657600" cy="841248"/>
+            <a:off x="6245352" y="3474720"/>
+            <a:ext cx="5486400" cy="786384"/>
           </a:xfrm>
           <a:prstGeom prst="rect">
             <a:avLst/>
@@ -4011,409 +5116,22 @@
       </p:sp>
       <p:sp>
         <p:nvSpPr>
-          <p:cNvPr id="16" name="Text 13"/>
-          <p:cNvSpPr txBox="1"/>
-          <p:nvPr/>
-        </p:nvSpPr>
-        <p:spPr>
-          <a:xfrm>
-            <a:off x="4434840" y="1554480"/>
-            <a:ext cx="1051560" cy="841248"/>
-          </a:xfrm>
-          <a:prstGeom prst="rect">
-            <a:avLst/>
-          </a:prstGeom>
-          <a:noFill/>
-          <a:ln/>
-        </p:spPr>
-        <p:txBody>
-          <a:bodyPr wrap="square" lIns="0" tIns="0" rIns="0" bIns="0" rtlCol="0" anchor="ctr"/>
-          <a:lstStyle/>
-          <a:p>
-            <a:pPr algn="ctr" indent="0" marL="0">
-              <a:buNone/>
-            </a:pPr>
-            <a:r>
-              <a:rPr lang="en-US" sz="2200" b="1" dirty="0">
-                <a:solidFill>
-                  <a:srgbClr val="B23B3B"/>
-                </a:solidFill>
-                <a:latin typeface="Arial" pitchFamily="34" charset="0"/>
-                <a:ea typeface="Arial" pitchFamily="34" charset="-122"/>
-                <a:cs typeface="Arial" pitchFamily="34" charset="-120"/>
-              </a:rPr>
-              <a:t>~2×</a:t>
-            </a:r>
-            <a:endParaRPr lang="en-US" sz="2200" dirty="0"/>
-          </a:p>
-        </p:txBody>
-      </p:sp>
-      <p:sp>
-        <p:nvSpPr>
-          <p:cNvPr id="17" name="Text 14"/>
-          <p:cNvSpPr txBox="1"/>
-          <p:nvPr/>
-        </p:nvSpPr>
-        <p:spPr>
-          <a:xfrm>
-            <a:off x="5532120" y="1627632"/>
-            <a:ext cx="2377440" cy="731520"/>
-          </a:xfrm>
-          <a:prstGeom prst="rect">
-            <a:avLst/>
-          </a:prstGeom>
-          <a:noFill/>
-          <a:ln/>
-        </p:spPr>
-        <p:txBody>
-          <a:bodyPr wrap="square" lIns="0" tIns="0" rIns="0" bIns="0" rtlCol="0" anchor="ctr"/>
-          <a:lstStyle/>
-          <a:p>
-            <a:pPr indent="0" marL="0">
-              <a:buNone/>
-            </a:pPr>
-            <a:r>
-              <a:rPr lang="en-US" sz="1000" dirty="0">
-                <a:solidFill>
-                  <a:srgbClr val="262626"/>
-                </a:solidFill>
-                <a:latin typeface="Arial" pitchFamily="34" charset="0"/>
-                <a:ea typeface="Arial" pitchFamily="34" charset="-122"/>
-                <a:cs typeface="Arial" pitchFamily="34" charset="-120"/>
-              </a:rPr>
-              <a:t>KOSPI in 2026: ~+100% YTD, crossed 9,000 (Jun 2026), then two violent single-day crashes</a:t>
-            </a:r>
-            <a:endParaRPr lang="en-US" sz="1000" dirty="0"/>
-          </a:p>
-        </p:txBody>
-      </p:sp>
-      <p:sp>
-        <p:nvSpPr>
-          <p:cNvPr id="18" name="Shape 15"/>
+          <p:cNvPr id="34" name="Shape 30"/>
           <p:cNvSpPr/>
           <p:nvPr/>
         </p:nvSpPr>
         <p:spPr>
           <a:xfrm>
-            <a:off x="4343400" y="2487168"/>
-            <a:ext cx="3657600" cy="841248"/>
-          </a:xfrm>
-          <a:prstGeom prst="rect">
+            <a:off x="6336792" y="3657600"/>
+            <a:ext cx="384048" cy="384048"/>
+          </a:xfrm>
+          <a:prstGeom prst="ellipse">
             <a:avLst/>
           </a:prstGeom>
           <a:solidFill>
             <a:srgbClr val="FFFFFF"/>
           </a:solidFill>
-          <a:ln w="12700">
-            <a:solidFill>
-              <a:srgbClr val="F2F2F2"/>
-            </a:solidFill>
-            <a:prstDash val="solid"/>
-          </a:ln>
-        </p:spPr>
-      </p:sp>
-      <p:sp>
-        <p:nvSpPr>
-          <p:cNvPr id="19" name="Text 16"/>
-          <p:cNvSpPr txBox="1"/>
-          <p:nvPr/>
-        </p:nvSpPr>
-        <p:spPr>
-          <a:xfrm>
-            <a:off x="4434840" y="2487168"/>
-            <a:ext cx="1051560" cy="841248"/>
-          </a:xfrm>
-          <a:prstGeom prst="rect">
-            <a:avLst/>
-          </a:prstGeom>
-          <a:noFill/>
-          <a:ln/>
-        </p:spPr>
-        <p:txBody>
-          <a:bodyPr wrap="square" lIns="0" tIns="0" rIns="0" bIns="0" rtlCol="0" anchor="ctr"/>
-          <a:lstStyle/>
-          <a:p>
-            <a:pPr algn="ctr" indent="0" marL="0">
-              <a:buNone/>
-            </a:pPr>
-            <a:r>
-              <a:rPr lang="en-US" sz="2200" b="1" dirty="0">
-                <a:solidFill>
-                  <a:srgbClr val="2C5F82"/>
-                </a:solidFill>
-                <a:latin typeface="Arial" pitchFamily="34" charset="0"/>
-                <a:ea typeface="Arial" pitchFamily="34" charset="-122"/>
-                <a:cs typeface="Arial" pitchFamily="34" charset="-120"/>
-              </a:rPr>
-              <a:t>&gt;40%</a:t>
-            </a:r>
-            <a:endParaRPr lang="en-US" sz="2200" dirty="0"/>
-          </a:p>
-        </p:txBody>
-      </p:sp>
-      <p:sp>
-        <p:nvSpPr>
-          <p:cNvPr id="20" name="Text 17"/>
-          <p:cNvSpPr txBox="1"/>
-          <p:nvPr/>
-        </p:nvSpPr>
-        <p:spPr>
-          <a:xfrm>
-            <a:off x="5532120" y="2560320"/>
-            <a:ext cx="2377440" cy="731520"/>
-          </a:xfrm>
-          <a:prstGeom prst="rect">
-            <a:avLst/>
-          </a:prstGeom>
-          <a:noFill/>
-          <a:ln/>
-        </p:spPr>
-        <p:txBody>
-          <a:bodyPr wrap="square" lIns="0" tIns="0" rIns="0" bIns="0" rtlCol="0" anchor="ctr"/>
-          <a:lstStyle/>
-          <a:p>
-            <a:pPr indent="0" marL="0">
-              <a:buNone/>
-            </a:pPr>
-            <a:r>
-              <a:rPr lang="en-US" sz="1000" dirty="0">
-                <a:solidFill>
-                  <a:srgbClr val="262626"/>
-                </a:solidFill>
-                <a:latin typeface="Arial" pitchFamily="34" charset="0"/>
-                <a:ea typeface="Arial" pitchFamily="34" charset="-122"/>
-                <a:cs typeface="Arial" pitchFamily="34" charset="-120"/>
-              </a:rPr>
-              <a:t>TSMC's weight in the TAIEX: one stock drives the index</a:t>
-            </a:r>
-            <a:endParaRPr lang="en-US" sz="1000" dirty="0"/>
-          </a:p>
-        </p:txBody>
-      </p:sp>
-      <p:sp>
-        <p:nvSpPr>
-          <p:cNvPr id="21" name="Shape 18"/>
-          <p:cNvSpPr/>
-          <p:nvPr/>
-        </p:nvSpPr>
-        <p:spPr>
-          <a:xfrm>
-            <a:off x="4343400" y="3419856"/>
-            <a:ext cx="3657600" cy="841248"/>
-          </a:xfrm>
-          <a:prstGeom prst="rect">
-            <a:avLst/>
-          </a:prstGeom>
-          <a:solidFill>
-            <a:srgbClr val="F2F2F2"/>
-          </a:solidFill>
-          <a:ln w="12700">
-            <a:solidFill>
-              <a:srgbClr val="F2F2F2"/>
-            </a:solidFill>
-            <a:prstDash val="solid"/>
-          </a:ln>
-        </p:spPr>
-      </p:sp>
-      <p:sp>
-        <p:nvSpPr>
-          <p:cNvPr id="22" name="Text 19"/>
-          <p:cNvSpPr txBox="1"/>
-          <p:nvPr/>
-        </p:nvSpPr>
-        <p:spPr>
-          <a:xfrm>
-            <a:off x="4434840" y="3419856"/>
-            <a:ext cx="1051560" cy="841248"/>
-          </a:xfrm>
-          <a:prstGeom prst="rect">
-            <a:avLst/>
-          </a:prstGeom>
-          <a:noFill/>
-          <a:ln/>
-        </p:spPr>
-        <p:txBody>
-          <a:bodyPr wrap="square" lIns="0" tIns="0" rIns="0" bIns="0" rtlCol="0" anchor="ctr"/>
-          <a:lstStyle/>
-          <a:p>
-            <a:pPr algn="ctr" indent="0" marL="0">
-              <a:buNone/>
-            </a:pPr>
-            <a:r>
-              <a:rPr lang="en-US" sz="2200" b="1" dirty="0">
-                <a:solidFill>
-                  <a:srgbClr val="2C5F82"/>
-                </a:solidFill>
-                <a:latin typeface="Arial" pitchFamily="34" charset="0"/>
-                <a:ea typeface="Arial" pitchFamily="34" charset="-122"/>
-                <a:cs typeface="Arial" pitchFamily="34" charset="-120"/>
-              </a:rPr>
-              <a:t>12%</a:t>
-            </a:r>
-            <a:endParaRPr lang="en-US" sz="2200" dirty="0"/>
-          </a:p>
-        </p:txBody>
-      </p:sp>
-      <p:sp>
-        <p:nvSpPr>
-          <p:cNvPr id="23" name="Text 20"/>
-          <p:cNvSpPr txBox="1"/>
-          <p:nvPr/>
-        </p:nvSpPr>
-        <p:spPr>
-          <a:xfrm>
-            <a:off x="5532120" y="3493008"/>
-            <a:ext cx="2377440" cy="731520"/>
-          </a:xfrm>
-          <a:prstGeom prst="rect">
-            <a:avLst/>
-          </a:prstGeom>
-          <a:noFill/>
-          <a:ln/>
-        </p:spPr>
-        <p:txBody>
-          <a:bodyPr wrap="square" lIns="0" tIns="0" rIns="0" bIns="0" rtlCol="0" anchor="ctr"/>
-          <a:lstStyle/>
-          <a:p>
-            <a:pPr indent="0" marL="0">
-              <a:buNone/>
-            </a:pPr>
-            <a:r>
-              <a:rPr lang="en-US" sz="1000" dirty="0">
-                <a:solidFill>
-                  <a:srgbClr val="262626"/>
-                </a:solidFill>
-                <a:latin typeface="Arial" pitchFamily="34" charset="0"/>
-                <a:ea typeface="Arial" pitchFamily="34" charset="-122"/>
-                <a:cs typeface="Arial" pitchFamily="34" charset="-120"/>
-              </a:rPr>
-              <a:t>Advantest's Nikkei 225 weight (Jul 2026): above the 10% cap, so Nikkei is cutting it</a:t>
-            </a:r>
-            <a:endParaRPr lang="en-US" sz="1000" dirty="0"/>
-          </a:p>
-        </p:txBody>
-      </p:sp>
-      <p:sp>
-        <p:nvSpPr>
-          <p:cNvPr id="24" name="Shape 21"/>
-          <p:cNvSpPr/>
-          <p:nvPr/>
-        </p:nvSpPr>
-        <p:spPr>
-          <a:xfrm>
-            <a:off x="4343400" y="4352544"/>
-            <a:ext cx="3657600" cy="841248"/>
-          </a:xfrm>
-          <a:prstGeom prst="rect">
-            <a:avLst/>
-          </a:prstGeom>
-          <a:solidFill>
-            <a:srgbClr val="FFFFFF"/>
-          </a:solidFill>
-          <a:ln w="12700">
-            <a:solidFill>
-              <a:srgbClr val="F2F2F2"/>
-            </a:solidFill>
-            <a:prstDash val="solid"/>
-          </a:ln>
-        </p:spPr>
-      </p:sp>
-      <p:sp>
-        <p:nvSpPr>
-          <p:cNvPr id="25" name="Text 22"/>
-          <p:cNvSpPr txBox="1"/>
-          <p:nvPr/>
-        </p:nvSpPr>
-        <p:spPr>
-          <a:xfrm>
-            <a:off x="4434840" y="4352544"/>
-            <a:ext cx="1051560" cy="841248"/>
-          </a:xfrm>
-          <a:prstGeom prst="rect">
-            <a:avLst/>
-          </a:prstGeom>
-          <a:noFill/>
-          <a:ln/>
-        </p:spPr>
-        <p:txBody>
-          <a:bodyPr wrap="square" lIns="0" tIns="0" rIns="0" bIns="0" rtlCol="0" anchor="ctr"/>
-          <a:lstStyle/>
-          <a:p>
-            <a:pPr algn="ctr" indent="0" marL="0">
-              <a:buNone/>
-            </a:pPr>
-            <a:r>
-              <a:rPr lang="en-US" sz="2200" b="1" dirty="0">
-                <a:solidFill>
-                  <a:srgbClr val="B23B3B"/>
-                </a:solidFill>
-                <a:latin typeface="Arial" pitchFamily="34" charset="0"/>
-                <a:ea typeface="Arial" pitchFamily="34" charset="-122"/>
-                <a:cs typeface="Arial" pitchFamily="34" charset="-120"/>
-              </a:rPr>
-              <a:t>−4%</a:t>
-            </a:r>
-            <a:endParaRPr lang="en-US" sz="2200" dirty="0"/>
-          </a:p>
-        </p:txBody>
-      </p:sp>
-      <p:sp>
-        <p:nvSpPr>
-          <p:cNvPr id="26" name="Text 23"/>
-          <p:cNvSpPr txBox="1"/>
-          <p:nvPr/>
-        </p:nvSpPr>
-        <p:spPr>
-          <a:xfrm>
-            <a:off x="5532120" y="4425696"/>
-            <a:ext cx="2377440" cy="731520"/>
-          </a:xfrm>
-          <a:prstGeom prst="rect">
-            <a:avLst/>
-          </a:prstGeom>
-          <a:noFill/>
-          <a:ln/>
-        </p:spPr>
-        <p:txBody>
-          <a:bodyPr wrap="square" lIns="0" tIns="0" rIns="0" bIns="0" rtlCol="0" anchor="ctr"/>
-          <a:lstStyle/>
-          <a:p>
-            <a:pPr indent="0" marL="0">
-              <a:buNone/>
-            </a:pPr>
-            <a:r>
-              <a:rPr lang="en-US" sz="1000" dirty="0">
-                <a:solidFill>
-                  <a:srgbClr val="262626"/>
-                </a:solidFill>
-                <a:latin typeface="Arial" pitchFamily="34" charset="0"/>
-                <a:ea typeface="Arial" pitchFamily="34" charset="-122"/>
-                <a:cs typeface="Arial" pitchFamily="34" charset="-120"/>
-              </a:rPr>
-              <a:t>Nikkei fall in a chip-led selloff, mid-July 2026</a:t>
-            </a:r>
-            <a:endParaRPr lang="en-US" sz="1000" dirty="0"/>
-          </a:p>
-        </p:txBody>
-      </p:sp>
-      <p:sp>
-        <p:nvSpPr>
-          <p:cNvPr id="27" name="Shape 24"/>
-          <p:cNvSpPr/>
-          <p:nvPr/>
-        </p:nvSpPr>
-        <p:spPr>
-          <a:xfrm>
-            <a:off x="8229600" y="1051560"/>
-            <a:ext cx="3502152" cy="384048"/>
-          </a:xfrm>
-          <a:prstGeom prst="rect">
-            <a:avLst/>
-          </a:prstGeom>
-          <a:solidFill>
-            <a:srgbClr val="2C5F82"/>
-          </a:solidFill>
-          <a:ln w="12700">
+          <a:ln w="15875">
             <a:solidFill>
               <a:srgbClr val="2C5F82"/>
             </a:solidFill>
@@ -4423,14 +5141,14 @@
       </p:sp>
       <p:sp>
         <p:nvSpPr>
-          <p:cNvPr id="28" name="Text 25"/>
+          <p:cNvPr id="35" name="Text 31"/>
           <p:cNvSpPr txBox="1"/>
           <p:nvPr/>
         </p:nvSpPr>
         <p:spPr>
           <a:xfrm>
-            <a:off x="8229600" y="1051560"/>
-            <a:ext cx="3502152" cy="384048"/>
+            <a:off x="6336792" y="3657600"/>
+            <a:ext cx="384048" cy="384048"/>
           </a:xfrm>
           <a:prstGeom prst="rect">
             <a:avLst/>
@@ -4443,70 +5161,6 @@
           <a:lstStyle/>
           <a:p>
             <a:pPr algn="ctr" indent="0" marL="0">
-              <a:buNone/>
-            </a:pPr>
-            <a:r>
-              <a:rPr lang="en-US" sz="1400" b="1" i="1" dirty="0">
-                <a:solidFill>
-                  <a:srgbClr val="FFFFFF"/>
-                </a:solidFill>
-                <a:latin typeface="Arial" pitchFamily="34" charset="0"/>
-                <a:ea typeface="Arial" pitchFamily="34" charset="-122"/>
-                <a:cs typeface="Arial" pitchFamily="34" charset="-120"/>
-              </a:rPr>
-              <a:t>Tailwind: governance reform</a:t>
-            </a:r>
-            <a:endParaRPr lang="en-US" sz="1400" dirty="0"/>
-          </a:p>
-        </p:txBody>
-      </p:sp>
-      <p:sp>
-        <p:nvSpPr>
-          <p:cNvPr id="29" name="Shape 26"/>
-          <p:cNvSpPr/>
-          <p:nvPr/>
-        </p:nvSpPr>
-        <p:spPr>
-          <a:xfrm>
-            <a:off x="8229600" y="1554480"/>
-            <a:ext cx="3502152" cy="1755648"/>
-          </a:xfrm>
-          <a:prstGeom prst="rect">
-            <a:avLst/>
-          </a:prstGeom>
-          <a:solidFill>
-            <a:srgbClr val="E8EFF5"/>
-          </a:solidFill>
-          <a:ln w="12700">
-            <a:solidFill>
-              <a:srgbClr val="E8EFF5"/>
-            </a:solidFill>
-            <a:prstDash val="solid"/>
-          </a:ln>
-        </p:spPr>
-      </p:sp>
-      <p:sp>
-        <p:nvSpPr>
-          <p:cNvPr id="30" name="Text 27"/>
-          <p:cNvSpPr txBox="1"/>
-          <p:nvPr/>
-        </p:nvSpPr>
-        <p:spPr>
-          <a:xfrm>
-            <a:off x="8366760" y="1645920"/>
-            <a:ext cx="3200400" cy="274320"/>
-          </a:xfrm>
-          <a:prstGeom prst="rect">
-            <a:avLst/>
-          </a:prstGeom>
-          <a:noFill/>
-          <a:ln/>
-        </p:spPr>
-        <p:txBody>
-          <a:bodyPr wrap="square" lIns="0" tIns="0" rIns="0" bIns="0" rtlCol="0" anchor="t"/>
-          <a:lstStyle/>
-          <a:p>
-            <a:pPr indent="0" marL="0">
               <a:buNone/>
             </a:pPr>
             <a:r>
@@ -4518,7 +5172,7 @@
                 <a:ea typeface="Arial" pitchFamily="34" charset="-122"/>
                 <a:cs typeface="Arial" pitchFamily="34" charset="-120"/>
               </a:rPr>
-              <a:t>Japan</a:t>
+              <a:t>1</a:t>
             </a:r>
             <a:endParaRPr lang="en-US" sz="1300" dirty="0"/>
           </a:p>
@@ -4526,14 +5180,14 @@
       </p:sp>
       <p:sp>
         <p:nvSpPr>
-          <p:cNvPr id="31" name="Text 28"/>
+          <p:cNvPr id="36" name="Text 32"/>
           <p:cNvSpPr txBox="1"/>
           <p:nvPr/>
         </p:nvSpPr>
         <p:spPr>
           <a:xfrm>
-            <a:off x="8366760" y="1965960"/>
-            <a:ext cx="3246120" cy="1280160"/>
+            <a:off x="6812280" y="3474720"/>
+            <a:ext cx="1005840" cy="786384"/>
           </a:xfrm>
           <a:prstGeom prst="rect">
             <a:avLst/>
@@ -4542,14 +5196,53 @@
           <a:ln/>
         </p:spPr>
         <p:txBody>
-          <a:bodyPr wrap="square" lIns="0" tIns="0" rIns="0" bIns="0" rtlCol="0" anchor="t"/>
+          <a:bodyPr wrap="square" lIns="0" tIns="0" rIns="0" bIns="0" rtlCol="0" anchor="ctr"/>
+          <a:lstStyle/>
+          <a:p>
+            <a:pPr algn="ctr" indent="0" marL="0">
+              <a:buNone/>
+            </a:pPr>
+            <a:r>
+              <a:rPr lang="en-US" sz="1900" b="1" dirty="0">
+                <a:solidFill>
+                  <a:srgbClr val="2C5F82"/>
+                </a:solidFill>
+                <a:latin typeface="Arial" pitchFamily="34" charset="0"/>
+                <a:ea typeface="Arial" pitchFamily="34" charset="-122"/>
+                <a:cs typeface="Arial" pitchFamily="34" charset="-120"/>
+              </a:rPr>
+              <a:t>75.8%</a:t>
+            </a:r>
+            <a:endParaRPr lang="en-US" sz="1900" dirty="0"/>
+          </a:p>
+        </p:txBody>
+      </p:sp>
+      <p:sp>
+        <p:nvSpPr>
+          <p:cNvPr id="37" name="Text 33"/>
+          <p:cNvSpPr txBox="1"/>
+          <p:nvPr/>
+        </p:nvSpPr>
+        <p:spPr>
+          <a:xfrm>
+            <a:off x="7891272" y="3529584"/>
+            <a:ext cx="3749040" cy="713232"/>
+          </a:xfrm>
+          <a:prstGeom prst="rect">
+            <a:avLst/>
+          </a:prstGeom>
+          <a:noFill/>
+          <a:ln/>
+        </p:spPr>
+        <p:txBody>
+          <a:bodyPr wrap="square" lIns="0" tIns="0" rIns="0" bIns="0" rtlCol="0" anchor="ctr"/>
           <a:lstStyle/>
           <a:p>
             <a:pPr indent="0" marL="0">
               <a:buNone/>
             </a:pPr>
             <a:r>
-              <a:rPr lang="en-US" sz="1000" dirty="0">
+              <a:rPr lang="en-US" sz="950" b="1" dirty="0">
                 <a:solidFill>
                   <a:srgbClr val="262626"/>
                 </a:solidFill>
@@ -4557,32 +5250,49 @@
                 <a:ea typeface="Arial" pitchFamily="34" charset="-122"/>
                 <a:cs typeface="Arial" pitchFamily="34" charset="-120"/>
               </a:rPr>
-              <a:t>TSE's 2023 push on companies below 1× book: record buybacks (¥18.7trn FY2024, ~¥20trn forecast FY2025); share of Prime firms below 1× P/B down from ~50% to 44%</a:t>
+              <a:t>High USD rates make protection cheap</a:t>
             </a:r>
-            <a:endParaRPr lang="en-US" sz="1000" dirty="0"/>
+            <a:endParaRPr lang="en-US" sz="950" dirty="0"/>
+          </a:p>
+          <a:p>
+            <a:pPr indent="0" marL="0">
+              <a:buNone/>
+            </a:pPr>
+            <a:r>
+              <a:rPr lang="en-US" sz="950" dirty="0">
+                <a:solidFill>
+                  <a:srgbClr val="595959"/>
+                </a:solidFill>
+                <a:latin typeface="Arial" pitchFamily="34" charset="0"/>
+                <a:ea typeface="Arial" pitchFamily="34" charset="-122"/>
+                <a:cs typeface="Arial" pitchFamily="34" charset="-120"/>
+              </a:rPr>
+              <a:t>At 5.69% 5Y funding, USD 100 at year 5 costs only USD 75.8 today, and early calls make it cheaper still (89.9% in our note).</a:t>
+            </a:r>
+            <a:endParaRPr lang="en-US" sz="950" dirty="0"/>
           </a:p>
         </p:txBody>
       </p:sp>
       <p:sp>
         <p:nvSpPr>
-          <p:cNvPr id="32" name="Shape 29"/>
+          <p:cNvPr id="38" name="Shape 34"/>
           <p:cNvSpPr/>
           <p:nvPr/>
         </p:nvSpPr>
         <p:spPr>
           <a:xfrm>
-            <a:off x="8229600" y="3429000"/>
-            <a:ext cx="3502152" cy="1755648"/>
+            <a:off x="6245352" y="4261104"/>
+            <a:ext cx="5486400" cy="786384"/>
           </a:xfrm>
           <a:prstGeom prst="rect">
             <a:avLst/>
           </a:prstGeom>
           <a:solidFill>
-            <a:srgbClr val="E8EFF5"/>
+            <a:srgbClr val="FFFFFF"/>
           </a:solidFill>
           <a:ln w="12700">
             <a:solidFill>
-              <a:srgbClr val="E8EFF5"/>
+              <a:srgbClr val="F2F2F2"/>
             </a:solidFill>
             <a:prstDash val="solid"/>
           </a:ln>
@@ -4590,14 +5300,39 @@
       </p:sp>
       <p:sp>
         <p:nvSpPr>
-          <p:cNvPr id="33" name="Text 30"/>
+          <p:cNvPr id="39" name="Shape 35"/>
+          <p:cNvSpPr/>
+          <p:nvPr/>
+        </p:nvSpPr>
+        <p:spPr>
+          <a:xfrm>
+            <a:off x="6336792" y="4443984"/>
+            <a:ext cx="384048" cy="384048"/>
+          </a:xfrm>
+          <a:prstGeom prst="ellipse">
+            <a:avLst/>
+          </a:prstGeom>
+          <a:solidFill>
+            <a:srgbClr val="FFFFFF"/>
+          </a:solidFill>
+          <a:ln w="15875">
+            <a:solidFill>
+              <a:srgbClr val="2C5F82"/>
+            </a:solidFill>
+            <a:prstDash val="solid"/>
+          </a:ln>
+        </p:spPr>
+      </p:sp>
+      <p:sp>
+        <p:nvSpPr>
+          <p:cNvPr id="40" name="Text 36"/>
           <p:cNvSpPr txBox="1"/>
           <p:nvPr/>
         </p:nvSpPr>
         <p:spPr>
           <a:xfrm>
-            <a:off x="8366760" y="3520440"/>
-            <a:ext cx="3200400" cy="274320"/>
+            <a:off x="6336792" y="4443984"/>
+            <a:ext cx="384048" cy="384048"/>
           </a:xfrm>
           <a:prstGeom prst="rect">
             <a:avLst/>
@@ -4606,10 +5341,10 @@
           <a:ln/>
         </p:spPr>
         <p:txBody>
-          <a:bodyPr wrap="square" lIns="0" tIns="0" rIns="0" bIns="0" rtlCol="0" anchor="t"/>
+          <a:bodyPr wrap="square" lIns="0" tIns="0" rIns="0" bIns="0" rtlCol="0" anchor="ctr"/>
           <a:lstStyle/>
           <a:p>
-            <a:pPr indent="0" marL="0">
+            <a:pPr algn="ctr" indent="0" marL="0">
               <a:buNone/>
             </a:pPr>
             <a:r>
@@ -4621,7 +5356,7 @@
                 <a:ea typeface="Arial" pitchFamily="34" charset="-122"/>
                 <a:cs typeface="Arial" pitchFamily="34" charset="-120"/>
               </a:rPr>
-              <a:t>Korea</a:t>
+              <a:t>2</a:t>
             </a:r>
             <a:endParaRPr lang="en-US" sz="1300" dirty="0"/>
           </a:p>
@@ -4629,14 +5364,14 @@
       </p:sp>
       <p:sp>
         <p:nvSpPr>
-          <p:cNvPr id="34" name="Text 31"/>
+          <p:cNvPr id="41" name="Text 37"/>
           <p:cNvSpPr txBox="1"/>
           <p:nvPr/>
         </p:nvSpPr>
         <p:spPr>
           <a:xfrm>
-            <a:off x="8366760" y="3840480"/>
-            <a:ext cx="3246120" cy="1280160"/>
+            <a:off x="6812280" y="4261104"/>
+            <a:ext cx="1005840" cy="786384"/>
           </a:xfrm>
           <a:prstGeom prst="rect">
             <a:avLst/>
@@ -4645,14 +5380,53 @@
           <a:ln/>
         </p:spPr>
         <p:txBody>
-          <a:bodyPr wrap="square" lIns="0" tIns="0" rIns="0" bIns="0" rtlCol="0" anchor="t"/>
+          <a:bodyPr wrap="square" lIns="0" tIns="0" rIns="0" bIns="0" rtlCol="0" anchor="ctr"/>
+          <a:lstStyle/>
+          <a:p>
+            <a:pPr algn="ctr" indent="0" marL="0">
+              <a:buNone/>
+            </a:pPr>
+            <a:r>
+              <a:rPr lang="en-US" sz="1900" b="1" dirty="0">
+                <a:solidFill>
+                  <a:srgbClr val="2C5F82"/>
+                </a:solidFill>
+                <a:latin typeface="Arial" pitchFamily="34" charset="0"/>
+                <a:ea typeface="Arial" pitchFamily="34" charset="-122"/>
+                <a:cs typeface="Arial" pitchFamily="34" charset="-120"/>
+              </a:rPr>
+              <a:t>21%</a:t>
+            </a:r>
+            <a:endParaRPr lang="en-US" sz="1900" dirty="0"/>
+          </a:p>
+        </p:txBody>
+      </p:sp>
+      <p:sp>
+        <p:nvSpPr>
+          <p:cNvPr id="42" name="Text 38"/>
+          <p:cNvSpPr txBox="1"/>
+          <p:nvPr/>
+        </p:nvSpPr>
+        <p:spPr>
+          <a:xfrm>
+            <a:off x="7891272" y="4315968"/>
+            <a:ext cx="3749040" cy="713232"/>
+          </a:xfrm>
+          <a:prstGeom prst="rect">
+            <a:avLst/>
+          </a:prstGeom>
+          <a:noFill/>
+          <a:ln/>
+        </p:spPr>
+        <p:txBody>
+          <a:bodyPr wrap="square" lIns="0" tIns="0" rIns="0" bIns="0" rtlCol="0" anchor="ctr"/>
           <a:lstStyle/>
           <a:p>
             <a:pPr indent="0" marL="0">
               <a:buNone/>
             </a:pPr>
             <a:r>
-              <a:rPr lang="en-US" sz="1000" dirty="0">
+              <a:rPr lang="en-US" sz="950" b="1" dirty="0">
                 <a:solidFill>
                   <a:srgbClr val="262626"/>
                 </a:solidFill>
@@ -4660,21 +5434,222 @@
                 <a:ea typeface="Arial" pitchFamily="34" charset="-122"/>
                 <a:cs typeface="Arial" pitchFamily="34" charset="-120"/>
               </a:rPr>
-              <a:t>Corporate Value-up Programme (Feb 2024): Korea Value-Up Index beat KOSPI 200 by &gt;30% from late 2024 to Feb 2026</a:t>
+              <a:t>Volatility funds the coupon, not losses</a:t>
             </a:r>
-            <a:endParaRPr lang="en-US" sz="1000" dirty="0"/>
+            <a:endParaRPr lang="en-US" sz="950" dirty="0"/>
+          </a:p>
+          <a:p>
+            <a:pPr indent="0" marL="0">
+              <a:buNone/>
+            </a:pPr>
+            <a:r>
+              <a:rPr lang="en-US" sz="950" dirty="0">
+                <a:solidFill>
+                  <a:srgbClr val="595959"/>
+                </a:solidFill>
+                <a:latin typeface="Arial" pitchFamily="34" charset="0"/>
+                <a:ea typeface="Arial" pitchFamily="34" charset="-122"/>
+                <a:cs typeface="Arial" pitchFamily="34" charset="-120"/>
+              </a:rPr>
+              <a:t>Higher vol means more chances to touch 100%: fair coupon 7.1% rising to 7.5% if vol is 3pts higher.</a:t>
+            </a:r>
+            <a:endParaRPr lang="en-US" sz="950" dirty="0"/>
           </a:p>
         </p:txBody>
       </p:sp>
       <p:sp>
         <p:nvSpPr>
-          <p:cNvPr id="35" name="Text 32"/>
+          <p:cNvPr id="43" name="Shape 39"/>
+          <p:cNvSpPr/>
+          <p:nvPr/>
+        </p:nvSpPr>
+        <p:spPr>
+          <a:xfrm>
+            <a:off x="6245352" y="5047488"/>
+            <a:ext cx="5486400" cy="786384"/>
+          </a:xfrm>
+          <a:prstGeom prst="rect">
+            <a:avLst/>
+          </a:prstGeom>
+          <a:solidFill>
+            <a:srgbClr val="F2F2F2"/>
+          </a:solidFill>
+          <a:ln w="12700">
+            <a:solidFill>
+              <a:srgbClr val="F2F2F2"/>
+            </a:solidFill>
+            <a:prstDash val="solid"/>
+          </a:ln>
+        </p:spPr>
+      </p:sp>
+      <p:sp>
+        <p:nvSpPr>
+          <p:cNvPr id="44" name="Shape 40"/>
+          <p:cNvSpPr/>
+          <p:nvPr/>
+        </p:nvSpPr>
+        <p:spPr>
+          <a:xfrm>
+            <a:off x="6336792" y="5230368"/>
+            <a:ext cx="384048" cy="384048"/>
+          </a:xfrm>
+          <a:prstGeom prst="ellipse">
+            <a:avLst/>
+          </a:prstGeom>
+          <a:solidFill>
+            <a:srgbClr val="FFFFFF"/>
+          </a:solidFill>
+          <a:ln w="15875">
+            <a:solidFill>
+              <a:srgbClr val="2C5F82"/>
+            </a:solidFill>
+            <a:prstDash val="solid"/>
+          </a:ln>
+        </p:spPr>
+      </p:sp>
+      <p:sp>
+        <p:nvSpPr>
+          <p:cNvPr id="45" name="Text 41"/>
           <p:cNvSpPr txBox="1"/>
           <p:nvPr/>
         </p:nvSpPr>
         <p:spPr>
           <a:xfrm>
-            <a:off x="457200" y="5358384"/>
+            <a:off x="6336792" y="5230368"/>
+            <a:ext cx="384048" cy="384048"/>
+          </a:xfrm>
+          <a:prstGeom prst="rect">
+            <a:avLst/>
+          </a:prstGeom>
+          <a:noFill/>
+          <a:ln/>
+        </p:spPr>
+        <p:txBody>
+          <a:bodyPr wrap="square" lIns="0" tIns="0" rIns="0" bIns="0" rtlCol="0" anchor="ctr"/>
+          <a:lstStyle/>
+          <a:p>
+            <a:pPr algn="ctr" indent="0" marL="0">
+              <a:buNone/>
+            </a:pPr>
+            <a:r>
+              <a:rPr lang="en-US" sz="1300" b="1" i="1" dirty="0">
+                <a:solidFill>
+                  <a:srgbClr val="2C5F82"/>
+                </a:solidFill>
+                <a:latin typeface="Arial" pitchFamily="34" charset="0"/>
+                <a:ea typeface="Arial" pitchFamily="34" charset="-122"/>
+                <a:cs typeface="Arial" pitchFamily="34" charset="-120"/>
+              </a:rPr>
+              <a:t>3</a:t>
+            </a:r>
+            <a:endParaRPr lang="en-US" sz="1300" dirty="0"/>
+          </a:p>
+        </p:txBody>
+      </p:sp>
+      <p:sp>
+        <p:nvSpPr>
+          <p:cNvPr id="46" name="Text 42"/>
+          <p:cNvSpPr txBox="1"/>
+          <p:nvPr/>
+        </p:nvSpPr>
+        <p:spPr>
+          <a:xfrm>
+            <a:off x="6812280" y="5047488"/>
+            <a:ext cx="1005840" cy="786384"/>
+          </a:xfrm>
+          <a:prstGeom prst="rect">
+            <a:avLst/>
+          </a:prstGeom>
+          <a:noFill/>
+          <a:ln/>
+        </p:spPr>
+        <p:txBody>
+          <a:bodyPr wrap="square" lIns="0" tIns="0" rIns="0" bIns="0" rtlCol="0" anchor="ctr"/>
+          <a:lstStyle/>
+          <a:p>
+            <a:pPr algn="ctr" indent="0" marL="0">
+              <a:buNone/>
+            </a:pPr>
+            <a:r>
+              <a:rPr lang="en-US" sz="1900" b="1" dirty="0">
+                <a:solidFill>
+                  <a:srgbClr val="2C5F82"/>
+                </a:solidFill>
+                <a:latin typeface="Arial" pitchFamily="34" charset="0"/>
+                <a:ea typeface="Arial" pitchFamily="34" charset="-122"/>
+                <a:cs typeface="Arial" pitchFamily="34" charset="-120"/>
+              </a:rPr>
+              <a:t>82%</a:t>
+            </a:r>
+            <a:endParaRPr lang="en-US" sz="1900" dirty="0"/>
+          </a:p>
+        </p:txBody>
+      </p:sp>
+      <p:sp>
+        <p:nvSpPr>
+          <p:cNvPr id="47" name="Text 43"/>
+          <p:cNvSpPr txBox="1"/>
+          <p:nvPr/>
+        </p:nvSpPr>
+        <p:spPr>
+          <a:xfrm>
+            <a:off x="7891272" y="5102352"/>
+            <a:ext cx="3749040" cy="713232"/>
+          </a:xfrm>
+          <a:prstGeom prst="rect">
+            <a:avLst/>
+          </a:prstGeom>
+          <a:noFill/>
+          <a:ln/>
+        </p:spPr>
+        <p:txBody>
+          <a:bodyPr wrap="square" lIns="0" tIns="0" rIns="0" bIns="0" rtlCol="0" anchor="ctr"/>
+          <a:lstStyle/>
+          <a:p>
+            <a:pPr indent="0" marL="0">
+              <a:buNone/>
+            </a:pPr>
+            <a:r>
+              <a:rPr lang="en-US" sz="950" b="1" dirty="0">
+                <a:solidFill>
+                  <a:srgbClr val="262626"/>
+                </a:solidFill>
+                <a:latin typeface="Arial" pitchFamily="34" charset="0"/>
+                <a:ea typeface="Arial" pitchFamily="34" charset="-122"/>
+                <a:cs typeface="Arial" pitchFamily="34" charset="-120"/>
+              </a:rPr>
+              <a:t>The autocall only needs a recovery</a:t>
+            </a:r>
+            <a:endParaRPr lang="en-US" sz="950" dirty="0"/>
+          </a:p>
+          <a:p>
+            <a:pPr indent="0" marL="0">
+              <a:buNone/>
+            </a:pPr>
+            <a:r>
+              <a:rPr lang="en-US" sz="950" dirty="0">
+                <a:solidFill>
+                  <a:srgbClr val="595959"/>
+                </a:solidFill>
+                <a:latin typeface="Arial" pitchFamily="34" charset="0"/>
+                <a:ea typeface="Arial" pitchFamily="34" charset="-122"/>
+                <a:cs typeface="Arial" pitchFamily="34" charset="-120"/>
+              </a:rPr>
+              <a:t>Called in 82% of paths (51% at year 1); memory pays missed coupons later. Result: 6.75% p.a. and 0% capital loss.</a:t>
+            </a:r>
+            <a:endParaRPr lang="en-US" sz="950" dirty="0"/>
+          </a:p>
+        </p:txBody>
+      </p:sp>
+      <p:sp>
+        <p:nvSpPr>
+          <p:cNvPr id="48" name="Text 44"/>
+          <p:cNvSpPr txBox="1"/>
+          <p:nvPr/>
+        </p:nvSpPr>
+        <p:spPr>
+          <a:xfrm>
+            <a:off x="457200" y="5870448"/>
             <a:ext cx="11274552" cy="274320"/>
           </a:xfrm>
           <a:prstGeom prst="rect">
@@ -4699,73 +5674,9 @@
                 <a:ea typeface="Arial" pitchFamily="34" charset="-122"/>
                 <a:cs typeface="Arial" pitchFamily="34" charset="-120"/>
               </a:rPr>
-              <a:t>Sources: TWSE 2022 market highlights; Korea Times / Yonhap (KOSPI 2022); Bloomberg via BNN (SOX 2022); BIT Research (KOSPI 2026, verify on Bloomberg); Trading Economics (TSMC weight, Jul 2026); Nikkei Asia (Advantest weight cap); Nikkei index summary; Asset Management One via portfolio institutional (Japan buybacks); AllianceBernstein (Korea Value-Up Index).</a:t>
+              <a:t>Sources: TWSE, Korea Times, Bloomberg/BNN (2022); BIT Research (KOSPI 2026, single source); Trading Economics, Nikkei Asia (index weights); Asset Management One (buybacks); case funding grid; team Monte Carlo (pricing/scenario2_autocall_mc.py). Full list in appendix.</a:t>
             </a:r>
             <a:endParaRPr lang="en-US" sz="800" dirty="0"/>
-          </a:p>
-        </p:txBody>
-      </p:sp>
-      <p:sp>
-        <p:nvSpPr>
-          <p:cNvPr id="36" name="Shape 33"/>
-          <p:cNvSpPr/>
-          <p:nvPr/>
-        </p:nvSpPr>
-        <p:spPr>
-          <a:xfrm>
-            <a:off x="457200" y="5650992"/>
-            <a:ext cx="11274552" cy="502920"/>
-          </a:xfrm>
-          <a:prstGeom prst="rect">
-            <a:avLst/>
-          </a:prstGeom>
-          <a:solidFill>
-            <a:srgbClr val="2C5F82"/>
-          </a:solidFill>
-          <a:ln w="12700">
-            <a:solidFill>
-              <a:srgbClr val="2C5F82"/>
-            </a:solidFill>
-            <a:prstDash val="solid"/>
-          </a:ln>
-        </p:spPr>
-      </p:sp>
-      <p:sp>
-        <p:nvSpPr>
-          <p:cNvPr id="37" name="Text 34"/>
-          <p:cNvSpPr txBox="1"/>
-          <p:nvPr/>
-        </p:nvSpPr>
-        <p:spPr>
-          <a:xfrm>
-            <a:off x="594360" y="5650992"/>
-            <a:ext cx="11000232" cy="502920"/>
-          </a:xfrm>
-          <a:prstGeom prst="rect">
-            <a:avLst/>
-          </a:prstGeom>
-          <a:noFill/>
-          <a:ln/>
-        </p:spPr>
-        <p:txBody>
-          <a:bodyPr wrap="square" lIns="0" tIns="0" rIns="0" bIns="0" rtlCol="0" anchor="ctr"/>
-          <a:lstStyle/>
-          <a:p>
-            <a:pPr algn="ctr" indent="0" marL="0">
-              <a:buNone/>
-            </a:pPr>
-            <a:r>
-              <a:rPr lang="en-US" sz="1250" b="1" dirty="0">
-                <a:solidFill>
-                  <a:srgbClr val="FFFFFF"/>
-                </a:solidFill>
-                <a:latin typeface="Arial" pitchFamily="34" charset="0"/>
-                <a:ea typeface="Arial" pitchFamily="34" charset="-122"/>
-                <a:cs typeface="Arial" pitchFamily="34" charset="-120"/>
-              </a:rPr>
-              <a:t>Keep the AI exposure, hand the drawdown to Natixis: 100% capital protection, and a coupon that needs only a recovery to 100%.</a:t>
-            </a:r>
-            <a:endParaRPr lang="en-US" sz="1250" dirty="0"/>
           </a:p>
         </p:txBody>
       </p:sp>
@@ -4834,7 +5745,7 @@
                 <a:ea typeface="Arial" pitchFamily="34" charset="-122"/>
                 <a:cs typeface="Arial" pitchFamily="34" charset="-120"/>
               </a:rPr>
-              <a:t>Investment thesis 3: An autocallable beats the usual ways to own this theme</a:t>
+              <a:t>Thesis 2 evidence: the protected autocall beats the usual ways to own this theme</a:t>
             </a:r>
             <a:endParaRPr lang="en-US" sz="2400" dirty="0"/>
           </a:p>

</xml_diff>

<commit_message>
Thesis slides: add one-slide thesis 2 (traditional strategies fall short)
Four panels (rates make protection cheap, volatility demands protection,
autocall vs stocks and bond by market type, strategy summary table) plus an
implications column making the case for the protected autocall. An
alternative to the two-part thesis 2 plus evidence slide.

Co-Authored-By: Claude Opus 5.5 <noreply@anthropic.com>
Claude-Session: https://claude.ai/code/session_01Rwoh8cFDQqLD8JWT3mee6y
</commit_message>
<xml_diff>
--- a/deck/Investment-Thesis-Slides.pptx
+++ b/deck/Investment-Thesis-Slides.pptx
@@ -9,9 +9,10 @@
     <p:sldId id="257" r:id="rId3"/>
     <p:sldId id="258" r:id="rId4"/>
     <p:sldId id="259" r:id="rId5"/>
+    <p:sldId id="260" r:id="rId6"/>
   </p:sldIdLst>
   <p:notesMasterIdLst>
-    <p:notesMasterId r:id="rId6"/>
+    <p:notesMasterId r:id="rId7"/>
   </p:notesMasterIdLst>
   <p:sldSz cx="12192000" cy="6858000"/>
   <p:notesSz cx="6858000" cy="12192000"/>
@@ -1060,6 +1061,968 @@
   <c:date1904 val="0"/>
   <c:roundedCorners val="1"/>
   <c:chart>
+    <c:autoTitleDeleted val="1"/>
+    <c:plotArea>
+      <c:layout/>
+      <c:lineChart>
+        <c:varyColors val="0"/>
+        <c:ser>
+          <c:idx val="0"/>
+          <c:order val="0"/>
+          <c:tx>
+            <c:strRef>
+              <c:f>Sheet1!$B$1</c:f>
+              <c:strCache>
+                <c:ptCount val="1"/>
+                <c:pt idx="0">
+                  <c:v>USD funding</c:v>
+                </c:pt>
+              </c:strCache>
+            </c:strRef>
+          </c:tx>
+          <c:spPr>
+            <a:solidFill>
+              <a:srgbClr val="2C5F82"/>
+            </a:solidFill>
+            <a:ln w="25400" cap="flat">
+              <a:solidFill>
+                <a:srgbClr val="2C5F82"/>
+              </a:solidFill>
+              <a:prstDash val="solid"/>
+              <a:round/>
+            </a:ln>
+            <a:effectLst/>
+          </c:spPr>
+          <c:invertIfNegative val="0"/>
+          <c:dLbls>
+            <c:numFmt formatCode="#,##0" sourceLinked="0"/>
+            <c:txPr>
+              <a:bodyPr/>
+              <a:lstStyle/>
+              <a:p>
+                <a:pPr>
+                  <a:defRPr b="0" i="0" strike="noStrike" sz="1200" u="none">
+                    <a:solidFill>
+                      <a:srgbClr val="000000"/>
+                    </a:solidFill>
+                    <a:latin typeface="Arial"/>
+                  </a:defRPr>
+                </a:pPr>
+              </a:p>
+            </c:txPr>
+            <c:showLegendKey val="0"/>
+            <c:showVal val="0"/>
+            <c:showCatName val="0"/>
+            <c:showSerName val="0"/>
+            <c:showPercent val="0"/>
+            <c:showBubbleSize val="0"/>
+            <c:showLeaderLines val="0"/>
+          </c:dLbls>
+          <c:marker>
+            <c:symbol val="circle"/>
+            <c:size val="4"/>
+            <c:spPr>
+              <a:solidFill>
+                <a:srgbClr val="2C5F82"/>
+              </a:solidFill>
+              <a:ln w="9525" cap="flat">
+                <a:solidFill>
+                  <a:srgbClr val="2C5F82"/>
+                </a:solidFill>
+                <a:prstDash val="solid"/>
+                <a:round/>
+              </a:ln>
+              <a:effectLst/>
+            </c:spPr>
+          </c:marker>
+          <c:cat>
+            <c:multiLvlStrRef>
+              <c:f>Sheet1!$A$2:$A$8</c:f>
+              <c:multiLvlStrCache>
+                <c:ptCount val="7"/>
+                <c:lvl>
+                  <c:pt idx="0">
+                    <c:v>1Y</c:v>
+                  </c:pt>
+                  <c:pt idx="1">
+                    <c:v>2Y</c:v>
+                  </c:pt>
+                  <c:pt idx="2">
+                    <c:v>3Y</c:v>
+                  </c:pt>
+                  <c:pt idx="3">
+                    <c:v>5Y</c:v>
+                  </c:pt>
+                  <c:pt idx="4">
+                    <c:v>7Y</c:v>
+                  </c:pt>
+                  <c:pt idx="5">
+                    <c:v>10Y</c:v>
+                  </c:pt>
+                  <c:pt idx="6">
+                    <c:v>20Y</c:v>
+                  </c:pt>
+                </c:lvl>
+              </c:multiLvlStrCache>
+            </c:multiLvlStrRef>
+          </c:cat>
+          <c:val>
+            <c:numRef>
+              <c:f>Sheet1!$B$2:$B$8</c:f>
+              <c:numCache>
+                <c:formatCode>General</c:formatCode>
+                <c:ptCount val="7"/>
+                <c:pt idx="0">
+                  <c:v>4.78</c:v>
+                </c:pt>
+                <c:pt idx="1">
+                  <c:v>5.3</c:v>
+                </c:pt>
+                <c:pt idx="2">
+                  <c:v>5.52</c:v>
+                </c:pt>
+                <c:pt idx="3">
+                  <c:v>5.69</c:v>
+                </c:pt>
+                <c:pt idx="4">
+                  <c:v>5.75</c:v>
+                </c:pt>
+                <c:pt idx="5">
+                  <c:v>5.82</c:v>
+                </c:pt>
+                <c:pt idx="6">
+                  <c:v>6.04</c:v>
+                </c:pt>
+              </c:numCache>
+            </c:numRef>
+          </c:val>
+          <c:smooth val="0"/>
+        </c:ser>
+        <c:dLbls>
+          <c:numFmt formatCode="#,##0" sourceLinked="0"/>
+          <c:txPr>
+            <a:bodyPr/>
+            <a:lstStyle/>
+            <a:p>
+              <a:pPr>
+                <a:defRPr b="0" i="0" strike="noStrike" sz="1200" u="none">
+                  <a:solidFill>
+                    <a:srgbClr val="000000"/>
+                  </a:solidFill>
+                  <a:latin typeface="Arial"/>
+                </a:defRPr>
+              </a:pPr>
+            </a:p>
+          </c:txPr>
+          <c:showLegendKey val="0"/>
+          <c:showVal val="0"/>
+          <c:showCatName val="0"/>
+          <c:showSerName val="0"/>
+          <c:showPercent val="0"/>
+          <c:showBubbleSize val="0"/>
+          <c:showLeaderLines val="0"/>
+        </c:dLbls>
+        <c:marker val="1"/>
+        <c:axId val="2094734554"/>
+        <c:axId val="2094734552"/>
+        <c:axId val="2094734556"/>
+      </c:lineChart>
+      <c:catAx>
+        <c:axId val="2094734554"/>
+        <c:scaling>
+          <c:orientation val="minMax"/>
+        </c:scaling>
+        <c:delete val="0"/>
+        <c:axPos val="b"/>
+        <c:numFmt formatCode="General" sourceLinked="1"/>
+        <c:majorTickMark val="out"/>
+        <c:minorTickMark val="none"/>
+        <c:tickLblPos val="low"/>
+        <c:spPr>
+          <a:ln w="12700" cap="flat">
+            <a:solidFill>
+              <a:srgbClr val="BFBFBF"/>
+            </a:solidFill>
+            <a:prstDash val="solid"/>
+            <a:round/>
+          </a:ln>
+        </c:spPr>
+        <c:txPr>
+          <a:bodyPr/>
+          <a:lstStyle/>
+          <a:p>
+            <a:pPr>
+              <a:defRPr sz="800" b="0" i="0" u="none" strike="noStrike">
+                <a:solidFill>
+                  <a:srgbClr val="595959"/>
+                </a:solidFill>
+                <a:latin typeface="Arial"/>
+              </a:defRPr>
+            </a:pPr>
+            <a:endParaRPr lang="en-US"/>
+          </a:p>
+        </c:txPr>
+        <c:crossAx val="2094734552"/>
+        <c:crosses val="autoZero"/>
+        <c:auto val="1"/>
+        <c:lblAlgn val="ctr"/>
+        <c:noMultiLvlLbl val="1"/>
+      </c:catAx>
+      <c:valAx>
+        <c:axId val="2094734552"/>
+        <c:scaling>
+          <c:orientation val="minMax"/>
+          <c:max val="6.25"/>
+          <c:min val="4.5"/>
+        </c:scaling>
+        <c:delete val="0"/>
+        <c:axPos val="l"/>
+        <c:majorGridlines>
+          <c:spPr>
+            <a:ln w="6350" cap="flat">
+              <a:solidFill>
+                <a:srgbClr val="E3E3E3"/>
+              </a:solidFill>
+              <a:prstDash val="solid"/>
+              <a:round/>
+            </a:ln>
+          </c:spPr>
+        </c:majorGridlines>
+        <c:numFmt formatCode="0.0&quot;%&quot;" sourceLinked="0"/>
+        <c:majorTickMark val="out"/>
+        <c:minorTickMark val="none"/>
+        <c:tickLblPos val="nextTo"/>
+        <c:spPr>
+          <a:ln w="12700" cap="flat">
+            <a:solidFill>
+              <a:srgbClr val="888888"/>
+            </a:solidFill>
+            <a:prstDash val="solid"/>
+            <a:round/>
+          </a:ln>
+        </c:spPr>
+        <c:txPr>
+          <a:bodyPr/>
+          <a:lstStyle/>
+          <a:p>
+            <a:pPr>
+              <a:defRPr sz="800" b="0" i="0" u="none" strike="noStrike">
+                <a:solidFill>
+                  <a:srgbClr val="595959"/>
+                </a:solidFill>
+                <a:latin typeface="Arial"/>
+              </a:defRPr>
+            </a:pPr>
+            <a:endParaRPr lang="en-US"/>
+          </a:p>
+        </c:txPr>
+        <c:crossAx val="2094734554"/>
+        <c:crosses val="autoZero"/>
+        <c:crossBetween val="between"/>
+      </c:valAx>
+      <c:spPr>
+        <a:noFill/>
+        <a:ln>
+          <a:noFill/>
+        </a:ln>
+        <a:effectLst/>
+      </c:spPr>
+    </c:plotArea>
+    <c:plotVisOnly val="1"/>
+    <c:dispBlanksAs val="span"/>
+  </c:chart>
+  <c:spPr>
+    <a:noFill/>
+    <a:ln>
+      <a:noFill/>
+    </a:ln>
+    <a:effectLst/>
+  </c:spPr>
+  <c:externalData r:id="rId1">
+    <c:autoUpdate val="0"/>
+  </c:externalData>
+</c:chartSpace>
+</file>
+
+<file path=ppt/charts/chart5.xml><?xml version="1.0" encoding="utf-8"?>
+<c:chartSpace xmlns:c="http://schemas.openxmlformats.org/drawingml/2006/chart" xmlns:a="http://schemas.openxmlformats.org/drawingml/2006/main" xmlns:r="http://schemas.openxmlformats.org/officeDocument/2006/relationships">
+  <c:date1904 val="0"/>
+  <c:roundedCorners val="1"/>
+  <c:chart>
+    <c:autoTitleDeleted val="1"/>
+    <c:plotArea>
+      <c:layout/>
+      <c:barChart>
+        <c:barDir val="col"/>
+        <c:grouping val="clustered"/>
+        <c:varyColors val="0"/>
+        <c:ser>
+          <c:idx val="0"/>
+          <c:order val="0"/>
+          <c:tx>
+            <c:strRef>
+              <c:f>Sheet1!$B$1</c:f>
+              <c:strCache>
+                <c:ptCount val="1"/>
+                <c:pt idx="0">
+                  <c:v>2022</c:v>
+                </c:pt>
+              </c:strCache>
+            </c:strRef>
+          </c:tx>
+          <c:spPr>
+            <a:solidFill>
+              <a:srgbClr val="B23B3B"/>
+            </a:solidFill>
+            <a:effectLst/>
+          </c:spPr>
+          <c:invertIfNegative val="0"/>
+          <c:dLbls>
+            <c:numFmt formatCode="0&quot;%&quot;" sourceLinked="0"/>
+            <c:txPr>
+              <a:bodyPr/>
+              <a:lstStyle/>
+              <a:p>
+                <a:pPr>
+                  <a:defRPr b="0" i="0" strike="noStrike" sz="800" u="none">
+                    <a:solidFill>
+                      <a:srgbClr val="262626"/>
+                    </a:solidFill>
+                    <a:latin typeface="Arial"/>
+                  </a:defRPr>
+                </a:pPr>
+              </a:p>
+            </c:txPr>
+            <c:showLegendKey val="0"/>
+            <c:showVal val="1"/>
+            <c:showCatName val="0"/>
+            <c:showSerName val="0"/>
+            <c:showPercent val="0"/>
+            <c:showBubbleSize val="0"/>
+            <c:showLeaderLines val="0"/>
+          </c:dLbls>
+          <c:cat>
+            <c:multiLvlStrRef>
+              <c:f>Sheet1!$A$2:$A$4</c:f>
+              <c:multiLvlStrCache>
+                <c:ptCount val="3"/>
+                <c:lvl>
+                  <c:pt idx="0">
+                    <c:v>TAIEX</c:v>
+                  </c:pt>
+                  <c:pt idx="1">
+                    <c:v>KOSPI</c:v>
+                  </c:pt>
+                  <c:pt idx="2">
+                    <c:v>Global chip index</c:v>
+                  </c:pt>
+                </c:lvl>
+              </c:multiLvlStrCache>
+            </c:multiLvlStrRef>
+          </c:cat>
+          <c:val>
+            <c:numRef>
+              <c:f>Sheet1!$B$2:$B$4</c:f>
+              <c:numCache>
+                <c:formatCode>General</c:formatCode>
+                <c:ptCount val="3"/>
+                <c:pt idx="0">
+                  <c:v>-31.6</c:v>
+                </c:pt>
+                <c:pt idx="1">
+                  <c:v>-24.9</c:v>
+                </c:pt>
+                <c:pt idx="2">
+                  <c:v>-36</c:v>
+                </c:pt>
+              </c:numCache>
+            </c:numRef>
+          </c:val>
+        </c:ser>
+        <c:dLbls>
+          <c:numFmt formatCode="0&quot;%&quot;" sourceLinked="0"/>
+          <c:txPr>
+            <a:bodyPr/>
+            <a:lstStyle/>
+            <a:p>
+              <a:pPr>
+                <a:defRPr b="0" i="0" strike="noStrike" sz="800" u="none">
+                  <a:solidFill>
+                    <a:srgbClr val="262626"/>
+                  </a:solidFill>
+                  <a:latin typeface="Arial"/>
+                </a:defRPr>
+              </a:pPr>
+            </a:p>
+          </c:txPr>
+          <c:showLegendKey val="0"/>
+          <c:showVal val="1"/>
+          <c:showCatName val="0"/>
+          <c:showSerName val="0"/>
+          <c:showPercent val="0"/>
+          <c:showBubbleSize val="0"/>
+          <c:showLeaderLines val="0"/>
+        </c:dLbls>
+        <c:gapWidth val="150"/>
+        <c:overlap val="0"/>
+        <c:axId val="2094734554"/>
+        <c:axId val="2094734552"/>
+        <c:axId val="2094734556"/>
+      </c:barChart>
+      <c:catAx>
+        <c:axId val="2094734554"/>
+        <c:scaling>
+          <c:orientation val="minMax"/>
+        </c:scaling>
+        <c:delete val="0"/>
+        <c:axPos val="b"/>
+        <c:numFmt formatCode="General" sourceLinked="1"/>
+        <c:majorTickMark val="out"/>
+        <c:minorTickMark val="none"/>
+        <c:tickLblPos val="low"/>
+        <c:spPr>
+          <a:ln w="12700" cap="flat">
+            <a:solidFill>
+              <a:srgbClr val="BFBFBF"/>
+            </a:solidFill>
+            <a:prstDash val="solid"/>
+            <a:round/>
+          </a:ln>
+        </c:spPr>
+        <c:txPr>
+          <a:bodyPr/>
+          <a:lstStyle/>
+          <a:p>
+            <a:pPr>
+              <a:defRPr sz="800" b="0" i="0" u="none" strike="noStrike">
+                <a:solidFill>
+                  <a:srgbClr val="595959"/>
+                </a:solidFill>
+                <a:latin typeface="Arial"/>
+              </a:defRPr>
+            </a:pPr>
+            <a:endParaRPr lang="en-US"/>
+          </a:p>
+        </c:txPr>
+        <c:crossAx val="2094734552"/>
+        <c:crosses val="autoZero"/>
+        <c:auto val="1"/>
+        <c:lblAlgn val="ctr"/>
+        <c:noMultiLvlLbl val="1"/>
+      </c:catAx>
+      <c:valAx>
+        <c:axId val="2094734552"/>
+        <c:scaling>
+          <c:orientation val="minMax"/>
+          <c:max val="0"/>
+          <c:min val="-45"/>
+        </c:scaling>
+        <c:delete val="1"/>
+        <c:axPos val="l"/>
+        <c:numFmt formatCode="General" sourceLinked="0"/>
+        <c:majorTickMark val="out"/>
+        <c:minorTickMark val="none"/>
+        <c:tickLblPos val="nextTo"/>
+        <c:spPr>
+          <a:ln w="12700" cap="flat">
+            <a:solidFill>
+              <a:srgbClr val="888888"/>
+            </a:solidFill>
+            <a:prstDash val="solid"/>
+            <a:round/>
+          </a:ln>
+        </c:spPr>
+        <c:txPr>
+          <a:bodyPr/>
+          <a:lstStyle/>
+          <a:p>
+            <a:pPr>
+              <a:defRPr sz="900" b="0" i="0" u="none" strike="noStrike">
+                <a:solidFill>
+                  <a:srgbClr val="595959"/>
+                </a:solidFill>
+                <a:latin typeface="Arial"/>
+              </a:defRPr>
+            </a:pPr>
+            <a:endParaRPr lang="en-US"/>
+          </a:p>
+        </c:txPr>
+        <c:crossAx val="2094734554"/>
+        <c:crosses val="autoZero"/>
+        <c:crossBetween val="between"/>
+      </c:valAx>
+      <c:spPr>
+        <a:noFill/>
+        <a:ln>
+          <a:noFill/>
+        </a:ln>
+        <a:effectLst/>
+      </c:spPr>
+    </c:plotArea>
+    <c:plotVisOnly val="1"/>
+    <c:dispBlanksAs val="span"/>
+  </c:chart>
+  <c:spPr>
+    <a:noFill/>
+    <a:ln>
+      <a:noFill/>
+    </a:ln>
+    <a:effectLst/>
+  </c:spPr>
+  <c:externalData r:id="rId1">
+    <c:autoUpdate val="0"/>
+  </c:externalData>
+</c:chartSpace>
+</file>
+
+<file path=ppt/charts/chart6.xml><?xml version="1.0" encoding="utf-8"?>
+<c:chartSpace xmlns:c="http://schemas.openxmlformats.org/drawingml/2006/chart" xmlns:a="http://schemas.openxmlformats.org/drawingml/2006/main" xmlns:r="http://schemas.openxmlformats.org/officeDocument/2006/relationships">
+  <c:date1904 val="0"/>
+  <c:roundedCorners val="1"/>
+  <c:chart>
+    <c:autoTitleDeleted val="1"/>
+    <c:plotArea>
+      <c:layout/>
+      <c:barChart>
+        <c:barDir val="col"/>
+        <c:grouping val="clustered"/>
+        <c:varyColors val="0"/>
+        <c:ser>
+          <c:idx val="0"/>
+          <c:order val="0"/>
+          <c:tx>
+            <c:strRef>
+              <c:f>Sheet1!$B$1</c:f>
+              <c:strCache>
+                <c:ptCount val="1"/>
+                <c:pt idx="0">
+                  <c:v>Our autocall</c:v>
+                </c:pt>
+              </c:strCache>
+            </c:strRef>
+          </c:tx>
+          <c:spPr>
+            <a:solidFill>
+              <a:srgbClr val="2C5F82"/>
+            </a:solidFill>
+            <a:effectLst/>
+          </c:spPr>
+          <c:invertIfNegative val="0"/>
+          <c:dLbls>
+            <c:numFmt formatCode="0" sourceLinked="0"/>
+            <c:txPr>
+              <a:bodyPr/>
+              <a:lstStyle/>
+              <a:p>
+                <a:pPr>
+                  <a:defRPr b="0" i="0" strike="noStrike" sz="700" u="none">
+                    <a:solidFill>
+                      <a:srgbClr val="262626"/>
+                    </a:solidFill>
+                    <a:latin typeface="Arial"/>
+                  </a:defRPr>
+                </a:pPr>
+              </a:p>
+            </c:txPr>
+            <c:showLegendKey val="0"/>
+            <c:showVal val="1"/>
+            <c:showCatName val="0"/>
+            <c:showSerName val="0"/>
+            <c:showPercent val="0"/>
+            <c:showBubbleSize val="0"/>
+            <c:showLeaderLines val="0"/>
+          </c:dLbls>
+          <c:cat>
+            <c:multiLvlStrRef>
+              <c:f>Sheet1!$A$2:$A$5</c:f>
+              <c:multiLvlStrCache>
+                <c:ptCount val="4"/>
+                <c:lvl>
+                  <c:pt idx="0">
+                    <c:v>Bear</c:v>
+                  </c:pt>
+                  <c:pt idx="1">
+                    <c:v>Flat</c:v>
+                  </c:pt>
+                  <c:pt idx="2">
+                    <c:v>Moderate</c:v>
+                  </c:pt>
+                  <c:pt idx="3">
+                    <c:v>Bull</c:v>
+                  </c:pt>
+                </c:lvl>
+              </c:multiLvlStrCache>
+            </c:multiLvlStrRef>
+          </c:cat>
+          <c:val>
+            <c:numRef>
+              <c:f>Sheet1!$B$2:$B$5</c:f>
+              <c:numCache>
+                <c:formatCode>General</c:formatCode>
+                <c:ptCount val="4"/>
+                <c:pt idx="0">
+                  <c:v>3.7</c:v>
+                </c:pt>
+                <c:pt idx="1">
+                  <c:v>6.2</c:v>
+                </c:pt>
+                <c:pt idx="2">
+                  <c:v>6.8</c:v>
+                </c:pt>
+                <c:pt idx="3">
+                  <c:v>6.8</c:v>
+                </c:pt>
+              </c:numCache>
+            </c:numRef>
+          </c:val>
+        </c:ser>
+        <c:ser>
+          <c:idx val="1"/>
+          <c:order val="1"/>
+          <c:tx>
+            <c:strRef>
+              <c:f>Sheet1!$C$1</c:f>
+              <c:strCache>
+                <c:ptCount val="1"/>
+                <c:pt idx="0">
+                  <c:v>Hold the basket</c:v>
+                </c:pt>
+              </c:strCache>
+            </c:strRef>
+          </c:tx>
+          <c:spPr>
+            <a:solidFill>
+              <a:srgbClr val="A6A6A6"/>
+            </a:solidFill>
+            <a:effectLst/>
+          </c:spPr>
+          <c:invertIfNegative val="0"/>
+          <c:dLbls>
+            <c:numFmt formatCode="0" sourceLinked="0"/>
+            <c:txPr>
+              <a:bodyPr/>
+              <a:lstStyle/>
+              <a:p>
+                <a:pPr>
+                  <a:defRPr b="0" i="0" strike="noStrike" sz="700" u="none">
+                    <a:solidFill>
+                      <a:srgbClr val="262626"/>
+                    </a:solidFill>
+                    <a:latin typeface="Arial"/>
+                  </a:defRPr>
+                </a:pPr>
+              </a:p>
+            </c:txPr>
+            <c:showLegendKey val="0"/>
+            <c:showVal val="1"/>
+            <c:showCatName val="0"/>
+            <c:showSerName val="0"/>
+            <c:showPercent val="0"/>
+            <c:showBubbleSize val="0"/>
+            <c:showLeaderLines val="0"/>
+          </c:dLbls>
+          <c:cat>
+            <c:multiLvlStrRef>
+              <c:f>Sheet1!$A$2:$A$5</c:f>
+              <c:multiLvlStrCache>
+                <c:ptCount val="4"/>
+                <c:lvl>
+                  <c:pt idx="0">
+                    <c:v>Bear</c:v>
+                  </c:pt>
+                  <c:pt idx="1">
+                    <c:v>Flat</c:v>
+                  </c:pt>
+                  <c:pt idx="2">
+                    <c:v>Moderate</c:v>
+                  </c:pt>
+                  <c:pt idx="3">
+                    <c:v>Bull</c:v>
+                  </c:pt>
+                </c:lvl>
+              </c:multiLvlStrCache>
+            </c:multiLvlStrRef>
+          </c:cat>
+          <c:val>
+            <c:numRef>
+              <c:f>Sheet1!$C$2:$C$5</c:f>
+              <c:numCache>
+                <c:formatCode>General</c:formatCode>
+                <c:ptCount val="4"/>
+                <c:pt idx="0">
+                  <c:v>-6.4</c:v>
+                </c:pt>
+                <c:pt idx="1">
+                  <c:v>2</c:v>
+                </c:pt>
+                <c:pt idx="2">
+                  <c:v>6.8</c:v>
+                </c:pt>
+                <c:pt idx="3">
+                  <c:v>15.9</c:v>
+                </c:pt>
+              </c:numCache>
+            </c:numRef>
+          </c:val>
+        </c:ser>
+        <c:ser>
+          <c:idx val="2"/>
+          <c:order val="2"/>
+          <c:tx>
+            <c:strRef>
+              <c:f>Sheet1!$D$1</c:f>
+              <c:strCache>
+                <c:ptCount val="1"/>
+                <c:pt idx="0">
+                  <c:v>5Y bond</c:v>
+                </c:pt>
+              </c:strCache>
+            </c:strRef>
+          </c:tx>
+          <c:spPr>
+            <a:solidFill>
+              <a:srgbClr val="404040"/>
+            </a:solidFill>
+            <a:effectLst/>
+          </c:spPr>
+          <c:invertIfNegative val="0"/>
+          <c:dLbls>
+            <c:numFmt formatCode="0" sourceLinked="0"/>
+            <c:txPr>
+              <a:bodyPr/>
+              <a:lstStyle/>
+              <a:p>
+                <a:pPr>
+                  <a:defRPr b="0" i="0" strike="noStrike" sz="700" u="none">
+                    <a:solidFill>
+                      <a:srgbClr val="262626"/>
+                    </a:solidFill>
+                    <a:latin typeface="Arial"/>
+                  </a:defRPr>
+                </a:pPr>
+              </a:p>
+            </c:txPr>
+            <c:showLegendKey val="0"/>
+            <c:showVal val="1"/>
+            <c:showCatName val="0"/>
+            <c:showSerName val="0"/>
+            <c:showPercent val="0"/>
+            <c:showBubbleSize val="0"/>
+            <c:showLeaderLines val="0"/>
+          </c:dLbls>
+          <c:cat>
+            <c:multiLvlStrRef>
+              <c:f>Sheet1!$A$2:$A$5</c:f>
+              <c:multiLvlStrCache>
+                <c:ptCount val="4"/>
+                <c:lvl>
+                  <c:pt idx="0">
+                    <c:v>Bear</c:v>
+                  </c:pt>
+                  <c:pt idx="1">
+                    <c:v>Flat</c:v>
+                  </c:pt>
+                  <c:pt idx="2">
+                    <c:v>Moderate</c:v>
+                  </c:pt>
+                  <c:pt idx="3">
+                    <c:v>Bull</c:v>
+                  </c:pt>
+                </c:lvl>
+              </c:multiLvlStrCache>
+            </c:multiLvlStrRef>
+          </c:cat>
+          <c:val>
+            <c:numRef>
+              <c:f>Sheet1!$D$2:$D$5</c:f>
+              <c:numCache>
+                <c:formatCode>General</c:formatCode>
+                <c:ptCount val="4"/>
+                <c:pt idx="0">
+                  <c:v>5.7</c:v>
+                </c:pt>
+                <c:pt idx="1">
+                  <c:v>5.7</c:v>
+                </c:pt>
+                <c:pt idx="2">
+                  <c:v>5.7</c:v>
+                </c:pt>
+                <c:pt idx="3">
+                  <c:v>5.7</c:v>
+                </c:pt>
+              </c:numCache>
+            </c:numRef>
+          </c:val>
+        </c:ser>
+        <c:dLbls>
+          <c:numFmt formatCode="0" sourceLinked="0"/>
+          <c:txPr>
+            <a:bodyPr/>
+            <a:lstStyle/>
+            <a:p>
+              <a:pPr>
+                <a:defRPr b="0" i="0" strike="noStrike" sz="700" u="none">
+                  <a:solidFill>
+                    <a:srgbClr val="262626"/>
+                  </a:solidFill>
+                  <a:latin typeface="Arial"/>
+                </a:defRPr>
+              </a:pPr>
+            </a:p>
+          </c:txPr>
+          <c:showLegendKey val="0"/>
+          <c:showVal val="1"/>
+          <c:showCatName val="0"/>
+          <c:showSerName val="0"/>
+          <c:showPercent val="0"/>
+          <c:showBubbleSize val="0"/>
+          <c:showLeaderLines val="0"/>
+        </c:dLbls>
+        <c:gapWidth val="150"/>
+        <c:overlap val="0"/>
+        <c:axId val="2094734554"/>
+        <c:axId val="2094734552"/>
+        <c:axId val="2094734556"/>
+      </c:barChart>
+      <c:catAx>
+        <c:axId val="2094734554"/>
+        <c:scaling>
+          <c:orientation val="minMax"/>
+        </c:scaling>
+        <c:delete val="0"/>
+        <c:axPos val="b"/>
+        <c:numFmt formatCode="General" sourceLinked="1"/>
+        <c:majorTickMark val="out"/>
+        <c:minorTickMark val="none"/>
+        <c:tickLblPos val="low"/>
+        <c:spPr>
+          <a:ln w="12700" cap="flat">
+            <a:solidFill>
+              <a:srgbClr val="BFBFBF"/>
+            </a:solidFill>
+            <a:prstDash val="solid"/>
+            <a:round/>
+          </a:ln>
+        </c:spPr>
+        <c:txPr>
+          <a:bodyPr/>
+          <a:lstStyle/>
+          <a:p>
+            <a:pPr>
+              <a:defRPr sz="800" b="0" i="0" u="none" strike="noStrike">
+                <a:solidFill>
+                  <a:srgbClr val="595959"/>
+                </a:solidFill>
+                <a:latin typeface="Arial"/>
+              </a:defRPr>
+            </a:pPr>
+            <a:endParaRPr lang="en-US"/>
+          </a:p>
+        </c:txPr>
+        <c:crossAx val="2094734552"/>
+        <c:crosses val="autoZero"/>
+        <c:auto val="1"/>
+        <c:lblAlgn val="ctr"/>
+        <c:noMultiLvlLbl val="1"/>
+      </c:catAx>
+      <c:valAx>
+        <c:axId val="2094734552"/>
+        <c:scaling>
+          <c:orientation val="minMax"/>
+          <c:max val="20"/>
+          <c:min val="-10"/>
+        </c:scaling>
+        <c:delete val="0"/>
+        <c:axPos val="l"/>
+        <c:majorGridlines>
+          <c:spPr>
+            <a:ln w="6350" cap="flat">
+              <a:solidFill>
+                <a:srgbClr val="E3E3E3"/>
+              </a:solidFill>
+              <a:prstDash val="solid"/>
+              <a:round/>
+            </a:ln>
+          </c:spPr>
+        </c:majorGridlines>
+        <c:numFmt formatCode="0&quot;%&quot;" sourceLinked="0"/>
+        <c:majorTickMark val="out"/>
+        <c:minorTickMark val="none"/>
+        <c:tickLblPos val="nextTo"/>
+        <c:spPr>
+          <a:ln w="12700" cap="flat">
+            <a:solidFill>
+              <a:srgbClr val="888888"/>
+            </a:solidFill>
+            <a:prstDash val="solid"/>
+            <a:round/>
+          </a:ln>
+        </c:spPr>
+        <c:txPr>
+          <a:bodyPr/>
+          <a:lstStyle/>
+          <a:p>
+            <a:pPr>
+              <a:defRPr sz="800" b="0" i="0" u="none" strike="noStrike">
+                <a:solidFill>
+                  <a:srgbClr val="595959"/>
+                </a:solidFill>
+                <a:latin typeface="Arial"/>
+              </a:defRPr>
+            </a:pPr>
+            <a:endParaRPr lang="en-US"/>
+          </a:p>
+        </c:txPr>
+        <c:crossAx val="2094734554"/>
+        <c:crosses val="autoZero"/>
+        <c:crossBetween val="between"/>
+      </c:valAx>
+      <c:spPr>
+        <a:noFill/>
+        <a:ln>
+          <a:noFill/>
+        </a:ln>
+        <a:effectLst/>
+      </c:spPr>
+    </c:plotArea>
+    <c:legend>
+      <c:legendPos val="r"/>
+      <c:overlay val="0"/>
+      <c:txPr>
+        <a:bodyPr/>
+        <a:lstStyle/>
+        <a:p>
+          <a:pPr>
+            <a:defRPr sz="800">
+              <a:latin typeface="Arial"/>
+              <a:cs typeface="Arial"/>
+            </a:defRPr>
+          </a:pPr>
+          <a:endParaRPr lang="en-US"/>
+        </a:p>
+      </c:txPr>
+    </c:legend>
+    <c:plotVisOnly val="1"/>
+    <c:dispBlanksAs val="span"/>
+  </c:chart>
+  <c:spPr>
+    <a:noFill/>
+    <a:ln>
+      <a:noFill/>
+    </a:ln>
+    <a:effectLst/>
+  </c:spPr>
+  <c:externalData r:id="rId1">
+    <c:autoUpdate val="0"/>
+  </c:externalData>
+</c:chartSpace>
+</file>
+
+<file path=ppt/charts/chart7.xml><?xml version="1.0" encoding="utf-8"?>
+<c:chartSpace xmlns:c="http://schemas.openxmlformats.org/drawingml/2006/chart" xmlns:a="http://schemas.openxmlformats.org/drawingml/2006/main" xmlns:r="http://schemas.openxmlformats.org/officeDocument/2006/relationships">
+  <c:date1904 val="0"/>
+  <c:roundedCorners val="1"/>
+  <c:chart>
     <c:title>
       <c:tx>
         <c:rich>
@@ -2187,7 +3150,7 @@
           <a:p>
             <a:r>
               <a:rPr lang="en-US" dirty="0"/>
-              <a:t>Thesis 2 evidence. Same simulated paths for all four strategies. The note beats holding the basket in bear and flat markets, ties in moderate ones and lags only in bull markets. It beats the plain principal-protected note in every market except a bull market. Be upfront about the bond: a fixed 5.69% wins in bear markets and on average unless equities return ~8% a year, but a bond gives none of the AI exposure the family asked for.</a:t>
+              <a:t>One-slide version of thesis 2, modelled on the 'traditional strategies fall short' format. Four panels: rates (protection is cheap), volatility (protection is needed), the market-type comparison and the summary table (the autocall beats the alternatives). Implications on the right make the case for the autocall. Use this instead of the two-part thesis 2 plus evidence slide if you need to save a slide.</a:t>
             </a:r>
             <a:endParaRPr lang="en-US" dirty="0"/>
           </a:p>
@@ -2275,7 +3238,7 @@
           <a:p>
             <a:r>
               <a:rPr lang="en-US" dirty="0"/>
-              <a:t/>
+              <a:t>Thesis 2 evidence. Same simulated paths for all four strategies. The note beats holding the basket in bear and flat markets, ties in moderate ones and lags only in bull markets. It beats the plain principal-protected note in every market except a bull market. Be upfront about the bond: a fixed 5.69% wins in bear markets and on average unless equities return ~8% a year, but a bond gives none of the AI exposure the family asked for.</a:t>
             </a:r>
             <a:endParaRPr lang="en-US" dirty="0"/>
           </a:p>
@@ -2299,6 +3262,94 @@
             <a:fld id="{F7021451-1387-4CA6-816F-3879F97B5CBC}" type="slidenum">
               <a:rPr lang="en-US"/>
               <a:t>4</a:t>
+            </a:fld>
+            <a:endParaRPr lang="en-US"/>
+          </a:p>
+        </p:txBody>
+      </p:sp>
+    </p:spTree>
+    <p:extLst>
+      <p:ext uri="{BB962C8B-B14F-4D97-AF65-F5344CB8AC3E}">
+        <p14:creationId xmlns:p14="http://schemas.microsoft.com/office/powerpoint/2010/main" val="1024086991"/>
+      </p:ext>
+    </p:extLst>
+  </p:cSld>
+  <p:clrMapOvr>
+    <a:masterClrMapping/>
+  </p:clrMapOvr>
+</p:notes>
+</file>
+
+<file path=ppt/notesSlides/notesSlide5.xml><?xml version="1.0" encoding="utf-8"?>
+<p:notes xmlns:a="http://schemas.openxmlformats.org/drawingml/2006/main" xmlns:r="http://schemas.openxmlformats.org/officeDocument/2006/relationships" xmlns:p="http://schemas.openxmlformats.org/presentationml/2006/main">
+  <p:cSld>
+    <p:spTree>
+      <p:nvGrpSpPr>
+        <p:cNvPr id="1" name=""/>
+        <p:cNvGrpSpPr/>
+        <p:nvPr/>
+      </p:nvGrpSpPr>
+      <p:grpSpPr>
+        <a:xfrm>
+          <a:off x="0" y="0"/>
+          <a:ext cx="0" cy="0"/>
+          <a:chOff x="0" y="0"/>
+          <a:chExt cx="0" cy="0"/>
+        </a:xfrm>
+      </p:grpSpPr>
+      <p:sp>
+        <p:nvSpPr>
+          <p:cNvPr id="2" name="Slide Image Placeholder 1"/>
+          <p:cNvSpPr>
+            <a:spLocks noGrp="1" noRot="1" noChangeAspect="1"/>
+          </p:cNvSpPr>
+          <p:nvPr>
+            <p:ph type="sldImg"/>
+          </p:nvPr>
+        </p:nvSpPr>
+        <p:spPr/>
+      </p:sp>
+      <p:sp>
+        <p:nvSpPr>
+          <p:cNvPr id="3" name="Notes Placeholder 2"/>
+          <p:cNvSpPr>
+            <a:spLocks noGrp="1"/>
+          </p:cNvSpPr>
+          <p:nvPr>
+            <p:ph type="body" idx="1"/>
+          </p:nvPr>
+        </p:nvSpPr>
+        <p:spPr/>
+        <p:txBody>
+          <a:bodyPr/>
+          <a:lstStyle/>
+          <a:p>
+            <a:r>
+              <a:rPr lang="en-US" dirty="0"/>
+              <a:t/>
+            </a:r>
+            <a:endParaRPr lang="en-US" dirty="0"/>
+          </a:p>
+        </p:txBody>
+      </p:sp>
+      <p:sp>
+        <p:nvSpPr>
+          <p:cNvPr id="4" name="Slide Number Placeholder 3"/>
+          <p:cNvSpPr>
+            <a:spLocks noGrp="1"/>
+          </p:cNvSpPr>
+          <p:nvPr>
+            <p:ph type="sldNum" sz="quarter" idx="10"/>
+          </p:nvPr>
+        </p:nvSpPr>
+        <p:spPr/>
+        <p:txBody>
+          <a:bodyPr/>
+          <a:lstStyle/>
+          <a:p>
+            <a:fld id="{F7021451-1387-4CA6-816F-3879F97B5CBC}" type="slidenum">
+              <a:rPr lang="en-US"/>
+              <a:t>5</a:t>
             </a:fld>
             <a:endParaRPr lang="en-US"/>
           </a:p>
@@ -5745,6 +6796,2916 @@
                 <a:ea typeface="Arial" pitchFamily="34" charset="-122"/>
                 <a:cs typeface="Arial" pitchFamily="34" charset="-120"/>
               </a:rPr>
+              <a:t>Investment thesis 2: Traditional strategies fall short; a protected autocall fits 2026</a:t>
+            </a:r>
+            <a:endParaRPr lang="en-US" sz="2400" dirty="0"/>
+          </a:p>
+        </p:txBody>
+      </p:sp>
+      <p:sp>
+        <p:nvSpPr>
+          <p:cNvPr id="3" name="Shape 1"/>
+          <p:cNvSpPr/>
+          <p:nvPr/>
+        </p:nvSpPr>
+        <p:spPr>
+          <a:xfrm>
+            <a:off x="457200" y="896112"/>
+            <a:ext cx="11274552" cy="0"/>
+          </a:xfrm>
+          <a:prstGeom prst="line">
+            <a:avLst/>
+          </a:prstGeom>
+          <a:noFill/>
+          <a:ln w="12700">
+            <a:solidFill>
+              <a:srgbClr val="2C5F82"/>
+            </a:solidFill>
+            <a:prstDash val="solid"/>
+          </a:ln>
+        </p:spPr>
+      </p:sp>
+      <p:sp>
+        <p:nvSpPr>
+          <p:cNvPr id="4" name="Shape 2"/>
+          <p:cNvSpPr/>
+          <p:nvPr/>
+        </p:nvSpPr>
+        <p:spPr>
+          <a:xfrm>
+            <a:off x="457200" y="6382512"/>
+            <a:ext cx="11274552" cy="0"/>
+          </a:xfrm>
+          <a:prstGeom prst="line">
+            <a:avLst/>
+          </a:prstGeom>
+          <a:noFill/>
+          <a:ln w="9525">
+            <a:solidFill>
+              <a:srgbClr val="BFBFBF"/>
+            </a:solidFill>
+            <a:prstDash val="solid"/>
+          </a:ln>
+        </p:spPr>
+      </p:sp>
+      <p:sp>
+        <p:nvSpPr>
+          <p:cNvPr id="5" name="Shape 3"/>
+          <p:cNvSpPr/>
+          <p:nvPr/>
+        </p:nvSpPr>
+        <p:spPr>
+          <a:xfrm>
+            <a:off x="1005840" y="6364224"/>
+            <a:ext cx="2514600" cy="45720"/>
+          </a:xfrm>
+          <a:prstGeom prst="rect">
+            <a:avLst/>
+          </a:prstGeom>
+          <a:solidFill>
+            <a:srgbClr val="2C5F82"/>
+          </a:solidFill>
+          <a:ln w="12700">
+            <a:solidFill>
+              <a:srgbClr val="2C5F82"/>
+            </a:solidFill>
+            <a:prstDash val="solid"/>
+          </a:ln>
+        </p:spPr>
+      </p:sp>
+      <p:sp>
+        <p:nvSpPr>
+          <p:cNvPr id="6" name="Text 4"/>
+          <p:cNvSpPr txBox="1"/>
+          <p:nvPr/>
+        </p:nvSpPr>
+        <p:spPr>
+          <a:xfrm>
+            <a:off x="457200" y="6446520"/>
+            <a:ext cx="3611880" cy="274320"/>
+          </a:xfrm>
+          <a:prstGeom prst="rect">
+            <a:avLst/>
+          </a:prstGeom>
+          <a:noFill/>
+          <a:ln/>
+        </p:spPr>
+        <p:txBody>
+          <a:bodyPr wrap="square" lIns="0" tIns="0" rIns="0" bIns="0" rtlCol="0" anchor="t"/>
+          <a:lstStyle/>
+          <a:p>
+            <a:pPr algn="ctr" indent="0" marL="0">
+              <a:buNone/>
+            </a:pPr>
+            <a:r>
+              <a:rPr lang="en-US" sz="1200" b="1" spc="100" kern="0" dirty="0">
+                <a:solidFill>
+                  <a:srgbClr val="2C5F82"/>
+                </a:solidFill>
+                <a:latin typeface="Arial" pitchFamily="34" charset="0"/>
+                <a:ea typeface="Arial" pitchFamily="34" charset="-122"/>
+                <a:cs typeface="Arial" pitchFamily="34" charset="-120"/>
+              </a:rPr>
+              <a:t>ANALYSIS</a:t>
+            </a:r>
+            <a:endParaRPr lang="en-US" sz="1200" dirty="0"/>
+          </a:p>
+        </p:txBody>
+      </p:sp>
+      <p:sp>
+        <p:nvSpPr>
+          <p:cNvPr id="7" name="Text 5"/>
+          <p:cNvSpPr txBox="1"/>
+          <p:nvPr/>
+        </p:nvSpPr>
+        <p:spPr>
+          <a:xfrm>
+            <a:off x="4288536" y="6446520"/>
+            <a:ext cx="3611880" cy="274320"/>
+          </a:xfrm>
+          <a:prstGeom prst="rect">
+            <a:avLst/>
+          </a:prstGeom>
+          <a:noFill/>
+          <a:ln/>
+        </p:spPr>
+        <p:txBody>
+          <a:bodyPr wrap="square" lIns="0" tIns="0" rIns="0" bIns="0" rtlCol="0" anchor="t"/>
+          <a:lstStyle/>
+          <a:p>
+            <a:pPr algn="ctr" indent="0" marL="0">
+              <a:buNone/>
+            </a:pPr>
+            <a:r>
+              <a:rPr lang="en-US" sz="1200" spc="100" kern="0" dirty="0">
+                <a:solidFill>
+                  <a:srgbClr val="595959"/>
+                </a:solidFill>
+                <a:latin typeface="Arial" pitchFamily="34" charset="0"/>
+                <a:ea typeface="Arial" pitchFamily="34" charset="-122"/>
+                <a:cs typeface="Arial" pitchFamily="34" charset="-120"/>
+              </a:rPr>
+              <a:t>STRATEGY</a:t>
+            </a:r>
+            <a:endParaRPr lang="en-US" sz="1200" dirty="0"/>
+          </a:p>
+        </p:txBody>
+      </p:sp>
+      <p:sp>
+        <p:nvSpPr>
+          <p:cNvPr id="8" name="Text 6"/>
+          <p:cNvSpPr txBox="1"/>
+          <p:nvPr/>
+        </p:nvSpPr>
+        <p:spPr>
+          <a:xfrm>
+            <a:off x="8129016" y="6446520"/>
+            <a:ext cx="3611880" cy="274320"/>
+          </a:xfrm>
+          <a:prstGeom prst="rect">
+            <a:avLst/>
+          </a:prstGeom>
+          <a:noFill/>
+          <a:ln/>
+        </p:spPr>
+        <p:txBody>
+          <a:bodyPr wrap="square" lIns="0" tIns="0" rIns="0" bIns="0" rtlCol="0" anchor="t"/>
+          <a:lstStyle/>
+          <a:p>
+            <a:pPr algn="ctr" indent="0" marL="0">
+              <a:buNone/>
+            </a:pPr>
+            <a:r>
+              <a:rPr lang="en-US" sz="1200" spc="100" kern="0" dirty="0">
+                <a:solidFill>
+                  <a:srgbClr val="595959"/>
+                </a:solidFill>
+                <a:latin typeface="Arial" pitchFamily="34" charset="0"/>
+                <a:ea typeface="Arial" pitchFamily="34" charset="-122"/>
+                <a:cs typeface="Arial" pitchFamily="34" charset="-120"/>
+              </a:rPr>
+              <a:t>APPENDIX</a:t>
+            </a:r>
+            <a:endParaRPr lang="en-US" sz="1200" dirty="0"/>
+          </a:p>
+        </p:txBody>
+      </p:sp>
+      <p:sp>
+        <p:nvSpPr>
+          <p:cNvPr id="9" name="Text 7"/>
+          <p:cNvSpPr txBox="1"/>
+          <p:nvPr/>
+        </p:nvSpPr>
+        <p:spPr>
+          <a:xfrm>
+            <a:off x="457200" y="960120"/>
+            <a:ext cx="11247120" cy="274320"/>
+          </a:xfrm>
+          <a:prstGeom prst="rect">
+            <a:avLst/>
+          </a:prstGeom>
+          <a:noFill/>
+          <a:ln/>
+        </p:spPr>
+        <p:txBody>
+          <a:bodyPr wrap="square" lIns="0" tIns="0" rIns="0" bIns="0" rtlCol="0" anchor="t"/>
+          <a:lstStyle/>
+          <a:p>
+            <a:pPr indent="0" marL="0">
+              <a:buNone/>
+            </a:pPr>
+            <a:r>
+              <a:rPr lang="en-US" sz="1150" b="1" i="1" dirty="0">
+                <a:solidFill>
+                  <a:srgbClr val="262626"/>
+                </a:solidFill>
+                <a:latin typeface="Arial" pitchFamily="34" charset="0"/>
+                <a:ea typeface="Arial" pitchFamily="34" charset="-122"/>
+                <a:cs typeface="Arial" pitchFamily="34" charset="-120"/>
+              </a:rPr>
+              <a:t>A volatile chip boom plus high USD rates: the conditions where an autocall beats bonds, stocks and plain protected notes</a:t>
+            </a:r>
+            <a:endParaRPr lang="en-US" sz="1150" dirty="0"/>
+          </a:p>
+        </p:txBody>
+      </p:sp>
+      <p:sp>
+        <p:nvSpPr>
+          <p:cNvPr id="10" name="Shape 8"/>
+          <p:cNvSpPr/>
+          <p:nvPr/>
+        </p:nvSpPr>
+        <p:spPr>
+          <a:xfrm>
+            <a:off x="457200" y="1325880"/>
+            <a:ext cx="3730752" cy="292608"/>
+          </a:xfrm>
+          <a:prstGeom prst="rect">
+            <a:avLst/>
+          </a:prstGeom>
+          <a:solidFill>
+            <a:srgbClr val="2C5F82"/>
+          </a:solidFill>
+          <a:ln w="12700">
+            <a:solidFill>
+              <a:srgbClr val="2C5F82"/>
+            </a:solidFill>
+            <a:prstDash val="solid"/>
+          </a:ln>
+        </p:spPr>
+      </p:sp>
+      <p:sp>
+        <p:nvSpPr>
+          <p:cNvPr id="11" name="Text 9"/>
+          <p:cNvSpPr txBox="1"/>
+          <p:nvPr/>
+        </p:nvSpPr>
+        <p:spPr>
+          <a:xfrm>
+            <a:off x="457200" y="1325880"/>
+            <a:ext cx="3730752" cy="292608"/>
+          </a:xfrm>
+          <a:prstGeom prst="rect">
+            <a:avLst/>
+          </a:prstGeom>
+          <a:noFill/>
+          <a:ln/>
+        </p:spPr>
+        <p:txBody>
+          <a:bodyPr wrap="square" lIns="0" tIns="0" rIns="0" bIns="0" rtlCol="0" anchor="ctr"/>
+          <a:lstStyle/>
+          <a:p>
+            <a:pPr algn="ctr" indent="0" marL="0">
+              <a:buNone/>
+            </a:pPr>
+            <a:r>
+              <a:rPr lang="en-US" sz="1050" b="1" dirty="0">
+                <a:solidFill>
+                  <a:srgbClr val="FFFFFF"/>
+                </a:solidFill>
+                <a:latin typeface="Arial" pitchFamily="34" charset="0"/>
+                <a:ea typeface="Arial" pitchFamily="34" charset="-122"/>
+                <a:cs typeface="Arial" pitchFamily="34" charset="-120"/>
+              </a:rPr>
+              <a:t>High USD rates make protection cheap</a:t>
+            </a:r>
+            <a:endParaRPr lang="en-US" sz="1050" dirty="0"/>
+          </a:p>
+        </p:txBody>
+      </p:sp>
+      <p:graphicFrame>
+        <p:nvGraphicFramePr>
+          <p:cNvPr id="12" name="Chart 0" descr=""/>
+          <p:cNvGraphicFramePr/>
+          <p:nvPr/>
+        </p:nvGraphicFramePr>
+        <p:xfrm>
+          <a:off x="457200" y="1655064"/>
+          <a:ext cx="3730752" cy="1261872"/>
+        </p:xfrm>
+        <a:graphic xmlns:a="http://schemas.openxmlformats.org/drawingml/2006/main">
+          <a:graphicData uri="http://schemas.openxmlformats.org/drawingml/2006/chart">
+            <c:chart xmlns:c="http://schemas.openxmlformats.org/drawingml/2006/chart" r:id="rId1"/>
+          </a:graphicData>
+        </a:graphic>
+      </p:graphicFrame>
+      <p:sp>
+        <p:nvSpPr>
+          <p:cNvPr id="13" name="Text 10"/>
+          <p:cNvSpPr txBox="1"/>
+          <p:nvPr/>
+        </p:nvSpPr>
+        <p:spPr>
+          <a:xfrm>
+            <a:off x="457200" y="2953512"/>
+            <a:ext cx="3730752" cy="365760"/>
+          </a:xfrm>
+          <a:prstGeom prst="rect">
+            <a:avLst/>
+          </a:prstGeom>
+          <a:noFill/>
+          <a:ln/>
+        </p:spPr>
+        <p:txBody>
+          <a:bodyPr wrap="square" lIns="0" tIns="0" rIns="0" bIns="0" rtlCol="0" anchor="t"/>
+          <a:lstStyle/>
+          <a:p>
+            <a:pPr indent="0" marL="0">
+              <a:buNone/>
+            </a:pPr>
+            <a:r>
+              <a:rPr lang="en-US" sz="850" dirty="0">
+                <a:solidFill>
+                  <a:srgbClr val="595959"/>
+                </a:solidFill>
+                <a:latin typeface="Arial" pitchFamily="34" charset="0"/>
+                <a:ea typeface="Arial" pitchFamily="34" charset="-122"/>
+                <a:cs typeface="Arial" pitchFamily="34" charset="-120"/>
+              </a:rPr>
+              <a:t>Case funding grid: 5Y at 5.69%, so USD 100 repaid at year 5 costs only USD 75.8 today. If rates fall, protection gets dearer.</a:t>
+            </a:r>
+            <a:endParaRPr lang="en-US" sz="850" dirty="0"/>
+          </a:p>
+        </p:txBody>
+      </p:sp>
+      <p:sp>
+        <p:nvSpPr>
+          <p:cNvPr id="14" name="Shape 11"/>
+          <p:cNvSpPr/>
+          <p:nvPr/>
+        </p:nvSpPr>
+        <p:spPr>
+          <a:xfrm>
+            <a:off x="4370832" y="1325880"/>
+            <a:ext cx="3730752" cy="292608"/>
+          </a:xfrm>
+          <a:prstGeom prst="rect">
+            <a:avLst/>
+          </a:prstGeom>
+          <a:solidFill>
+            <a:srgbClr val="2C5F82"/>
+          </a:solidFill>
+          <a:ln w="12700">
+            <a:solidFill>
+              <a:srgbClr val="2C5F82"/>
+            </a:solidFill>
+            <a:prstDash val="solid"/>
+          </a:ln>
+        </p:spPr>
+      </p:sp>
+      <p:sp>
+        <p:nvSpPr>
+          <p:cNvPr id="15" name="Text 12"/>
+          <p:cNvSpPr txBox="1"/>
+          <p:nvPr/>
+        </p:nvSpPr>
+        <p:spPr>
+          <a:xfrm>
+            <a:off x="4370832" y="1325880"/>
+            <a:ext cx="3730752" cy="292608"/>
+          </a:xfrm>
+          <a:prstGeom prst="rect">
+            <a:avLst/>
+          </a:prstGeom>
+          <a:noFill/>
+          <a:ln/>
+        </p:spPr>
+        <p:txBody>
+          <a:bodyPr wrap="square" lIns="0" tIns="0" rIns="0" bIns="0" rtlCol="0" anchor="ctr"/>
+          <a:lstStyle/>
+          <a:p>
+            <a:pPr algn="ctr" indent="0" marL="0">
+              <a:buNone/>
+            </a:pPr>
+            <a:r>
+              <a:rPr lang="en-US" sz="1050" b="1" dirty="0">
+                <a:solidFill>
+                  <a:srgbClr val="FFFFFF"/>
+                </a:solidFill>
+                <a:latin typeface="Arial" pitchFamily="34" charset="0"/>
+                <a:ea typeface="Arial" pitchFamily="34" charset="-122"/>
+                <a:cs typeface="Arial" pitchFamily="34" charset="-120"/>
+              </a:rPr>
+              <a:t>Volatility demands protection</a:t>
+            </a:r>
+            <a:endParaRPr lang="en-US" sz="1050" dirty="0"/>
+          </a:p>
+        </p:txBody>
+      </p:sp>
+      <p:graphicFrame>
+        <p:nvGraphicFramePr>
+          <p:cNvPr id="16" name="Chart 1" descr=""/>
+          <p:cNvGraphicFramePr/>
+          <p:nvPr/>
+        </p:nvGraphicFramePr>
+        <p:xfrm>
+          <a:off x="4370832" y="1655064"/>
+          <a:ext cx="3730752" cy="1261872"/>
+        </p:xfrm>
+        <a:graphic xmlns:a="http://schemas.openxmlformats.org/drawingml/2006/main">
+          <a:graphicData uri="http://schemas.openxmlformats.org/drawingml/2006/chart">
+            <c:chart xmlns:c="http://schemas.openxmlformats.org/drawingml/2006/chart" r:id="rId2"/>
+          </a:graphicData>
+        </a:graphic>
+      </p:graphicFrame>
+      <p:sp>
+        <p:nvSpPr>
+          <p:cNvPr id="17" name="Text 13"/>
+          <p:cNvSpPr txBox="1"/>
+          <p:nvPr/>
+        </p:nvSpPr>
+        <p:spPr>
+          <a:xfrm>
+            <a:off x="4370832" y="2953512"/>
+            <a:ext cx="3730752" cy="365760"/>
+          </a:xfrm>
+          <a:prstGeom prst="rect">
+            <a:avLst/>
+          </a:prstGeom>
+          <a:noFill/>
+          <a:ln/>
+        </p:spPr>
+        <p:txBody>
+          <a:bodyPr wrap="square" lIns="0" tIns="0" rIns="0" bIns="0" rtlCol="0" anchor="t"/>
+          <a:lstStyle/>
+          <a:p>
+            <a:pPr indent="0" marL="0">
+              <a:buNone/>
+            </a:pPr>
+            <a:r>
+              <a:rPr lang="en-US" sz="850" dirty="0">
+                <a:solidFill>
+                  <a:srgbClr val="595959"/>
+                </a:solidFill>
+                <a:latin typeface="Arial" pitchFamily="34" charset="0"/>
+                <a:ea typeface="Arial" pitchFamily="34" charset="-122"/>
+                <a:cs typeface="Arial" pitchFamily="34" charset="-120"/>
+              </a:rPr>
+              <a:t>2022 down-cycle: chip markets fell 25–36% in a year. In 2026 KOSPI roughly doubled, then had two violent one-day crashes (verify).</a:t>
+            </a:r>
+            <a:endParaRPr lang="en-US" sz="850" dirty="0"/>
+          </a:p>
+        </p:txBody>
+      </p:sp>
+      <p:sp>
+        <p:nvSpPr>
+          <p:cNvPr id="18" name="Shape 14"/>
+          <p:cNvSpPr/>
+          <p:nvPr/>
+        </p:nvSpPr>
+        <p:spPr>
+          <a:xfrm>
+            <a:off x="457200" y="3383280"/>
+            <a:ext cx="3730752" cy="292608"/>
+          </a:xfrm>
+          <a:prstGeom prst="rect">
+            <a:avLst/>
+          </a:prstGeom>
+          <a:solidFill>
+            <a:srgbClr val="2C5F82"/>
+          </a:solidFill>
+          <a:ln w="12700">
+            <a:solidFill>
+              <a:srgbClr val="2C5F82"/>
+            </a:solidFill>
+            <a:prstDash val="solid"/>
+          </a:ln>
+        </p:spPr>
+      </p:sp>
+      <p:sp>
+        <p:nvSpPr>
+          <p:cNvPr id="19" name="Text 15"/>
+          <p:cNvSpPr txBox="1"/>
+          <p:nvPr/>
+        </p:nvSpPr>
+        <p:spPr>
+          <a:xfrm>
+            <a:off x="457200" y="3383280"/>
+            <a:ext cx="3730752" cy="292608"/>
+          </a:xfrm>
+          <a:prstGeom prst="rect">
+            <a:avLst/>
+          </a:prstGeom>
+          <a:noFill/>
+          <a:ln/>
+        </p:spPr>
+        <p:txBody>
+          <a:bodyPr wrap="square" lIns="0" tIns="0" rIns="0" bIns="0" rtlCol="0" anchor="ctr"/>
+          <a:lstStyle/>
+          <a:p>
+            <a:pPr algn="ctr" indent="0" marL="0">
+              <a:buNone/>
+            </a:pPr>
+            <a:r>
+              <a:rPr lang="en-US" sz="1050" b="1" dirty="0">
+                <a:solidFill>
+                  <a:srgbClr val="FFFFFF"/>
+                </a:solidFill>
+                <a:latin typeface="Arial" pitchFamily="34" charset="0"/>
+                <a:ea typeface="Arial" pitchFamily="34" charset="-122"/>
+                <a:cs typeface="Arial" pitchFamily="34" charset="-120"/>
+              </a:rPr>
+              <a:t>The autocall wins in most markets</a:t>
+            </a:r>
+            <a:endParaRPr lang="en-US" sz="1050" dirty="0"/>
+          </a:p>
+        </p:txBody>
+      </p:sp>
+      <p:graphicFrame>
+        <p:nvGraphicFramePr>
+          <p:cNvPr id="20" name="Chart 2" descr=""/>
+          <p:cNvGraphicFramePr/>
+          <p:nvPr/>
+        </p:nvGraphicFramePr>
+        <p:xfrm>
+          <a:off x="457200" y="3712464"/>
+          <a:ext cx="3730752" cy="1261872"/>
+        </p:xfrm>
+        <a:graphic xmlns:a="http://schemas.openxmlformats.org/drawingml/2006/main">
+          <a:graphicData uri="http://schemas.openxmlformats.org/drawingml/2006/chart">
+            <c:chart xmlns:c="http://schemas.openxmlformats.org/drawingml/2006/chart" r:id="rId3"/>
+          </a:graphicData>
+        </a:graphic>
+      </p:graphicFrame>
+      <p:sp>
+        <p:nvSpPr>
+          <p:cNvPr id="21" name="Text 16"/>
+          <p:cNvSpPr txBox="1"/>
+          <p:nvPr/>
+        </p:nvSpPr>
+        <p:spPr>
+          <a:xfrm>
+            <a:off x="457200" y="5010912"/>
+            <a:ext cx="3730752" cy="365760"/>
+          </a:xfrm>
+          <a:prstGeom prst="rect">
+            <a:avLst/>
+          </a:prstGeom>
+          <a:noFill/>
+          <a:ln/>
+        </p:spPr>
+        <p:txBody>
+          <a:bodyPr wrap="square" lIns="0" tIns="0" rIns="0" bIns="0" rtlCol="0" anchor="t"/>
+          <a:lstStyle/>
+          <a:p>
+            <a:pPr indent="0" marL="0">
+              <a:buNone/>
+            </a:pPr>
+            <a:r>
+              <a:rPr lang="en-US" sz="850" dirty="0">
+                <a:solidFill>
+                  <a:srgbClr val="595959"/>
+                </a:solidFill>
+                <a:latin typeface="Arial" pitchFamily="34" charset="0"/>
+                <a:ea typeface="Arial" pitchFamily="34" charset="-122"/>
+                <a:cs typeface="Arial" pitchFamily="34" charset="-120"/>
+              </a:rPr>
+              <a:t>Mean return % p.a. by type of 5-year market (team simulation, equities +4% p.a.). Ties the stocks in moderate markets, beats them in bear and flat ones.</a:t>
+            </a:r>
+            <a:endParaRPr lang="en-US" sz="850" dirty="0"/>
+          </a:p>
+        </p:txBody>
+      </p:sp>
+      <p:sp>
+        <p:nvSpPr>
+          <p:cNvPr id="22" name="Shape 17"/>
+          <p:cNvSpPr/>
+          <p:nvPr/>
+        </p:nvSpPr>
+        <p:spPr>
+          <a:xfrm>
+            <a:off x="4370832" y="3383280"/>
+            <a:ext cx="3730752" cy="292608"/>
+          </a:xfrm>
+          <a:prstGeom prst="rect">
+            <a:avLst/>
+          </a:prstGeom>
+          <a:solidFill>
+            <a:srgbClr val="2C5F82"/>
+          </a:solidFill>
+          <a:ln w="12700">
+            <a:solidFill>
+              <a:srgbClr val="2C5F82"/>
+            </a:solidFill>
+            <a:prstDash val="solid"/>
+          </a:ln>
+        </p:spPr>
+      </p:sp>
+      <p:sp>
+        <p:nvSpPr>
+          <p:cNvPr id="23" name="Text 18"/>
+          <p:cNvSpPr txBox="1"/>
+          <p:nvPr/>
+        </p:nvSpPr>
+        <p:spPr>
+          <a:xfrm>
+            <a:off x="4370832" y="3383280"/>
+            <a:ext cx="3730752" cy="292608"/>
+          </a:xfrm>
+          <a:prstGeom prst="rect">
+            <a:avLst/>
+          </a:prstGeom>
+          <a:noFill/>
+          <a:ln/>
+        </p:spPr>
+        <p:txBody>
+          <a:bodyPr wrap="square" lIns="0" tIns="0" rIns="0" bIns="0" rtlCol="0" anchor="ctr"/>
+          <a:lstStyle/>
+          <a:p>
+            <a:pPr algn="ctr" indent="0" marL="0">
+              <a:buNone/>
+            </a:pPr>
+            <a:r>
+              <a:rPr lang="en-US" sz="1050" b="1" dirty="0">
+                <a:solidFill>
+                  <a:srgbClr val="FFFFFF"/>
+                </a:solidFill>
+                <a:latin typeface="Arial" pitchFamily="34" charset="0"/>
+                <a:ea typeface="Arial" pitchFamily="34" charset="-122"/>
+                <a:cs typeface="Arial" pitchFamily="34" charset="-120"/>
+              </a:rPr>
+              <a:t>Bonds, stocks and plain protection fall short</a:t>
+            </a:r>
+            <a:endParaRPr lang="en-US" sz="1050" dirty="0"/>
+          </a:p>
+        </p:txBody>
+      </p:sp>
+      <p:graphicFrame>
+        <p:nvGraphicFramePr>
+          <p:cNvPr id="4" name="Table 0"/>
+          <p:cNvGraphicFramePr>
+            <a:graphicFrameLocks noGrp="1"/>
+          </p:cNvGraphicFramePr>
+          <p:nvPr>
+            <p:extLst>
+              <p:ext uri="{D42A27DB-BD31-4B8C-83A1-F6EECF244321}">
+                <p14:modId xmlns:p14="http://schemas.microsoft.com/office/powerpoint/2010/main" val="1579011935"/>
+              </p:ext>
+            </p:extLst>
+          </p:nvPr>
+        </p:nvGraphicFramePr>
+        <p:xfrm>
+          <a:off x="4370832" y="3730752"/>
+          <a:ext cx="3730752" cy="914400"/>
+        </p:xfrm>
+        <a:graphic>
+          <a:graphicData uri="http://schemas.openxmlformats.org/drawingml/2006/table">
+            <a:tbl>
+              <a:tblPr/>
+              <a:tblGrid>
+                <a:gridCol w="1691640"/>
+                <a:gridCol w="658368"/>
+                <a:gridCol w="694944"/>
+                <a:gridCol w="685800"/>
+              </a:tblGrid>
+              <a:tr h="246888">
+                <a:tc>
+                  <a:txBody>
+                    <a:bodyPr/>
+                    <a:lstStyle/>
+                    <a:p>
+                      <a:pPr indent="0" marL="0">
+                        <a:buNone/>
+                      </a:pPr>
+                      <a:r>
+                        <a:rPr lang="en-US" sz="900" b="1" dirty="0">
+                          <a:solidFill>
+                            <a:srgbClr val="FFFFFF"/>
+                          </a:solidFill>
+                          <a:latin typeface="Arial" pitchFamily="34" charset="0"/>
+                          <a:ea typeface="Arial" pitchFamily="34" charset="-122"/>
+                          <a:cs typeface="Arial" pitchFamily="34" charset="-120"/>
+                        </a:rPr>
+                        <a:t>Strategy</a:t>
+                      </a:r>
+                      <a:endParaRPr lang="en-US" sz="900" dirty="0">
+                        <a:latin typeface="Arial" charset="0"/>
+                        <a:ea typeface="Arial" charset="0"/>
+                        <a:cs typeface="Arial" charset="0"/>
+                      </a:endParaRPr>
+                    </a:p>
+                  </a:txBody>
+                  <a:tcPr marL="50800" marR="50800" marT="12700" marB="12700" anchor="ctr">
+                    <a:lnL w="6350" cap="flat" cmpd="sng" algn="ctr">
+                      <a:solidFill>
+                        <a:srgbClr val="BFBFBF"/>
+                      </a:solidFill>
+                      <a:prstDash val="solid"/>
+                      <a:round/>
+                      <a:headEnd type="none" w="med" len="med"/>
+                      <a:tailEnd type="none" w="med" len="med"/>
+                    </a:lnL>
+                    <a:lnR w="6350" cap="flat" cmpd="sng" algn="ctr">
+                      <a:solidFill>
+                        <a:srgbClr val="BFBFBF"/>
+                      </a:solidFill>
+                      <a:prstDash val="solid"/>
+                      <a:round/>
+                      <a:headEnd type="none" w="med" len="med"/>
+                      <a:tailEnd type="none" w="med" len="med"/>
+                    </a:lnR>
+                    <a:lnT w="6350" cap="flat" cmpd="sng" algn="ctr">
+                      <a:solidFill>
+                        <a:srgbClr val="BFBFBF"/>
+                      </a:solidFill>
+                      <a:prstDash val="solid"/>
+                      <a:round/>
+                      <a:headEnd type="none" w="med" len="med"/>
+                      <a:tailEnd type="none" w="med" len="med"/>
+                    </a:lnT>
+                    <a:lnB w="6350" cap="flat" cmpd="sng" algn="ctr">
+                      <a:solidFill>
+                        <a:srgbClr val="BFBFBF"/>
+                      </a:solidFill>
+                      <a:prstDash val="solid"/>
+                      <a:round/>
+                      <a:headEnd type="none" w="med" len="med"/>
+                      <a:tailEnd type="none" w="med" len="med"/>
+                    </a:lnB>
+                    <a:solidFill>
+                      <a:srgbClr val="2C5F82"/>
+                    </a:solidFill>
+                  </a:tcPr>
+                </a:tc>
+                <a:tc>
+                  <a:txBody>
+                    <a:bodyPr/>
+                    <a:lstStyle/>
+                    <a:p>
+                      <a:pPr indent="0" marL="0">
+                        <a:buNone/>
+                      </a:pPr>
+                      <a:r>
+                        <a:rPr lang="en-US" sz="900" b="1" dirty="0">
+                          <a:solidFill>
+                            <a:srgbClr val="FFFFFF"/>
+                          </a:solidFill>
+                          <a:latin typeface="Arial" pitchFamily="34" charset="0"/>
+                          <a:ea typeface="Arial" pitchFamily="34" charset="-122"/>
+                          <a:cs typeface="Arial" pitchFamily="34" charset="-120"/>
+                        </a:rPr>
+                        <a:t>Mean</a:t>
+                      </a:r>
+                      <a:endParaRPr lang="en-US" sz="900" dirty="0">
+                        <a:latin typeface="Arial" charset="0"/>
+                        <a:ea typeface="Arial" charset="0"/>
+                        <a:cs typeface="Arial" charset="0"/>
+                      </a:endParaRPr>
+                    </a:p>
+                  </a:txBody>
+                  <a:tcPr marL="50800" marR="50800" marT="12700" marB="12700" anchor="ctr">
+                    <a:lnL w="6350" cap="flat" cmpd="sng" algn="ctr">
+                      <a:solidFill>
+                        <a:srgbClr val="BFBFBF"/>
+                      </a:solidFill>
+                      <a:prstDash val="solid"/>
+                      <a:round/>
+                      <a:headEnd type="none" w="med" len="med"/>
+                      <a:tailEnd type="none" w="med" len="med"/>
+                    </a:lnL>
+                    <a:lnR w="6350" cap="flat" cmpd="sng" algn="ctr">
+                      <a:solidFill>
+                        <a:srgbClr val="BFBFBF"/>
+                      </a:solidFill>
+                      <a:prstDash val="solid"/>
+                      <a:round/>
+                      <a:headEnd type="none" w="med" len="med"/>
+                      <a:tailEnd type="none" w="med" len="med"/>
+                    </a:lnR>
+                    <a:lnT w="6350" cap="flat" cmpd="sng" algn="ctr">
+                      <a:solidFill>
+                        <a:srgbClr val="BFBFBF"/>
+                      </a:solidFill>
+                      <a:prstDash val="solid"/>
+                      <a:round/>
+                      <a:headEnd type="none" w="med" len="med"/>
+                      <a:tailEnd type="none" w="med" len="med"/>
+                    </a:lnT>
+                    <a:lnB w="6350" cap="flat" cmpd="sng" algn="ctr">
+                      <a:solidFill>
+                        <a:srgbClr val="BFBFBF"/>
+                      </a:solidFill>
+                      <a:prstDash val="solid"/>
+                      <a:round/>
+                      <a:headEnd type="none" w="med" len="med"/>
+                      <a:tailEnd type="none" w="med" len="med"/>
+                    </a:lnB>
+                    <a:solidFill>
+                      <a:srgbClr val="2C5F82"/>
+                    </a:solidFill>
+                  </a:tcPr>
+                </a:tc>
+                <a:tc>
+                  <a:txBody>
+                    <a:bodyPr/>
+                    <a:lstStyle/>
+                    <a:p>
+                      <a:pPr indent="0" marL="0">
+                        <a:buNone/>
+                      </a:pPr>
+                      <a:r>
+                        <a:rPr lang="en-US" sz="900" b="1" dirty="0">
+                          <a:solidFill>
+                            <a:srgbClr val="FFFFFF"/>
+                          </a:solidFill>
+                          <a:latin typeface="Arial" pitchFamily="34" charset="0"/>
+                          <a:ea typeface="Arial" pitchFamily="34" charset="-122"/>
+                          <a:cs typeface="Arial" pitchFamily="34" charset="-120"/>
+                        </a:rPr>
+                        <a:t>Median</a:t>
+                      </a:r>
+                      <a:endParaRPr lang="en-US" sz="900" dirty="0">
+                        <a:latin typeface="Arial" charset="0"/>
+                        <a:ea typeface="Arial" charset="0"/>
+                        <a:cs typeface="Arial" charset="0"/>
+                      </a:endParaRPr>
+                    </a:p>
+                  </a:txBody>
+                  <a:tcPr marL="50800" marR="50800" marT="12700" marB="12700" anchor="ctr">
+                    <a:lnL w="6350" cap="flat" cmpd="sng" algn="ctr">
+                      <a:solidFill>
+                        <a:srgbClr val="BFBFBF"/>
+                      </a:solidFill>
+                      <a:prstDash val="solid"/>
+                      <a:round/>
+                      <a:headEnd type="none" w="med" len="med"/>
+                      <a:tailEnd type="none" w="med" len="med"/>
+                    </a:lnL>
+                    <a:lnR w="6350" cap="flat" cmpd="sng" algn="ctr">
+                      <a:solidFill>
+                        <a:srgbClr val="BFBFBF"/>
+                      </a:solidFill>
+                      <a:prstDash val="solid"/>
+                      <a:round/>
+                      <a:headEnd type="none" w="med" len="med"/>
+                      <a:tailEnd type="none" w="med" len="med"/>
+                    </a:lnR>
+                    <a:lnT w="6350" cap="flat" cmpd="sng" algn="ctr">
+                      <a:solidFill>
+                        <a:srgbClr val="BFBFBF"/>
+                      </a:solidFill>
+                      <a:prstDash val="solid"/>
+                      <a:round/>
+                      <a:headEnd type="none" w="med" len="med"/>
+                      <a:tailEnd type="none" w="med" len="med"/>
+                    </a:lnT>
+                    <a:lnB w="6350" cap="flat" cmpd="sng" algn="ctr">
+                      <a:solidFill>
+                        <a:srgbClr val="BFBFBF"/>
+                      </a:solidFill>
+                      <a:prstDash val="solid"/>
+                      <a:round/>
+                      <a:headEnd type="none" w="med" len="med"/>
+                      <a:tailEnd type="none" w="med" len="med"/>
+                    </a:lnB>
+                    <a:solidFill>
+                      <a:srgbClr val="2C5F82"/>
+                    </a:solidFill>
+                  </a:tcPr>
+                </a:tc>
+                <a:tc>
+                  <a:txBody>
+                    <a:bodyPr/>
+                    <a:lstStyle/>
+                    <a:p>
+                      <a:pPr indent="0" marL="0">
+                        <a:buNone/>
+                      </a:pPr>
+                      <a:r>
+                        <a:rPr lang="en-US" sz="900" b="1" dirty="0">
+                          <a:solidFill>
+                            <a:srgbClr val="FFFFFF"/>
+                          </a:solidFill>
+                          <a:latin typeface="Arial" pitchFamily="34" charset="0"/>
+                          <a:ea typeface="Arial" pitchFamily="34" charset="-122"/>
+                          <a:cs typeface="Arial" pitchFamily="34" charset="-120"/>
+                        </a:rPr>
+                        <a:t>Loss risk</a:t>
+                      </a:r>
+                      <a:endParaRPr lang="en-US" sz="900" dirty="0">
+                        <a:latin typeface="Arial" charset="0"/>
+                        <a:ea typeface="Arial" charset="0"/>
+                        <a:cs typeface="Arial" charset="0"/>
+                      </a:endParaRPr>
+                    </a:p>
+                  </a:txBody>
+                  <a:tcPr marL="50800" marR="50800" marT="12700" marB="12700" anchor="ctr">
+                    <a:lnL w="6350" cap="flat" cmpd="sng" algn="ctr">
+                      <a:solidFill>
+                        <a:srgbClr val="BFBFBF"/>
+                      </a:solidFill>
+                      <a:prstDash val="solid"/>
+                      <a:round/>
+                      <a:headEnd type="none" w="med" len="med"/>
+                      <a:tailEnd type="none" w="med" len="med"/>
+                    </a:lnL>
+                    <a:lnR w="6350" cap="flat" cmpd="sng" algn="ctr">
+                      <a:solidFill>
+                        <a:srgbClr val="BFBFBF"/>
+                      </a:solidFill>
+                      <a:prstDash val="solid"/>
+                      <a:round/>
+                      <a:headEnd type="none" w="med" len="med"/>
+                      <a:tailEnd type="none" w="med" len="med"/>
+                    </a:lnR>
+                    <a:lnT w="6350" cap="flat" cmpd="sng" algn="ctr">
+                      <a:solidFill>
+                        <a:srgbClr val="BFBFBF"/>
+                      </a:solidFill>
+                      <a:prstDash val="solid"/>
+                      <a:round/>
+                      <a:headEnd type="none" w="med" len="med"/>
+                      <a:tailEnd type="none" w="med" len="med"/>
+                    </a:lnT>
+                    <a:lnB w="6350" cap="flat" cmpd="sng" algn="ctr">
+                      <a:solidFill>
+                        <a:srgbClr val="BFBFBF"/>
+                      </a:solidFill>
+                      <a:prstDash val="solid"/>
+                      <a:round/>
+                      <a:headEnd type="none" w="med" len="med"/>
+                      <a:tailEnd type="none" w="med" len="med"/>
+                    </a:lnB>
+                    <a:solidFill>
+                      <a:srgbClr val="2C5F82"/>
+                    </a:solidFill>
+                  </a:tcPr>
+                </a:tc>
+              </a:tr>
+              <a:tr h="246888">
+                <a:tc>
+                  <a:txBody>
+                    <a:bodyPr/>
+                    <a:lstStyle/>
+                    <a:p>
+                      <a:pPr indent="0" marL="0">
+                        <a:buNone/>
+                      </a:pPr>
+                      <a:r>
+                        <a:rPr lang="en-US" sz="900" b="1" dirty="0">
+                          <a:solidFill>
+                            <a:srgbClr val="2C5F82"/>
+                          </a:solidFill>
+                          <a:latin typeface="Arial" pitchFamily="34" charset="0"/>
+                          <a:ea typeface="Arial" pitchFamily="34" charset="-122"/>
+                          <a:cs typeface="Arial" pitchFamily="34" charset="-120"/>
+                        </a:rPr>
+                        <a:t>Our protected autocall</a:t>
+                      </a:r>
+                      <a:endParaRPr lang="en-US" sz="900" dirty="0">
+                        <a:latin typeface="Arial" charset="0"/>
+                        <a:ea typeface="Arial" charset="0"/>
+                        <a:cs typeface="Arial" charset="0"/>
+                      </a:endParaRPr>
+                    </a:p>
+                  </a:txBody>
+                  <a:tcPr marL="50800" marR="50800" marT="12700" marB="12700" anchor="ctr">
+                    <a:lnL w="6350" cap="flat" cmpd="sng" algn="ctr">
+                      <a:solidFill>
+                        <a:srgbClr val="BFBFBF"/>
+                      </a:solidFill>
+                      <a:prstDash val="solid"/>
+                      <a:round/>
+                      <a:headEnd type="none" w="med" len="med"/>
+                      <a:tailEnd type="none" w="med" len="med"/>
+                    </a:lnL>
+                    <a:lnR w="6350" cap="flat" cmpd="sng" algn="ctr">
+                      <a:solidFill>
+                        <a:srgbClr val="BFBFBF"/>
+                      </a:solidFill>
+                      <a:prstDash val="solid"/>
+                      <a:round/>
+                      <a:headEnd type="none" w="med" len="med"/>
+                      <a:tailEnd type="none" w="med" len="med"/>
+                    </a:lnR>
+                    <a:lnT w="6350" cap="flat" cmpd="sng" algn="ctr">
+                      <a:solidFill>
+                        <a:srgbClr val="BFBFBF"/>
+                      </a:solidFill>
+                      <a:prstDash val="solid"/>
+                      <a:round/>
+                      <a:headEnd type="none" w="med" len="med"/>
+                      <a:tailEnd type="none" w="med" len="med"/>
+                    </a:lnT>
+                    <a:lnB w="6350" cap="flat" cmpd="sng" algn="ctr">
+                      <a:solidFill>
+                        <a:srgbClr val="BFBFBF"/>
+                      </a:solidFill>
+                      <a:prstDash val="solid"/>
+                      <a:round/>
+                      <a:headEnd type="none" w="med" len="med"/>
+                      <a:tailEnd type="none" w="med" len="med"/>
+                    </a:lnB>
+                    <a:solidFill>
+                      <a:srgbClr val="E8EFF5"/>
+                    </a:solidFill>
+                  </a:tcPr>
+                </a:tc>
+                <a:tc>
+                  <a:txBody>
+                    <a:bodyPr/>
+                    <a:lstStyle/>
+                    <a:p>
+                      <a:pPr indent="0" marL="0">
+                        <a:buNone/>
+                      </a:pPr>
+                      <a:r>
+                        <a:rPr lang="en-US" sz="900" b="1" dirty="0">
+                          <a:solidFill>
+                            <a:srgbClr val="2C5F82"/>
+                          </a:solidFill>
+                          <a:latin typeface="Arial" pitchFamily="34" charset="0"/>
+                          <a:ea typeface="Arial" pitchFamily="34" charset="-122"/>
+                          <a:cs typeface="Arial" pitchFamily="34" charset="-120"/>
+                        </a:rPr>
+                        <a:t>5.4%</a:t>
+                      </a:r>
+                      <a:endParaRPr lang="en-US" sz="900" dirty="0">
+                        <a:latin typeface="Arial" charset="0"/>
+                        <a:ea typeface="Arial" charset="0"/>
+                        <a:cs typeface="Arial" charset="0"/>
+                      </a:endParaRPr>
+                    </a:p>
+                  </a:txBody>
+                  <a:tcPr marL="50800" marR="50800" marT="12700" marB="12700" anchor="ctr">
+                    <a:lnL w="6350" cap="flat" cmpd="sng" algn="ctr">
+                      <a:solidFill>
+                        <a:srgbClr val="BFBFBF"/>
+                      </a:solidFill>
+                      <a:prstDash val="solid"/>
+                      <a:round/>
+                      <a:headEnd type="none" w="med" len="med"/>
+                      <a:tailEnd type="none" w="med" len="med"/>
+                    </a:lnL>
+                    <a:lnR w="6350" cap="flat" cmpd="sng" algn="ctr">
+                      <a:solidFill>
+                        <a:srgbClr val="BFBFBF"/>
+                      </a:solidFill>
+                      <a:prstDash val="solid"/>
+                      <a:round/>
+                      <a:headEnd type="none" w="med" len="med"/>
+                      <a:tailEnd type="none" w="med" len="med"/>
+                    </a:lnR>
+                    <a:lnT w="6350" cap="flat" cmpd="sng" algn="ctr">
+                      <a:solidFill>
+                        <a:srgbClr val="BFBFBF"/>
+                      </a:solidFill>
+                      <a:prstDash val="solid"/>
+                      <a:round/>
+                      <a:headEnd type="none" w="med" len="med"/>
+                      <a:tailEnd type="none" w="med" len="med"/>
+                    </a:lnT>
+                    <a:lnB w="6350" cap="flat" cmpd="sng" algn="ctr">
+                      <a:solidFill>
+                        <a:srgbClr val="BFBFBF"/>
+                      </a:solidFill>
+                      <a:prstDash val="solid"/>
+                      <a:round/>
+                      <a:headEnd type="none" w="med" len="med"/>
+                      <a:tailEnd type="none" w="med" len="med"/>
+                    </a:lnB>
+                    <a:solidFill>
+                      <a:srgbClr val="E8EFF5"/>
+                    </a:solidFill>
+                  </a:tcPr>
+                </a:tc>
+                <a:tc>
+                  <a:txBody>
+                    <a:bodyPr/>
+                    <a:lstStyle/>
+                    <a:p>
+                      <a:pPr indent="0" marL="0">
+                        <a:buNone/>
+                      </a:pPr>
+                      <a:r>
+                        <a:rPr lang="en-US" sz="900" b="1" dirty="0">
+                          <a:solidFill>
+                            <a:srgbClr val="2C5F82"/>
+                          </a:solidFill>
+                          <a:latin typeface="Arial" pitchFamily="34" charset="0"/>
+                          <a:ea typeface="Arial" pitchFamily="34" charset="-122"/>
+                          <a:cs typeface="Arial" pitchFamily="34" charset="-120"/>
+                        </a:rPr>
+                        <a:t>6.8%</a:t>
+                      </a:r>
+                      <a:endParaRPr lang="en-US" sz="900" dirty="0">
+                        <a:latin typeface="Arial" charset="0"/>
+                        <a:ea typeface="Arial" charset="0"/>
+                        <a:cs typeface="Arial" charset="0"/>
+                      </a:endParaRPr>
+                    </a:p>
+                  </a:txBody>
+                  <a:tcPr marL="50800" marR="50800" marT="12700" marB="12700" anchor="ctr">
+                    <a:lnL w="6350" cap="flat" cmpd="sng" algn="ctr">
+                      <a:solidFill>
+                        <a:srgbClr val="BFBFBF"/>
+                      </a:solidFill>
+                      <a:prstDash val="solid"/>
+                      <a:round/>
+                      <a:headEnd type="none" w="med" len="med"/>
+                      <a:tailEnd type="none" w="med" len="med"/>
+                    </a:lnL>
+                    <a:lnR w="6350" cap="flat" cmpd="sng" algn="ctr">
+                      <a:solidFill>
+                        <a:srgbClr val="BFBFBF"/>
+                      </a:solidFill>
+                      <a:prstDash val="solid"/>
+                      <a:round/>
+                      <a:headEnd type="none" w="med" len="med"/>
+                      <a:tailEnd type="none" w="med" len="med"/>
+                    </a:lnR>
+                    <a:lnT w="6350" cap="flat" cmpd="sng" algn="ctr">
+                      <a:solidFill>
+                        <a:srgbClr val="BFBFBF"/>
+                      </a:solidFill>
+                      <a:prstDash val="solid"/>
+                      <a:round/>
+                      <a:headEnd type="none" w="med" len="med"/>
+                      <a:tailEnd type="none" w="med" len="med"/>
+                    </a:lnT>
+                    <a:lnB w="6350" cap="flat" cmpd="sng" algn="ctr">
+                      <a:solidFill>
+                        <a:srgbClr val="BFBFBF"/>
+                      </a:solidFill>
+                      <a:prstDash val="solid"/>
+                      <a:round/>
+                      <a:headEnd type="none" w="med" len="med"/>
+                      <a:tailEnd type="none" w="med" len="med"/>
+                    </a:lnB>
+                    <a:solidFill>
+                      <a:srgbClr val="E8EFF5"/>
+                    </a:solidFill>
+                  </a:tcPr>
+                </a:tc>
+                <a:tc>
+                  <a:txBody>
+                    <a:bodyPr/>
+                    <a:lstStyle/>
+                    <a:p>
+                      <a:pPr indent="0" marL="0">
+                        <a:buNone/>
+                      </a:pPr>
+                      <a:r>
+                        <a:rPr lang="en-US" sz="900" b="1" dirty="0">
+                          <a:solidFill>
+                            <a:srgbClr val="2C5F82"/>
+                          </a:solidFill>
+                          <a:latin typeface="Arial" pitchFamily="34" charset="0"/>
+                          <a:ea typeface="Arial" pitchFamily="34" charset="-122"/>
+                          <a:cs typeface="Arial" pitchFamily="34" charset="-120"/>
+                        </a:rPr>
+                        <a:t>0%</a:t>
+                      </a:r>
+                      <a:endParaRPr lang="en-US" sz="900" dirty="0">
+                        <a:latin typeface="Arial" charset="0"/>
+                        <a:ea typeface="Arial" charset="0"/>
+                        <a:cs typeface="Arial" charset="0"/>
+                      </a:endParaRPr>
+                    </a:p>
+                  </a:txBody>
+                  <a:tcPr marL="50800" marR="50800" marT="12700" marB="12700" anchor="ctr">
+                    <a:lnL w="6350" cap="flat" cmpd="sng" algn="ctr">
+                      <a:solidFill>
+                        <a:srgbClr val="BFBFBF"/>
+                      </a:solidFill>
+                      <a:prstDash val="solid"/>
+                      <a:round/>
+                      <a:headEnd type="none" w="med" len="med"/>
+                      <a:tailEnd type="none" w="med" len="med"/>
+                    </a:lnL>
+                    <a:lnR w="6350" cap="flat" cmpd="sng" algn="ctr">
+                      <a:solidFill>
+                        <a:srgbClr val="BFBFBF"/>
+                      </a:solidFill>
+                      <a:prstDash val="solid"/>
+                      <a:round/>
+                      <a:headEnd type="none" w="med" len="med"/>
+                      <a:tailEnd type="none" w="med" len="med"/>
+                    </a:lnR>
+                    <a:lnT w="6350" cap="flat" cmpd="sng" algn="ctr">
+                      <a:solidFill>
+                        <a:srgbClr val="BFBFBF"/>
+                      </a:solidFill>
+                      <a:prstDash val="solid"/>
+                      <a:round/>
+                      <a:headEnd type="none" w="med" len="med"/>
+                      <a:tailEnd type="none" w="med" len="med"/>
+                    </a:lnT>
+                    <a:lnB w="6350" cap="flat" cmpd="sng" algn="ctr">
+                      <a:solidFill>
+                        <a:srgbClr val="BFBFBF"/>
+                      </a:solidFill>
+                      <a:prstDash val="solid"/>
+                      <a:round/>
+                      <a:headEnd type="none" w="med" len="med"/>
+                      <a:tailEnd type="none" w="med" len="med"/>
+                    </a:lnB>
+                    <a:solidFill>
+                      <a:srgbClr val="E8EFF5"/>
+                    </a:solidFill>
+                  </a:tcPr>
+                </a:tc>
+              </a:tr>
+              <a:tr h="246888">
+                <a:tc>
+                  <a:txBody>
+                    <a:bodyPr/>
+                    <a:lstStyle/>
+                    <a:p>
+                      <a:pPr indent="0" marL="0">
+                        <a:buNone/>
+                      </a:pPr>
+                      <a:r>
+                        <a:rPr lang="en-US" sz="900" dirty="0">
+                          <a:solidFill>
+                            <a:srgbClr val="262626"/>
+                          </a:solidFill>
+                          <a:latin typeface="Arial" pitchFamily="34" charset="0"/>
+                          <a:ea typeface="Arial" pitchFamily="34" charset="-122"/>
+                          <a:cs typeface="Arial" pitchFamily="34" charset="-120"/>
+                        </a:rPr>
+                        <a:t>5Y USD bond</a:t>
+                      </a:r>
+                      <a:endParaRPr lang="en-US" sz="900" dirty="0">
+                        <a:latin typeface="Arial" charset="0"/>
+                        <a:ea typeface="Arial" charset="0"/>
+                        <a:cs typeface="Arial" charset="0"/>
+                      </a:endParaRPr>
+                    </a:p>
+                  </a:txBody>
+                  <a:tcPr marL="50800" marR="50800" marT="12700" marB="12700" anchor="ctr">
+                    <a:lnL w="6350" cap="flat" cmpd="sng" algn="ctr">
+                      <a:solidFill>
+                        <a:srgbClr val="BFBFBF"/>
+                      </a:solidFill>
+                      <a:prstDash val="solid"/>
+                      <a:round/>
+                      <a:headEnd type="none" w="med" len="med"/>
+                      <a:tailEnd type="none" w="med" len="med"/>
+                    </a:lnL>
+                    <a:lnR w="6350" cap="flat" cmpd="sng" algn="ctr">
+                      <a:solidFill>
+                        <a:srgbClr val="BFBFBF"/>
+                      </a:solidFill>
+                      <a:prstDash val="solid"/>
+                      <a:round/>
+                      <a:headEnd type="none" w="med" len="med"/>
+                      <a:tailEnd type="none" w="med" len="med"/>
+                    </a:lnR>
+                    <a:lnT w="6350" cap="flat" cmpd="sng" algn="ctr">
+                      <a:solidFill>
+                        <a:srgbClr val="BFBFBF"/>
+                      </a:solidFill>
+                      <a:prstDash val="solid"/>
+                      <a:round/>
+                      <a:headEnd type="none" w="med" len="med"/>
+                      <a:tailEnd type="none" w="med" len="med"/>
+                    </a:lnT>
+                    <a:lnB w="6350" cap="flat" cmpd="sng" algn="ctr">
+                      <a:solidFill>
+                        <a:srgbClr val="BFBFBF"/>
+                      </a:solidFill>
+                      <a:prstDash val="solid"/>
+                      <a:round/>
+                      <a:headEnd type="none" w="med" len="med"/>
+                      <a:tailEnd type="none" w="med" len="med"/>
+                    </a:lnB>
+                    <a:solidFill>
+                      <a:srgbClr val="FFFFFF"/>
+                    </a:solidFill>
+                  </a:tcPr>
+                </a:tc>
+                <a:tc>
+                  <a:txBody>
+                    <a:bodyPr/>
+                    <a:lstStyle/>
+                    <a:p>
+                      <a:pPr indent="0" marL="0">
+                        <a:buNone/>
+                      </a:pPr>
+                      <a:r>
+                        <a:rPr lang="en-US" sz="900" dirty="0">
+                          <a:solidFill>
+                            <a:srgbClr val="262626"/>
+                          </a:solidFill>
+                          <a:latin typeface="Arial" pitchFamily="34" charset="0"/>
+                          <a:ea typeface="Arial" pitchFamily="34" charset="-122"/>
+                          <a:cs typeface="Arial" pitchFamily="34" charset="-120"/>
+                        </a:rPr>
+                        <a:t>5.7%</a:t>
+                      </a:r>
+                      <a:endParaRPr lang="en-US" sz="900" dirty="0">
+                        <a:latin typeface="Arial" charset="0"/>
+                        <a:ea typeface="Arial" charset="0"/>
+                        <a:cs typeface="Arial" charset="0"/>
+                      </a:endParaRPr>
+                    </a:p>
+                  </a:txBody>
+                  <a:tcPr marL="50800" marR="50800" marT="12700" marB="12700" anchor="ctr">
+                    <a:lnL w="6350" cap="flat" cmpd="sng" algn="ctr">
+                      <a:solidFill>
+                        <a:srgbClr val="BFBFBF"/>
+                      </a:solidFill>
+                      <a:prstDash val="solid"/>
+                      <a:round/>
+                      <a:headEnd type="none" w="med" len="med"/>
+                      <a:tailEnd type="none" w="med" len="med"/>
+                    </a:lnL>
+                    <a:lnR w="6350" cap="flat" cmpd="sng" algn="ctr">
+                      <a:solidFill>
+                        <a:srgbClr val="BFBFBF"/>
+                      </a:solidFill>
+                      <a:prstDash val="solid"/>
+                      <a:round/>
+                      <a:headEnd type="none" w="med" len="med"/>
+                      <a:tailEnd type="none" w="med" len="med"/>
+                    </a:lnR>
+                    <a:lnT w="6350" cap="flat" cmpd="sng" algn="ctr">
+                      <a:solidFill>
+                        <a:srgbClr val="BFBFBF"/>
+                      </a:solidFill>
+                      <a:prstDash val="solid"/>
+                      <a:round/>
+                      <a:headEnd type="none" w="med" len="med"/>
+                      <a:tailEnd type="none" w="med" len="med"/>
+                    </a:lnT>
+                    <a:lnB w="6350" cap="flat" cmpd="sng" algn="ctr">
+                      <a:solidFill>
+                        <a:srgbClr val="BFBFBF"/>
+                      </a:solidFill>
+                      <a:prstDash val="solid"/>
+                      <a:round/>
+                      <a:headEnd type="none" w="med" len="med"/>
+                      <a:tailEnd type="none" w="med" len="med"/>
+                    </a:lnB>
+                    <a:solidFill>
+                      <a:srgbClr val="FFFFFF"/>
+                    </a:solidFill>
+                  </a:tcPr>
+                </a:tc>
+                <a:tc>
+                  <a:txBody>
+                    <a:bodyPr/>
+                    <a:lstStyle/>
+                    <a:p>
+                      <a:pPr indent="0" marL="0">
+                        <a:buNone/>
+                      </a:pPr>
+                      <a:r>
+                        <a:rPr lang="en-US" sz="900" dirty="0">
+                          <a:solidFill>
+                            <a:srgbClr val="262626"/>
+                          </a:solidFill>
+                          <a:latin typeface="Arial" pitchFamily="34" charset="0"/>
+                          <a:ea typeface="Arial" pitchFamily="34" charset="-122"/>
+                          <a:cs typeface="Arial" pitchFamily="34" charset="-120"/>
+                        </a:rPr>
+                        <a:t>5.7%</a:t>
+                      </a:r>
+                      <a:endParaRPr lang="en-US" sz="900" dirty="0">
+                        <a:latin typeface="Arial" charset="0"/>
+                        <a:ea typeface="Arial" charset="0"/>
+                        <a:cs typeface="Arial" charset="0"/>
+                      </a:endParaRPr>
+                    </a:p>
+                  </a:txBody>
+                  <a:tcPr marL="50800" marR="50800" marT="12700" marB="12700" anchor="ctr">
+                    <a:lnL w="6350" cap="flat" cmpd="sng" algn="ctr">
+                      <a:solidFill>
+                        <a:srgbClr val="BFBFBF"/>
+                      </a:solidFill>
+                      <a:prstDash val="solid"/>
+                      <a:round/>
+                      <a:headEnd type="none" w="med" len="med"/>
+                      <a:tailEnd type="none" w="med" len="med"/>
+                    </a:lnL>
+                    <a:lnR w="6350" cap="flat" cmpd="sng" algn="ctr">
+                      <a:solidFill>
+                        <a:srgbClr val="BFBFBF"/>
+                      </a:solidFill>
+                      <a:prstDash val="solid"/>
+                      <a:round/>
+                      <a:headEnd type="none" w="med" len="med"/>
+                      <a:tailEnd type="none" w="med" len="med"/>
+                    </a:lnR>
+                    <a:lnT w="6350" cap="flat" cmpd="sng" algn="ctr">
+                      <a:solidFill>
+                        <a:srgbClr val="BFBFBF"/>
+                      </a:solidFill>
+                      <a:prstDash val="solid"/>
+                      <a:round/>
+                      <a:headEnd type="none" w="med" len="med"/>
+                      <a:tailEnd type="none" w="med" len="med"/>
+                    </a:lnT>
+                    <a:lnB w="6350" cap="flat" cmpd="sng" algn="ctr">
+                      <a:solidFill>
+                        <a:srgbClr val="BFBFBF"/>
+                      </a:solidFill>
+                      <a:prstDash val="solid"/>
+                      <a:round/>
+                      <a:headEnd type="none" w="med" len="med"/>
+                      <a:tailEnd type="none" w="med" len="med"/>
+                    </a:lnB>
+                    <a:solidFill>
+                      <a:srgbClr val="FFFFFF"/>
+                    </a:solidFill>
+                  </a:tcPr>
+                </a:tc>
+                <a:tc>
+                  <a:txBody>
+                    <a:bodyPr/>
+                    <a:lstStyle/>
+                    <a:p>
+                      <a:pPr indent="0" marL="0">
+                        <a:buNone/>
+                      </a:pPr>
+                      <a:r>
+                        <a:rPr lang="en-US" sz="900" dirty="0">
+                          <a:solidFill>
+                            <a:srgbClr val="262626"/>
+                          </a:solidFill>
+                          <a:latin typeface="Arial" pitchFamily="34" charset="0"/>
+                          <a:ea typeface="Arial" pitchFamily="34" charset="-122"/>
+                          <a:cs typeface="Arial" pitchFamily="34" charset="-120"/>
+                        </a:rPr>
+                        <a:t>0%</a:t>
+                      </a:r>
+                      <a:endParaRPr lang="en-US" sz="900" dirty="0">
+                        <a:latin typeface="Arial" charset="0"/>
+                        <a:ea typeface="Arial" charset="0"/>
+                        <a:cs typeface="Arial" charset="0"/>
+                      </a:endParaRPr>
+                    </a:p>
+                  </a:txBody>
+                  <a:tcPr marL="50800" marR="50800" marT="12700" marB="12700" anchor="ctr">
+                    <a:lnL w="6350" cap="flat" cmpd="sng" algn="ctr">
+                      <a:solidFill>
+                        <a:srgbClr val="BFBFBF"/>
+                      </a:solidFill>
+                      <a:prstDash val="solid"/>
+                      <a:round/>
+                      <a:headEnd type="none" w="med" len="med"/>
+                      <a:tailEnd type="none" w="med" len="med"/>
+                    </a:lnL>
+                    <a:lnR w="6350" cap="flat" cmpd="sng" algn="ctr">
+                      <a:solidFill>
+                        <a:srgbClr val="BFBFBF"/>
+                      </a:solidFill>
+                      <a:prstDash val="solid"/>
+                      <a:round/>
+                      <a:headEnd type="none" w="med" len="med"/>
+                      <a:tailEnd type="none" w="med" len="med"/>
+                    </a:lnR>
+                    <a:lnT w="6350" cap="flat" cmpd="sng" algn="ctr">
+                      <a:solidFill>
+                        <a:srgbClr val="BFBFBF"/>
+                      </a:solidFill>
+                      <a:prstDash val="solid"/>
+                      <a:round/>
+                      <a:headEnd type="none" w="med" len="med"/>
+                      <a:tailEnd type="none" w="med" len="med"/>
+                    </a:lnT>
+                    <a:lnB w="6350" cap="flat" cmpd="sng" algn="ctr">
+                      <a:solidFill>
+                        <a:srgbClr val="BFBFBF"/>
+                      </a:solidFill>
+                      <a:prstDash val="solid"/>
+                      <a:round/>
+                      <a:headEnd type="none" w="med" len="med"/>
+                      <a:tailEnd type="none" w="med" len="med"/>
+                    </a:lnB>
+                    <a:solidFill>
+                      <a:srgbClr val="FFFFFF"/>
+                    </a:solidFill>
+                  </a:tcPr>
+                </a:tc>
+              </a:tr>
+              <a:tr h="246888">
+                <a:tc>
+                  <a:txBody>
+                    <a:bodyPr/>
+                    <a:lstStyle/>
+                    <a:p>
+                      <a:pPr indent="0" marL="0">
+                        <a:buNone/>
+                      </a:pPr>
+                      <a:r>
+                        <a:rPr lang="en-US" sz="900" dirty="0">
+                          <a:solidFill>
+                            <a:srgbClr val="262626"/>
+                          </a:solidFill>
+                          <a:latin typeface="Arial" pitchFamily="34" charset="0"/>
+                          <a:ea typeface="Arial" pitchFamily="34" charset="-122"/>
+                          <a:cs typeface="Arial" pitchFamily="34" charset="-120"/>
+                        </a:rPr>
+                        <a:t>Hold the basket</a:t>
+                      </a:r>
+                      <a:endParaRPr lang="en-US" sz="900" dirty="0">
+                        <a:latin typeface="Arial" charset="0"/>
+                        <a:ea typeface="Arial" charset="0"/>
+                        <a:cs typeface="Arial" charset="0"/>
+                      </a:endParaRPr>
+                    </a:p>
+                  </a:txBody>
+                  <a:tcPr marL="50800" marR="50800" marT="12700" marB="12700" anchor="ctr">
+                    <a:lnL w="6350" cap="flat" cmpd="sng" algn="ctr">
+                      <a:solidFill>
+                        <a:srgbClr val="BFBFBF"/>
+                      </a:solidFill>
+                      <a:prstDash val="solid"/>
+                      <a:round/>
+                      <a:headEnd type="none" w="med" len="med"/>
+                      <a:tailEnd type="none" w="med" len="med"/>
+                    </a:lnL>
+                    <a:lnR w="6350" cap="flat" cmpd="sng" algn="ctr">
+                      <a:solidFill>
+                        <a:srgbClr val="BFBFBF"/>
+                      </a:solidFill>
+                      <a:prstDash val="solid"/>
+                      <a:round/>
+                      <a:headEnd type="none" w="med" len="med"/>
+                      <a:tailEnd type="none" w="med" len="med"/>
+                    </a:lnR>
+                    <a:lnT w="6350" cap="flat" cmpd="sng" algn="ctr">
+                      <a:solidFill>
+                        <a:srgbClr val="BFBFBF"/>
+                      </a:solidFill>
+                      <a:prstDash val="solid"/>
+                      <a:round/>
+                      <a:headEnd type="none" w="med" len="med"/>
+                      <a:tailEnd type="none" w="med" len="med"/>
+                    </a:lnT>
+                    <a:lnB w="6350" cap="flat" cmpd="sng" algn="ctr">
+                      <a:solidFill>
+                        <a:srgbClr val="BFBFBF"/>
+                      </a:solidFill>
+                      <a:prstDash val="solid"/>
+                      <a:round/>
+                      <a:headEnd type="none" w="med" len="med"/>
+                      <a:tailEnd type="none" w="med" len="med"/>
+                    </a:lnB>
+                    <a:solidFill>
+                      <a:srgbClr val="FFFFFF"/>
+                    </a:solidFill>
+                  </a:tcPr>
+                </a:tc>
+                <a:tc>
+                  <a:txBody>
+                    <a:bodyPr/>
+                    <a:lstStyle/>
+                    <a:p>
+                      <a:pPr indent="0" marL="0">
+                        <a:buNone/>
+                      </a:pPr>
+                      <a:r>
+                        <a:rPr lang="en-US" sz="900" dirty="0">
+                          <a:solidFill>
+                            <a:srgbClr val="262626"/>
+                          </a:solidFill>
+                          <a:latin typeface="Arial" pitchFamily="34" charset="0"/>
+                          <a:ea typeface="Arial" pitchFamily="34" charset="-122"/>
+                          <a:cs typeface="Arial" pitchFamily="34" charset="-120"/>
+                        </a:rPr>
+                        <a:t>2.3%</a:t>
+                      </a:r>
+                      <a:endParaRPr lang="en-US" sz="900" dirty="0">
+                        <a:latin typeface="Arial" charset="0"/>
+                        <a:ea typeface="Arial" charset="0"/>
+                        <a:cs typeface="Arial" charset="0"/>
+                      </a:endParaRPr>
+                    </a:p>
+                  </a:txBody>
+                  <a:tcPr marL="50800" marR="50800" marT="12700" marB="12700" anchor="ctr">
+                    <a:lnL w="6350" cap="flat" cmpd="sng" algn="ctr">
+                      <a:solidFill>
+                        <a:srgbClr val="BFBFBF"/>
+                      </a:solidFill>
+                      <a:prstDash val="solid"/>
+                      <a:round/>
+                      <a:headEnd type="none" w="med" len="med"/>
+                      <a:tailEnd type="none" w="med" len="med"/>
+                    </a:lnL>
+                    <a:lnR w="6350" cap="flat" cmpd="sng" algn="ctr">
+                      <a:solidFill>
+                        <a:srgbClr val="BFBFBF"/>
+                      </a:solidFill>
+                      <a:prstDash val="solid"/>
+                      <a:round/>
+                      <a:headEnd type="none" w="med" len="med"/>
+                      <a:tailEnd type="none" w="med" len="med"/>
+                    </a:lnR>
+                    <a:lnT w="6350" cap="flat" cmpd="sng" algn="ctr">
+                      <a:solidFill>
+                        <a:srgbClr val="BFBFBF"/>
+                      </a:solidFill>
+                      <a:prstDash val="solid"/>
+                      <a:round/>
+                      <a:headEnd type="none" w="med" len="med"/>
+                      <a:tailEnd type="none" w="med" len="med"/>
+                    </a:lnT>
+                    <a:lnB w="6350" cap="flat" cmpd="sng" algn="ctr">
+                      <a:solidFill>
+                        <a:srgbClr val="BFBFBF"/>
+                      </a:solidFill>
+                      <a:prstDash val="solid"/>
+                      <a:round/>
+                      <a:headEnd type="none" w="med" len="med"/>
+                      <a:tailEnd type="none" w="med" len="med"/>
+                    </a:lnB>
+                    <a:solidFill>
+                      <a:srgbClr val="FFFFFF"/>
+                    </a:solidFill>
+                  </a:tcPr>
+                </a:tc>
+                <a:tc>
+                  <a:txBody>
+                    <a:bodyPr/>
+                    <a:lstStyle/>
+                    <a:p>
+                      <a:pPr indent="0" marL="0">
+                        <a:buNone/>
+                      </a:pPr>
+                      <a:r>
+                        <a:rPr lang="en-US" sz="900" dirty="0">
+                          <a:solidFill>
+                            <a:srgbClr val="262626"/>
+                          </a:solidFill>
+                          <a:latin typeface="Arial" pitchFamily="34" charset="0"/>
+                          <a:ea typeface="Arial" pitchFamily="34" charset="-122"/>
+                          <a:cs typeface="Arial" pitchFamily="34" charset="-120"/>
+                        </a:rPr>
+                        <a:t>1.9%</a:t>
+                      </a:r>
+                      <a:endParaRPr lang="en-US" sz="900" dirty="0">
+                        <a:latin typeface="Arial" charset="0"/>
+                        <a:ea typeface="Arial" charset="0"/>
+                        <a:cs typeface="Arial" charset="0"/>
+                      </a:endParaRPr>
+                    </a:p>
+                  </a:txBody>
+                  <a:tcPr marL="50800" marR="50800" marT="12700" marB="12700" anchor="ctr">
+                    <a:lnL w="6350" cap="flat" cmpd="sng" algn="ctr">
+                      <a:solidFill>
+                        <a:srgbClr val="BFBFBF"/>
+                      </a:solidFill>
+                      <a:prstDash val="solid"/>
+                      <a:round/>
+                      <a:headEnd type="none" w="med" len="med"/>
+                      <a:tailEnd type="none" w="med" len="med"/>
+                    </a:lnL>
+                    <a:lnR w="6350" cap="flat" cmpd="sng" algn="ctr">
+                      <a:solidFill>
+                        <a:srgbClr val="BFBFBF"/>
+                      </a:solidFill>
+                      <a:prstDash val="solid"/>
+                      <a:round/>
+                      <a:headEnd type="none" w="med" len="med"/>
+                      <a:tailEnd type="none" w="med" len="med"/>
+                    </a:lnR>
+                    <a:lnT w="6350" cap="flat" cmpd="sng" algn="ctr">
+                      <a:solidFill>
+                        <a:srgbClr val="BFBFBF"/>
+                      </a:solidFill>
+                      <a:prstDash val="solid"/>
+                      <a:round/>
+                      <a:headEnd type="none" w="med" len="med"/>
+                      <a:tailEnd type="none" w="med" len="med"/>
+                    </a:lnT>
+                    <a:lnB w="6350" cap="flat" cmpd="sng" algn="ctr">
+                      <a:solidFill>
+                        <a:srgbClr val="BFBFBF"/>
+                      </a:solidFill>
+                      <a:prstDash val="solid"/>
+                      <a:round/>
+                      <a:headEnd type="none" w="med" len="med"/>
+                      <a:tailEnd type="none" w="med" len="med"/>
+                    </a:lnB>
+                    <a:solidFill>
+                      <a:srgbClr val="FFFFFF"/>
+                    </a:solidFill>
+                  </a:tcPr>
+                </a:tc>
+                <a:tc>
+                  <a:txBody>
+                    <a:bodyPr/>
+                    <a:lstStyle/>
+                    <a:p>
+                      <a:pPr indent="0" marL="0">
+                        <a:buNone/>
+                      </a:pPr>
+                      <a:r>
+                        <a:rPr lang="en-US" sz="900" dirty="0">
+                          <a:solidFill>
+                            <a:srgbClr val="262626"/>
+                          </a:solidFill>
+                          <a:latin typeface="Arial" pitchFamily="34" charset="0"/>
+                          <a:ea typeface="Arial" pitchFamily="34" charset="-122"/>
+                          <a:cs typeface="Arial" pitchFamily="34" charset="-120"/>
+                        </a:rPr>
+                        <a:t>42%</a:t>
+                      </a:r>
+                      <a:endParaRPr lang="en-US" sz="900" dirty="0">
+                        <a:latin typeface="Arial" charset="0"/>
+                        <a:ea typeface="Arial" charset="0"/>
+                        <a:cs typeface="Arial" charset="0"/>
+                      </a:endParaRPr>
+                    </a:p>
+                  </a:txBody>
+                  <a:tcPr marL="50800" marR="50800" marT="12700" marB="12700" anchor="ctr">
+                    <a:lnL w="6350" cap="flat" cmpd="sng" algn="ctr">
+                      <a:solidFill>
+                        <a:srgbClr val="BFBFBF"/>
+                      </a:solidFill>
+                      <a:prstDash val="solid"/>
+                      <a:round/>
+                      <a:headEnd type="none" w="med" len="med"/>
+                      <a:tailEnd type="none" w="med" len="med"/>
+                    </a:lnL>
+                    <a:lnR w="6350" cap="flat" cmpd="sng" algn="ctr">
+                      <a:solidFill>
+                        <a:srgbClr val="BFBFBF"/>
+                      </a:solidFill>
+                      <a:prstDash val="solid"/>
+                      <a:round/>
+                      <a:headEnd type="none" w="med" len="med"/>
+                      <a:tailEnd type="none" w="med" len="med"/>
+                    </a:lnR>
+                    <a:lnT w="6350" cap="flat" cmpd="sng" algn="ctr">
+                      <a:solidFill>
+                        <a:srgbClr val="BFBFBF"/>
+                      </a:solidFill>
+                      <a:prstDash val="solid"/>
+                      <a:round/>
+                      <a:headEnd type="none" w="med" len="med"/>
+                      <a:tailEnd type="none" w="med" len="med"/>
+                    </a:lnT>
+                    <a:lnB w="6350" cap="flat" cmpd="sng" algn="ctr">
+                      <a:solidFill>
+                        <a:srgbClr val="BFBFBF"/>
+                      </a:solidFill>
+                      <a:prstDash val="solid"/>
+                      <a:round/>
+                      <a:headEnd type="none" w="med" len="med"/>
+                      <a:tailEnd type="none" w="med" len="med"/>
+                    </a:lnB>
+                    <a:solidFill>
+                      <a:srgbClr val="FFFFFF"/>
+                    </a:solidFill>
+                  </a:tcPr>
+                </a:tc>
+              </a:tr>
+              <a:tr h="246888">
+                <a:tc>
+                  <a:txBody>
+                    <a:bodyPr/>
+                    <a:lstStyle/>
+                    <a:p>
+                      <a:pPr indent="0" marL="0">
+                        <a:buNone/>
+                      </a:pPr>
+                      <a:r>
+                        <a:rPr lang="en-US" sz="900" dirty="0">
+                          <a:solidFill>
+                            <a:srgbClr val="262626"/>
+                          </a:solidFill>
+                          <a:latin typeface="Arial" pitchFamily="34" charset="0"/>
+                          <a:ea typeface="Arial" pitchFamily="34" charset="-122"/>
+                          <a:cs typeface="Arial" pitchFamily="34" charset="-120"/>
+                        </a:rPr>
+                        <a:t>Plain protected note</a:t>
+                      </a:r>
+                      <a:endParaRPr lang="en-US" sz="900" dirty="0">
+                        <a:latin typeface="Arial" charset="0"/>
+                        <a:ea typeface="Arial" charset="0"/>
+                        <a:cs typeface="Arial" charset="0"/>
+                      </a:endParaRPr>
+                    </a:p>
+                  </a:txBody>
+                  <a:tcPr marL="50800" marR="50800" marT="12700" marB="12700" anchor="ctr">
+                    <a:lnL w="6350" cap="flat" cmpd="sng" algn="ctr">
+                      <a:solidFill>
+                        <a:srgbClr val="BFBFBF"/>
+                      </a:solidFill>
+                      <a:prstDash val="solid"/>
+                      <a:round/>
+                      <a:headEnd type="none" w="med" len="med"/>
+                      <a:tailEnd type="none" w="med" len="med"/>
+                    </a:lnL>
+                    <a:lnR w="6350" cap="flat" cmpd="sng" algn="ctr">
+                      <a:solidFill>
+                        <a:srgbClr val="BFBFBF"/>
+                      </a:solidFill>
+                      <a:prstDash val="solid"/>
+                      <a:round/>
+                      <a:headEnd type="none" w="med" len="med"/>
+                      <a:tailEnd type="none" w="med" len="med"/>
+                    </a:lnR>
+                    <a:lnT w="6350" cap="flat" cmpd="sng" algn="ctr">
+                      <a:solidFill>
+                        <a:srgbClr val="BFBFBF"/>
+                      </a:solidFill>
+                      <a:prstDash val="solid"/>
+                      <a:round/>
+                      <a:headEnd type="none" w="med" len="med"/>
+                      <a:tailEnd type="none" w="med" len="med"/>
+                    </a:lnT>
+                    <a:lnB w="6350" cap="flat" cmpd="sng" algn="ctr">
+                      <a:solidFill>
+                        <a:srgbClr val="BFBFBF"/>
+                      </a:solidFill>
+                      <a:prstDash val="solid"/>
+                      <a:round/>
+                      <a:headEnd type="none" w="med" len="med"/>
+                      <a:tailEnd type="none" w="med" len="med"/>
+                    </a:lnB>
+                    <a:solidFill>
+                      <a:srgbClr val="FFFFFF"/>
+                    </a:solidFill>
+                  </a:tcPr>
+                </a:tc>
+                <a:tc>
+                  <a:txBody>
+                    <a:bodyPr/>
+                    <a:lstStyle/>
+                    <a:p>
+                      <a:pPr indent="0" marL="0">
+                        <a:buNone/>
+                      </a:pPr>
+                      <a:r>
+                        <a:rPr lang="en-US" sz="900" dirty="0">
+                          <a:solidFill>
+                            <a:srgbClr val="262626"/>
+                          </a:solidFill>
+                          <a:latin typeface="Arial" pitchFamily="34" charset="0"/>
+                          <a:ea typeface="Arial" pitchFamily="34" charset="-122"/>
+                          <a:cs typeface="Arial" pitchFamily="34" charset="-120"/>
+                        </a:rPr>
+                        <a:t>3.7%</a:t>
+                      </a:r>
+                      <a:endParaRPr lang="en-US" sz="900" dirty="0">
+                        <a:latin typeface="Arial" charset="0"/>
+                        <a:ea typeface="Arial" charset="0"/>
+                        <a:cs typeface="Arial" charset="0"/>
+                      </a:endParaRPr>
+                    </a:p>
+                  </a:txBody>
+                  <a:tcPr marL="50800" marR="50800" marT="12700" marB="12700" anchor="ctr">
+                    <a:lnL w="6350" cap="flat" cmpd="sng" algn="ctr">
+                      <a:solidFill>
+                        <a:srgbClr val="BFBFBF"/>
+                      </a:solidFill>
+                      <a:prstDash val="solid"/>
+                      <a:round/>
+                      <a:headEnd type="none" w="med" len="med"/>
+                      <a:tailEnd type="none" w="med" len="med"/>
+                    </a:lnL>
+                    <a:lnR w="6350" cap="flat" cmpd="sng" algn="ctr">
+                      <a:solidFill>
+                        <a:srgbClr val="BFBFBF"/>
+                      </a:solidFill>
+                      <a:prstDash val="solid"/>
+                      <a:round/>
+                      <a:headEnd type="none" w="med" len="med"/>
+                      <a:tailEnd type="none" w="med" len="med"/>
+                    </a:lnR>
+                    <a:lnT w="6350" cap="flat" cmpd="sng" algn="ctr">
+                      <a:solidFill>
+                        <a:srgbClr val="BFBFBF"/>
+                      </a:solidFill>
+                      <a:prstDash val="solid"/>
+                      <a:round/>
+                      <a:headEnd type="none" w="med" len="med"/>
+                      <a:tailEnd type="none" w="med" len="med"/>
+                    </a:lnT>
+                    <a:lnB w="6350" cap="flat" cmpd="sng" algn="ctr">
+                      <a:solidFill>
+                        <a:srgbClr val="BFBFBF"/>
+                      </a:solidFill>
+                      <a:prstDash val="solid"/>
+                      <a:round/>
+                      <a:headEnd type="none" w="med" len="med"/>
+                      <a:tailEnd type="none" w="med" len="med"/>
+                    </a:lnB>
+                    <a:solidFill>
+                      <a:srgbClr val="FFFFFF"/>
+                    </a:solidFill>
+                  </a:tcPr>
+                </a:tc>
+                <a:tc>
+                  <a:txBody>
+                    <a:bodyPr/>
+                    <a:lstStyle/>
+                    <a:p>
+                      <a:pPr indent="0" marL="0">
+                        <a:buNone/>
+                      </a:pPr>
+                      <a:r>
+                        <a:rPr lang="en-US" sz="900" dirty="0">
+                          <a:solidFill>
+                            <a:srgbClr val="262626"/>
+                          </a:solidFill>
+                          <a:latin typeface="Arial" pitchFamily="34" charset="0"/>
+                          <a:ea typeface="Arial" pitchFamily="34" charset="-122"/>
+                          <a:cs typeface="Arial" pitchFamily="34" charset="-120"/>
+                        </a:rPr>
+                        <a:t>0.0%</a:t>
+                      </a:r>
+                      <a:endParaRPr lang="en-US" sz="900" dirty="0">
+                        <a:latin typeface="Arial" charset="0"/>
+                        <a:ea typeface="Arial" charset="0"/>
+                        <a:cs typeface="Arial" charset="0"/>
+                      </a:endParaRPr>
+                    </a:p>
+                  </a:txBody>
+                  <a:tcPr marL="50800" marR="50800" marT="12700" marB="12700" anchor="ctr">
+                    <a:lnL w="6350" cap="flat" cmpd="sng" algn="ctr">
+                      <a:solidFill>
+                        <a:srgbClr val="BFBFBF"/>
+                      </a:solidFill>
+                      <a:prstDash val="solid"/>
+                      <a:round/>
+                      <a:headEnd type="none" w="med" len="med"/>
+                      <a:tailEnd type="none" w="med" len="med"/>
+                    </a:lnL>
+                    <a:lnR w="6350" cap="flat" cmpd="sng" algn="ctr">
+                      <a:solidFill>
+                        <a:srgbClr val="BFBFBF"/>
+                      </a:solidFill>
+                      <a:prstDash val="solid"/>
+                      <a:round/>
+                      <a:headEnd type="none" w="med" len="med"/>
+                      <a:tailEnd type="none" w="med" len="med"/>
+                    </a:lnR>
+                    <a:lnT w="6350" cap="flat" cmpd="sng" algn="ctr">
+                      <a:solidFill>
+                        <a:srgbClr val="BFBFBF"/>
+                      </a:solidFill>
+                      <a:prstDash val="solid"/>
+                      <a:round/>
+                      <a:headEnd type="none" w="med" len="med"/>
+                      <a:tailEnd type="none" w="med" len="med"/>
+                    </a:lnT>
+                    <a:lnB w="6350" cap="flat" cmpd="sng" algn="ctr">
+                      <a:solidFill>
+                        <a:srgbClr val="BFBFBF"/>
+                      </a:solidFill>
+                      <a:prstDash val="solid"/>
+                      <a:round/>
+                      <a:headEnd type="none" w="med" len="med"/>
+                      <a:tailEnd type="none" w="med" len="med"/>
+                    </a:lnB>
+                    <a:solidFill>
+                      <a:srgbClr val="FFFFFF"/>
+                    </a:solidFill>
+                  </a:tcPr>
+                </a:tc>
+                <a:tc>
+                  <a:txBody>
+                    <a:bodyPr/>
+                    <a:lstStyle/>
+                    <a:p>
+                      <a:pPr indent="0" marL="0">
+                        <a:buNone/>
+                      </a:pPr>
+                      <a:r>
+                        <a:rPr lang="en-US" sz="900" dirty="0">
+                          <a:solidFill>
+                            <a:srgbClr val="262626"/>
+                          </a:solidFill>
+                          <a:latin typeface="Arial" pitchFamily="34" charset="0"/>
+                          <a:ea typeface="Arial" pitchFamily="34" charset="-122"/>
+                          <a:cs typeface="Arial" pitchFamily="34" charset="-120"/>
+                        </a:rPr>
+                        <a:t>0%</a:t>
+                      </a:r>
+                      <a:endParaRPr lang="en-US" sz="900" dirty="0">
+                        <a:latin typeface="Arial" charset="0"/>
+                        <a:ea typeface="Arial" charset="0"/>
+                        <a:cs typeface="Arial" charset="0"/>
+                      </a:endParaRPr>
+                    </a:p>
+                  </a:txBody>
+                  <a:tcPr marL="50800" marR="50800" marT="12700" marB="12700" anchor="ctr">
+                    <a:lnL w="6350" cap="flat" cmpd="sng" algn="ctr">
+                      <a:solidFill>
+                        <a:srgbClr val="BFBFBF"/>
+                      </a:solidFill>
+                      <a:prstDash val="solid"/>
+                      <a:round/>
+                      <a:headEnd type="none" w="med" len="med"/>
+                      <a:tailEnd type="none" w="med" len="med"/>
+                    </a:lnL>
+                    <a:lnR w="6350" cap="flat" cmpd="sng" algn="ctr">
+                      <a:solidFill>
+                        <a:srgbClr val="BFBFBF"/>
+                      </a:solidFill>
+                      <a:prstDash val="solid"/>
+                      <a:round/>
+                      <a:headEnd type="none" w="med" len="med"/>
+                      <a:tailEnd type="none" w="med" len="med"/>
+                    </a:lnR>
+                    <a:lnT w="6350" cap="flat" cmpd="sng" algn="ctr">
+                      <a:solidFill>
+                        <a:srgbClr val="BFBFBF"/>
+                      </a:solidFill>
+                      <a:prstDash val="solid"/>
+                      <a:round/>
+                      <a:headEnd type="none" w="med" len="med"/>
+                      <a:tailEnd type="none" w="med" len="med"/>
+                    </a:lnT>
+                    <a:lnB w="6350" cap="flat" cmpd="sng" algn="ctr">
+                      <a:solidFill>
+                        <a:srgbClr val="BFBFBF"/>
+                      </a:solidFill>
+                      <a:prstDash val="solid"/>
+                      <a:round/>
+                      <a:headEnd type="none" w="med" len="med"/>
+                      <a:tailEnd type="none" w="med" len="med"/>
+                    </a:lnB>
+                    <a:solidFill>
+                      <a:srgbClr val="FFFFFF"/>
+                    </a:solidFill>
+                  </a:tcPr>
+                </a:tc>
+              </a:tr>
+            </a:tbl>
+          </a:graphicData>
+        </a:graphic>
+      </p:graphicFrame>
+      <p:sp>
+        <p:nvSpPr>
+          <p:cNvPr id="25" name="Text 19"/>
+          <p:cNvSpPr txBox="1"/>
+          <p:nvPr/>
+        </p:nvSpPr>
+        <p:spPr>
+          <a:xfrm>
+            <a:off x="4370832" y="5010912"/>
+            <a:ext cx="3730752" cy="365760"/>
+          </a:xfrm>
+          <a:prstGeom prst="rect">
+            <a:avLst/>
+          </a:prstGeom>
+          <a:noFill/>
+          <a:ln/>
+        </p:spPr>
+        <p:txBody>
+          <a:bodyPr wrap="square" lIns="0" tIns="0" rIns="0" bIns="0" rtlCol="0" anchor="t"/>
+          <a:lstStyle/>
+          <a:p>
+            <a:pPr indent="0" marL="0">
+              <a:buNone/>
+            </a:pPr>
+            <a:r>
+              <a:rPr lang="en-US" sz="850" dirty="0">
+                <a:solidFill>
+                  <a:srgbClr val="595959"/>
+                </a:solidFill>
+                <a:latin typeface="Arial" pitchFamily="34" charset="0"/>
+                <a:ea typeface="Arial" pitchFamily="34" charset="-122"/>
+                <a:cs typeface="Arial" pitchFamily="34" charset="-120"/>
+              </a:rPr>
+              <a:t>The bond is steady but gives no AI exposure; the stocks lose money in 42% of paths; a plain protected note's median outcome is 0%.</a:t>
+            </a:r>
+            <a:endParaRPr lang="en-US" sz="850" dirty="0"/>
+          </a:p>
+        </p:txBody>
+      </p:sp>
+      <p:sp>
+        <p:nvSpPr>
+          <p:cNvPr id="26" name="Text 20"/>
+          <p:cNvSpPr txBox="1"/>
+          <p:nvPr/>
+        </p:nvSpPr>
+        <p:spPr>
+          <a:xfrm>
+            <a:off x="8211312" y="1280160"/>
+            <a:ext cx="3520440" cy="320040"/>
+          </a:xfrm>
+          <a:prstGeom prst="rect">
+            <a:avLst/>
+          </a:prstGeom>
+          <a:noFill/>
+          <a:ln/>
+        </p:spPr>
+        <p:txBody>
+          <a:bodyPr wrap="square" lIns="0" tIns="0" rIns="0" bIns="0" rtlCol="0" anchor="t"/>
+          <a:lstStyle/>
+          <a:p>
+            <a:pPr algn="ctr" indent="0" marL="0">
+              <a:buNone/>
+            </a:pPr>
+            <a:r>
+              <a:rPr lang="en-US" sz="1500" b="1" dirty="0">
+                <a:solidFill>
+                  <a:srgbClr val="262626"/>
+                </a:solidFill>
+                <a:latin typeface="Arial" pitchFamily="34" charset="0"/>
+                <a:ea typeface="Arial" pitchFamily="34" charset="-122"/>
+                <a:cs typeface="Arial" pitchFamily="34" charset="-120"/>
+              </a:rPr>
+              <a:t>Implications</a:t>
+            </a:r>
+            <a:endParaRPr lang="en-US" sz="1500" dirty="0"/>
+          </a:p>
+        </p:txBody>
+      </p:sp>
+      <p:sp>
+        <p:nvSpPr>
+          <p:cNvPr id="27" name="Shape 21"/>
+          <p:cNvSpPr/>
+          <p:nvPr/>
+        </p:nvSpPr>
+        <p:spPr>
+          <a:xfrm>
+            <a:off x="8485632" y="1627632"/>
+            <a:ext cx="2971800" cy="0"/>
+          </a:xfrm>
+          <a:prstGeom prst="line">
+            <a:avLst/>
+          </a:prstGeom>
+          <a:noFill/>
+          <a:ln w="9525">
+            <a:solidFill>
+              <a:srgbClr val="2C5F82"/>
+            </a:solidFill>
+            <a:prstDash val="solid"/>
+          </a:ln>
+        </p:spPr>
+      </p:sp>
+      <p:sp>
+        <p:nvSpPr>
+          <p:cNvPr id="28" name="Shape 22"/>
+          <p:cNvSpPr/>
+          <p:nvPr/>
+        </p:nvSpPr>
+        <p:spPr>
+          <a:xfrm>
+            <a:off x="8211312" y="1719072"/>
+            <a:ext cx="3520440" cy="658368"/>
+          </a:xfrm>
+          <a:prstGeom prst="rect">
+            <a:avLst/>
+          </a:prstGeom>
+          <a:solidFill>
+            <a:srgbClr val="FFFFFF"/>
+          </a:solidFill>
+          <a:ln w="12700">
+            <a:solidFill>
+              <a:srgbClr val="2C5F82"/>
+            </a:solidFill>
+            <a:prstDash val="solid"/>
+          </a:ln>
+        </p:spPr>
+      </p:sp>
+      <p:sp>
+        <p:nvSpPr>
+          <p:cNvPr id="29" name="Text 23"/>
+          <p:cNvSpPr txBox="1"/>
+          <p:nvPr/>
+        </p:nvSpPr>
+        <p:spPr>
+          <a:xfrm>
+            <a:off x="8257032" y="1719072"/>
+            <a:ext cx="411480" cy="658368"/>
+          </a:xfrm>
+          <a:prstGeom prst="rect">
+            <a:avLst/>
+          </a:prstGeom>
+          <a:noFill/>
+          <a:ln/>
+        </p:spPr>
+        <p:txBody>
+          <a:bodyPr wrap="square" lIns="0" tIns="0" rIns="0" bIns="0" rtlCol="0" anchor="ctr"/>
+          <a:lstStyle/>
+          <a:p>
+            <a:pPr algn="ctr" indent="0" marL="0">
+              <a:buNone/>
+            </a:pPr>
+            <a:r>
+              <a:rPr lang="en-US" sz="2200" b="1" i="1" dirty="0">
+                <a:solidFill>
+                  <a:srgbClr val="2C5F82"/>
+                </a:solidFill>
+                <a:latin typeface="Arial" pitchFamily="34" charset="0"/>
+                <a:ea typeface="Arial" pitchFamily="34" charset="-122"/>
+                <a:cs typeface="Arial" pitchFamily="34" charset="-120"/>
+              </a:rPr>
+              <a:t>1</a:t>
+            </a:r>
+            <a:endParaRPr lang="en-US" sz="2200" dirty="0"/>
+          </a:p>
+        </p:txBody>
+      </p:sp>
+      <p:sp>
+        <p:nvSpPr>
+          <p:cNvPr id="30" name="Text 24"/>
+          <p:cNvSpPr txBox="1"/>
+          <p:nvPr/>
+        </p:nvSpPr>
+        <p:spPr>
+          <a:xfrm>
+            <a:off x="8714232" y="1746504"/>
+            <a:ext cx="2926080" cy="603504"/>
+          </a:xfrm>
+          <a:prstGeom prst="rect">
+            <a:avLst/>
+          </a:prstGeom>
+          <a:noFill/>
+          <a:ln/>
+        </p:spPr>
+        <p:txBody>
+          <a:bodyPr wrap="square" lIns="0" tIns="0" rIns="0" bIns="0" rtlCol="0" anchor="ctr"/>
+          <a:lstStyle/>
+          <a:p>
+            <a:pPr indent="0" marL="0">
+              <a:buNone/>
+            </a:pPr>
+            <a:r>
+              <a:rPr lang="en-US" sz="900" b="1" dirty="0">
+                <a:solidFill>
+                  <a:srgbClr val="262626"/>
+                </a:solidFill>
+                <a:latin typeface="Arial" pitchFamily="34" charset="0"/>
+                <a:ea typeface="Arial" pitchFamily="34" charset="-122"/>
+                <a:cs typeface="Arial" pitchFamily="34" charset="-120"/>
+              </a:rPr>
+              <a:t>Lock in protection now: </a:t>
+            </a:r>
+            <a:pPr indent="0" marL="0">
+              <a:buNone/>
+            </a:pPr>
+            <a:r>
+              <a:rPr lang="en-US" sz="900" dirty="0">
+                <a:solidFill>
+                  <a:srgbClr val="595959"/>
+                </a:solidFill>
+                <a:latin typeface="Arial" pitchFamily="34" charset="0"/>
+                <a:ea typeface="Arial" pitchFamily="34" charset="-122"/>
+                <a:cs typeface="Arial" pitchFamily="34" charset="-120"/>
+              </a:rPr>
+              <a:t>High rates fund 100% capital protection; that window narrows as rates fall</a:t>
+            </a:r>
+            <a:endParaRPr lang="en-US" sz="900" dirty="0"/>
+          </a:p>
+        </p:txBody>
+      </p:sp>
+      <p:sp>
+        <p:nvSpPr>
+          <p:cNvPr id="31" name="Shape 25"/>
+          <p:cNvSpPr/>
+          <p:nvPr/>
+        </p:nvSpPr>
+        <p:spPr>
+          <a:xfrm>
+            <a:off x="8211312" y="2450592"/>
+            <a:ext cx="3520440" cy="658368"/>
+          </a:xfrm>
+          <a:prstGeom prst="rect">
+            <a:avLst/>
+          </a:prstGeom>
+          <a:solidFill>
+            <a:srgbClr val="FFFFFF"/>
+          </a:solidFill>
+          <a:ln w="12700">
+            <a:solidFill>
+              <a:srgbClr val="2C5F82"/>
+            </a:solidFill>
+            <a:prstDash val="solid"/>
+          </a:ln>
+        </p:spPr>
+      </p:sp>
+      <p:sp>
+        <p:nvSpPr>
+          <p:cNvPr id="32" name="Text 26"/>
+          <p:cNvSpPr txBox="1"/>
+          <p:nvPr/>
+        </p:nvSpPr>
+        <p:spPr>
+          <a:xfrm>
+            <a:off x="8257032" y="2450592"/>
+            <a:ext cx="411480" cy="658368"/>
+          </a:xfrm>
+          <a:prstGeom prst="rect">
+            <a:avLst/>
+          </a:prstGeom>
+          <a:noFill/>
+          <a:ln/>
+        </p:spPr>
+        <p:txBody>
+          <a:bodyPr wrap="square" lIns="0" tIns="0" rIns="0" bIns="0" rtlCol="0" anchor="ctr"/>
+          <a:lstStyle/>
+          <a:p>
+            <a:pPr algn="ctr" indent="0" marL="0">
+              <a:buNone/>
+            </a:pPr>
+            <a:r>
+              <a:rPr lang="en-US" sz="2200" b="1" i="1" dirty="0">
+                <a:solidFill>
+                  <a:srgbClr val="2C5F82"/>
+                </a:solidFill>
+                <a:latin typeface="Arial" pitchFamily="34" charset="0"/>
+                <a:ea typeface="Arial" pitchFamily="34" charset="-122"/>
+                <a:cs typeface="Arial" pitchFamily="34" charset="-120"/>
+              </a:rPr>
+              <a:t>2</a:t>
+            </a:r>
+            <a:endParaRPr lang="en-US" sz="2200" dirty="0"/>
+          </a:p>
+        </p:txBody>
+      </p:sp>
+      <p:sp>
+        <p:nvSpPr>
+          <p:cNvPr id="33" name="Text 27"/>
+          <p:cNvSpPr txBox="1"/>
+          <p:nvPr/>
+        </p:nvSpPr>
+        <p:spPr>
+          <a:xfrm>
+            <a:off x="8714232" y="2478024"/>
+            <a:ext cx="2926080" cy="603504"/>
+          </a:xfrm>
+          <a:prstGeom prst="rect">
+            <a:avLst/>
+          </a:prstGeom>
+          <a:noFill/>
+          <a:ln/>
+        </p:spPr>
+        <p:txBody>
+          <a:bodyPr wrap="square" lIns="0" tIns="0" rIns="0" bIns="0" rtlCol="0" anchor="ctr"/>
+          <a:lstStyle/>
+          <a:p>
+            <a:pPr indent="0" marL="0">
+              <a:buNone/>
+            </a:pPr>
+            <a:r>
+              <a:rPr lang="en-US" sz="900" b="1" dirty="0">
+                <a:solidFill>
+                  <a:srgbClr val="262626"/>
+                </a:solidFill>
+                <a:latin typeface="Arial" pitchFamily="34" charset="0"/>
+                <a:ea typeface="Arial" pitchFamily="34" charset="-122"/>
+                <a:cs typeface="Arial" pitchFamily="34" charset="-120"/>
+              </a:rPr>
+              <a:t>Volatility becomes income: </a:t>
+            </a:r>
+            <a:pPr indent="0" marL="0">
+              <a:buNone/>
+            </a:pPr>
+            <a:r>
+              <a:rPr lang="en-US" sz="900" dirty="0">
+                <a:solidFill>
+                  <a:srgbClr val="595959"/>
+                </a:solidFill>
+                <a:latin typeface="Arial" pitchFamily="34" charset="0"/>
+                <a:ea typeface="Arial" pitchFamily="34" charset="-122"/>
+                <a:cs typeface="Arial" pitchFamily="34" charset="-120"/>
+              </a:rPr>
+              <a:t>It raises the chance of touching 100%: fair coupon 7.1%, 7.5% if vol rises 3pts</a:t>
+            </a:r>
+            <a:endParaRPr lang="en-US" sz="900" dirty="0"/>
+          </a:p>
+        </p:txBody>
+      </p:sp>
+      <p:sp>
+        <p:nvSpPr>
+          <p:cNvPr id="34" name="Shape 28"/>
+          <p:cNvSpPr/>
+          <p:nvPr/>
+        </p:nvSpPr>
+        <p:spPr>
+          <a:xfrm>
+            <a:off x="8211312" y="3182112"/>
+            <a:ext cx="3520440" cy="658368"/>
+          </a:xfrm>
+          <a:prstGeom prst="rect">
+            <a:avLst/>
+          </a:prstGeom>
+          <a:solidFill>
+            <a:srgbClr val="FFFFFF"/>
+          </a:solidFill>
+          <a:ln w="12700">
+            <a:solidFill>
+              <a:srgbClr val="2C5F82"/>
+            </a:solidFill>
+            <a:prstDash val="solid"/>
+          </a:ln>
+        </p:spPr>
+      </p:sp>
+      <p:sp>
+        <p:nvSpPr>
+          <p:cNvPr id="35" name="Text 29"/>
+          <p:cNvSpPr txBox="1"/>
+          <p:nvPr/>
+        </p:nvSpPr>
+        <p:spPr>
+          <a:xfrm>
+            <a:off x="8257032" y="3182112"/>
+            <a:ext cx="411480" cy="658368"/>
+          </a:xfrm>
+          <a:prstGeom prst="rect">
+            <a:avLst/>
+          </a:prstGeom>
+          <a:noFill/>
+          <a:ln/>
+        </p:spPr>
+        <p:txBody>
+          <a:bodyPr wrap="square" lIns="0" tIns="0" rIns="0" bIns="0" rtlCol="0" anchor="ctr"/>
+          <a:lstStyle/>
+          <a:p>
+            <a:pPr algn="ctr" indent="0" marL="0">
+              <a:buNone/>
+            </a:pPr>
+            <a:r>
+              <a:rPr lang="en-US" sz="2200" b="1" i="1" dirty="0">
+                <a:solidFill>
+                  <a:srgbClr val="2C5F82"/>
+                </a:solidFill>
+                <a:latin typeface="Arial" pitchFamily="34" charset="0"/>
+                <a:ea typeface="Arial" pitchFamily="34" charset="-122"/>
+                <a:cs typeface="Arial" pitchFamily="34" charset="-120"/>
+              </a:rPr>
+              <a:t>3</a:t>
+            </a:r>
+            <a:endParaRPr lang="en-US" sz="2200" dirty="0"/>
+          </a:p>
+        </p:txBody>
+      </p:sp>
+      <p:sp>
+        <p:nvSpPr>
+          <p:cNvPr id="36" name="Text 30"/>
+          <p:cNvSpPr txBox="1"/>
+          <p:nvPr/>
+        </p:nvSpPr>
+        <p:spPr>
+          <a:xfrm>
+            <a:off x="8714232" y="3209544"/>
+            <a:ext cx="2926080" cy="603504"/>
+          </a:xfrm>
+          <a:prstGeom prst="rect">
+            <a:avLst/>
+          </a:prstGeom>
+          <a:noFill/>
+          <a:ln/>
+        </p:spPr>
+        <p:txBody>
+          <a:bodyPr wrap="square" lIns="0" tIns="0" rIns="0" bIns="0" rtlCol="0" anchor="ctr"/>
+          <a:lstStyle/>
+          <a:p>
+            <a:pPr indent="0" marL="0">
+              <a:buNone/>
+            </a:pPr>
+            <a:r>
+              <a:rPr lang="en-US" sz="900" b="1" dirty="0">
+                <a:solidFill>
+                  <a:srgbClr val="262626"/>
+                </a:solidFill>
+                <a:latin typeface="Arial" pitchFamily="34" charset="0"/>
+                <a:ea typeface="Arial" pitchFamily="34" charset="-122"/>
+                <a:cs typeface="Arial" pitchFamily="34" charset="-120"/>
+              </a:rPr>
+              <a:t>Pays without a rally: </a:t>
+            </a:r>
+            <a:pPr indent="0" marL="0">
+              <a:buNone/>
+            </a:pPr>
+            <a:r>
+              <a:rPr lang="en-US" sz="900" dirty="0">
+                <a:solidFill>
+                  <a:srgbClr val="595959"/>
+                </a:solidFill>
+                <a:latin typeface="Arial" pitchFamily="34" charset="0"/>
+                <a:ea typeface="Arial" pitchFamily="34" charset="-122"/>
+                <a:cs typeface="Arial" pitchFamily="34" charset="-120"/>
+              </a:rPr>
+              <a:t>6.2% p.a. vs 2.0% for the stocks when the basket goes sideways</a:t>
+            </a:r>
+            <a:endParaRPr lang="en-US" sz="900" dirty="0"/>
+          </a:p>
+        </p:txBody>
+      </p:sp>
+      <p:sp>
+        <p:nvSpPr>
+          <p:cNvPr id="37" name="Shape 31"/>
+          <p:cNvSpPr/>
+          <p:nvPr/>
+        </p:nvSpPr>
+        <p:spPr>
+          <a:xfrm>
+            <a:off x="8211312" y="3913632"/>
+            <a:ext cx="3520440" cy="658368"/>
+          </a:xfrm>
+          <a:prstGeom prst="rect">
+            <a:avLst/>
+          </a:prstGeom>
+          <a:solidFill>
+            <a:srgbClr val="FFFFFF"/>
+          </a:solidFill>
+          <a:ln w="12700">
+            <a:solidFill>
+              <a:srgbClr val="2C5F82"/>
+            </a:solidFill>
+            <a:prstDash val="solid"/>
+          </a:ln>
+        </p:spPr>
+      </p:sp>
+      <p:sp>
+        <p:nvSpPr>
+          <p:cNvPr id="38" name="Text 32"/>
+          <p:cNvSpPr txBox="1"/>
+          <p:nvPr/>
+        </p:nvSpPr>
+        <p:spPr>
+          <a:xfrm>
+            <a:off x="8257032" y="3913632"/>
+            <a:ext cx="411480" cy="658368"/>
+          </a:xfrm>
+          <a:prstGeom prst="rect">
+            <a:avLst/>
+          </a:prstGeom>
+          <a:noFill/>
+          <a:ln/>
+        </p:spPr>
+        <p:txBody>
+          <a:bodyPr wrap="square" lIns="0" tIns="0" rIns="0" bIns="0" rtlCol="0" anchor="ctr"/>
+          <a:lstStyle/>
+          <a:p>
+            <a:pPr algn="ctr" indent="0" marL="0">
+              <a:buNone/>
+            </a:pPr>
+            <a:r>
+              <a:rPr lang="en-US" sz="2200" b="1" i="1" dirty="0">
+                <a:solidFill>
+                  <a:srgbClr val="2C5F82"/>
+                </a:solidFill>
+                <a:latin typeface="Arial" pitchFamily="34" charset="0"/>
+                <a:ea typeface="Arial" pitchFamily="34" charset="-122"/>
+                <a:cs typeface="Arial" pitchFamily="34" charset="-120"/>
+              </a:rPr>
+              <a:t>4</a:t>
+            </a:r>
+            <a:endParaRPr lang="en-US" sz="2200" dirty="0"/>
+          </a:p>
+        </p:txBody>
+      </p:sp>
+      <p:sp>
+        <p:nvSpPr>
+          <p:cNvPr id="39" name="Text 33"/>
+          <p:cNvSpPr txBox="1"/>
+          <p:nvPr/>
+        </p:nvSpPr>
+        <p:spPr>
+          <a:xfrm>
+            <a:off x="8714232" y="3941064"/>
+            <a:ext cx="2926080" cy="603504"/>
+          </a:xfrm>
+          <a:prstGeom prst="rect">
+            <a:avLst/>
+          </a:prstGeom>
+          <a:noFill/>
+          <a:ln/>
+        </p:spPr>
+        <p:txBody>
+          <a:bodyPr wrap="square" lIns="0" tIns="0" rIns="0" bIns="0" rtlCol="0" anchor="ctr"/>
+          <a:lstStyle/>
+          <a:p>
+            <a:pPr indent="0" marL="0">
+              <a:buNone/>
+            </a:pPr>
+            <a:r>
+              <a:rPr lang="en-US" sz="900" b="1" dirty="0">
+                <a:solidFill>
+                  <a:srgbClr val="262626"/>
+                </a:solidFill>
+                <a:latin typeface="Arial" pitchFamily="34" charset="0"/>
+                <a:ea typeface="Arial" pitchFamily="34" charset="-122"/>
+                <a:cs typeface="Arial" pitchFamily="34" charset="-120"/>
+              </a:rPr>
+              <a:t>Early exit built in: </a:t>
+            </a:r>
+            <a:pPr indent="0" marL="0">
+              <a:buNone/>
+            </a:pPr>
+            <a:r>
+              <a:rPr lang="en-US" sz="900" dirty="0">
+                <a:solidFill>
+                  <a:srgbClr val="595959"/>
+                </a:solidFill>
+                <a:latin typeface="Arial" pitchFamily="34" charset="0"/>
+                <a:ea typeface="Arial" pitchFamily="34" charset="-122"/>
+                <a:cs typeface="Arial" pitchFamily="34" charset="-120"/>
+              </a:rPr>
+              <a:t>51% called at year 1 and 82% within 5 years: capital recycled, missed coupons caught up</a:t>
+            </a:r>
+            <a:endParaRPr lang="en-US" sz="900" dirty="0"/>
+          </a:p>
+        </p:txBody>
+      </p:sp>
+      <p:sp>
+        <p:nvSpPr>
+          <p:cNvPr id="40" name="Shape 34"/>
+          <p:cNvSpPr/>
+          <p:nvPr/>
+        </p:nvSpPr>
+        <p:spPr>
+          <a:xfrm>
+            <a:off x="8211312" y="4645152"/>
+            <a:ext cx="3520440" cy="658368"/>
+          </a:xfrm>
+          <a:prstGeom prst="rect">
+            <a:avLst/>
+          </a:prstGeom>
+          <a:solidFill>
+            <a:srgbClr val="FFFFFF"/>
+          </a:solidFill>
+          <a:ln w="12700">
+            <a:solidFill>
+              <a:srgbClr val="2C5F82"/>
+            </a:solidFill>
+            <a:prstDash val="solid"/>
+          </a:ln>
+        </p:spPr>
+      </p:sp>
+      <p:sp>
+        <p:nvSpPr>
+          <p:cNvPr id="41" name="Text 35"/>
+          <p:cNvSpPr txBox="1"/>
+          <p:nvPr/>
+        </p:nvSpPr>
+        <p:spPr>
+          <a:xfrm>
+            <a:off x="8257032" y="4645152"/>
+            <a:ext cx="411480" cy="658368"/>
+          </a:xfrm>
+          <a:prstGeom prst="rect">
+            <a:avLst/>
+          </a:prstGeom>
+          <a:noFill/>
+          <a:ln/>
+        </p:spPr>
+        <p:txBody>
+          <a:bodyPr wrap="square" lIns="0" tIns="0" rIns="0" bIns="0" rtlCol="0" anchor="ctr"/>
+          <a:lstStyle/>
+          <a:p>
+            <a:pPr algn="ctr" indent="0" marL="0">
+              <a:buNone/>
+            </a:pPr>
+            <a:r>
+              <a:rPr lang="en-US" sz="2200" b="1" i="1" dirty="0">
+                <a:solidFill>
+                  <a:srgbClr val="2C5F82"/>
+                </a:solidFill>
+                <a:latin typeface="Arial" pitchFamily="34" charset="0"/>
+                <a:ea typeface="Arial" pitchFamily="34" charset="-122"/>
+                <a:cs typeface="Arial" pitchFamily="34" charset="-120"/>
+              </a:rPr>
+              <a:t>5</a:t>
+            </a:r>
+            <a:endParaRPr lang="en-US" sz="2200" dirty="0"/>
+          </a:p>
+        </p:txBody>
+      </p:sp>
+      <p:sp>
+        <p:nvSpPr>
+          <p:cNvPr id="42" name="Text 36"/>
+          <p:cNvSpPr txBox="1"/>
+          <p:nvPr/>
+        </p:nvSpPr>
+        <p:spPr>
+          <a:xfrm>
+            <a:off x="8714232" y="4672584"/>
+            <a:ext cx="2926080" cy="603504"/>
+          </a:xfrm>
+          <a:prstGeom prst="rect">
+            <a:avLst/>
+          </a:prstGeom>
+          <a:noFill/>
+          <a:ln/>
+        </p:spPr>
+        <p:txBody>
+          <a:bodyPr wrap="square" lIns="0" tIns="0" rIns="0" bIns="0" rtlCol="0" anchor="ctr"/>
+          <a:lstStyle/>
+          <a:p>
+            <a:pPr indent="0" marL="0">
+              <a:buNone/>
+            </a:pPr>
+            <a:r>
+              <a:rPr lang="en-US" sz="900" b="1" dirty="0">
+                <a:solidFill>
+                  <a:srgbClr val="262626"/>
+                </a:solidFill>
+                <a:latin typeface="Arial" pitchFamily="34" charset="0"/>
+                <a:ea typeface="Arial" pitchFamily="34" charset="-122"/>
+                <a:cs typeface="Arial" pitchFamily="34" charset="-120"/>
+              </a:rPr>
+              <a:t>Proven in Asia: </a:t>
+            </a:r>
+            <a:pPr indent="0" marL="0">
+              <a:buNone/>
+            </a:pPr>
+            <a:r>
+              <a:rPr lang="en-US" sz="900" dirty="0">
+                <a:solidFill>
+                  <a:srgbClr val="595959"/>
+                </a:solidFill>
+                <a:latin typeface="Arial" pitchFamily="34" charset="0"/>
+                <a:ea typeface="Arial" pitchFamily="34" charset="-122"/>
+                <a:cs typeface="Arial" pitchFamily="34" charset="-120"/>
+              </a:rPr>
+              <a:t>Taiwan structured-note issuance +81% in 2025; snowball autocalls the favourite payoff (SRP)</a:t>
+            </a:r>
+            <a:endParaRPr lang="en-US" sz="900" dirty="0"/>
+          </a:p>
+        </p:txBody>
+      </p:sp>
+      <p:sp>
+        <p:nvSpPr>
+          <p:cNvPr id="43" name="Shape 37"/>
+          <p:cNvSpPr/>
+          <p:nvPr/>
+        </p:nvSpPr>
+        <p:spPr>
+          <a:xfrm>
+            <a:off x="457200" y="5486400"/>
+            <a:ext cx="11274552" cy="438912"/>
+          </a:xfrm>
+          <a:prstGeom prst="rect">
+            <a:avLst/>
+          </a:prstGeom>
+          <a:solidFill>
+            <a:srgbClr val="2C5F82"/>
+          </a:solidFill>
+          <a:ln w="12700">
+            <a:solidFill>
+              <a:srgbClr val="2C5F82"/>
+            </a:solidFill>
+            <a:prstDash val="solid"/>
+          </a:ln>
+        </p:spPr>
+      </p:sp>
+      <p:sp>
+        <p:nvSpPr>
+          <p:cNvPr id="44" name="Text 38"/>
+          <p:cNvSpPr txBox="1"/>
+          <p:nvPr/>
+        </p:nvSpPr>
+        <p:spPr>
+          <a:xfrm>
+            <a:off x="594360" y="5486400"/>
+            <a:ext cx="11000232" cy="438912"/>
+          </a:xfrm>
+          <a:prstGeom prst="rect">
+            <a:avLst/>
+          </a:prstGeom>
+          <a:noFill/>
+          <a:ln/>
+        </p:spPr>
+        <p:txBody>
+          <a:bodyPr wrap="square" lIns="0" tIns="0" rIns="0" bIns="0" rtlCol="0" anchor="ctr"/>
+          <a:lstStyle/>
+          <a:p>
+            <a:pPr algn="ctr" indent="0" marL="0">
+              <a:buNone/>
+            </a:pPr>
+            <a:r>
+              <a:rPr lang="en-US" sz="1250" b="1" dirty="0">
+                <a:solidFill>
+                  <a:srgbClr val="FFFFFF"/>
+                </a:solidFill>
+                <a:latin typeface="Arial" pitchFamily="34" charset="0"/>
+                <a:ea typeface="Arial" pitchFamily="34" charset="-122"/>
+                <a:cs typeface="Arial" pitchFamily="34" charset="-120"/>
+              </a:rPr>
+              <a:t>Result: 6.75% a year whenever the basket is back at its start, 100% of capital at maturity, money back in ~2.1 years on average.</a:t>
+            </a:r>
+            <a:endParaRPr lang="en-US" sz="1250" dirty="0"/>
+          </a:p>
+        </p:txBody>
+      </p:sp>
+      <p:sp>
+        <p:nvSpPr>
+          <p:cNvPr id="45" name="Text 39"/>
+          <p:cNvSpPr txBox="1"/>
+          <p:nvPr/>
+        </p:nvSpPr>
+        <p:spPr>
+          <a:xfrm>
+            <a:off x="457200" y="5998464"/>
+            <a:ext cx="11274552" cy="274320"/>
+          </a:xfrm>
+          <a:prstGeom prst="rect">
+            <a:avLst/>
+          </a:prstGeom>
+          <a:noFill/>
+          <a:ln/>
+        </p:spPr>
+        <p:txBody>
+          <a:bodyPr wrap="square" lIns="0" tIns="0" rIns="0" bIns="0" rtlCol="0" anchor="t"/>
+          <a:lstStyle/>
+          <a:p>
+            <a:pPr indent="0" marL="0">
+              <a:buNone/>
+            </a:pPr>
+            <a:r>
+              <a:rPr lang="en-US" sz="800" i="1" dirty="0">
+                <a:solidFill>
+                  <a:srgbClr val="595959"/>
+                </a:solidFill>
+                <a:latin typeface="Arial" pitchFamily="34" charset="0"/>
+                <a:ea typeface="Arial" pitchFamily="34" charset="-122"/>
+                <a:cs typeface="Arial" pitchFamily="34" charset="-120"/>
+              </a:rPr>
+              <a:t>Sources: case funding grid; TWSE, Korea Times, Bloomberg/BNN (2022); BIT Research (KOSPI 2026, single source); StructuredRetailProducts.com; team Monte Carlo (pricing/scenario2_vs_traditional.py, scenario2_autocall_mc.py).</a:t>
+            </a:r>
+            <a:endParaRPr lang="en-US" sz="800" dirty="0"/>
+          </a:p>
+        </p:txBody>
+      </p:sp>
+    </p:spTree>
+  </p:cSld>
+  <p:clrMapOvr>
+    <a:masterClrMapping/>
+  </p:clrMapOvr>
+</p:sld>
+</file>
+
+<file path=ppt/slides/slide4.xml><?xml version="1.0" encoding="utf-8"?>
+<p:sld xmlns:a="http://schemas.openxmlformats.org/drawingml/2006/main" xmlns:r="http://schemas.openxmlformats.org/officeDocument/2006/relationships" xmlns:p="http://schemas.openxmlformats.org/presentationml/2006/main">
+  <p:cSld name="Slide 4">
+    <p:bg>
+      <p:bgPr>
+        <a:solidFill>
+          <a:srgbClr val="FFFFFF"/>
+        </a:solidFill>
+      </p:bgPr>
+    </p:bg>
+    <p:spTree>
+      <p:nvGrpSpPr>
+        <p:cNvPr id="1" name=""/>
+        <p:cNvGrpSpPr/>
+        <p:nvPr/>
+      </p:nvGrpSpPr>
+      <p:grpSpPr>
+        <a:xfrm>
+          <a:off x="0" y="0"/>
+          <a:ext cx="0" cy="0"/>
+          <a:chOff x="0" y="0"/>
+          <a:chExt cx="0" cy="0"/>
+        </a:xfrm>
+      </p:grpSpPr>
+      <p:sp>
+        <p:nvSpPr>
+          <p:cNvPr id="2" name="Text 0"/>
+          <p:cNvSpPr txBox="1"/>
+          <p:nvPr/>
+        </p:nvSpPr>
+        <p:spPr>
+          <a:xfrm>
+            <a:off x="457200" y="274320"/>
+            <a:ext cx="11247120" cy="548640"/>
+          </a:xfrm>
+          <a:prstGeom prst="rect">
+            <a:avLst/>
+          </a:prstGeom>
+          <a:noFill/>
+          <a:ln/>
+        </p:spPr>
+        <p:txBody>
+          <a:bodyPr wrap="square" lIns="0" tIns="0" rIns="0" bIns="0" rtlCol="0" anchor="ctr"/>
+          <a:lstStyle/>
+          <a:p>
+            <a:pPr indent="0" marL="0">
+              <a:buNone/>
+            </a:pPr>
+            <a:r>
+              <a:rPr lang="en-US" sz="2400" dirty="0">
+                <a:solidFill>
+                  <a:srgbClr val="262626"/>
+                </a:solidFill>
+                <a:latin typeface="Arial" pitchFamily="34" charset="0"/>
+                <a:ea typeface="Arial" pitchFamily="34" charset="-122"/>
+                <a:cs typeface="Arial" pitchFamily="34" charset="-120"/>
+              </a:rPr>
               <a:t>Thesis 2 evidence: the protected autocall beats the usual ways to own this theme</a:t>
             </a:r>
             <a:endParaRPr lang="en-US" sz="2400" dirty="0"/>
@@ -6085,7 +10046,7 @@
       </p:sp>
       <p:graphicFrame>
         <p:nvGraphicFramePr>
-          <p:cNvPr id="4" name="Table 0"/>
+          <p:cNvPr id="5" name="Table 0"/>
           <p:cNvGraphicFramePr>
             <a:graphicFrameLocks noGrp="1"/>
           </p:cNvGraphicFramePr>
@@ -8088,9 +12049,9 @@
 </p:sld>
 </file>
 
-<file path=ppt/slides/slide4.xml><?xml version="1.0" encoding="utf-8"?>
+<file path=ppt/slides/slide5.xml><?xml version="1.0" encoding="utf-8"?>
 <p:sld xmlns:a="http://schemas.openxmlformats.org/drawingml/2006/main" xmlns:r="http://schemas.openxmlformats.org/officeDocument/2006/relationships" xmlns:p="http://schemas.openxmlformats.org/presentationml/2006/main">
-  <p:cSld name="Slide 4">
+  <p:cSld name="Slide 5">
     <p:bg>
       <p:bgPr>
         <a:solidFill>
@@ -8341,7 +12302,7 @@
       </p:sp>
       <p:graphicFrame>
         <p:nvGraphicFramePr>
-          <p:cNvPr id="5" name="Table 0"/>
+          <p:cNvPr id="6" name="Table 0"/>
           <p:cNvGraphicFramePr>
             <a:graphicFrameLocks noGrp="1"/>
           </p:cNvGraphicFramePr>

</xml_diff>

<commit_message>
Thesis slides: link every market finding to why autocallables fit
Evidence stays market-only, but each thesis-2 point now ends with its
autocall implication (paid on recovery, diversified basket, cheap capped
upside, short duration, volatility-funded coupons, affordable protection).
The one-slide version is retitled 'traditional strategies fall short;
autocallables fit 2026', with SRP issuance data as market proof. Thesis 1
and the J.P. Morgan slide now point to the structure.

Co-Authored-By: Claude Opus 5.5 <noreply@anthropic.com>
Claude-Session: https://claude.ai/code/session_01Rwoh8cFDQqLD8JWT3mee6y
</commit_message>
<xml_diff>
--- a/deck/Investment-Thesis-Slides.pptx
+++ b/deck/Investment-Thesis-Slides.pptx
@@ -4819,7 +4819,7 @@
           <a:p>
             <a:r>
               <a:rPr lang="en-US" dirty="0"/>
-              <a:t>Thesis 2, market evidence only. Economic: AI-hardware demand is structural, but the equity path is violent (2022 falls, 2026 round trips), concentrated in a handful of names, and valuations already assume a lot while memory price momentum slows. Finance: the Fed is hiking again, so long bonds carry real rate risk; volatility is at record highs; and high rates make guaranteeing future capital unusually cheap. Implication for any investor: the theme is attractive, but how you hold it matters as much as whether you hold it.</a:t>
+              <a:t>Thesis 2, market evidence only. Economic: AI-hardware demand is structural, but the equity path is violent (2022 falls, 2026 round trips), concentrated in a handful of names, and valuations already assume a lot while memory price momentum slows. Finance: the Fed is hiking again, so long bonds carry real rate risk; volatility is at record highs; and high rates make guaranteeing future capital unusually cheap. Each point ends with the autocall link: coupons paid on recovery (not timing), a diversified basket, capped upside that costs little, short duration, coupons funded by volatility, and protection funded by high rates.</a:t>
             </a:r>
             <a:endParaRPr lang="en-US" dirty="0"/>
           </a:p>
@@ -4907,7 +4907,7 @@
           <a:p>
             <a:r>
               <a:rPr lang="en-US" dirty="0"/>
-              <a:t>One-slide thesis 2, modelled on the 'traditional strategies fall short' format, using market evidence only: rising rates (bond duration risk), violent equity paths, concentration, record volatility and a late, richly priced cycle. No reference to our product here; the product section answers these implications.</a:t>
+              <a:t>One-slide thesis 2, modelled on the 'traditional strategies fall short' format, using market evidence only: rising rates (bond duration risk), violent equity paths, concentration, record volatility and a late, richly priced cycle. Implications link each market fact to why an autocallable structure fits; our specific note and its numbers come in the product section.</a:t>
             </a:r>
             <a:endParaRPr lang="en-US" dirty="0"/>
           </a:p>
@@ -6711,7 +6711,7 @@
                 <a:ea typeface="Arial" pitchFamily="34" charset="-122"/>
                 <a:cs typeface="Arial" pitchFamily="34" charset="-120"/>
               </a:rPr>
-              <a:t>Structural demand, cyclical prices: the theme and its risks come together</a:t>
+              <a:t>Structural demand, cyclical prices: own it through a structure built for volatility (thesis 2)</a:t>
             </a:r>
             <a:endParaRPr lang="en-US" sz="850" dirty="0"/>
           </a:p>
@@ -7993,7 +7993,7 @@
                 <a:ea typeface="Arial" pitchFamily="34" charset="-122"/>
                 <a:cs typeface="Arial" pitchFamily="34" charset="-120"/>
               </a:rPr>
-              <a:t>J.P. Morgan's view: the AI moat drives the market, but concentration, Taiwan and capex payback are the key risks for 2026.</a:t>
+              <a:t>J.P. Morgan's key risks (concentration, Taiwan, a 10–15% correction) are what a capital-protected autocall is built to absorb.</a:t>
             </a:r>
             <a:endParaRPr lang="en-US" sz="1250" dirty="0"/>
           </a:p>
@@ -8064,7 +8064,7 @@
                 <a:ea typeface="Arial" pitchFamily="34" charset="-122"/>
                 <a:cs typeface="Arial" pitchFamily="34" charset="-120"/>
               </a:rPr>
-              <a:t>Investment thesis 2: A strong theme on a fragile path</a:t>
+              <a:t>Investment thesis 2: Volatile markets and high rates favour autocallables</a:t>
             </a:r>
             <a:endParaRPr lang="en-US" sz="2400" dirty="0"/>
           </a:p>
@@ -8316,7 +8316,7 @@
                 <a:ea typeface="Arial" pitchFamily="34" charset="-122"/>
                 <a:cs typeface="Arial" pitchFamily="34" charset="-120"/>
               </a:rPr>
-              <a:t>Economic aspect: growth is structural, the path is not</a:t>
+              <a:t>Economic aspect: a strong theme on a volatile path</a:t>
             </a:r>
             <a:endParaRPr lang="en-US" sz="1400" dirty="0"/>
           </a:p>
@@ -8355,7 +8355,7 @@
                 <a:ea typeface="Arial" pitchFamily="34" charset="-122"/>
                 <a:cs typeface="Arial" pitchFamily="34" charset="-120"/>
               </a:rPr>
-              <a:t>A violent, concentrated and late-cycle equity market</a:t>
+              <a:t>Structural growth, but a violent, concentrated and late-cycle equity market</a:t>
             </a:r>
             <a:endParaRPr lang="en-US" sz="1050" dirty="0"/>
           </a:p>
@@ -8615,7 +8615,7 @@
         </p:nvSpPr>
         <p:spPr>
           <a:xfrm>
-            <a:off x="2148840" y="3520440"/>
+            <a:off x="2148840" y="3511296"/>
             <a:ext cx="3703320" cy="731520"/>
           </a:xfrm>
           <a:prstGeom prst="rect">
@@ -8629,10 +8629,13 @@
           <a:lstStyle/>
           <a:p>
             <a:pPr indent="0" marL="0">
+              <a:spcAft>
+                <a:spcPts val="100"/>
+              </a:spcAft>
               <a:buNone/>
             </a:pPr>
             <a:r>
-              <a:rPr lang="en-US" sz="930" b="1" dirty="0">
+              <a:rPr lang="en-US" sz="880" b="1" dirty="0">
                 <a:solidFill>
                   <a:srgbClr val="262626"/>
                 </a:solidFill>
@@ -8640,16 +8643,16 @@
                 <a:ea typeface="Arial" pitchFamily="34" charset="-122"/>
                 <a:cs typeface="Arial" pitchFamily="34" charset="-120"/>
               </a:rPr>
-              <a:t>Round trips happen fast</a:t>
-            </a:r>
-            <a:endParaRPr lang="en-US" sz="930" dirty="0"/>
-          </a:p>
-          <a:p>
+              <a:t>Round trips happen fast: </a:t>
+            </a:r>
             <a:pPr indent="0" marL="0">
+              <a:spcAft>
+                <a:spcPts val="100"/>
+              </a:spcAft>
               <a:buNone/>
             </a:pPr>
             <a:r>
-              <a:rPr lang="en-US" sz="930" dirty="0">
+              <a:rPr lang="en-US" sz="880" dirty="0">
                 <a:solidFill>
                   <a:srgbClr val="595959"/>
                 </a:solidFill>
@@ -8657,9 +8660,29 @@
                 <a:ea typeface="Arial" pitchFamily="34" charset="-122"/>
                 <a:cs typeface="Arial" pitchFamily="34" charset="-120"/>
               </a:rPr>
-              <a:t>KOSPI hit 9,000+ in June (~+110% YTD), then 6,789 on 28 Aug: about −25% in ten weeks. J.P. Morgan's 2026 base case includes a 10–15% correction.</a:t>
-            </a:r>
-            <a:endParaRPr lang="en-US" sz="930" dirty="0"/>
+              <a:t>KOSPI went from 9,000+ in June to 6,789 on 28 Aug; J.P. Morgan expects a 10–15% correction in 2026.</a:t>
+            </a:r>
+            <a:endParaRPr lang="en-US" sz="880" dirty="0"/>
+          </a:p>
+          <a:p>
+            <a:pPr indent="0" marL="0">
+              <a:spcAft>
+                <a:spcPts val="100"/>
+              </a:spcAft>
+              <a:buNone/>
+            </a:pPr>
+            <a:r>
+              <a:rPr lang="en-US" sz="880" b="1" dirty="0">
+                <a:solidFill>
+                  <a:srgbClr val="2C5F82"/>
+                </a:solidFill>
+                <a:latin typeface="Arial" pitchFamily="34" charset="0"/>
+                <a:ea typeface="Arial" pitchFamily="34" charset="-122"/>
+                <a:cs typeface="Arial" pitchFamily="34" charset="-120"/>
+              </a:rPr>
+              <a:t>→ Autocall coupons are paid when the basket gets back to its start: no need to time the bottom</a:t>
+            </a:r>
+            <a:endParaRPr lang="en-US" sz="880" dirty="0"/>
           </a:p>
         </p:txBody>
       </p:sp>
@@ -8799,7 +8822,7 @@
         </p:nvSpPr>
         <p:spPr>
           <a:xfrm>
-            <a:off x="2148840" y="4306824"/>
+            <a:off x="2148840" y="4297680"/>
             <a:ext cx="3703320" cy="731520"/>
           </a:xfrm>
           <a:prstGeom prst="rect">
@@ -8813,10 +8836,13 @@
           <a:lstStyle/>
           <a:p>
             <a:pPr indent="0" marL="0">
+              <a:spcAft>
+                <a:spcPts val="100"/>
+              </a:spcAft>
               <a:buNone/>
             </a:pPr>
             <a:r>
-              <a:rPr lang="en-US" sz="930" b="1" dirty="0">
+              <a:rPr lang="en-US" sz="880" b="1" dirty="0">
                 <a:solidFill>
                   <a:srgbClr val="262626"/>
                 </a:solidFill>
@@ -8824,16 +8850,16 @@
                 <a:ea typeface="Arial" pitchFamily="34" charset="-122"/>
                 <a:cs typeface="Arial" pitchFamily="34" charset="-120"/>
               </a:rPr>
-              <a:t>Returns hinge on a few names</a:t>
-            </a:r>
-            <a:endParaRPr lang="en-US" sz="930" dirty="0"/>
-          </a:p>
-          <a:p>
+              <a:t>Returns hinge on a few names: </a:t>
+            </a:r>
             <a:pPr indent="0" marL="0">
+              <a:spcAft>
+                <a:spcPts val="100"/>
+              </a:spcAft>
               <a:buNone/>
             </a:pPr>
             <a:r>
-              <a:rPr lang="en-US" sz="930" dirty="0">
+              <a:rPr lang="en-US" sz="880" dirty="0">
                 <a:solidFill>
                   <a:srgbClr val="595959"/>
                 </a:solidFill>
@@ -8841,9 +8867,29 @@
                 <a:ea typeface="Arial" pitchFamily="34" charset="-122"/>
                 <a:cs typeface="Arial" pitchFamily="34" charset="-120"/>
               </a:rPr>
-              <a:t>TSMC is &gt;40% of the TAIEX, Samsung + SK hynix ~48% of KOSPI, Advantest + TEL ~20% of the Nikkei. ~92% of advanced chips come from Taiwan.</a:t>
-            </a:r>
-            <a:endParaRPr lang="en-US" sz="930" dirty="0"/>
+              <a:t>TSMC &gt;40% of TAIEX; Samsung + SK hynix ~48% of KOSPI; ~92% of advanced chips from Taiwan.</a:t>
+            </a:r>
+            <a:endParaRPr lang="en-US" sz="880" dirty="0"/>
+          </a:p>
+          <a:p>
+            <a:pPr indent="0" marL="0">
+              <a:spcAft>
+                <a:spcPts val="100"/>
+              </a:spcAft>
+              <a:buNone/>
+            </a:pPr>
+            <a:r>
+              <a:rPr lang="en-US" sz="880" b="1" dirty="0">
+                <a:solidFill>
+                  <a:srgbClr val="2C5F82"/>
+                </a:solidFill>
+                <a:latin typeface="Arial" pitchFamily="34" charset="0"/>
+                <a:ea typeface="Arial" pitchFamily="34" charset="-122"/>
+                <a:cs typeface="Arial" pitchFamily="34" charset="-120"/>
+              </a:rPr>
+              <a:t>→ Use a diversified index basket, not a worst-of on single names</a:t>
+            </a:r>
+            <a:endParaRPr lang="en-US" sz="880" dirty="0"/>
           </a:p>
         </p:txBody>
       </p:sp>
@@ -8983,7 +9029,7 @@
         </p:nvSpPr>
         <p:spPr>
           <a:xfrm>
-            <a:off x="2148840" y="5093208"/>
+            <a:off x="2148840" y="5084064"/>
             <a:ext cx="3703320" cy="731520"/>
           </a:xfrm>
           <a:prstGeom prst="rect">
@@ -8997,10 +9043,13 @@
           <a:lstStyle/>
           <a:p>
             <a:pPr indent="0" marL="0">
+              <a:spcAft>
+                <a:spcPts val="100"/>
+              </a:spcAft>
               <a:buNone/>
             </a:pPr>
             <a:r>
-              <a:rPr lang="en-US" sz="930" b="1" dirty="0">
+              <a:rPr lang="en-US" sz="880" b="1" dirty="0">
                 <a:solidFill>
                   <a:srgbClr val="262626"/>
                 </a:solidFill>
@@ -9008,16 +9057,16 @@
                 <a:ea typeface="Arial" pitchFamily="34" charset="-122"/>
                 <a:cs typeface="Arial" pitchFamily="34" charset="-120"/>
               </a:rPr>
-              <a:t>Valuations price in a lot</a:t>
-            </a:r>
-            <a:endParaRPr lang="en-US" sz="930" dirty="0"/>
-          </a:p>
-          <a:p>
+              <a:t>Valuations price in a lot: </a:t>
+            </a:r>
             <a:pPr indent="0" marL="0">
+              <a:spcAft>
+                <a:spcPts val="100"/>
+              </a:spcAft>
               <a:buNone/>
             </a:pPr>
             <a:r>
-              <a:rPr lang="en-US" sz="930" dirty="0">
+              <a:rPr lang="en-US" sz="880" dirty="0">
                 <a:solidFill>
                   <a:srgbClr val="595959"/>
                 </a:solidFill>
@@ -9025,9 +9074,29 @@
                 <a:ea typeface="Arial" pitchFamily="34" charset="-122"/>
                 <a:cs typeface="Arial" pitchFamily="34" charset="-120"/>
               </a:rPr>
-              <a:t>Nikkei CAPE 38.6×; Taiwan among the most expensive markets; KOSPI's 7.8× forward vs 23× trailing P/E assumes earnings triple, while DRAM price gains slow.</a:t>
-            </a:r>
-            <a:endParaRPr lang="en-US" sz="930" dirty="0"/>
+              <a:t>Nikkei CAPE 38.6×; Taiwan among the most expensive markets; DRAM price gains slowing.</a:t>
+            </a:r>
+            <a:endParaRPr lang="en-US" sz="880" dirty="0"/>
+          </a:p>
+          <a:p>
+            <a:pPr indent="0" marL="0">
+              <a:spcAft>
+                <a:spcPts val="100"/>
+              </a:spcAft>
+              <a:buNone/>
+            </a:pPr>
+            <a:r>
+              <a:rPr lang="en-US" sz="880" b="1" dirty="0">
+                <a:solidFill>
+                  <a:srgbClr val="2C5F82"/>
+                </a:solidFill>
+                <a:latin typeface="Arial" pitchFamily="34" charset="0"/>
+                <a:ea typeface="Arial" pitchFamily="34" charset="-122"/>
+                <a:cs typeface="Arial" pitchFamily="34" charset="-120"/>
+              </a:rPr>
+              <a:t>→ Capping upside at the coupon costs little when the good news is already priced</a:t>
+            </a:r>
+            <a:endParaRPr lang="en-US" sz="880" dirty="0"/>
           </a:p>
         </p:txBody>
       </p:sp>
@@ -9089,7 +9158,7 @@
                 <a:ea typeface="Arial" pitchFamily="34" charset="-122"/>
                 <a:cs typeface="Arial" pitchFamily="34" charset="-120"/>
               </a:rPr>
-              <a:t>Finance aspect: rates and volatility have changed</a:t>
+              <a:t>Finance aspect: today's rates and volatility suit autocalls</a:t>
             </a:r>
             <a:endParaRPr lang="en-US" sz="1400" dirty="0"/>
           </a:p>
@@ -9388,7 +9457,7 @@
         </p:nvSpPr>
         <p:spPr>
           <a:xfrm>
-            <a:off x="7936992" y="3520440"/>
+            <a:off x="7936992" y="3511296"/>
             <a:ext cx="3703320" cy="731520"/>
           </a:xfrm>
           <a:prstGeom prst="rect">
@@ -9402,10 +9471,13 @@
           <a:lstStyle/>
           <a:p>
             <a:pPr indent="0" marL="0">
+              <a:spcAft>
+                <a:spcPts val="100"/>
+              </a:spcAft>
               <a:buNone/>
             </a:pPr>
             <a:r>
-              <a:rPr lang="en-US" sz="930" b="1" dirty="0">
+              <a:rPr lang="en-US" sz="880" b="1" dirty="0">
                 <a:solidFill>
                   <a:srgbClr val="262626"/>
                 </a:solidFill>
@@ -9413,16 +9485,16 @@
                 <a:ea typeface="Arial" pitchFamily="34" charset="-122"/>
                 <a:cs typeface="Arial" pitchFamily="34" charset="-120"/>
               </a:rPr>
-              <a:t>Long bonds carry rate risk</a:t>
-            </a:r>
-            <a:endParaRPr lang="en-US" sz="930" dirty="0"/>
-          </a:p>
-          <a:p>
+              <a:t>Long bonds carry rate risk: </a:t>
+            </a:r>
             <a:pPr indent="0" marL="0">
+              <a:spcAft>
+                <a:spcPts val="100"/>
+              </a:spcAft>
               <a:buNone/>
             </a:pPr>
             <a:r>
-              <a:rPr lang="en-US" sz="930" dirty="0">
+              <a:rPr lang="en-US" sz="880" dirty="0">
                 <a:solidFill>
                   <a:srgbClr val="595959"/>
                 </a:solidFill>
@@ -9430,9 +9502,29 @@
                 <a:ea typeface="Arial" pitchFamily="34" charset="-122"/>
                 <a:cs typeface="Arial" pitchFamily="34" charset="-120"/>
               </a:rPr>
-              <a:t>A 5-year bond loses about 4.0% of its value for every 1% rise in rates, just as the Fed turns hawkish again.</a:t>
-            </a:r>
-            <a:endParaRPr lang="en-US" sz="930" dirty="0"/>
+              <a:t>A 5-year bond loses ~4.0% per 1% rate rise, as the Fed hikes again.</a:t>
+            </a:r>
+            <a:endParaRPr lang="en-US" sz="880" dirty="0"/>
+          </a:p>
+          <a:p>
+            <a:pPr indent="0" marL="0">
+              <a:spcAft>
+                <a:spcPts val="100"/>
+              </a:spcAft>
+              <a:buNone/>
+            </a:pPr>
+            <a:r>
+              <a:rPr lang="en-US" sz="880" b="1" dirty="0">
+                <a:solidFill>
+                  <a:srgbClr val="2C5F82"/>
+                </a:solidFill>
+                <a:latin typeface="Arial" pitchFamily="34" charset="0"/>
+                <a:ea typeface="Arial" pitchFamily="34" charset="-122"/>
+                <a:cs typeface="Arial" pitchFamily="34" charset="-120"/>
+              </a:rPr>
+              <a:t>→ Autocalls can redeem from year 1: short duration, and cash to reinvest at higher rates</a:t>
+            </a:r>
+            <a:endParaRPr lang="en-US" sz="880" dirty="0"/>
           </a:p>
         </p:txBody>
       </p:sp>
@@ -9572,7 +9664,7 @@
         </p:nvSpPr>
         <p:spPr>
           <a:xfrm>
-            <a:off x="7936992" y="4306824"/>
+            <a:off x="7936992" y="4297680"/>
             <a:ext cx="3703320" cy="731520"/>
           </a:xfrm>
           <a:prstGeom prst="rect">
@@ -9586,10 +9678,13 @@
           <a:lstStyle/>
           <a:p>
             <a:pPr indent="0" marL="0">
+              <a:spcAft>
+                <a:spcPts val="100"/>
+              </a:spcAft>
               <a:buNone/>
             </a:pPr>
             <a:r>
-              <a:rPr lang="en-US" sz="930" b="1" dirty="0">
+              <a:rPr lang="en-US" sz="880" b="1" dirty="0">
                 <a:solidFill>
                   <a:srgbClr val="262626"/>
                 </a:solidFill>
@@ -9597,16 +9692,16 @@
                 <a:ea typeface="Arial" pitchFamily="34" charset="-122"/>
                 <a:cs typeface="Arial" pitchFamily="34" charset="-120"/>
               </a:rPr>
-              <a:t>Volatility is at records</a:t>
-            </a:r>
-            <a:endParaRPr lang="en-US" sz="930" dirty="0"/>
-          </a:p>
-          <a:p>
+              <a:t>Volatility is at records: </a:t>
+            </a:r>
             <a:pPr indent="0" marL="0">
+              <a:spcAft>
+                <a:spcPts val="100"/>
+              </a:spcAft>
               <a:buNone/>
             </a:pPr>
             <a:r>
-              <a:rPr lang="en-US" sz="930" dirty="0">
+              <a:rPr lang="en-US" sz="880" dirty="0">
                 <a:solidFill>
                   <a:srgbClr val="595959"/>
                 </a:solidFill>
@@ -9614,9 +9709,29 @@
                 <a:ea typeface="Arial" pitchFamily="34" charset="-122"/>
                 <a:cs typeface="Arial" pitchFamily="34" charset="-120"/>
               </a:rPr>
-              <a:t>VKOSPI closed at an all-time high of 91.2 on 9 Jun 2026, above the 2008 crisis peak; Korea's circuit breakers fired three times in June.</a:t>
-            </a:r>
-            <a:endParaRPr lang="en-US" sz="930" dirty="0"/>
+              <a:t>VKOSPI closed at an all-time high of 91.2 (9 Jun 2026), above the 2008 peak.</a:t>
+            </a:r>
+            <a:endParaRPr lang="en-US" sz="880" dirty="0"/>
+          </a:p>
+          <a:p>
+            <a:pPr indent="0" marL="0">
+              <a:spcAft>
+                <a:spcPts val="100"/>
+              </a:spcAft>
+              <a:buNone/>
+            </a:pPr>
+            <a:r>
+              <a:rPr lang="en-US" sz="880" b="1" dirty="0">
+                <a:solidFill>
+                  <a:srgbClr val="2C5F82"/>
+                </a:solidFill>
+                <a:latin typeface="Arial" pitchFamily="34" charset="0"/>
+                <a:ea typeface="Arial" pitchFamily="34" charset="-122"/>
+                <a:cs typeface="Arial" pitchFamily="34" charset="-120"/>
+              </a:rPr>
+              <a:t>→ Rich option premium funds higher autocall coupons</a:t>
+            </a:r>
+            <a:endParaRPr lang="en-US" sz="880" dirty="0"/>
           </a:p>
         </p:txBody>
       </p:sp>
@@ -9756,7 +9871,7 @@
         </p:nvSpPr>
         <p:spPr>
           <a:xfrm>
-            <a:off x="7936992" y="5093208"/>
+            <a:off x="7936992" y="5084064"/>
             <a:ext cx="3703320" cy="731520"/>
           </a:xfrm>
           <a:prstGeom prst="rect">
@@ -9770,10 +9885,13 @@
           <a:lstStyle/>
           <a:p>
             <a:pPr indent="0" marL="0">
+              <a:spcAft>
+                <a:spcPts val="100"/>
+              </a:spcAft>
               <a:buNone/>
             </a:pPr>
             <a:r>
-              <a:rPr lang="en-US" sz="930" b="1" dirty="0">
+              <a:rPr lang="en-US" sz="880" b="1" dirty="0">
                 <a:solidFill>
                   <a:srgbClr val="262626"/>
                 </a:solidFill>
@@ -9781,16 +9899,16 @@
                 <a:ea typeface="Arial" pitchFamily="34" charset="-122"/>
                 <a:cs typeface="Arial" pitchFamily="34" charset="-120"/>
               </a:rPr>
-              <a:t>High rates make guarantees cheap</a:t>
-            </a:r>
-            <a:endParaRPr lang="en-US" sz="930" dirty="0"/>
-          </a:p>
-          <a:p>
+              <a:t>High rates make guarantees cheap: </a:t>
+            </a:r>
             <a:pPr indent="0" marL="0">
+              <a:spcAft>
+                <a:spcPts val="100"/>
+              </a:spcAft>
               <a:buNone/>
             </a:pPr>
             <a:r>
-              <a:rPr lang="en-US" sz="930" dirty="0">
+              <a:rPr lang="en-US" sz="880" dirty="0">
                 <a:solidFill>
                   <a:srgbClr val="595959"/>
                 </a:solidFill>
@@ -9798,9 +9916,29 @@
                 <a:ea typeface="Arial" pitchFamily="34" charset="-122"/>
                 <a:cs typeface="Arial" pitchFamily="34" charset="-120"/>
               </a:rPr>
-              <a:t>At a 5.69% 5-year USD funding rate, USD 100 payable in 5 years costs only USD 75.8 today.</a:t>
-            </a:r>
-            <a:endParaRPr lang="en-US" sz="930" dirty="0"/>
+              <a:t>At 5.69% 5Y USD funding, USD 100 payable in 5 years costs only USD 75.8 today.</a:t>
+            </a:r>
+            <a:endParaRPr lang="en-US" sz="880" dirty="0"/>
+          </a:p>
+          <a:p>
+            <a:pPr indent="0" marL="0">
+              <a:spcAft>
+                <a:spcPts val="100"/>
+              </a:spcAft>
+              <a:buNone/>
+            </a:pPr>
+            <a:r>
+              <a:rPr lang="en-US" sz="880" b="1" dirty="0">
+                <a:solidFill>
+                  <a:srgbClr val="2C5F82"/>
+                </a:solidFill>
+                <a:latin typeface="Arial" pitchFamily="34" charset="0"/>
+                <a:ea typeface="Arial" pitchFamily="34" charset="-122"/>
+                <a:cs typeface="Arial" pitchFamily="34" charset="-120"/>
+              </a:rPr>
+              <a:t>→ Full capital protection is affordable inside an autocall</a:t>
+            </a:r>
+            <a:endParaRPr lang="en-US" sz="880" dirty="0"/>
           </a:p>
         </p:txBody>
       </p:sp>
@@ -9908,7 +10046,7 @@
                 <a:ea typeface="Arial" pitchFamily="34" charset="-122"/>
                 <a:cs typeface="Arial" pitchFamily="34" charset="-120"/>
               </a:rPr>
-              <a:t>Investment thesis 2: Traditional strategies fall short in 2026</a:t>
+              <a:t>Investment thesis 2: Traditional strategies fall short; autocallables fit 2026</a:t>
             </a:r>
             <a:endParaRPr lang="en-US" sz="2400" dirty="0"/>
           </a:p>
@@ -10681,14 +10819,53 @@
       </p:sp>
       <p:sp>
         <p:nvSpPr>
-          <p:cNvPr id="28" name="Shape 22"/>
+          <p:cNvPr id="28" name="Text 22"/>
+          <p:cNvSpPr txBox="1"/>
+          <p:nvPr/>
+        </p:nvSpPr>
+        <p:spPr>
+          <a:xfrm>
+            <a:off x="8211312" y="1645920"/>
+            <a:ext cx="3520440" cy="274320"/>
+          </a:xfrm>
+          <a:prstGeom prst="rect">
+            <a:avLst/>
+          </a:prstGeom>
+          <a:noFill/>
+          <a:ln/>
+        </p:spPr>
+        <p:txBody>
+          <a:bodyPr wrap="square" lIns="0" tIns="0" rIns="0" bIns="0" rtlCol="0" anchor="t"/>
+          <a:lstStyle/>
+          <a:p>
+            <a:pPr algn="ctr" indent="0" marL="0">
+              <a:buNone/>
+            </a:pPr>
+            <a:r>
+              <a:rPr lang="en-US" sz="800" i="1" dirty="0">
+                <a:solidFill>
+                  <a:srgbClr val="595959"/>
+                </a:solidFill>
+                <a:latin typeface="Arial" pitchFamily="34" charset="0"/>
+                <a:ea typeface="Arial" pitchFamily="34" charset="-122"/>
+                <a:cs typeface="Arial" pitchFamily="34" charset="-120"/>
+              </a:rPr>
+              <a:t>Market proof: Taiwan structured-note issuance +81% in 2025, snowball autocalls the favourite payoff (SRP)</a:t>
+            </a:r>
+            <a:endParaRPr lang="en-US" sz="800" dirty="0"/>
+          </a:p>
+        </p:txBody>
+      </p:sp>
+      <p:sp>
+        <p:nvSpPr>
+          <p:cNvPr id="29" name="Shape 23"/>
           <p:cNvSpPr/>
           <p:nvPr/>
         </p:nvSpPr>
         <p:spPr>
           <a:xfrm>
-            <a:off x="8211312" y="1719072"/>
-            <a:ext cx="3520440" cy="658368"/>
+            <a:off x="8211312" y="1938528"/>
+            <a:ext cx="3520440" cy="621792"/>
           </a:xfrm>
           <a:prstGeom prst="rect">
             <a:avLst/>
@@ -10706,14 +10883,14 @@
       </p:sp>
       <p:sp>
         <p:nvSpPr>
-          <p:cNvPr id="29" name="Text 23"/>
+          <p:cNvPr id="30" name="Text 24"/>
           <p:cNvSpPr txBox="1"/>
           <p:nvPr/>
         </p:nvSpPr>
         <p:spPr>
           <a:xfrm>
-            <a:off x="8257032" y="1719072"/>
-            <a:ext cx="411480" cy="658368"/>
+            <a:off x="8257032" y="1938528"/>
+            <a:ext cx="411480" cy="621792"/>
           </a:xfrm>
           <a:prstGeom prst="rect">
             <a:avLst/>
@@ -10745,14 +10922,14 @@
       </p:sp>
       <p:sp>
         <p:nvSpPr>
-          <p:cNvPr id="30" name="Text 24"/>
+          <p:cNvPr id="31" name="Text 25"/>
           <p:cNvSpPr txBox="1"/>
           <p:nvPr/>
         </p:nvSpPr>
         <p:spPr>
           <a:xfrm>
-            <a:off x="8714232" y="1746504"/>
-            <a:ext cx="2926080" cy="603504"/>
+            <a:off x="8714232" y="1956816"/>
+            <a:ext cx="2926080" cy="585216"/>
           </a:xfrm>
           <a:prstGeom prst="rect">
             <a:avLst/>
@@ -10768,7 +10945,7 @@
               <a:buNone/>
             </a:pPr>
             <a:r>
-              <a:rPr lang="en-US" sz="900" b="1" dirty="0">
+              <a:rPr lang="en-US" sz="880" b="1" dirty="0">
                 <a:solidFill>
                   <a:srgbClr val="262626"/>
                 </a:solidFill>
@@ -10776,13 +10953,13 @@
                 <a:ea typeface="Arial" pitchFamily="34" charset="-122"/>
                 <a:cs typeface="Arial" pitchFamily="34" charset="-120"/>
               </a:rPr>
-              <a:t>Bonds: duration hurts: </a:t>
+              <a:t>Early exit beats duration: </a:t>
             </a:r>
             <a:pPr indent="0" marL="0">
               <a:buNone/>
             </a:pPr>
             <a:r>
-              <a:rPr lang="en-US" sz="900" dirty="0">
+              <a:rPr lang="en-US" sz="880" dirty="0">
                 <a:solidFill>
                   <a:srgbClr val="595959"/>
                 </a:solidFill>
@@ -10790,22 +10967,22 @@
                 <a:ea typeface="Arial" pitchFamily="34" charset="-122"/>
                 <a:cs typeface="Arial" pitchFamily="34" charset="-120"/>
               </a:rPr>
-              <a:t>A 5Y bond loses ~4.0% per 1% rate rise as the Fed hikes again</a:t>
-            </a:r>
-            <a:endParaRPr lang="en-US" sz="900" dirty="0"/>
+              <a:t>Bonds lose ~4.0% per 1% rate rise; autocalls can redeem from year 1</a:t>
+            </a:r>
+            <a:endParaRPr lang="en-US" sz="880" dirty="0"/>
           </a:p>
         </p:txBody>
       </p:sp>
       <p:sp>
         <p:nvSpPr>
-          <p:cNvPr id="31" name="Shape 25"/>
+          <p:cNvPr id="32" name="Shape 26"/>
           <p:cNvSpPr/>
           <p:nvPr/>
         </p:nvSpPr>
         <p:spPr>
           <a:xfrm>
-            <a:off x="8211312" y="2450592"/>
-            <a:ext cx="3520440" cy="658368"/>
+            <a:off x="8211312" y="2633472"/>
+            <a:ext cx="3520440" cy="621792"/>
           </a:xfrm>
           <a:prstGeom prst="rect">
             <a:avLst/>
@@ -10823,14 +11000,14 @@
       </p:sp>
       <p:sp>
         <p:nvSpPr>
-          <p:cNvPr id="32" name="Text 26"/>
+          <p:cNvPr id="33" name="Text 27"/>
           <p:cNvSpPr txBox="1"/>
           <p:nvPr/>
         </p:nvSpPr>
         <p:spPr>
           <a:xfrm>
-            <a:off x="8257032" y="2450592"/>
-            <a:ext cx="411480" cy="658368"/>
+            <a:off x="8257032" y="2633472"/>
+            <a:ext cx="411480" cy="621792"/>
           </a:xfrm>
           <a:prstGeom prst="rect">
             <a:avLst/>
@@ -10862,14 +11039,14 @@
       </p:sp>
       <p:sp>
         <p:nvSpPr>
-          <p:cNvPr id="33" name="Text 27"/>
+          <p:cNvPr id="34" name="Text 28"/>
           <p:cNvSpPr txBox="1"/>
           <p:nvPr/>
         </p:nvSpPr>
         <p:spPr>
           <a:xfrm>
-            <a:off x="8714232" y="2478024"/>
-            <a:ext cx="2926080" cy="603504"/>
+            <a:off x="8714232" y="2651760"/>
+            <a:ext cx="2926080" cy="585216"/>
           </a:xfrm>
           <a:prstGeom prst="rect">
             <a:avLst/>
@@ -10885,7 +11062,7 @@
               <a:buNone/>
             </a:pPr>
             <a:r>
-              <a:rPr lang="en-US" sz="900" b="1" dirty="0">
+              <a:rPr lang="en-US" sz="880" b="1" dirty="0">
                 <a:solidFill>
                   <a:srgbClr val="262626"/>
                 </a:solidFill>
@@ -10893,13 +11070,13 @@
                 <a:ea typeface="Arial" pitchFamily="34" charset="-122"/>
                 <a:cs typeface="Arial" pitchFamily="34" charset="-120"/>
               </a:rPr>
-              <a:t>Stocks: drawdowns are fast: </a:t>
+              <a:t>Paid on recovery, not timing: </a:t>
             </a:r>
             <a:pPr indent="0" marL="0">
               <a:buNone/>
             </a:pPr>
             <a:r>
-              <a:rPr lang="en-US" sz="900" dirty="0">
+              <a:rPr lang="en-US" sz="880" dirty="0">
                 <a:solidFill>
                   <a:srgbClr val="595959"/>
                 </a:solidFill>
@@ -10907,22 +11084,22 @@
                 <a:ea typeface="Arial" pitchFamily="34" charset="-122"/>
                 <a:cs typeface="Arial" pitchFamily="34" charset="-120"/>
               </a:rPr>
-              <a:t>−25% in ten weeks (KOSPI 2026); −25–36% in 2022</a:t>
-            </a:r>
-            <a:endParaRPr lang="en-US" sz="900" dirty="0"/>
+              <a:t>−25% in ten weeks (KOSPI 2026): autocall coupons pay once the basket is back at its start</a:t>
+            </a:r>
+            <a:endParaRPr lang="en-US" sz="880" dirty="0"/>
           </a:p>
         </p:txBody>
       </p:sp>
       <p:sp>
         <p:nvSpPr>
-          <p:cNvPr id="34" name="Shape 28"/>
+          <p:cNvPr id="35" name="Shape 29"/>
           <p:cNvSpPr/>
           <p:nvPr/>
         </p:nvSpPr>
         <p:spPr>
           <a:xfrm>
-            <a:off x="8211312" y="3182112"/>
-            <a:ext cx="3520440" cy="658368"/>
+            <a:off x="8211312" y="3328416"/>
+            <a:ext cx="3520440" cy="621792"/>
           </a:xfrm>
           <a:prstGeom prst="rect">
             <a:avLst/>
@@ -10940,14 +11117,14 @@
       </p:sp>
       <p:sp>
         <p:nvSpPr>
-          <p:cNvPr id="35" name="Text 29"/>
+          <p:cNvPr id="36" name="Text 30"/>
           <p:cNvSpPr txBox="1"/>
           <p:nvPr/>
         </p:nvSpPr>
         <p:spPr>
           <a:xfrm>
-            <a:off x="8257032" y="3182112"/>
-            <a:ext cx="411480" cy="658368"/>
+            <a:off x="8257032" y="3328416"/>
+            <a:ext cx="411480" cy="621792"/>
           </a:xfrm>
           <a:prstGeom prst="rect">
             <a:avLst/>
@@ -10979,14 +11156,14 @@
       </p:sp>
       <p:sp>
         <p:nvSpPr>
-          <p:cNvPr id="36" name="Text 30"/>
+          <p:cNvPr id="37" name="Text 31"/>
           <p:cNvSpPr txBox="1"/>
           <p:nvPr/>
         </p:nvSpPr>
         <p:spPr>
           <a:xfrm>
-            <a:off x="8714232" y="3209544"/>
-            <a:ext cx="2926080" cy="603504"/>
+            <a:off x="8714232" y="3346704"/>
+            <a:ext cx="2926080" cy="585216"/>
           </a:xfrm>
           <a:prstGeom prst="rect">
             <a:avLst/>
@@ -11002,7 +11179,7 @@
               <a:buNone/>
             </a:pPr>
             <a:r>
-              <a:rPr lang="en-US" sz="900" b="1" dirty="0">
+              <a:rPr lang="en-US" sz="880" b="1" dirty="0">
                 <a:solidFill>
                   <a:srgbClr val="262626"/>
                 </a:solidFill>
@@ -11010,13 +11187,13 @@
                 <a:ea typeface="Arial" pitchFamily="34" charset="-122"/>
                 <a:cs typeface="Arial" pitchFamily="34" charset="-120"/>
               </a:rPr>
-              <a:t>Concentration: few names drive all: </a:t>
+              <a:t>Diversify the basket: </a:t>
             </a:r>
             <a:pPr indent="0" marL="0">
               <a:buNone/>
             </a:pPr>
             <a:r>
-              <a:rPr lang="en-US" sz="900" dirty="0">
+              <a:rPr lang="en-US" sz="880" dirty="0">
                 <a:solidFill>
                   <a:srgbClr val="595959"/>
                 </a:solidFill>
@@ -11024,22 +11201,22 @@
                 <a:ea typeface="Arial" pitchFamily="34" charset="-122"/>
                 <a:cs typeface="Arial" pitchFamily="34" charset="-120"/>
               </a:rPr>
-              <a:t>TSMC &gt;40% of TAIEX; Samsung + SK hynix ~48% of KOSPI; ~92% of advanced chips from Taiwan</a:t>
-            </a:r>
-            <a:endParaRPr lang="en-US" sz="900" dirty="0"/>
+              <a:t>TSMC &gt;40% of TAIEX, ~92% of advanced chips from Taiwan: use an index basket, not worst-of</a:t>
+            </a:r>
+            <a:endParaRPr lang="en-US" sz="880" dirty="0"/>
           </a:p>
         </p:txBody>
       </p:sp>
       <p:sp>
         <p:nvSpPr>
-          <p:cNvPr id="37" name="Shape 31"/>
+          <p:cNvPr id="38" name="Shape 32"/>
           <p:cNvSpPr/>
           <p:nvPr/>
         </p:nvSpPr>
         <p:spPr>
           <a:xfrm>
-            <a:off x="8211312" y="3913632"/>
-            <a:ext cx="3520440" cy="658368"/>
+            <a:off x="8211312" y="4023360"/>
+            <a:ext cx="3520440" cy="621792"/>
           </a:xfrm>
           <a:prstGeom prst="rect">
             <a:avLst/>
@@ -11057,14 +11234,14 @@
       </p:sp>
       <p:sp>
         <p:nvSpPr>
-          <p:cNvPr id="38" name="Text 32"/>
+          <p:cNvPr id="39" name="Text 33"/>
           <p:cNvSpPr txBox="1"/>
           <p:nvPr/>
         </p:nvSpPr>
         <p:spPr>
           <a:xfrm>
-            <a:off x="8257032" y="3913632"/>
-            <a:ext cx="411480" cy="658368"/>
+            <a:off x="8257032" y="4023360"/>
+            <a:ext cx="411480" cy="621792"/>
           </a:xfrm>
           <a:prstGeom prst="rect">
             <a:avLst/>
@@ -11096,14 +11273,14 @@
       </p:sp>
       <p:sp>
         <p:nvSpPr>
-          <p:cNvPr id="39" name="Text 33"/>
+          <p:cNvPr id="40" name="Text 34"/>
           <p:cNvSpPr txBox="1"/>
           <p:nvPr/>
         </p:nvSpPr>
         <p:spPr>
           <a:xfrm>
-            <a:off x="8714232" y="3941064"/>
-            <a:ext cx="2926080" cy="603504"/>
+            <a:off x="8714232" y="4041648"/>
+            <a:ext cx="2926080" cy="585216"/>
           </a:xfrm>
           <a:prstGeom prst="rect">
             <a:avLst/>
@@ -11119,7 +11296,7 @@
               <a:buNone/>
             </a:pPr>
             <a:r>
-              <a:rPr lang="en-US" sz="900" b="1" dirty="0">
+              <a:rPr lang="en-US" sz="880" b="1" dirty="0">
                 <a:solidFill>
                   <a:srgbClr val="262626"/>
                 </a:solidFill>
@@ -11127,13 +11304,13 @@
                 <a:ea typeface="Arial" pitchFamily="34" charset="-122"/>
                 <a:cs typeface="Arial" pitchFamily="34" charset="-120"/>
               </a:rPr>
-              <a:t>Volatility: at records: </a:t>
+              <a:t>Volatility funds the coupon: </a:t>
             </a:r>
             <a:pPr indent="0" marL="0">
               <a:buNone/>
             </a:pPr>
             <a:r>
-              <a:rPr lang="en-US" sz="900" dirty="0">
+              <a:rPr lang="en-US" sz="880" dirty="0">
                 <a:solidFill>
                   <a:srgbClr val="595959"/>
                 </a:solidFill>
@@ -11141,22 +11318,22 @@
                 <a:ea typeface="Arial" pitchFamily="34" charset="-122"/>
                 <a:cs typeface="Arial" pitchFamily="34" charset="-120"/>
               </a:rPr>
-              <a:t>VKOSPI closed at 91.2 (9 Jun 2026), above 2008; circuit breakers fired 3 times in June</a:t>
-            </a:r>
-            <a:endParaRPr lang="en-US" sz="900" dirty="0"/>
+              <a:t>VKOSPI at a record 91.2: richer option premium means higher autocall coupons</a:t>
+            </a:r>
+            <a:endParaRPr lang="en-US" sz="880" dirty="0"/>
           </a:p>
         </p:txBody>
       </p:sp>
       <p:sp>
         <p:nvSpPr>
-          <p:cNvPr id="40" name="Shape 34"/>
+          <p:cNvPr id="41" name="Shape 35"/>
           <p:cNvSpPr/>
           <p:nvPr/>
         </p:nvSpPr>
         <p:spPr>
           <a:xfrm>
-            <a:off x="8211312" y="4645152"/>
-            <a:ext cx="3520440" cy="658368"/>
+            <a:off x="8211312" y="4718304"/>
+            <a:ext cx="3520440" cy="621792"/>
           </a:xfrm>
           <a:prstGeom prst="rect">
             <a:avLst/>
@@ -11174,14 +11351,14 @@
       </p:sp>
       <p:sp>
         <p:nvSpPr>
-          <p:cNvPr id="41" name="Text 35"/>
+          <p:cNvPr id="42" name="Text 36"/>
           <p:cNvSpPr txBox="1"/>
           <p:nvPr/>
         </p:nvSpPr>
         <p:spPr>
           <a:xfrm>
-            <a:off x="8257032" y="4645152"/>
-            <a:ext cx="411480" cy="658368"/>
+            <a:off x="8257032" y="4718304"/>
+            <a:ext cx="411480" cy="621792"/>
           </a:xfrm>
           <a:prstGeom prst="rect">
             <a:avLst/>
@@ -11213,14 +11390,14 @@
       </p:sp>
       <p:sp>
         <p:nvSpPr>
-          <p:cNvPr id="42" name="Text 36"/>
+          <p:cNvPr id="43" name="Text 37"/>
           <p:cNvSpPr txBox="1"/>
           <p:nvPr/>
         </p:nvSpPr>
         <p:spPr>
           <a:xfrm>
-            <a:off x="8714232" y="4672584"/>
-            <a:ext cx="2926080" cy="603504"/>
+            <a:off x="8714232" y="4736592"/>
+            <a:ext cx="2926080" cy="585216"/>
           </a:xfrm>
           <a:prstGeom prst="rect">
             <a:avLst/>
@@ -11236,7 +11413,7 @@
               <a:buNone/>
             </a:pPr>
             <a:r>
-              <a:rPr lang="en-US" sz="900" b="1" dirty="0">
+              <a:rPr lang="en-US" sz="880" b="1" dirty="0">
                 <a:solidFill>
                   <a:srgbClr val="262626"/>
                 </a:solidFill>
@@ -11244,13 +11421,13 @@
                 <a:ea typeface="Arial" pitchFamily="34" charset="-122"/>
                 <a:cs typeface="Arial" pitchFamily="34" charset="-120"/>
               </a:rPr>
-              <a:t>Cycle: late and priced: </a:t>
+              <a:t>Protection is affordable: </a:t>
             </a:r>
             <a:pPr indent="0" marL="0">
               <a:buNone/>
             </a:pPr>
             <a:r>
-              <a:rPr lang="en-US" sz="900" dirty="0">
+              <a:rPr lang="en-US" sz="880" dirty="0">
                 <a:solidFill>
                   <a:srgbClr val="595959"/>
                 </a:solidFill>
@@ -11258,15 +11435,15 @@
                 <a:ea typeface="Arial" pitchFamily="34" charset="-122"/>
                 <a:cs typeface="Arial" pitchFamily="34" charset="-120"/>
               </a:rPr>
-              <a:t>DRAM price gains slowing; J.P. Morgan's base case has a 10–15% correction in 2026</a:t>
-            </a:r>
-            <a:endParaRPr lang="en-US" sz="900" dirty="0"/>
+              <a:t>USD 100 in 5 years costs USD 75.8 at 5.69%: capital protection fits inside an autocall</a:t>
+            </a:r>
+            <a:endParaRPr lang="en-US" sz="880" dirty="0"/>
           </a:p>
         </p:txBody>
       </p:sp>
       <p:sp>
         <p:nvSpPr>
-          <p:cNvPr id="43" name="Shape 37"/>
+          <p:cNvPr id="44" name="Shape 38"/>
           <p:cNvSpPr/>
           <p:nvPr/>
         </p:nvSpPr>
@@ -11291,7 +11468,7 @@
       </p:sp>
       <p:sp>
         <p:nvSpPr>
-          <p:cNvPr id="44" name="Text 38"/>
+          <p:cNvPr id="45" name="Text 39"/>
           <p:cNvSpPr txBox="1"/>
           <p:nvPr/>
         </p:nvSpPr>
@@ -11322,7 +11499,7 @@
                 <a:ea typeface="Arial" pitchFamily="34" charset="-122"/>
                 <a:cs typeface="Arial" pitchFamily="34" charset="-120"/>
               </a:rPr>
-              <a:t>The theme is attractive, but holding it through plain bonds or plain equities leaves investors exposed to rate, drawdown and concentration risk.</a:t>
+              <a:t>Plain bonds and equities leave investors exposed; a capital-protected autocall keeps the theme and manages the risks.</a:t>
             </a:r>
             <a:endParaRPr lang="en-US" sz="1200" dirty="0"/>
           </a:p>
@@ -11330,7 +11507,7 @@
       </p:sp>
       <p:sp>
         <p:nvSpPr>
-          <p:cNvPr id="45" name="Text 39"/>
+          <p:cNvPr id="46" name="Text 40"/>
           <p:cNvSpPr txBox="1"/>
           <p:nvPr/>
         </p:nvSpPr>
@@ -11361,7 +11538,7 @@
                 <a:ea typeface="Arial" pitchFamily="34" charset="-122"/>
                 <a:cs typeface="Arial" pitchFamily="34" charset="-120"/>
               </a:rPr>
-              <a:t>Sources: Federal Reserve via Advisor Perspectives; TWSE, KRX/press, Nikkei (index levels); Siblis Research (P/E); Herald / SBS (VKOSPI); TrendForce; J.P. Morgan 2026 Outlook; case funding grid with standard bond maths.</a:t>
+              <a:t>Sources: Federal Reserve via Advisor Perspectives; TWSE, KRX/press, Nikkei (index levels); Siblis Research (P/E); Herald / SBS (VKOSPI); TrendForce; J.P. Morgan 2026 Outlook; StructuredRetailProducts.com; case funding grid with standard bond maths.</a:t>
             </a:r>
             <a:endParaRPr lang="en-US" sz="800" dirty="0"/>
           </a:p>
@@ -13878,6 +14055,144 @@
                           <a:ea typeface="Arial" pitchFamily="34" charset="-122"/>
                           <a:cs typeface="Arial" pitchFamily="34" charset="-120"/>
                         </a:rPr>
+                        <a:t>Taiwan structured notes 2025: ~75,900 products, +81%; snowball autocalls favoured</a:t>
+                      </a:r>
+                      <a:endParaRPr lang="en-US" sz="850" dirty="0">
+                        <a:latin typeface="Arial" charset="0"/>
+                        <a:ea typeface="Arial" charset="0"/>
+                        <a:cs typeface="Arial" charset="0"/>
+                      </a:endParaRPr>
+                    </a:p>
+                  </a:txBody>
+                  <a:tcPr marL="63500" marR="63500" marT="12700" marB="12700" anchor="ctr">
+                    <a:lnL w="6350" cap="flat" cmpd="sng" algn="ctr">
+                      <a:solidFill>
+                        <a:srgbClr val="BFBFBF"/>
+                      </a:solidFill>
+                      <a:prstDash val="solid"/>
+                      <a:round/>
+                      <a:headEnd type="none" w="med" len="med"/>
+                      <a:tailEnd type="none" w="med" len="med"/>
+                    </a:lnL>
+                    <a:lnR w="6350" cap="flat" cmpd="sng" algn="ctr">
+                      <a:solidFill>
+                        <a:srgbClr val="BFBFBF"/>
+                      </a:solidFill>
+                      <a:prstDash val="solid"/>
+                      <a:round/>
+                      <a:headEnd type="none" w="med" len="med"/>
+                      <a:tailEnd type="none" w="med" len="med"/>
+                    </a:lnR>
+                    <a:lnT w="6350" cap="flat" cmpd="sng" algn="ctr">
+                      <a:solidFill>
+                        <a:srgbClr val="BFBFBF"/>
+                      </a:solidFill>
+                      <a:prstDash val="solid"/>
+                      <a:round/>
+                      <a:headEnd type="none" w="med" len="med"/>
+                      <a:tailEnd type="none" w="med" len="med"/>
+                    </a:lnT>
+                    <a:lnB w="6350" cap="flat" cmpd="sng" algn="ctr">
+                      <a:solidFill>
+                        <a:srgbClr val="BFBFBF"/>
+                      </a:solidFill>
+                      <a:prstDash val="solid"/>
+                      <a:round/>
+                      <a:headEnd type="none" w="med" len="med"/>
+                      <a:tailEnd type="none" w="med" len="med"/>
+                    </a:lnB>
+                    <a:solidFill>
+                      <a:srgbClr val="FFFFFF"/>
+                    </a:solidFill>
+                  </a:tcPr>
+                </a:tc>
+                <a:tc>
+                  <a:txBody>
+                    <a:bodyPr/>
+                    <a:lstStyle/>
+                    <a:p>
+                      <a:pPr indent="0" marL="0">
+                        <a:buNone/>
+                      </a:pPr>
+                      <a:r>
+                        <a:rPr lang="en-US" sz="850" dirty="0">
+                          <a:solidFill>
+                            <a:srgbClr val="262626"/>
+                          </a:solidFill>
+                          <a:latin typeface="Arial" pitchFamily="34" charset="0"/>
+                          <a:ea typeface="Arial" pitchFamily="34" charset="-122"/>
+                          <a:cs typeface="Arial" pitchFamily="34" charset="-120"/>
+                        </a:rPr>
+                        <a:t>StructuredRetailProducts.com, Taiwan Q4 2025 review</a:t>
+                      </a:r>
+                      <a:endParaRPr lang="en-US" sz="850" dirty="0">
+                        <a:latin typeface="Arial" charset="0"/>
+                        <a:ea typeface="Arial" charset="0"/>
+                        <a:cs typeface="Arial" charset="0"/>
+                      </a:endParaRPr>
+                    </a:p>
+                  </a:txBody>
+                  <a:tcPr marL="63500" marR="63500" marT="12700" marB="12700" anchor="ctr">
+                    <a:lnL w="6350" cap="flat" cmpd="sng" algn="ctr">
+                      <a:solidFill>
+                        <a:srgbClr val="BFBFBF"/>
+                      </a:solidFill>
+                      <a:prstDash val="solid"/>
+                      <a:round/>
+                      <a:headEnd type="none" w="med" len="med"/>
+                      <a:tailEnd type="none" w="med" len="med"/>
+                    </a:lnL>
+                    <a:lnR w="6350" cap="flat" cmpd="sng" algn="ctr">
+                      <a:solidFill>
+                        <a:srgbClr val="BFBFBF"/>
+                      </a:solidFill>
+                      <a:prstDash val="solid"/>
+                      <a:round/>
+                      <a:headEnd type="none" w="med" len="med"/>
+                      <a:tailEnd type="none" w="med" len="med"/>
+                    </a:lnR>
+                    <a:lnT w="6350" cap="flat" cmpd="sng" algn="ctr">
+                      <a:solidFill>
+                        <a:srgbClr val="BFBFBF"/>
+                      </a:solidFill>
+                      <a:prstDash val="solid"/>
+                      <a:round/>
+                      <a:headEnd type="none" w="med" len="med"/>
+                      <a:tailEnd type="none" w="med" len="med"/>
+                    </a:lnT>
+                    <a:lnB w="6350" cap="flat" cmpd="sng" algn="ctr">
+                      <a:solidFill>
+                        <a:srgbClr val="BFBFBF"/>
+                      </a:solidFill>
+                      <a:prstDash val="solid"/>
+                      <a:round/>
+                      <a:headEnd type="none" w="med" len="med"/>
+                      <a:tailEnd type="none" w="med" len="med"/>
+                    </a:lnB>
+                    <a:solidFill>
+                      <a:srgbClr val="FFFFFF"/>
+                    </a:solidFill>
+                  </a:tcPr>
+                </a:tc>
+              </a:tr>
+              <a:tr h="256032">
+                <a:tc>
+                  <a:txBody>
+                    <a:bodyPr/>
+                    <a:lstStyle/>
+                    <a:p>
+                      <a:pPr indent="0" marL="0">
+                        <a:buNone/>
+                      </a:pPr>
+                      <a:r>
+                        <a:rPr lang="en-US" sz="850" dirty="0">
+                          <a:solidFill>
+                            <a:srgbClr val="262626"/>
+                          </a:solidFill>
+                          <a:latin typeface="Arial" pitchFamily="34" charset="0"/>
+                          <a:ea typeface="Arial" pitchFamily="34" charset="-122"/>
+                          <a:cs typeface="Arial" pitchFamily="34" charset="-120"/>
+                        </a:rPr>
                         <a:t>5Y bond value change for −2% to +2% rate moves; 5Y discount factor 75.8%</a:t>
                       </a:r>
                       <a:endParaRPr lang="en-US" sz="850" dirty="0">

</xml_diff>

<commit_message>
Scenario 2: rebuild product on five Asian ETFs (3119 HK, 2644 JP, EWT, EWY, 00878 TT), coupon 7.2%
Re-priced the capital-protected memory autocallable on the new ETF basket,
updated the product deck, thesis slides and strategy write-up.

Co-Authored-By: Claude Opus 5.5 <noreply@anthropic.com>
Claude-Session: https://claude.ai/code/session_01Rwoh8cFDQqLD8JWT3mee6y
</commit_message>
<xml_diff>
--- a/deck/Investment-Thesis-Slides.pptx
+++ b/deck/Investment-Thesis-Slides.pptx
@@ -8887,7 +8887,7 @@
                 <a:ea typeface="Arial" pitchFamily="34" charset="-122"/>
                 <a:cs typeface="Arial" pitchFamily="34" charset="-120"/>
               </a:rPr>
-              <a:t>→ Use a diversified index basket, not a worst-of on single names</a:t>
+              <a:t>→ Use a diversified ETF basket, not a worst-of on single names</a:t>
             </a:r>
             <a:endParaRPr lang="en-US" sz="880" dirty="0"/>
           </a:p>
@@ -11201,7 +11201,7 @@
                 <a:ea typeface="Arial" pitchFamily="34" charset="-122"/>
                 <a:cs typeface="Arial" pitchFamily="34" charset="-120"/>
               </a:rPr>
-              <a:t>TSMC &gt;40% of TAIEX, ~92% of advanced chips from Taiwan: use an index basket, not worst-of</a:t>
+              <a:t>TSMC &gt;40% of TAIEX, ~92% of advanced chips from Taiwan: use a diversified ETF basket, not worst-of</a:t>
             </a:r>
             <a:endParaRPr lang="en-US" sz="880" dirty="0"/>
           </a:p>

</xml_diff>

<commit_message>
Add FOMC dot plot (16 Sep 2026 SEP) to the investment thesis
New thesis slide with a redrawn dot plot (medians 4.125% 2026-27, 3.875% 2028, 3.625% 2029,
3.25% longer run) and autocall links; dot counts in thesis_market_data.json; sources updated.

Co-Authored-By: Claude Opus 5.5 <noreply@anthropic.com>
Claude-Session: https://claude.ai/code/session_01Rwoh8cFDQqLD8JWT3mee6y
</commit_message>
<xml_diff>
--- a/deck/Investment-Thesis-Slides.pptx
+++ b/deck/Investment-Thesis-Slides.pptx
@@ -10,9 +10,10 @@
     <p:sldId id="258" r:id="rId4"/>
     <p:sldId id="259" r:id="rId5"/>
     <p:sldId id="260" r:id="rId6"/>
+    <p:sldId id="261" r:id="rId7"/>
   </p:sldIdLst>
   <p:notesMasterIdLst>
-    <p:notesMasterId r:id="rId7"/>
+    <p:notesMasterId r:id="rId8"/>
   </p:notesMasterIdLst>
   <p:sldSz cx="12192000" cy="6858000"/>
   <p:notesSz cx="6858000" cy="12192000"/>
@@ -4907,7 +4908,7 @@
           <a:p>
             <a:r>
               <a:rPr lang="en-US" dirty="0"/>
-              <a:t>One-slide thesis 2, modelled on the 'traditional strategies fall short' format, using market evidence only: rising rates (bond duration risk), violent equity paths, concentration, record volatility and a late, richly priced cycle. Implications link each market fact to why an autocallable structure fits; our specific note and its numbers come in the product section.</a:t>
+              <a:t>The dot plot is the Fed's own forecast. Each dot is one FOMC participant's view of the right policy rate at year-end. Three readings: (1) the median sees one more hike this year and no cuts until 2028, so USD rates stay high for most of our 5-year horizon; (2) a hawkish minority sees 4.375%, so long bonds carry real downside; (3) the dots are widely spread, so rate volatility, and with it option premium, stays high. Each reading links to why a short-dated autocall with a 70% floor fits: cheap floor, early redemption, coupon funded by volatility, and supportive easing later in the life of the note.</a:t>
             </a:r>
             <a:endParaRPr lang="en-US" dirty="0"/>
           </a:p>
@@ -4995,7 +4996,7 @@
           <a:p>
             <a:r>
               <a:rPr lang="en-US" dirty="0"/>
-              <a:t/>
+              <a:t>One-slide thesis 2, modelled on the 'traditional strategies fall short' format, using market evidence only: rising rates (bond duration risk), violent equity paths, concentration, record volatility and a late, richly priced cycle. Implications link each market fact to why an autocallable structure fits; our specific note and its numbers come in the product section.</a:t>
             </a:r>
             <a:endParaRPr lang="en-US" dirty="0"/>
           </a:p>
@@ -5019,6 +5020,94 @@
             <a:fld id="{F7021451-1387-4CA6-816F-3879F97B5CBC}" type="slidenum">
               <a:rPr lang="en-US"/>
               <a:t>5</a:t>
+            </a:fld>
+            <a:endParaRPr lang="en-US"/>
+          </a:p>
+        </p:txBody>
+      </p:sp>
+    </p:spTree>
+    <p:extLst>
+      <p:ext uri="{BB962C8B-B14F-4D97-AF65-F5344CB8AC3E}">
+        <p14:creationId xmlns:p14="http://schemas.microsoft.com/office/powerpoint/2010/main" val="1024086991"/>
+      </p:ext>
+    </p:extLst>
+  </p:cSld>
+  <p:clrMapOvr>
+    <a:masterClrMapping/>
+  </p:clrMapOvr>
+</p:notes>
+</file>
+
+<file path=ppt/notesSlides/notesSlide6.xml><?xml version="1.0" encoding="utf-8"?>
+<p:notes xmlns:a="http://schemas.openxmlformats.org/drawingml/2006/main" xmlns:r="http://schemas.openxmlformats.org/officeDocument/2006/relationships" xmlns:p="http://schemas.openxmlformats.org/presentationml/2006/main">
+  <p:cSld>
+    <p:spTree>
+      <p:nvGrpSpPr>
+        <p:cNvPr id="1" name=""/>
+        <p:cNvGrpSpPr/>
+        <p:nvPr/>
+      </p:nvGrpSpPr>
+      <p:grpSpPr>
+        <a:xfrm>
+          <a:off x="0" y="0"/>
+          <a:ext cx="0" cy="0"/>
+          <a:chOff x="0" y="0"/>
+          <a:chExt cx="0" cy="0"/>
+        </a:xfrm>
+      </p:grpSpPr>
+      <p:sp>
+        <p:nvSpPr>
+          <p:cNvPr id="2" name="Slide Image Placeholder 1"/>
+          <p:cNvSpPr>
+            <a:spLocks noGrp="1" noRot="1" noChangeAspect="1"/>
+          </p:cNvSpPr>
+          <p:nvPr>
+            <p:ph type="sldImg"/>
+          </p:nvPr>
+        </p:nvSpPr>
+        <p:spPr/>
+      </p:sp>
+      <p:sp>
+        <p:nvSpPr>
+          <p:cNvPr id="3" name="Notes Placeholder 2"/>
+          <p:cNvSpPr>
+            <a:spLocks noGrp="1"/>
+          </p:cNvSpPr>
+          <p:nvPr>
+            <p:ph type="body" idx="1"/>
+          </p:nvPr>
+        </p:nvSpPr>
+        <p:spPr/>
+        <p:txBody>
+          <a:bodyPr/>
+          <a:lstStyle/>
+          <a:p>
+            <a:r>
+              <a:rPr lang="en-US" dirty="0"/>
+              <a:t/>
+            </a:r>
+            <a:endParaRPr lang="en-US" dirty="0"/>
+          </a:p>
+        </p:txBody>
+      </p:sp>
+      <p:sp>
+        <p:nvSpPr>
+          <p:cNvPr id="4" name="Slide Number Placeholder 3"/>
+          <p:cNvSpPr>
+            <a:spLocks noGrp="1"/>
+          </p:cNvSpPr>
+          <p:nvPr>
+            <p:ph type="sldNum" sz="quarter" idx="10"/>
+          </p:nvPr>
+        </p:nvSpPr>
+        <p:spPr/>
+        <p:txBody>
+          <a:bodyPr/>
+          <a:lstStyle/>
+          <a:p>
+            <a:fld id="{F7021451-1387-4CA6-816F-3879F97B5CBC}" type="slidenum">
+              <a:rPr lang="en-US"/>
+              <a:t>6</a:t>
             </a:fld>
             <a:endParaRPr lang="en-US"/>
           </a:p>
@@ -10046,7 +10135,7 @@
                 <a:ea typeface="Arial" pitchFamily="34" charset="-122"/>
                 <a:cs typeface="Arial" pitchFamily="34" charset="-120"/>
               </a:rPr>
-              <a:t>Investment thesis 2: Traditional strategies fall short; autocallables fit 2026</a:t>
+              <a:t>Investment thesis 2 (rates): the Fed's dot plot says higher for longer</a:t>
             </a:r>
             <a:endParaRPr lang="en-US" sz="2400" dirty="0"/>
           </a:p>
@@ -10240,16 +10329,40 @@
           </a:p>
         </p:txBody>
       </p:sp>
-      <p:sp>
-        <p:nvSpPr>
-          <p:cNvPr id="9" name="Text 7"/>
+      <p:pic>
+        <p:nvPicPr>
+          <p:cNvPr id="9" name="Image 0" descr="/home/user/natixis-case-comp/deck/fomc_dot_plot.png">    </p:cNvPr>
+          <p:cNvPicPr>
+            <a:picLocks noChangeAspect="1"/>
+          </p:cNvPicPr>
+          <p:nvPr/>
+        </p:nvPicPr>
+        <p:blipFill>
+          <a:blip r:embed="rId1"/>
+          <a:stretch>
+            <a:fillRect/>
+          </a:stretch>
+        </p:blipFill>
+        <p:spPr>
+          <a:xfrm>
+            <a:off x="457200" y="1051560"/>
+            <a:ext cx="6583680" cy="4133939"/>
+          </a:xfrm>
+          <a:prstGeom prst="rect">
+            <a:avLst/>
+          </a:prstGeom>
+        </p:spPr>
+      </p:pic>
+      <p:sp>
+        <p:nvSpPr>
+          <p:cNvPr id="10" name="Text 7"/>
           <p:cNvSpPr txBox="1"/>
           <p:nvPr/>
         </p:nvSpPr>
         <p:spPr>
           <a:xfrm>
-            <a:off x="457200" y="960120"/>
-            <a:ext cx="11247120" cy="274320"/>
+            <a:off x="457200" y="5230368"/>
+            <a:ext cx="6583680" cy="274320"/>
           </a:xfrm>
           <a:prstGeom prst="rect">
             <a:avLst/>
@@ -10265,30 +10378,602 @@
               <a:buNone/>
             </a:pPr>
             <a:r>
-              <a:rPr lang="en-US" sz="1150" b="1" i="1" dirty="0">
-                <a:solidFill>
-                  <a:srgbClr val="262626"/>
+              <a:rPr lang="en-US" sz="850" i="1" dirty="0">
+                <a:solidFill>
+                  <a:srgbClr val="595959"/>
                 </a:solidFill>
                 <a:latin typeface="Arial" pitchFamily="34" charset="0"/>
                 <a:ea typeface="Arial" pitchFamily="34" charset="-122"/>
                 <a:cs typeface="Arial" pitchFamily="34" charset="-120"/>
               </a:rPr>
-              <a:t>Long bonds face rising rates; buy-and-hold equity faces record volatility, concentration and stretched valuations</a:t>
-            </a:r>
-            <a:endParaRPr lang="en-US" sz="1150" dirty="0"/>
+              <a:t>FOMC participants' view of the appropriate fed funds rate (midpoint of target range), Summary of Economic Projections, 16 Sep 2026</a:t>
+            </a:r>
+            <a:endParaRPr lang="en-US" sz="850" dirty="0"/>
           </a:p>
         </p:txBody>
       </p:sp>
       <p:sp>
         <p:nvSpPr>
-          <p:cNvPr id="10" name="Shape 8"/>
+          <p:cNvPr id="11" name="Shape 8"/>
           <p:cNvSpPr/>
           <p:nvPr/>
         </p:nvSpPr>
         <p:spPr>
           <a:xfrm>
-            <a:off x="457200" y="1325880"/>
-            <a:ext cx="3730752" cy="292608"/>
+            <a:off x="7269480" y="1051560"/>
+            <a:ext cx="4462272" cy="932688"/>
+          </a:xfrm>
+          <a:prstGeom prst="rect">
+            <a:avLst/>
+          </a:prstGeom>
+          <a:solidFill>
+            <a:srgbClr val="F2F2F2"/>
+          </a:solidFill>
+          <a:ln w="12700">
+            <a:solidFill>
+              <a:srgbClr val="F2F2F2"/>
+            </a:solidFill>
+            <a:prstDash val="solid"/>
+          </a:ln>
+        </p:spPr>
+      </p:sp>
+      <p:sp>
+        <p:nvSpPr>
+          <p:cNvPr id="12" name="Text 9"/>
+          <p:cNvSpPr txBox="1"/>
+          <p:nvPr/>
+        </p:nvSpPr>
+        <p:spPr>
+          <a:xfrm>
+            <a:off x="7315200" y="1051560"/>
+            <a:ext cx="1051560" cy="932688"/>
+          </a:xfrm>
+          <a:prstGeom prst="rect">
+            <a:avLst/>
+          </a:prstGeom>
+          <a:noFill/>
+          <a:ln/>
+        </p:spPr>
+        <p:txBody>
+          <a:bodyPr wrap="square" lIns="0" tIns="0" rIns="0" bIns="0" rtlCol="0" anchor="ctr"/>
+          <a:lstStyle/>
+          <a:p>
+            <a:pPr algn="ctr" indent="0" marL="0">
+              <a:buNone/>
+            </a:pPr>
+            <a:r>
+              <a:rPr lang="en-US" sz="1600" b="1" dirty="0">
+                <a:solidFill>
+                  <a:srgbClr val="2C5F82"/>
+                </a:solidFill>
+                <a:latin typeface="Arial" pitchFamily="34" charset="0"/>
+                <a:ea typeface="Arial" pitchFamily="34" charset="-122"/>
+                <a:cs typeface="Arial" pitchFamily="34" charset="-120"/>
+              </a:rPr>
+              <a:t>4.125%</a:t>
+            </a:r>
+            <a:endParaRPr lang="en-US" sz="1600" dirty="0"/>
+          </a:p>
+        </p:txBody>
+      </p:sp>
+      <p:sp>
+        <p:nvSpPr>
+          <p:cNvPr id="13" name="Text 10"/>
+          <p:cNvSpPr txBox="1"/>
+          <p:nvPr/>
+        </p:nvSpPr>
+        <p:spPr>
+          <a:xfrm>
+            <a:off x="8412480" y="1088136"/>
+            <a:ext cx="3227832" cy="859536"/>
+          </a:xfrm>
+          <a:prstGeom prst="rect">
+            <a:avLst/>
+          </a:prstGeom>
+          <a:noFill/>
+          <a:ln/>
+        </p:spPr>
+        <p:txBody>
+          <a:bodyPr wrap="square" lIns="0" tIns="0" rIns="0" bIns="0" rtlCol="0" anchor="ctr"/>
+          <a:lstStyle/>
+          <a:p>
+            <a:pPr indent="0" marL="0">
+              <a:spcAft>
+                <a:spcPts val="100"/>
+              </a:spcAft>
+              <a:buNone/>
+            </a:pPr>
+            <a:r>
+              <a:rPr lang="en-US" sz="880" b="1" dirty="0">
+                <a:solidFill>
+                  <a:srgbClr val="262626"/>
+                </a:solidFill>
+                <a:latin typeface="Arial" pitchFamily="34" charset="0"/>
+                <a:ea typeface="Arial" pitchFamily="34" charset="-122"/>
+                <a:cs typeface="Arial" pitchFamily="34" charset="-120"/>
+              </a:rPr>
+              <a:t>Rates stay high through 2027: </a:t>
+            </a:r>
+            <a:pPr indent="0" marL="0">
+              <a:spcAft>
+                <a:spcPts val="100"/>
+              </a:spcAft>
+              <a:buNone/>
+            </a:pPr>
+            <a:r>
+              <a:rPr lang="en-US" sz="880" dirty="0">
+                <a:solidFill>
+                  <a:srgbClr val="595959"/>
+                </a:solidFill>
+                <a:latin typeface="Arial" pitchFamily="34" charset="0"/>
+                <a:ea typeface="Arial" pitchFamily="34" charset="-122"/>
+                <a:cs typeface="Arial" pitchFamily="34" charset="-120"/>
+              </a:rPr>
+              <a:t>Median 4.125% at end-2026 and 4.125% at end-2027 (one more hike from 3.75–4.00%); cuts only from 2028.</a:t>
+            </a:r>
+            <a:endParaRPr lang="en-US" sz="880" dirty="0"/>
+          </a:p>
+          <a:p>
+            <a:pPr indent="0" marL="0">
+              <a:spcAft>
+                <a:spcPts val="100"/>
+              </a:spcAft>
+              <a:buNone/>
+            </a:pPr>
+            <a:r>
+              <a:rPr lang="en-US" sz="880" b="1" dirty="0">
+                <a:solidFill>
+                  <a:srgbClr val="2C5F82"/>
+                </a:solidFill>
+                <a:latin typeface="Arial" pitchFamily="34" charset="0"/>
+                <a:ea typeface="Arial" pitchFamily="34" charset="-122"/>
+                <a:cs typeface="Arial" pitchFamily="34" charset="-120"/>
+              </a:rPr>
+              <a:t>→ USD funding stays high for most of a 5-year note: the principal and a 70% floor are cheap to build</a:t>
+            </a:r>
+            <a:endParaRPr lang="en-US" sz="880" dirty="0"/>
+          </a:p>
+        </p:txBody>
+      </p:sp>
+      <p:sp>
+        <p:nvSpPr>
+          <p:cNvPr id="14" name="Shape 11"/>
+          <p:cNvSpPr/>
+          <p:nvPr/>
+        </p:nvSpPr>
+        <p:spPr>
+          <a:xfrm>
+            <a:off x="7269480" y="2075688"/>
+            <a:ext cx="4462272" cy="932688"/>
+          </a:xfrm>
+          <a:prstGeom prst="rect">
+            <a:avLst/>
+          </a:prstGeom>
+          <a:solidFill>
+            <a:srgbClr val="FFFFFF"/>
+          </a:solidFill>
+          <a:ln w="12700">
+            <a:solidFill>
+              <a:srgbClr val="F2F2F2"/>
+            </a:solidFill>
+            <a:prstDash val="solid"/>
+          </a:ln>
+        </p:spPr>
+      </p:sp>
+      <p:sp>
+        <p:nvSpPr>
+          <p:cNvPr id="15" name="Text 12"/>
+          <p:cNvSpPr txBox="1"/>
+          <p:nvPr/>
+        </p:nvSpPr>
+        <p:spPr>
+          <a:xfrm>
+            <a:off x="7315200" y="2075688"/>
+            <a:ext cx="1051560" cy="932688"/>
+          </a:xfrm>
+          <a:prstGeom prst="rect">
+            <a:avLst/>
+          </a:prstGeom>
+          <a:noFill/>
+          <a:ln/>
+        </p:spPr>
+        <p:txBody>
+          <a:bodyPr wrap="square" lIns="0" tIns="0" rIns="0" bIns="0" rtlCol="0" anchor="ctr"/>
+          <a:lstStyle/>
+          <a:p>
+            <a:pPr algn="ctr" indent="0" marL="0">
+              <a:buNone/>
+            </a:pPr>
+            <a:r>
+              <a:rPr lang="en-US" sz="1600" b="1" dirty="0">
+                <a:solidFill>
+                  <a:srgbClr val="2C5F82"/>
+                </a:solidFill>
+                <a:latin typeface="Arial" pitchFamily="34" charset="0"/>
+                <a:ea typeface="Arial" pitchFamily="34" charset="-122"/>
+                <a:cs typeface="Arial" pitchFamily="34" charset="-120"/>
+              </a:rPr>
+              <a:t>12 dots</a:t>
+            </a:r>
+            <a:endParaRPr lang="en-US" sz="1600" dirty="0"/>
+          </a:p>
+        </p:txBody>
+      </p:sp>
+      <p:sp>
+        <p:nvSpPr>
+          <p:cNvPr id="16" name="Text 13"/>
+          <p:cNvSpPr txBox="1"/>
+          <p:nvPr/>
+        </p:nvSpPr>
+        <p:spPr>
+          <a:xfrm>
+            <a:off x="8412480" y="2112264"/>
+            <a:ext cx="3227832" cy="859536"/>
+          </a:xfrm>
+          <a:prstGeom prst="rect">
+            <a:avLst/>
+          </a:prstGeom>
+          <a:noFill/>
+          <a:ln/>
+        </p:spPr>
+        <p:txBody>
+          <a:bodyPr wrap="square" lIns="0" tIns="0" rIns="0" bIns="0" rtlCol="0" anchor="ctr"/>
+          <a:lstStyle/>
+          <a:p>
+            <a:pPr indent="0" marL="0">
+              <a:spcAft>
+                <a:spcPts val="100"/>
+              </a:spcAft>
+              <a:buNone/>
+            </a:pPr>
+            <a:r>
+              <a:rPr lang="en-US" sz="880" b="1" dirty="0">
+                <a:solidFill>
+                  <a:srgbClr val="262626"/>
+                </a:solidFill>
+                <a:latin typeface="Arial" pitchFamily="34" charset="0"/>
+                <a:ea typeface="Arial" pitchFamily="34" charset="-122"/>
+                <a:cs typeface="Arial" pitchFamily="34" charset="-120"/>
+              </a:rPr>
+              <a:t>Risk of more hikes: </a:t>
+            </a:r>
+            <a:pPr indent="0" marL="0">
+              <a:spcAft>
+                <a:spcPts val="100"/>
+              </a:spcAft>
+              <a:buNone/>
+            </a:pPr>
+            <a:r>
+              <a:rPr lang="en-US" sz="880" dirty="0">
+                <a:solidFill>
+                  <a:srgbClr val="595959"/>
+                </a:solidFill>
+                <a:latin typeface="Arial" pitchFamily="34" charset="0"/>
+                <a:ea typeface="Arial" pitchFamily="34" charset="-122"/>
+                <a:cs typeface="Arial" pitchFamily="34" charset="-120"/>
+              </a:rPr>
+              <a:t>4 participants see 4.375% this year and 8 in 2027, above the median.</a:t>
+            </a:r>
+            <a:endParaRPr lang="en-US" sz="880" dirty="0"/>
+          </a:p>
+          <a:p>
+            <a:pPr indent="0" marL="0">
+              <a:spcAft>
+                <a:spcPts val="100"/>
+              </a:spcAft>
+              <a:buNone/>
+            </a:pPr>
+            <a:r>
+              <a:rPr lang="en-US" sz="880" b="1" dirty="0">
+                <a:solidFill>
+                  <a:srgbClr val="2C5F82"/>
+                </a:solidFill>
+                <a:latin typeface="Arial" pitchFamily="34" charset="0"/>
+                <a:ea typeface="Arial" pitchFamily="34" charset="-122"/>
+                <a:cs typeface="Arial" pitchFamily="34" charset="-120"/>
+              </a:rPr>
+              <a:t>→ A 5-year bond loses if rates rise further; an autocall can redeem from year 1 (expected life ~2 years)</a:t>
+            </a:r>
+            <a:endParaRPr lang="en-US" sz="880" dirty="0"/>
+          </a:p>
+        </p:txBody>
+      </p:sp>
+      <p:sp>
+        <p:nvSpPr>
+          <p:cNvPr id="17" name="Shape 14"/>
+          <p:cNvSpPr/>
+          <p:nvPr/>
+        </p:nvSpPr>
+        <p:spPr>
+          <a:xfrm>
+            <a:off x="7269480" y="3099816"/>
+            <a:ext cx="4462272" cy="932688"/>
+          </a:xfrm>
+          <a:prstGeom prst="rect">
+            <a:avLst/>
+          </a:prstGeom>
+          <a:solidFill>
+            <a:srgbClr val="F2F2F2"/>
+          </a:solidFill>
+          <a:ln w="12700">
+            <a:solidFill>
+              <a:srgbClr val="F2F2F2"/>
+            </a:solidFill>
+            <a:prstDash val="solid"/>
+          </a:ln>
+        </p:spPr>
+      </p:sp>
+      <p:sp>
+        <p:nvSpPr>
+          <p:cNvPr id="18" name="Text 15"/>
+          <p:cNvSpPr txBox="1"/>
+          <p:nvPr/>
+        </p:nvSpPr>
+        <p:spPr>
+          <a:xfrm>
+            <a:off x="7315200" y="3099816"/>
+            <a:ext cx="1051560" cy="932688"/>
+          </a:xfrm>
+          <a:prstGeom prst="rect">
+            <a:avLst/>
+          </a:prstGeom>
+          <a:noFill/>
+          <a:ln/>
+        </p:spPr>
+        <p:txBody>
+          <a:bodyPr wrap="square" lIns="0" tIns="0" rIns="0" bIns="0" rtlCol="0" anchor="ctr"/>
+          <a:lstStyle/>
+          <a:p>
+            <a:pPr algn="ctr" indent="0" marL="0">
+              <a:buNone/>
+            </a:pPr>
+            <a:r>
+              <a:rPr lang="en-US" sz="1600" b="1" dirty="0">
+                <a:solidFill>
+                  <a:srgbClr val="2C5F82"/>
+                </a:solidFill>
+                <a:latin typeface="Arial" pitchFamily="34" charset="0"/>
+                <a:ea typeface="Arial" pitchFamily="34" charset="-122"/>
+                <a:cs typeface="Arial" pitchFamily="34" charset="-120"/>
+              </a:rPr>
+              <a:t>125bp</a:t>
+            </a:r>
+            <a:endParaRPr lang="en-US" sz="1600" dirty="0"/>
+          </a:p>
+        </p:txBody>
+      </p:sp>
+      <p:sp>
+        <p:nvSpPr>
+          <p:cNvPr id="19" name="Text 16"/>
+          <p:cNvSpPr txBox="1"/>
+          <p:nvPr/>
+        </p:nvSpPr>
+        <p:spPr>
+          <a:xfrm>
+            <a:off x="8412480" y="3136392"/>
+            <a:ext cx="3227832" cy="859536"/>
+          </a:xfrm>
+          <a:prstGeom prst="rect">
+            <a:avLst/>
+          </a:prstGeom>
+          <a:noFill/>
+          <a:ln/>
+        </p:spPr>
+        <p:txBody>
+          <a:bodyPr wrap="square" lIns="0" tIns="0" rIns="0" bIns="0" rtlCol="0" anchor="ctr"/>
+          <a:lstStyle/>
+          <a:p>
+            <a:pPr indent="0" marL="0">
+              <a:spcAft>
+                <a:spcPts val="100"/>
+              </a:spcAft>
+              <a:buNone/>
+            </a:pPr>
+            <a:r>
+              <a:rPr lang="en-US" sz="880" b="1" dirty="0">
+                <a:solidFill>
+                  <a:srgbClr val="262626"/>
+                </a:solidFill>
+                <a:latin typeface="Arial" pitchFamily="34" charset="0"/>
+                <a:ea typeface="Arial" pitchFamily="34" charset="-122"/>
+                <a:cs typeface="Arial" pitchFamily="34" charset="-120"/>
+              </a:rPr>
+              <a:t>Wide disagreement: </a:t>
+            </a:r>
+            <a:pPr indent="0" marL="0">
+              <a:spcAft>
+                <a:spcPts val="100"/>
+              </a:spcAft>
+              <a:buNone/>
+            </a:pPr>
+            <a:r>
+              <a:rPr lang="en-US" sz="880" dirty="0">
+                <a:solidFill>
+                  <a:srgbClr val="595959"/>
+                </a:solidFill>
+                <a:latin typeface="Arial" pitchFamily="34" charset="0"/>
+                <a:ea typeface="Arial" pitchFamily="34" charset="-122"/>
+                <a:cs typeface="Arial" pitchFamily="34" charset="-120"/>
+              </a:rPr>
+              <a:t>2027 dots span 3.125%–4.375%; longer run 2.875%–3.875%. The rate path is uncertain.</a:t>
+            </a:r>
+            <a:endParaRPr lang="en-US" sz="880" dirty="0"/>
+          </a:p>
+          <a:p>
+            <a:pPr indent="0" marL="0">
+              <a:spcAft>
+                <a:spcPts val="100"/>
+              </a:spcAft>
+              <a:buNone/>
+            </a:pPr>
+            <a:r>
+              <a:rPr lang="en-US" sz="880" b="1" dirty="0">
+                <a:solidFill>
+                  <a:srgbClr val="2C5F82"/>
+                </a:solidFill>
+                <a:latin typeface="Arial" pitchFamily="34" charset="0"/>
+                <a:ea typeface="Arial" pitchFamily="34" charset="-122"/>
+                <a:cs typeface="Arial" pitchFamily="34" charset="-120"/>
+              </a:rPr>
+              <a:t>→ Rate uncertainty keeps volatility high, and richer option premium funds the coupon</a:t>
+            </a:r>
+            <a:endParaRPr lang="en-US" sz="880" dirty="0"/>
+          </a:p>
+        </p:txBody>
+      </p:sp>
+      <p:sp>
+        <p:nvSpPr>
+          <p:cNvPr id="20" name="Shape 17"/>
+          <p:cNvSpPr/>
+          <p:nvPr/>
+        </p:nvSpPr>
+        <p:spPr>
+          <a:xfrm>
+            <a:off x="7269480" y="4123944"/>
+            <a:ext cx="4462272" cy="932688"/>
+          </a:xfrm>
+          <a:prstGeom prst="rect">
+            <a:avLst/>
+          </a:prstGeom>
+          <a:solidFill>
+            <a:srgbClr val="FFFFFF"/>
+          </a:solidFill>
+          <a:ln w="12700">
+            <a:solidFill>
+              <a:srgbClr val="F2F2F2"/>
+            </a:solidFill>
+            <a:prstDash val="solid"/>
+          </a:ln>
+        </p:spPr>
+      </p:sp>
+      <p:sp>
+        <p:nvSpPr>
+          <p:cNvPr id="21" name="Text 18"/>
+          <p:cNvSpPr txBox="1"/>
+          <p:nvPr/>
+        </p:nvSpPr>
+        <p:spPr>
+          <a:xfrm>
+            <a:off x="7315200" y="4123944"/>
+            <a:ext cx="1051560" cy="932688"/>
+          </a:xfrm>
+          <a:prstGeom prst="rect">
+            <a:avLst/>
+          </a:prstGeom>
+          <a:noFill/>
+          <a:ln/>
+        </p:spPr>
+        <p:txBody>
+          <a:bodyPr wrap="square" lIns="0" tIns="0" rIns="0" bIns="0" rtlCol="0" anchor="ctr"/>
+          <a:lstStyle/>
+          <a:p>
+            <a:pPr algn="ctr" indent="0" marL="0">
+              <a:buNone/>
+            </a:pPr>
+            <a:r>
+              <a:rPr lang="en-US" sz="1600" b="1" dirty="0">
+                <a:solidFill>
+                  <a:srgbClr val="2C5F82"/>
+                </a:solidFill>
+                <a:latin typeface="Arial" pitchFamily="34" charset="0"/>
+                <a:ea typeface="Arial" pitchFamily="34" charset="-122"/>
+                <a:cs typeface="Arial" pitchFamily="34" charset="-120"/>
+              </a:rPr>
+              <a:t>3.25%</a:t>
+            </a:r>
+            <a:endParaRPr lang="en-US" sz="1600" dirty="0"/>
+          </a:p>
+        </p:txBody>
+      </p:sp>
+      <p:sp>
+        <p:nvSpPr>
+          <p:cNvPr id="22" name="Text 19"/>
+          <p:cNvSpPr txBox="1"/>
+          <p:nvPr/>
+        </p:nvSpPr>
+        <p:spPr>
+          <a:xfrm>
+            <a:off x="8412480" y="4160520"/>
+            <a:ext cx="3227832" cy="859536"/>
+          </a:xfrm>
+          <a:prstGeom prst="rect">
+            <a:avLst/>
+          </a:prstGeom>
+          <a:noFill/>
+          <a:ln/>
+        </p:spPr>
+        <p:txBody>
+          <a:bodyPr wrap="square" lIns="0" tIns="0" rIns="0" bIns="0" rtlCol="0" anchor="ctr"/>
+          <a:lstStyle/>
+          <a:p>
+            <a:pPr indent="0" marL="0">
+              <a:spcAft>
+                <a:spcPts val="100"/>
+              </a:spcAft>
+              <a:buNone/>
+            </a:pPr>
+            <a:r>
+              <a:rPr lang="en-US" sz="880" b="1" dirty="0">
+                <a:solidFill>
+                  <a:srgbClr val="262626"/>
+                </a:solidFill>
+                <a:latin typeface="Arial" pitchFamily="34" charset="0"/>
+                <a:ea typeface="Arial" pitchFamily="34" charset="-122"/>
+                <a:cs typeface="Arial" pitchFamily="34" charset="-120"/>
+              </a:rPr>
+              <a:t>Slow easing later: </a:t>
+            </a:r>
+            <a:pPr indent="0" marL="0">
+              <a:spcAft>
+                <a:spcPts val="100"/>
+              </a:spcAft>
+              <a:buNone/>
+            </a:pPr>
+            <a:r>
+              <a:rPr lang="en-US" sz="880" dirty="0">
+                <a:solidFill>
+                  <a:srgbClr val="595959"/>
+                </a:solidFill>
+                <a:latin typeface="Arial" pitchFamily="34" charset="0"/>
+                <a:ea typeface="Arial" pitchFamily="34" charset="-122"/>
+                <a:cs typeface="Arial" pitchFamily="34" charset="-120"/>
+              </a:rPr>
+              <a:t>Median falls to 3.875% in 2028 and 3.625% in 2029, towards 3.25% in the long run.</a:t>
+            </a:r>
+            <a:endParaRPr lang="en-US" sz="880" dirty="0"/>
+          </a:p>
+          <a:p>
+            <a:pPr indent="0" marL="0">
+              <a:spcAft>
+                <a:spcPts val="100"/>
+              </a:spcAft>
+              <a:buNone/>
+            </a:pPr>
+            <a:r>
+              <a:rPr lang="en-US" sz="880" b="1" dirty="0">
+                <a:solidFill>
+                  <a:srgbClr val="2C5F82"/>
+                </a:solidFill>
+                <a:latin typeface="Arial" pitchFamily="34" charset="0"/>
+                <a:ea typeface="Arial" pitchFamily="34" charset="-122"/>
+                <a:cs typeface="Arial" pitchFamily="34" charset="-120"/>
+              </a:rPr>
+              <a:t>→ Lower USD rates late in the note's life support Asian equities, helping the basket back to 100% (autocall)</a:t>
+            </a:r>
+            <a:endParaRPr lang="en-US" sz="880" dirty="0"/>
+          </a:p>
+        </p:txBody>
+      </p:sp>
+      <p:sp>
+        <p:nvSpPr>
+          <p:cNvPr id="23" name="Shape 20"/>
+          <p:cNvSpPr/>
+          <p:nvPr/>
+        </p:nvSpPr>
+        <p:spPr>
+          <a:xfrm>
+            <a:off x="457200" y="5559552"/>
+            <a:ext cx="11274552" cy="438912"/>
           </a:xfrm>
           <a:prstGeom prst="rect">
             <a:avLst/>
@@ -10306,14 +10991,14 @@
       </p:sp>
       <p:sp>
         <p:nvSpPr>
-          <p:cNvPr id="11" name="Text 9"/>
+          <p:cNvPr id="24" name="Text 21"/>
           <p:cNvSpPr txBox="1"/>
           <p:nvPr/>
         </p:nvSpPr>
         <p:spPr>
           <a:xfrm>
-            <a:off x="457200" y="1325880"/>
-            <a:ext cx="3730752" cy="292608"/>
+            <a:off x="594360" y="5559552"/>
+            <a:ext cx="11000232" cy="438912"/>
           </a:xfrm>
           <a:prstGeom prst="rect">
             <a:avLst/>
@@ -10329,7 +11014,7 @@
               <a:buNone/>
             </a:pPr>
             <a:r>
-              <a:rPr lang="en-US" sz="1050" b="1" dirty="0">
+              <a:rPr lang="en-US" sz="1200" b="1" dirty="0">
                 <a:solidFill>
                   <a:srgbClr val="FFFFFF"/>
                 </a:solidFill>
@@ -10337,38 +11022,22 @@
                 <a:ea typeface="Arial" pitchFamily="34" charset="-122"/>
                 <a:cs typeface="Arial" pitchFamily="34" charset="-120"/>
               </a:rPr>
-              <a:t>Rates are rising again</a:t>
-            </a:r>
-            <a:endParaRPr lang="en-US" sz="1050" dirty="0"/>
+              <a:t>Higher-for-longer USD rates make a capital floor cheap and long bonds risky: the setting suits a short-dated, buffered autocall.</a:t>
+            </a:r>
+            <a:endParaRPr lang="en-US" sz="1200" dirty="0"/>
           </a:p>
         </p:txBody>
       </p:sp>
-      <p:graphicFrame>
-        <p:nvGraphicFramePr>
-          <p:cNvPr id="12" name="Chart 0" descr=""/>
-          <p:cNvGraphicFramePr/>
-          <p:nvPr/>
-        </p:nvGraphicFramePr>
-        <p:xfrm>
-          <a:off x="457200" y="1655064"/>
-          <a:ext cx="3730752" cy="1261872"/>
-        </p:xfrm>
-        <a:graphic xmlns:a="http://schemas.openxmlformats.org/drawingml/2006/main">
-          <a:graphicData uri="http://schemas.openxmlformats.org/drawingml/2006/chart">
-            <c:chart xmlns:c="http://schemas.openxmlformats.org/drawingml/2006/chart" r:id="rId1"/>
-          </a:graphicData>
-        </a:graphic>
-      </p:graphicFrame>
-      <p:sp>
-        <p:nvSpPr>
-          <p:cNvPr id="13" name="Text 10"/>
+      <p:sp>
+        <p:nvSpPr>
+          <p:cNvPr id="25" name="Text 22"/>
           <p:cNvSpPr txBox="1"/>
           <p:nvPr/>
         </p:nvSpPr>
         <p:spPr>
           <a:xfrm>
-            <a:off x="457200" y="2953512"/>
-            <a:ext cx="3730752" cy="365760"/>
+            <a:off x="457200" y="6053328"/>
+            <a:ext cx="11274552" cy="274320"/>
           </a:xfrm>
           <a:prstGeom prst="rect">
             <a:avLst/>
@@ -10384,7 +11053,7 @@
               <a:buNone/>
             </a:pPr>
             <a:r>
-              <a:rPr lang="en-US" sz="850" dirty="0">
+              <a:rPr lang="en-US" sz="800" i="1" dirty="0">
                 <a:solidFill>
                   <a:srgbClr val="595959"/>
                 </a:solidFill>
@@ -10392,1153 +11061,7 @@
                 <a:ea typeface="Arial" pitchFamily="34" charset="-122"/>
                 <a:cs typeface="Arial" pitchFamily="34" charset="-120"/>
               </a:rPr>
-              <a:t>Fed funds upper bound: hikes 2022–23, cuts 2024–25, a hike again on 16 Sep 2026 (median dot 4.1% for end-2026).</a:t>
-            </a:r>
-            <a:endParaRPr lang="en-US" sz="850" dirty="0"/>
-          </a:p>
-        </p:txBody>
-      </p:sp>
-      <p:sp>
-        <p:nvSpPr>
-          <p:cNvPr id="14" name="Shape 11"/>
-          <p:cNvSpPr/>
-          <p:nvPr/>
-        </p:nvSpPr>
-        <p:spPr>
-          <a:xfrm>
-            <a:off x="4370832" y="1325880"/>
-            <a:ext cx="3730752" cy="292608"/>
-          </a:xfrm>
-          <a:prstGeom prst="rect">
-            <a:avLst/>
-          </a:prstGeom>
-          <a:solidFill>
-            <a:srgbClr val="2C5F82"/>
-          </a:solidFill>
-          <a:ln w="12700">
-            <a:solidFill>
-              <a:srgbClr val="2C5F82"/>
-            </a:solidFill>
-            <a:prstDash val="solid"/>
-          </a:ln>
-        </p:spPr>
-      </p:sp>
-      <p:sp>
-        <p:nvSpPr>
-          <p:cNvPr id="15" name="Text 12"/>
-          <p:cNvSpPr txBox="1"/>
-          <p:nvPr/>
-        </p:nvSpPr>
-        <p:spPr>
-          <a:xfrm>
-            <a:off x="4370832" y="1325880"/>
-            <a:ext cx="3730752" cy="292608"/>
-          </a:xfrm>
-          <a:prstGeom prst="rect">
-            <a:avLst/>
-          </a:prstGeom>
-          <a:noFill/>
-          <a:ln/>
-        </p:spPr>
-        <p:txBody>
-          <a:bodyPr wrap="square" lIns="0" tIns="0" rIns="0" bIns="0" rtlCol="0" anchor="ctr"/>
-          <a:lstStyle/>
-          <a:p>
-            <a:pPr algn="ctr" indent="0" marL="0">
-              <a:buNone/>
-            </a:pPr>
-            <a:r>
-              <a:rPr lang="en-US" sz="1050" b="1" dirty="0">
-                <a:solidFill>
-                  <a:srgbClr val="FFFFFF"/>
-                </a:solidFill>
-                <a:latin typeface="Arial" pitchFamily="34" charset="0"/>
-                <a:ea typeface="Arial" pitchFamily="34" charset="-122"/>
-                <a:cs typeface="Arial" pitchFamily="34" charset="-120"/>
-              </a:rPr>
-              <a:t>Equity paths are violent</a:t>
-            </a:r>
-            <a:endParaRPr lang="en-US" sz="1050" dirty="0"/>
-          </a:p>
-        </p:txBody>
-      </p:sp>
-      <p:graphicFrame>
-        <p:nvGraphicFramePr>
-          <p:cNvPr id="16" name="Chart 1" descr=""/>
-          <p:cNvGraphicFramePr/>
-          <p:nvPr/>
-        </p:nvGraphicFramePr>
-        <p:xfrm>
-          <a:off x="4370832" y="1655064"/>
-          <a:ext cx="3730752" cy="1261872"/>
-        </p:xfrm>
-        <a:graphic xmlns:a="http://schemas.openxmlformats.org/drawingml/2006/main">
-          <a:graphicData uri="http://schemas.openxmlformats.org/drawingml/2006/chart">
-            <c:chart xmlns:c="http://schemas.openxmlformats.org/drawingml/2006/chart" r:id="rId2"/>
-          </a:graphicData>
-        </a:graphic>
-      </p:graphicFrame>
-      <p:sp>
-        <p:nvSpPr>
-          <p:cNvPr id="17" name="Text 13"/>
-          <p:cNvSpPr txBox="1"/>
-          <p:nvPr/>
-        </p:nvSpPr>
-        <p:spPr>
-          <a:xfrm>
-            <a:off x="4370832" y="2953512"/>
-            <a:ext cx="3730752" cy="365760"/>
-          </a:xfrm>
-          <a:prstGeom prst="rect">
-            <a:avLst/>
-          </a:prstGeom>
-          <a:noFill/>
-          <a:ln/>
-        </p:spPr>
-        <p:txBody>
-          <a:bodyPr wrap="square" lIns="0" tIns="0" rIns="0" bIns="0" rtlCol="0" anchor="t"/>
-          <a:lstStyle/>
-          <a:p>
-            <a:pPr indent="0" marL="0">
-              <a:buNone/>
-            </a:pPr>
-            <a:r>
-              <a:rPr lang="en-US" sz="850" dirty="0">
-                <a:solidFill>
-                  <a:srgbClr val="595959"/>
-                </a:solidFill>
-                <a:latin typeface="Arial" pitchFamily="34" charset="0"/>
-                <a:ea typeface="Arial" pitchFamily="34" charset="-122"/>
-                <a:cs typeface="Arial" pitchFamily="34" charset="-120"/>
-              </a:rPr>
-              <a:t>Index levels, end-2021 = 100: −10–25% in 2022, then 2–3×. KOSPI fell ~25% from June to late August 2026.</a:t>
-            </a:r>
-            <a:endParaRPr lang="en-US" sz="850" dirty="0"/>
-          </a:p>
-        </p:txBody>
-      </p:sp>
-      <p:sp>
-        <p:nvSpPr>
-          <p:cNvPr id="18" name="Shape 14"/>
-          <p:cNvSpPr/>
-          <p:nvPr/>
-        </p:nvSpPr>
-        <p:spPr>
-          <a:xfrm>
-            <a:off x="457200" y="3383280"/>
-            <a:ext cx="3730752" cy="292608"/>
-          </a:xfrm>
-          <a:prstGeom prst="rect">
-            <a:avLst/>
-          </a:prstGeom>
-          <a:solidFill>
-            <a:srgbClr val="2C5F82"/>
-          </a:solidFill>
-          <a:ln w="12700">
-            <a:solidFill>
-              <a:srgbClr val="2C5F82"/>
-            </a:solidFill>
-            <a:prstDash val="solid"/>
-          </a:ln>
-        </p:spPr>
-      </p:sp>
-      <p:sp>
-        <p:nvSpPr>
-          <p:cNvPr id="19" name="Text 15"/>
-          <p:cNvSpPr txBox="1"/>
-          <p:nvPr/>
-        </p:nvSpPr>
-        <p:spPr>
-          <a:xfrm>
-            <a:off x="457200" y="3383280"/>
-            <a:ext cx="3730752" cy="292608"/>
-          </a:xfrm>
-          <a:prstGeom prst="rect">
-            <a:avLst/>
-          </a:prstGeom>
-          <a:noFill/>
-          <a:ln/>
-        </p:spPr>
-        <p:txBody>
-          <a:bodyPr wrap="square" lIns="0" tIns="0" rIns="0" bIns="0" rtlCol="0" anchor="ctr"/>
-          <a:lstStyle/>
-          <a:p>
-            <a:pPr algn="ctr" indent="0" marL="0">
-              <a:buNone/>
-            </a:pPr>
-            <a:r>
-              <a:rPr lang="en-US" sz="1050" b="1" dirty="0">
-                <a:solidFill>
-                  <a:srgbClr val="FFFFFF"/>
-                </a:solidFill>
-                <a:latin typeface="Arial" pitchFamily="34" charset="0"/>
-                <a:ea typeface="Arial" pitchFamily="34" charset="-122"/>
-                <a:cs typeface="Arial" pitchFamily="34" charset="-120"/>
-              </a:rPr>
-              <a:t>Long bonds carry rate risk</a:t>
-            </a:r>
-            <a:endParaRPr lang="en-US" sz="1050" dirty="0"/>
-          </a:p>
-        </p:txBody>
-      </p:sp>
-      <p:graphicFrame>
-        <p:nvGraphicFramePr>
-          <p:cNvPr id="20" name="Chart 2" descr=""/>
-          <p:cNvGraphicFramePr/>
-          <p:nvPr/>
-        </p:nvGraphicFramePr>
-        <p:xfrm>
-          <a:off x="457200" y="3712464"/>
-          <a:ext cx="3730752" cy="1261872"/>
-        </p:xfrm>
-        <a:graphic xmlns:a="http://schemas.openxmlformats.org/drawingml/2006/main">
-          <a:graphicData uri="http://schemas.openxmlformats.org/drawingml/2006/chart">
-            <c:chart xmlns:c="http://schemas.openxmlformats.org/drawingml/2006/chart" r:id="rId3"/>
-          </a:graphicData>
-        </a:graphic>
-      </p:graphicFrame>
-      <p:sp>
-        <p:nvSpPr>
-          <p:cNvPr id="21" name="Text 16"/>
-          <p:cNvSpPr txBox="1"/>
-          <p:nvPr/>
-        </p:nvSpPr>
-        <p:spPr>
-          <a:xfrm>
-            <a:off x="457200" y="5010912"/>
-            <a:ext cx="3730752" cy="365760"/>
-          </a:xfrm>
-          <a:prstGeom prst="rect">
-            <a:avLst/>
-          </a:prstGeom>
-          <a:noFill/>
-          <a:ln/>
-        </p:spPr>
-        <p:txBody>
-          <a:bodyPr wrap="square" lIns="0" tIns="0" rIns="0" bIns="0" rtlCol="0" anchor="t"/>
-          <a:lstStyle/>
-          <a:p>
-            <a:pPr indent="0" marL="0">
-              <a:buNone/>
-            </a:pPr>
-            <a:r>
-              <a:rPr lang="en-US" sz="850" dirty="0">
-                <a:solidFill>
-                  <a:srgbClr val="595959"/>
-                </a:solidFill>
-                <a:latin typeface="Arial" pitchFamily="34" charset="0"/>
-                <a:ea typeface="Arial" pitchFamily="34" charset="-122"/>
-                <a:cs typeface="Arial" pitchFamily="34" charset="-120"/>
-              </a:rPr>
-              <a:t>Value change of a 5-year USD bond (5.69% coupon) for parallel rate moves of −2% to +2%.</a:t>
-            </a:r>
-            <a:endParaRPr lang="en-US" sz="850" dirty="0"/>
-          </a:p>
-        </p:txBody>
-      </p:sp>
-      <p:sp>
-        <p:nvSpPr>
-          <p:cNvPr id="22" name="Shape 17"/>
-          <p:cNvSpPr/>
-          <p:nvPr/>
-        </p:nvSpPr>
-        <p:spPr>
-          <a:xfrm>
-            <a:off x="4370832" y="3383280"/>
-            <a:ext cx="3730752" cy="292608"/>
-          </a:xfrm>
-          <a:prstGeom prst="rect">
-            <a:avLst/>
-          </a:prstGeom>
-          <a:solidFill>
-            <a:srgbClr val="2C5F82"/>
-          </a:solidFill>
-          <a:ln w="12700">
-            <a:solidFill>
-              <a:srgbClr val="2C5F82"/>
-            </a:solidFill>
-            <a:prstDash val="solid"/>
-          </a:ln>
-        </p:spPr>
-      </p:sp>
-      <p:sp>
-        <p:nvSpPr>
-          <p:cNvPr id="23" name="Text 18"/>
-          <p:cNvSpPr txBox="1"/>
-          <p:nvPr/>
-        </p:nvSpPr>
-        <p:spPr>
-          <a:xfrm>
-            <a:off x="4370832" y="3383280"/>
-            <a:ext cx="3730752" cy="292608"/>
-          </a:xfrm>
-          <a:prstGeom prst="rect">
-            <a:avLst/>
-          </a:prstGeom>
-          <a:noFill/>
-          <a:ln/>
-        </p:spPr>
-        <p:txBody>
-          <a:bodyPr wrap="square" lIns="0" tIns="0" rIns="0" bIns="0" rtlCol="0" anchor="ctr"/>
-          <a:lstStyle/>
-          <a:p>
-            <a:pPr algn="ctr" indent="0" marL="0">
-              <a:buNone/>
-            </a:pPr>
-            <a:r>
-              <a:rPr lang="en-US" sz="1050" b="1" dirty="0">
-                <a:solidFill>
-                  <a:srgbClr val="FFFFFF"/>
-                </a:solidFill>
-                <a:latin typeface="Arial" pitchFamily="34" charset="0"/>
-                <a:ea typeface="Arial" pitchFamily="34" charset="-122"/>
-                <a:cs typeface="Arial" pitchFamily="34" charset="-120"/>
-              </a:rPr>
-              <a:t>Valuations already price in a lot</a:t>
-            </a:r>
-            <a:endParaRPr lang="en-US" sz="1050" dirty="0"/>
-          </a:p>
-        </p:txBody>
-      </p:sp>
-      <p:graphicFrame>
-        <p:nvGraphicFramePr>
-          <p:cNvPr id="24" name="Chart 3" descr=""/>
-          <p:cNvGraphicFramePr/>
-          <p:nvPr/>
-        </p:nvGraphicFramePr>
-        <p:xfrm>
-          <a:off x="4370832" y="3712464"/>
-          <a:ext cx="3730752" cy="1261872"/>
-        </p:xfrm>
-        <a:graphic xmlns:a="http://schemas.openxmlformats.org/drawingml/2006/main">
-          <a:graphicData uri="http://schemas.openxmlformats.org/drawingml/2006/chart">
-            <c:chart xmlns:c="http://schemas.openxmlformats.org/drawingml/2006/chart" r:id="rId4"/>
-          </a:graphicData>
-        </a:graphic>
-      </p:graphicFrame>
-      <p:sp>
-        <p:nvSpPr>
-          <p:cNvPr id="25" name="Text 19"/>
-          <p:cNvSpPr txBox="1"/>
-          <p:nvPr/>
-        </p:nvSpPr>
-        <p:spPr>
-          <a:xfrm>
-            <a:off x="4370832" y="5010912"/>
-            <a:ext cx="3730752" cy="365760"/>
-          </a:xfrm>
-          <a:prstGeom prst="rect">
-            <a:avLst/>
-          </a:prstGeom>
-          <a:noFill/>
-          <a:ln/>
-        </p:spPr>
-        <p:txBody>
-          <a:bodyPr wrap="square" lIns="0" tIns="0" rIns="0" bIns="0" rtlCol="0" anchor="t"/>
-          <a:lstStyle/>
-          <a:p>
-            <a:pPr indent="0" marL="0">
-              <a:buNone/>
-            </a:pPr>
-            <a:r>
-              <a:rPr lang="en-US" sz="850" dirty="0">
-                <a:solidFill>
-                  <a:srgbClr val="595959"/>
-                </a:solidFill>
-                <a:latin typeface="Arial" pitchFamily="34" charset="0"/>
-                <a:ea typeface="Arial" pitchFamily="34" charset="-122"/>
-                <a:cs typeface="Arial" pitchFamily="34" charset="-120"/>
-              </a:rPr>
-              <a:t>Siblis Research, 1 Jul 2026. Korea's gap assumes earnings roughly triple; Nikkei CAPE 38.6×; Taiwan among the most expensive markets.</a:t>
-            </a:r>
-            <a:endParaRPr lang="en-US" sz="850" dirty="0"/>
-          </a:p>
-        </p:txBody>
-      </p:sp>
-      <p:sp>
-        <p:nvSpPr>
-          <p:cNvPr id="26" name="Text 20"/>
-          <p:cNvSpPr txBox="1"/>
-          <p:nvPr/>
-        </p:nvSpPr>
-        <p:spPr>
-          <a:xfrm>
-            <a:off x="8211312" y="1280160"/>
-            <a:ext cx="3520440" cy="320040"/>
-          </a:xfrm>
-          <a:prstGeom prst="rect">
-            <a:avLst/>
-          </a:prstGeom>
-          <a:noFill/>
-          <a:ln/>
-        </p:spPr>
-        <p:txBody>
-          <a:bodyPr wrap="square" lIns="0" tIns="0" rIns="0" bIns="0" rtlCol="0" anchor="t"/>
-          <a:lstStyle/>
-          <a:p>
-            <a:pPr algn="ctr" indent="0" marL="0">
-              <a:buNone/>
-            </a:pPr>
-            <a:r>
-              <a:rPr lang="en-US" sz="1500" b="1" dirty="0">
-                <a:solidFill>
-                  <a:srgbClr val="262626"/>
-                </a:solidFill>
-                <a:latin typeface="Arial" pitchFamily="34" charset="0"/>
-                <a:ea typeface="Arial" pitchFamily="34" charset="-122"/>
-                <a:cs typeface="Arial" pitchFamily="34" charset="-120"/>
-              </a:rPr>
-              <a:t>Implications</a:t>
-            </a:r>
-            <a:endParaRPr lang="en-US" sz="1500" dirty="0"/>
-          </a:p>
-        </p:txBody>
-      </p:sp>
-      <p:sp>
-        <p:nvSpPr>
-          <p:cNvPr id="27" name="Shape 21"/>
-          <p:cNvSpPr/>
-          <p:nvPr/>
-        </p:nvSpPr>
-        <p:spPr>
-          <a:xfrm>
-            <a:off x="8485632" y="1627632"/>
-            <a:ext cx="2971800" cy="0"/>
-          </a:xfrm>
-          <a:prstGeom prst="line">
-            <a:avLst/>
-          </a:prstGeom>
-          <a:noFill/>
-          <a:ln w="9525">
-            <a:solidFill>
-              <a:srgbClr val="2C5F82"/>
-            </a:solidFill>
-            <a:prstDash val="solid"/>
-          </a:ln>
-        </p:spPr>
-      </p:sp>
-      <p:sp>
-        <p:nvSpPr>
-          <p:cNvPr id="28" name="Text 22"/>
-          <p:cNvSpPr txBox="1"/>
-          <p:nvPr/>
-        </p:nvSpPr>
-        <p:spPr>
-          <a:xfrm>
-            <a:off x="8211312" y="1645920"/>
-            <a:ext cx="3520440" cy="274320"/>
-          </a:xfrm>
-          <a:prstGeom prst="rect">
-            <a:avLst/>
-          </a:prstGeom>
-          <a:noFill/>
-          <a:ln/>
-        </p:spPr>
-        <p:txBody>
-          <a:bodyPr wrap="square" lIns="0" tIns="0" rIns="0" bIns="0" rtlCol="0" anchor="t"/>
-          <a:lstStyle/>
-          <a:p>
-            <a:pPr algn="ctr" indent="0" marL="0">
-              <a:buNone/>
-            </a:pPr>
-            <a:r>
-              <a:rPr lang="en-US" sz="800" i="1" dirty="0">
-                <a:solidFill>
-                  <a:srgbClr val="595959"/>
-                </a:solidFill>
-                <a:latin typeface="Arial" pitchFamily="34" charset="0"/>
-                <a:ea typeface="Arial" pitchFamily="34" charset="-122"/>
-                <a:cs typeface="Arial" pitchFamily="34" charset="-120"/>
-              </a:rPr>
-              <a:t>Market proof: Taiwan structured-note issuance +81% in 2025, snowball autocalls the favourite payoff (SRP)</a:t>
-            </a:r>
-            <a:endParaRPr lang="en-US" sz="800" dirty="0"/>
-          </a:p>
-        </p:txBody>
-      </p:sp>
-      <p:sp>
-        <p:nvSpPr>
-          <p:cNvPr id="29" name="Shape 23"/>
-          <p:cNvSpPr/>
-          <p:nvPr/>
-        </p:nvSpPr>
-        <p:spPr>
-          <a:xfrm>
-            <a:off x="8211312" y="1938528"/>
-            <a:ext cx="3520440" cy="621792"/>
-          </a:xfrm>
-          <a:prstGeom prst="rect">
-            <a:avLst/>
-          </a:prstGeom>
-          <a:solidFill>
-            <a:srgbClr val="FFFFFF"/>
-          </a:solidFill>
-          <a:ln w="12700">
-            <a:solidFill>
-              <a:srgbClr val="2C5F82"/>
-            </a:solidFill>
-            <a:prstDash val="solid"/>
-          </a:ln>
-        </p:spPr>
-      </p:sp>
-      <p:sp>
-        <p:nvSpPr>
-          <p:cNvPr id="30" name="Text 24"/>
-          <p:cNvSpPr txBox="1"/>
-          <p:nvPr/>
-        </p:nvSpPr>
-        <p:spPr>
-          <a:xfrm>
-            <a:off x="8257032" y="1938528"/>
-            <a:ext cx="411480" cy="621792"/>
-          </a:xfrm>
-          <a:prstGeom prst="rect">
-            <a:avLst/>
-          </a:prstGeom>
-          <a:noFill/>
-          <a:ln/>
-        </p:spPr>
-        <p:txBody>
-          <a:bodyPr wrap="square" lIns="0" tIns="0" rIns="0" bIns="0" rtlCol="0" anchor="ctr"/>
-          <a:lstStyle/>
-          <a:p>
-            <a:pPr algn="ctr" indent="0" marL="0">
-              <a:buNone/>
-            </a:pPr>
-            <a:r>
-              <a:rPr lang="en-US" sz="2200" b="1" i="1" dirty="0">
-                <a:solidFill>
-                  <a:srgbClr val="2C5F82"/>
-                </a:solidFill>
-                <a:latin typeface="Arial" pitchFamily="34" charset="0"/>
-                <a:ea typeface="Arial" pitchFamily="34" charset="-122"/>
-                <a:cs typeface="Arial" pitchFamily="34" charset="-120"/>
-              </a:rPr>
-              <a:t>1</a:t>
-            </a:r>
-            <a:endParaRPr lang="en-US" sz="2200" dirty="0"/>
-          </a:p>
-        </p:txBody>
-      </p:sp>
-      <p:sp>
-        <p:nvSpPr>
-          <p:cNvPr id="31" name="Text 25"/>
-          <p:cNvSpPr txBox="1"/>
-          <p:nvPr/>
-        </p:nvSpPr>
-        <p:spPr>
-          <a:xfrm>
-            <a:off x="8714232" y="1956816"/>
-            <a:ext cx="2926080" cy="585216"/>
-          </a:xfrm>
-          <a:prstGeom prst="rect">
-            <a:avLst/>
-          </a:prstGeom>
-          <a:noFill/>
-          <a:ln/>
-        </p:spPr>
-        <p:txBody>
-          <a:bodyPr wrap="square" lIns="0" tIns="0" rIns="0" bIns="0" rtlCol="0" anchor="ctr"/>
-          <a:lstStyle/>
-          <a:p>
-            <a:pPr indent="0" marL="0">
-              <a:buNone/>
-            </a:pPr>
-            <a:r>
-              <a:rPr lang="en-US" sz="880" b="1" dirty="0">
-                <a:solidFill>
-                  <a:srgbClr val="262626"/>
-                </a:solidFill>
-                <a:latin typeface="Arial" pitchFamily="34" charset="0"/>
-                <a:ea typeface="Arial" pitchFamily="34" charset="-122"/>
-                <a:cs typeface="Arial" pitchFamily="34" charset="-120"/>
-              </a:rPr>
-              <a:t>Early exit beats duration: </a:t>
-            </a:r>
-            <a:pPr indent="0" marL="0">
-              <a:buNone/>
-            </a:pPr>
-            <a:r>
-              <a:rPr lang="en-US" sz="880" dirty="0">
-                <a:solidFill>
-                  <a:srgbClr val="595959"/>
-                </a:solidFill>
-                <a:latin typeface="Arial" pitchFamily="34" charset="0"/>
-                <a:ea typeface="Arial" pitchFamily="34" charset="-122"/>
-                <a:cs typeface="Arial" pitchFamily="34" charset="-120"/>
-              </a:rPr>
-              <a:t>Bonds lose ~4.0% per 1% rate rise; autocalls can redeem from year 1</a:t>
-            </a:r>
-            <a:endParaRPr lang="en-US" sz="880" dirty="0"/>
-          </a:p>
-        </p:txBody>
-      </p:sp>
-      <p:sp>
-        <p:nvSpPr>
-          <p:cNvPr id="32" name="Shape 26"/>
-          <p:cNvSpPr/>
-          <p:nvPr/>
-        </p:nvSpPr>
-        <p:spPr>
-          <a:xfrm>
-            <a:off x="8211312" y="2633472"/>
-            <a:ext cx="3520440" cy="621792"/>
-          </a:xfrm>
-          <a:prstGeom prst="rect">
-            <a:avLst/>
-          </a:prstGeom>
-          <a:solidFill>
-            <a:srgbClr val="FFFFFF"/>
-          </a:solidFill>
-          <a:ln w="12700">
-            <a:solidFill>
-              <a:srgbClr val="2C5F82"/>
-            </a:solidFill>
-            <a:prstDash val="solid"/>
-          </a:ln>
-        </p:spPr>
-      </p:sp>
-      <p:sp>
-        <p:nvSpPr>
-          <p:cNvPr id="33" name="Text 27"/>
-          <p:cNvSpPr txBox="1"/>
-          <p:nvPr/>
-        </p:nvSpPr>
-        <p:spPr>
-          <a:xfrm>
-            <a:off x="8257032" y="2633472"/>
-            <a:ext cx="411480" cy="621792"/>
-          </a:xfrm>
-          <a:prstGeom prst="rect">
-            <a:avLst/>
-          </a:prstGeom>
-          <a:noFill/>
-          <a:ln/>
-        </p:spPr>
-        <p:txBody>
-          <a:bodyPr wrap="square" lIns="0" tIns="0" rIns="0" bIns="0" rtlCol="0" anchor="ctr"/>
-          <a:lstStyle/>
-          <a:p>
-            <a:pPr algn="ctr" indent="0" marL="0">
-              <a:buNone/>
-            </a:pPr>
-            <a:r>
-              <a:rPr lang="en-US" sz="2200" b="1" i="1" dirty="0">
-                <a:solidFill>
-                  <a:srgbClr val="2C5F82"/>
-                </a:solidFill>
-                <a:latin typeface="Arial" pitchFamily="34" charset="0"/>
-                <a:ea typeface="Arial" pitchFamily="34" charset="-122"/>
-                <a:cs typeface="Arial" pitchFamily="34" charset="-120"/>
-              </a:rPr>
-              <a:t>2</a:t>
-            </a:r>
-            <a:endParaRPr lang="en-US" sz="2200" dirty="0"/>
-          </a:p>
-        </p:txBody>
-      </p:sp>
-      <p:sp>
-        <p:nvSpPr>
-          <p:cNvPr id="34" name="Text 28"/>
-          <p:cNvSpPr txBox="1"/>
-          <p:nvPr/>
-        </p:nvSpPr>
-        <p:spPr>
-          <a:xfrm>
-            <a:off x="8714232" y="2651760"/>
-            <a:ext cx="2926080" cy="585216"/>
-          </a:xfrm>
-          <a:prstGeom prst="rect">
-            <a:avLst/>
-          </a:prstGeom>
-          <a:noFill/>
-          <a:ln/>
-        </p:spPr>
-        <p:txBody>
-          <a:bodyPr wrap="square" lIns="0" tIns="0" rIns="0" bIns="0" rtlCol="0" anchor="ctr"/>
-          <a:lstStyle/>
-          <a:p>
-            <a:pPr indent="0" marL="0">
-              <a:buNone/>
-            </a:pPr>
-            <a:r>
-              <a:rPr lang="en-US" sz="880" b="1" dirty="0">
-                <a:solidFill>
-                  <a:srgbClr val="262626"/>
-                </a:solidFill>
-                <a:latin typeface="Arial" pitchFamily="34" charset="0"/>
-                <a:ea typeface="Arial" pitchFamily="34" charset="-122"/>
-                <a:cs typeface="Arial" pitchFamily="34" charset="-120"/>
-              </a:rPr>
-              <a:t>Paid on recovery, not timing: </a:t>
-            </a:r>
-            <a:pPr indent="0" marL="0">
-              <a:buNone/>
-            </a:pPr>
-            <a:r>
-              <a:rPr lang="en-US" sz="880" dirty="0">
-                <a:solidFill>
-                  <a:srgbClr val="595959"/>
-                </a:solidFill>
-                <a:latin typeface="Arial" pitchFamily="34" charset="0"/>
-                <a:ea typeface="Arial" pitchFamily="34" charset="-122"/>
-                <a:cs typeface="Arial" pitchFamily="34" charset="-120"/>
-              </a:rPr>
-              <a:t>−25% in ten weeks (KOSPI 2026): autocall coupons pay once the basket is back at its start</a:t>
-            </a:r>
-            <a:endParaRPr lang="en-US" sz="880" dirty="0"/>
-          </a:p>
-        </p:txBody>
-      </p:sp>
-      <p:sp>
-        <p:nvSpPr>
-          <p:cNvPr id="35" name="Shape 29"/>
-          <p:cNvSpPr/>
-          <p:nvPr/>
-        </p:nvSpPr>
-        <p:spPr>
-          <a:xfrm>
-            <a:off x="8211312" y="3328416"/>
-            <a:ext cx="3520440" cy="621792"/>
-          </a:xfrm>
-          <a:prstGeom prst="rect">
-            <a:avLst/>
-          </a:prstGeom>
-          <a:solidFill>
-            <a:srgbClr val="FFFFFF"/>
-          </a:solidFill>
-          <a:ln w="12700">
-            <a:solidFill>
-              <a:srgbClr val="2C5F82"/>
-            </a:solidFill>
-            <a:prstDash val="solid"/>
-          </a:ln>
-        </p:spPr>
-      </p:sp>
-      <p:sp>
-        <p:nvSpPr>
-          <p:cNvPr id="36" name="Text 30"/>
-          <p:cNvSpPr txBox="1"/>
-          <p:nvPr/>
-        </p:nvSpPr>
-        <p:spPr>
-          <a:xfrm>
-            <a:off x="8257032" y="3328416"/>
-            <a:ext cx="411480" cy="621792"/>
-          </a:xfrm>
-          <a:prstGeom prst="rect">
-            <a:avLst/>
-          </a:prstGeom>
-          <a:noFill/>
-          <a:ln/>
-        </p:spPr>
-        <p:txBody>
-          <a:bodyPr wrap="square" lIns="0" tIns="0" rIns="0" bIns="0" rtlCol="0" anchor="ctr"/>
-          <a:lstStyle/>
-          <a:p>
-            <a:pPr algn="ctr" indent="0" marL="0">
-              <a:buNone/>
-            </a:pPr>
-            <a:r>
-              <a:rPr lang="en-US" sz="2200" b="1" i="1" dirty="0">
-                <a:solidFill>
-                  <a:srgbClr val="2C5F82"/>
-                </a:solidFill>
-                <a:latin typeface="Arial" pitchFamily="34" charset="0"/>
-                <a:ea typeface="Arial" pitchFamily="34" charset="-122"/>
-                <a:cs typeface="Arial" pitchFamily="34" charset="-120"/>
-              </a:rPr>
-              <a:t>3</a:t>
-            </a:r>
-            <a:endParaRPr lang="en-US" sz="2200" dirty="0"/>
-          </a:p>
-        </p:txBody>
-      </p:sp>
-      <p:sp>
-        <p:nvSpPr>
-          <p:cNvPr id="37" name="Text 31"/>
-          <p:cNvSpPr txBox="1"/>
-          <p:nvPr/>
-        </p:nvSpPr>
-        <p:spPr>
-          <a:xfrm>
-            <a:off x="8714232" y="3346704"/>
-            <a:ext cx="2926080" cy="585216"/>
-          </a:xfrm>
-          <a:prstGeom prst="rect">
-            <a:avLst/>
-          </a:prstGeom>
-          <a:noFill/>
-          <a:ln/>
-        </p:spPr>
-        <p:txBody>
-          <a:bodyPr wrap="square" lIns="0" tIns="0" rIns="0" bIns="0" rtlCol="0" anchor="ctr"/>
-          <a:lstStyle/>
-          <a:p>
-            <a:pPr indent="0" marL="0">
-              <a:buNone/>
-            </a:pPr>
-            <a:r>
-              <a:rPr lang="en-US" sz="880" b="1" dirty="0">
-                <a:solidFill>
-                  <a:srgbClr val="262626"/>
-                </a:solidFill>
-                <a:latin typeface="Arial" pitchFamily="34" charset="0"/>
-                <a:ea typeface="Arial" pitchFamily="34" charset="-122"/>
-                <a:cs typeface="Arial" pitchFamily="34" charset="-120"/>
-              </a:rPr>
-              <a:t>Diversify the basket: </a:t>
-            </a:r>
-            <a:pPr indent="0" marL="0">
-              <a:buNone/>
-            </a:pPr>
-            <a:r>
-              <a:rPr lang="en-US" sz="880" dirty="0">
-                <a:solidFill>
-                  <a:srgbClr val="595959"/>
-                </a:solidFill>
-                <a:latin typeface="Arial" pitchFamily="34" charset="0"/>
-                <a:ea typeface="Arial" pitchFamily="34" charset="-122"/>
-                <a:cs typeface="Arial" pitchFamily="34" charset="-120"/>
-              </a:rPr>
-              <a:t>TSMC &gt;40% of TAIEX, ~92% of advanced chips from Taiwan: use a diversified ETF basket, not worst-of</a:t>
-            </a:r>
-            <a:endParaRPr lang="en-US" sz="880" dirty="0"/>
-          </a:p>
-        </p:txBody>
-      </p:sp>
-      <p:sp>
-        <p:nvSpPr>
-          <p:cNvPr id="38" name="Shape 32"/>
-          <p:cNvSpPr/>
-          <p:nvPr/>
-        </p:nvSpPr>
-        <p:spPr>
-          <a:xfrm>
-            <a:off x="8211312" y="4023360"/>
-            <a:ext cx="3520440" cy="621792"/>
-          </a:xfrm>
-          <a:prstGeom prst="rect">
-            <a:avLst/>
-          </a:prstGeom>
-          <a:solidFill>
-            <a:srgbClr val="FFFFFF"/>
-          </a:solidFill>
-          <a:ln w="12700">
-            <a:solidFill>
-              <a:srgbClr val="2C5F82"/>
-            </a:solidFill>
-            <a:prstDash val="solid"/>
-          </a:ln>
-        </p:spPr>
-      </p:sp>
-      <p:sp>
-        <p:nvSpPr>
-          <p:cNvPr id="39" name="Text 33"/>
-          <p:cNvSpPr txBox="1"/>
-          <p:nvPr/>
-        </p:nvSpPr>
-        <p:spPr>
-          <a:xfrm>
-            <a:off x="8257032" y="4023360"/>
-            <a:ext cx="411480" cy="621792"/>
-          </a:xfrm>
-          <a:prstGeom prst="rect">
-            <a:avLst/>
-          </a:prstGeom>
-          <a:noFill/>
-          <a:ln/>
-        </p:spPr>
-        <p:txBody>
-          <a:bodyPr wrap="square" lIns="0" tIns="0" rIns="0" bIns="0" rtlCol="0" anchor="ctr"/>
-          <a:lstStyle/>
-          <a:p>
-            <a:pPr algn="ctr" indent="0" marL="0">
-              <a:buNone/>
-            </a:pPr>
-            <a:r>
-              <a:rPr lang="en-US" sz="2200" b="1" i="1" dirty="0">
-                <a:solidFill>
-                  <a:srgbClr val="2C5F82"/>
-                </a:solidFill>
-                <a:latin typeface="Arial" pitchFamily="34" charset="0"/>
-                <a:ea typeface="Arial" pitchFamily="34" charset="-122"/>
-                <a:cs typeface="Arial" pitchFamily="34" charset="-120"/>
-              </a:rPr>
-              <a:t>4</a:t>
-            </a:r>
-            <a:endParaRPr lang="en-US" sz="2200" dirty="0"/>
-          </a:p>
-        </p:txBody>
-      </p:sp>
-      <p:sp>
-        <p:nvSpPr>
-          <p:cNvPr id="40" name="Text 34"/>
-          <p:cNvSpPr txBox="1"/>
-          <p:nvPr/>
-        </p:nvSpPr>
-        <p:spPr>
-          <a:xfrm>
-            <a:off x="8714232" y="4041648"/>
-            <a:ext cx="2926080" cy="585216"/>
-          </a:xfrm>
-          <a:prstGeom prst="rect">
-            <a:avLst/>
-          </a:prstGeom>
-          <a:noFill/>
-          <a:ln/>
-        </p:spPr>
-        <p:txBody>
-          <a:bodyPr wrap="square" lIns="0" tIns="0" rIns="0" bIns="0" rtlCol="0" anchor="ctr"/>
-          <a:lstStyle/>
-          <a:p>
-            <a:pPr indent="0" marL="0">
-              <a:buNone/>
-            </a:pPr>
-            <a:r>
-              <a:rPr lang="en-US" sz="880" b="1" dirty="0">
-                <a:solidFill>
-                  <a:srgbClr val="262626"/>
-                </a:solidFill>
-                <a:latin typeface="Arial" pitchFamily="34" charset="0"/>
-                <a:ea typeface="Arial" pitchFamily="34" charset="-122"/>
-                <a:cs typeface="Arial" pitchFamily="34" charset="-120"/>
-              </a:rPr>
-              <a:t>Volatility funds the coupon: </a:t>
-            </a:r>
-            <a:pPr indent="0" marL="0">
-              <a:buNone/>
-            </a:pPr>
-            <a:r>
-              <a:rPr lang="en-US" sz="880" dirty="0">
-                <a:solidFill>
-                  <a:srgbClr val="595959"/>
-                </a:solidFill>
-                <a:latin typeface="Arial" pitchFamily="34" charset="0"/>
-                <a:ea typeface="Arial" pitchFamily="34" charset="-122"/>
-                <a:cs typeface="Arial" pitchFamily="34" charset="-120"/>
-              </a:rPr>
-              <a:t>VKOSPI at a record 91.2: richer option premium means higher autocall coupons</a:t>
-            </a:r>
-            <a:endParaRPr lang="en-US" sz="880" dirty="0"/>
-          </a:p>
-        </p:txBody>
-      </p:sp>
-      <p:sp>
-        <p:nvSpPr>
-          <p:cNvPr id="41" name="Shape 35"/>
-          <p:cNvSpPr/>
-          <p:nvPr/>
-        </p:nvSpPr>
-        <p:spPr>
-          <a:xfrm>
-            <a:off x="8211312" y="4718304"/>
-            <a:ext cx="3520440" cy="621792"/>
-          </a:xfrm>
-          <a:prstGeom prst="rect">
-            <a:avLst/>
-          </a:prstGeom>
-          <a:solidFill>
-            <a:srgbClr val="FFFFFF"/>
-          </a:solidFill>
-          <a:ln w="12700">
-            <a:solidFill>
-              <a:srgbClr val="2C5F82"/>
-            </a:solidFill>
-            <a:prstDash val="solid"/>
-          </a:ln>
-        </p:spPr>
-      </p:sp>
-      <p:sp>
-        <p:nvSpPr>
-          <p:cNvPr id="42" name="Text 36"/>
-          <p:cNvSpPr txBox="1"/>
-          <p:nvPr/>
-        </p:nvSpPr>
-        <p:spPr>
-          <a:xfrm>
-            <a:off x="8257032" y="4718304"/>
-            <a:ext cx="411480" cy="621792"/>
-          </a:xfrm>
-          <a:prstGeom prst="rect">
-            <a:avLst/>
-          </a:prstGeom>
-          <a:noFill/>
-          <a:ln/>
-        </p:spPr>
-        <p:txBody>
-          <a:bodyPr wrap="square" lIns="0" tIns="0" rIns="0" bIns="0" rtlCol="0" anchor="ctr"/>
-          <a:lstStyle/>
-          <a:p>
-            <a:pPr algn="ctr" indent="0" marL="0">
-              <a:buNone/>
-            </a:pPr>
-            <a:r>
-              <a:rPr lang="en-US" sz="2200" b="1" i="1" dirty="0">
-                <a:solidFill>
-                  <a:srgbClr val="2C5F82"/>
-                </a:solidFill>
-                <a:latin typeface="Arial" pitchFamily="34" charset="0"/>
-                <a:ea typeface="Arial" pitchFamily="34" charset="-122"/>
-                <a:cs typeface="Arial" pitchFamily="34" charset="-120"/>
-              </a:rPr>
-              <a:t>5</a:t>
-            </a:r>
-            <a:endParaRPr lang="en-US" sz="2200" dirty="0"/>
-          </a:p>
-        </p:txBody>
-      </p:sp>
-      <p:sp>
-        <p:nvSpPr>
-          <p:cNvPr id="43" name="Text 37"/>
-          <p:cNvSpPr txBox="1"/>
-          <p:nvPr/>
-        </p:nvSpPr>
-        <p:spPr>
-          <a:xfrm>
-            <a:off x="8714232" y="4736592"/>
-            <a:ext cx="2926080" cy="585216"/>
-          </a:xfrm>
-          <a:prstGeom prst="rect">
-            <a:avLst/>
-          </a:prstGeom>
-          <a:noFill/>
-          <a:ln/>
-        </p:spPr>
-        <p:txBody>
-          <a:bodyPr wrap="square" lIns="0" tIns="0" rIns="0" bIns="0" rtlCol="0" anchor="ctr"/>
-          <a:lstStyle/>
-          <a:p>
-            <a:pPr indent="0" marL="0">
-              <a:buNone/>
-            </a:pPr>
-            <a:r>
-              <a:rPr lang="en-US" sz="880" b="1" dirty="0">
-                <a:solidFill>
-                  <a:srgbClr val="262626"/>
-                </a:solidFill>
-                <a:latin typeface="Arial" pitchFamily="34" charset="0"/>
-                <a:ea typeface="Arial" pitchFamily="34" charset="-122"/>
-                <a:cs typeface="Arial" pitchFamily="34" charset="-120"/>
-              </a:rPr>
-              <a:t>Protection is affordable: </a:t>
-            </a:r>
-            <a:pPr indent="0" marL="0">
-              <a:buNone/>
-            </a:pPr>
-            <a:r>
-              <a:rPr lang="en-US" sz="880" dirty="0">
-                <a:solidFill>
-                  <a:srgbClr val="595959"/>
-                </a:solidFill>
-                <a:latin typeface="Arial" pitchFamily="34" charset="0"/>
-                <a:ea typeface="Arial" pitchFamily="34" charset="-122"/>
-                <a:cs typeface="Arial" pitchFamily="34" charset="-120"/>
-              </a:rPr>
-              <a:t>USD 100 in 5 years costs USD 75.8 at 5.69%: a buffer and a 70% floor fit inside an autocall</a:t>
-            </a:r>
-            <a:endParaRPr lang="en-US" sz="880" dirty="0"/>
-          </a:p>
-        </p:txBody>
-      </p:sp>
-      <p:sp>
-        <p:nvSpPr>
-          <p:cNvPr id="44" name="Shape 38"/>
-          <p:cNvSpPr/>
-          <p:nvPr/>
-        </p:nvSpPr>
-        <p:spPr>
-          <a:xfrm>
-            <a:off x="457200" y="5486400"/>
-            <a:ext cx="11274552" cy="438912"/>
-          </a:xfrm>
-          <a:prstGeom prst="rect">
-            <a:avLst/>
-          </a:prstGeom>
-          <a:solidFill>
-            <a:srgbClr val="2C5F82"/>
-          </a:solidFill>
-          <a:ln w="12700">
-            <a:solidFill>
-              <a:srgbClr val="2C5F82"/>
-            </a:solidFill>
-            <a:prstDash val="solid"/>
-          </a:ln>
-        </p:spPr>
-      </p:sp>
-      <p:sp>
-        <p:nvSpPr>
-          <p:cNvPr id="45" name="Text 39"/>
-          <p:cNvSpPr txBox="1"/>
-          <p:nvPr/>
-        </p:nvSpPr>
-        <p:spPr>
-          <a:xfrm>
-            <a:off x="594360" y="5486400"/>
-            <a:ext cx="11000232" cy="438912"/>
-          </a:xfrm>
-          <a:prstGeom prst="rect">
-            <a:avLst/>
-          </a:prstGeom>
-          <a:noFill/>
-          <a:ln/>
-        </p:spPr>
-        <p:txBody>
-          <a:bodyPr wrap="square" lIns="0" tIns="0" rIns="0" bIns="0" rtlCol="0" anchor="ctr"/>
-          <a:lstStyle/>
-          <a:p>
-            <a:pPr algn="ctr" indent="0" marL="0">
-              <a:buNone/>
-            </a:pPr>
-            <a:r>
-              <a:rPr lang="en-US" sz="1200" b="1" dirty="0">
-                <a:solidFill>
-                  <a:srgbClr val="FFFFFF"/>
-                </a:solidFill>
-                <a:latin typeface="Arial" pitchFamily="34" charset="0"/>
-                <a:ea typeface="Arial" pitchFamily="34" charset="-122"/>
-                <a:cs typeface="Arial" pitchFamily="34" charset="-120"/>
-              </a:rPr>
-              <a:t>Plain bonds and equities leave investors exposed; a buffered autocall with a 70% floor keeps the theme and manages the risks.</a:t>
-            </a:r>
-            <a:endParaRPr lang="en-US" sz="1200" dirty="0"/>
-          </a:p>
-        </p:txBody>
-      </p:sp>
-      <p:sp>
-        <p:nvSpPr>
-          <p:cNvPr id="46" name="Text 40"/>
-          <p:cNvSpPr txBox="1"/>
-          <p:nvPr/>
-        </p:nvSpPr>
-        <p:spPr>
-          <a:xfrm>
-            <a:off x="457200" y="5998464"/>
-            <a:ext cx="11274552" cy="274320"/>
-          </a:xfrm>
-          <a:prstGeom prst="rect">
-            <a:avLst/>
-          </a:prstGeom>
-          <a:noFill/>
-          <a:ln/>
-        </p:spPr>
-        <p:txBody>
-          <a:bodyPr wrap="square" lIns="0" tIns="0" rIns="0" bIns="0" rtlCol="0" anchor="t"/>
-          <a:lstStyle/>
-          <a:p>
-            <a:pPr indent="0" marL="0">
-              <a:buNone/>
-            </a:pPr>
-            <a:r>
-              <a:rPr lang="en-US" sz="800" i="1" dirty="0">
-                <a:solidFill>
-                  <a:srgbClr val="595959"/>
-                </a:solidFill>
-                <a:latin typeface="Arial" pitchFamily="34" charset="0"/>
-                <a:ea typeface="Arial" pitchFamily="34" charset="-122"/>
-                <a:cs typeface="Arial" pitchFamily="34" charset="-120"/>
-              </a:rPr>
-              <a:t>Sources: Federal Reserve via Advisor Perspectives; TWSE, KRX/press, Nikkei (index levels); Siblis Research (P/E); Herald / SBS (VKOSPI); TrendForce; J.P. Morgan 2026 Outlook; StructuredRetailProducts.com; case funding grid with standard bond maths.</a:t>
+              <a:t>Source: Federal Reserve, Summary of Economic Projections, Figure 2 (16 Sep 2026). Dot counts read from the chart (18 participants for 2026–27 and the longer run, 17 for 2028–29): verify against the SEP table.</a:t>
             </a:r>
             <a:endParaRPr lang="en-US" sz="800" dirty="0"/>
           </a:p>
@@ -11609,7 +11132,7 @@
                 <a:ea typeface="Arial" pitchFamily="34" charset="-122"/>
                 <a:cs typeface="Arial" pitchFamily="34" charset="-120"/>
               </a:rPr>
-              <a:t>Appendix: sources for the investment thesis</a:t>
+              <a:t>Investment thesis 2: Traditional strategies fall short; autocallables fit 2026</a:t>
             </a:r>
             <a:endParaRPr lang="en-US" sz="2400" dirty="0"/>
           </a:p>
@@ -11663,91 +11186,13 @@
       </p:sp>
       <p:sp>
         <p:nvSpPr>
-          <p:cNvPr id="5" name="Text 3"/>
-          <p:cNvSpPr txBox="1"/>
-          <p:nvPr/>
-        </p:nvSpPr>
-        <p:spPr>
-          <a:xfrm>
-            <a:off x="457200" y="6446520"/>
-            <a:ext cx="3611880" cy="274320"/>
-          </a:xfrm>
-          <a:prstGeom prst="rect">
-            <a:avLst/>
-          </a:prstGeom>
-          <a:noFill/>
-          <a:ln/>
-        </p:spPr>
-        <p:txBody>
-          <a:bodyPr wrap="square" lIns="0" tIns="0" rIns="0" bIns="0" rtlCol="0" anchor="t"/>
-          <a:lstStyle/>
-          <a:p>
-            <a:pPr algn="ctr" indent="0" marL="0">
-              <a:buNone/>
-            </a:pPr>
-            <a:r>
-              <a:rPr lang="en-US" sz="1200" spc="100" kern="0" dirty="0">
-                <a:solidFill>
-                  <a:srgbClr val="595959"/>
-                </a:solidFill>
-                <a:latin typeface="Arial" pitchFamily="34" charset="0"/>
-                <a:ea typeface="Arial" pitchFamily="34" charset="-122"/>
-                <a:cs typeface="Arial" pitchFamily="34" charset="-120"/>
-              </a:rPr>
-              <a:t>ANALYSIS</a:t>
-            </a:r>
-            <a:endParaRPr lang="en-US" sz="1200" dirty="0"/>
-          </a:p>
-        </p:txBody>
-      </p:sp>
-      <p:sp>
-        <p:nvSpPr>
-          <p:cNvPr id="6" name="Text 4"/>
-          <p:cNvSpPr txBox="1"/>
-          <p:nvPr/>
-        </p:nvSpPr>
-        <p:spPr>
-          <a:xfrm>
-            <a:off x="4288536" y="6446520"/>
-            <a:ext cx="3611880" cy="274320"/>
-          </a:xfrm>
-          <a:prstGeom prst="rect">
-            <a:avLst/>
-          </a:prstGeom>
-          <a:noFill/>
-          <a:ln/>
-        </p:spPr>
-        <p:txBody>
-          <a:bodyPr wrap="square" lIns="0" tIns="0" rIns="0" bIns="0" rtlCol="0" anchor="t"/>
-          <a:lstStyle/>
-          <a:p>
-            <a:pPr algn="ctr" indent="0" marL="0">
-              <a:buNone/>
-            </a:pPr>
-            <a:r>
-              <a:rPr lang="en-US" sz="1200" spc="100" kern="0" dirty="0">
-                <a:solidFill>
-                  <a:srgbClr val="595959"/>
-                </a:solidFill>
-                <a:latin typeface="Arial" pitchFamily="34" charset="0"/>
-                <a:ea typeface="Arial" pitchFamily="34" charset="-122"/>
-                <a:cs typeface="Arial" pitchFamily="34" charset="-120"/>
-              </a:rPr>
-              <a:t>STRATEGY</a:t>
-            </a:r>
-            <a:endParaRPr lang="en-US" sz="1200" dirty="0"/>
-          </a:p>
-        </p:txBody>
-      </p:sp>
-      <p:sp>
-        <p:nvSpPr>
-          <p:cNvPr id="7" name="Shape 5"/>
+          <p:cNvPr id="5" name="Shape 3"/>
           <p:cNvSpPr/>
           <p:nvPr/>
         </p:nvSpPr>
         <p:spPr>
           <a:xfrm>
-            <a:off x="8677656" y="6364224"/>
+            <a:off x="1005840" y="6364224"/>
             <a:ext cx="2514600" cy="45720"/>
           </a:xfrm>
           <a:prstGeom prst="rect">
@@ -11766,13 +11211,13 @@
       </p:sp>
       <p:sp>
         <p:nvSpPr>
-          <p:cNvPr id="8" name="Text 6"/>
+          <p:cNvPr id="6" name="Text 4"/>
           <p:cNvSpPr txBox="1"/>
           <p:nvPr/>
         </p:nvSpPr>
         <p:spPr>
           <a:xfrm>
-            <a:off x="8129016" y="6446520"/>
+            <a:off x="457200" y="6446520"/>
             <a:ext cx="3611880" cy="274320"/>
           </a:xfrm>
           <a:prstGeom prst="rect">
@@ -11797,15 +11242,1656 @@
                 <a:ea typeface="Arial" pitchFamily="34" charset="-122"/>
                 <a:cs typeface="Arial" pitchFamily="34" charset="-120"/>
               </a:rPr>
+              <a:t>ANALYSIS</a:t>
+            </a:r>
+            <a:endParaRPr lang="en-US" sz="1200" dirty="0"/>
+          </a:p>
+        </p:txBody>
+      </p:sp>
+      <p:sp>
+        <p:nvSpPr>
+          <p:cNvPr id="7" name="Text 5"/>
+          <p:cNvSpPr txBox="1"/>
+          <p:nvPr/>
+        </p:nvSpPr>
+        <p:spPr>
+          <a:xfrm>
+            <a:off x="4288536" y="6446520"/>
+            <a:ext cx="3611880" cy="274320"/>
+          </a:xfrm>
+          <a:prstGeom prst="rect">
+            <a:avLst/>
+          </a:prstGeom>
+          <a:noFill/>
+          <a:ln/>
+        </p:spPr>
+        <p:txBody>
+          <a:bodyPr wrap="square" lIns="0" tIns="0" rIns="0" bIns="0" rtlCol="0" anchor="t"/>
+          <a:lstStyle/>
+          <a:p>
+            <a:pPr algn="ctr" indent="0" marL="0">
+              <a:buNone/>
+            </a:pPr>
+            <a:r>
+              <a:rPr lang="en-US" sz="1200" spc="100" kern="0" dirty="0">
+                <a:solidFill>
+                  <a:srgbClr val="595959"/>
+                </a:solidFill>
+                <a:latin typeface="Arial" pitchFamily="34" charset="0"/>
+                <a:ea typeface="Arial" pitchFamily="34" charset="-122"/>
+                <a:cs typeface="Arial" pitchFamily="34" charset="-120"/>
+              </a:rPr>
+              <a:t>STRATEGY</a:t>
+            </a:r>
+            <a:endParaRPr lang="en-US" sz="1200" dirty="0"/>
+          </a:p>
+        </p:txBody>
+      </p:sp>
+      <p:sp>
+        <p:nvSpPr>
+          <p:cNvPr id="8" name="Text 6"/>
+          <p:cNvSpPr txBox="1"/>
+          <p:nvPr/>
+        </p:nvSpPr>
+        <p:spPr>
+          <a:xfrm>
+            <a:off x="8129016" y="6446520"/>
+            <a:ext cx="3611880" cy="274320"/>
+          </a:xfrm>
+          <a:prstGeom prst="rect">
+            <a:avLst/>
+          </a:prstGeom>
+          <a:noFill/>
+          <a:ln/>
+        </p:spPr>
+        <p:txBody>
+          <a:bodyPr wrap="square" lIns="0" tIns="0" rIns="0" bIns="0" rtlCol="0" anchor="t"/>
+          <a:lstStyle/>
+          <a:p>
+            <a:pPr algn="ctr" indent="0" marL="0">
+              <a:buNone/>
+            </a:pPr>
+            <a:r>
+              <a:rPr lang="en-US" sz="1200" spc="100" kern="0" dirty="0">
+                <a:solidFill>
+                  <a:srgbClr val="595959"/>
+                </a:solidFill>
+                <a:latin typeface="Arial" pitchFamily="34" charset="0"/>
+                <a:ea typeface="Arial" pitchFamily="34" charset="-122"/>
+                <a:cs typeface="Arial" pitchFamily="34" charset="-120"/>
+              </a:rPr>
               <a:t>APPENDIX</a:t>
             </a:r>
             <a:endParaRPr lang="en-US" sz="1200" dirty="0"/>
+          </a:p>
+        </p:txBody>
+      </p:sp>
+      <p:sp>
+        <p:nvSpPr>
+          <p:cNvPr id="9" name="Text 7"/>
+          <p:cNvSpPr txBox="1"/>
+          <p:nvPr/>
+        </p:nvSpPr>
+        <p:spPr>
+          <a:xfrm>
+            <a:off x="457200" y="960120"/>
+            <a:ext cx="11247120" cy="274320"/>
+          </a:xfrm>
+          <a:prstGeom prst="rect">
+            <a:avLst/>
+          </a:prstGeom>
+          <a:noFill/>
+          <a:ln/>
+        </p:spPr>
+        <p:txBody>
+          <a:bodyPr wrap="square" lIns="0" tIns="0" rIns="0" bIns="0" rtlCol="0" anchor="t"/>
+          <a:lstStyle/>
+          <a:p>
+            <a:pPr indent="0" marL="0">
+              <a:buNone/>
+            </a:pPr>
+            <a:r>
+              <a:rPr lang="en-US" sz="1150" b="1" i="1" dirty="0">
+                <a:solidFill>
+                  <a:srgbClr val="262626"/>
+                </a:solidFill>
+                <a:latin typeface="Arial" pitchFamily="34" charset="0"/>
+                <a:ea typeface="Arial" pitchFamily="34" charset="-122"/>
+                <a:cs typeface="Arial" pitchFamily="34" charset="-120"/>
+              </a:rPr>
+              <a:t>Long bonds face rising rates; buy-and-hold equity faces record volatility, concentration and stretched valuations</a:t>
+            </a:r>
+            <a:endParaRPr lang="en-US" sz="1150" dirty="0"/>
+          </a:p>
+        </p:txBody>
+      </p:sp>
+      <p:sp>
+        <p:nvSpPr>
+          <p:cNvPr id="10" name="Shape 8"/>
+          <p:cNvSpPr/>
+          <p:nvPr/>
+        </p:nvSpPr>
+        <p:spPr>
+          <a:xfrm>
+            <a:off x="457200" y="1325880"/>
+            <a:ext cx="3730752" cy="292608"/>
+          </a:xfrm>
+          <a:prstGeom prst="rect">
+            <a:avLst/>
+          </a:prstGeom>
+          <a:solidFill>
+            <a:srgbClr val="2C5F82"/>
+          </a:solidFill>
+          <a:ln w="12700">
+            <a:solidFill>
+              <a:srgbClr val="2C5F82"/>
+            </a:solidFill>
+            <a:prstDash val="solid"/>
+          </a:ln>
+        </p:spPr>
+      </p:sp>
+      <p:sp>
+        <p:nvSpPr>
+          <p:cNvPr id="11" name="Text 9"/>
+          <p:cNvSpPr txBox="1"/>
+          <p:nvPr/>
+        </p:nvSpPr>
+        <p:spPr>
+          <a:xfrm>
+            <a:off x="457200" y="1325880"/>
+            <a:ext cx="3730752" cy="292608"/>
+          </a:xfrm>
+          <a:prstGeom prst="rect">
+            <a:avLst/>
+          </a:prstGeom>
+          <a:noFill/>
+          <a:ln/>
+        </p:spPr>
+        <p:txBody>
+          <a:bodyPr wrap="square" lIns="0" tIns="0" rIns="0" bIns="0" rtlCol="0" anchor="ctr"/>
+          <a:lstStyle/>
+          <a:p>
+            <a:pPr algn="ctr" indent="0" marL="0">
+              <a:buNone/>
+            </a:pPr>
+            <a:r>
+              <a:rPr lang="en-US" sz="1050" b="1" dirty="0">
+                <a:solidFill>
+                  <a:srgbClr val="FFFFFF"/>
+                </a:solidFill>
+                <a:latin typeface="Arial" pitchFamily="34" charset="0"/>
+                <a:ea typeface="Arial" pitchFamily="34" charset="-122"/>
+                <a:cs typeface="Arial" pitchFamily="34" charset="-120"/>
+              </a:rPr>
+              <a:t>Rates are rising again</a:t>
+            </a:r>
+            <a:endParaRPr lang="en-US" sz="1050" dirty="0"/>
           </a:p>
         </p:txBody>
       </p:sp>
       <p:graphicFrame>
         <p:nvGraphicFramePr>
-          <p:cNvPr id="6" name="Table 0"/>
+          <p:cNvPr id="12" name="Chart 0" descr=""/>
+          <p:cNvGraphicFramePr/>
+          <p:nvPr/>
+        </p:nvGraphicFramePr>
+        <p:xfrm>
+          <a:off x="457200" y="1655064"/>
+          <a:ext cx="3730752" cy="1261872"/>
+        </p:xfrm>
+        <a:graphic xmlns:a="http://schemas.openxmlformats.org/drawingml/2006/main">
+          <a:graphicData uri="http://schemas.openxmlformats.org/drawingml/2006/chart">
+            <c:chart xmlns:c="http://schemas.openxmlformats.org/drawingml/2006/chart" r:id="rId1"/>
+          </a:graphicData>
+        </a:graphic>
+      </p:graphicFrame>
+      <p:sp>
+        <p:nvSpPr>
+          <p:cNvPr id="13" name="Text 10"/>
+          <p:cNvSpPr txBox="1"/>
+          <p:nvPr/>
+        </p:nvSpPr>
+        <p:spPr>
+          <a:xfrm>
+            <a:off x="457200" y="2953512"/>
+            <a:ext cx="3730752" cy="365760"/>
+          </a:xfrm>
+          <a:prstGeom prst="rect">
+            <a:avLst/>
+          </a:prstGeom>
+          <a:noFill/>
+          <a:ln/>
+        </p:spPr>
+        <p:txBody>
+          <a:bodyPr wrap="square" lIns="0" tIns="0" rIns="0" bIns="0" rtlCol="0" anchor="t"/>
+          <a:lstStyle/>
+          <a:p>
+            <a:pPr indent="0" marL="0">
+              <a:buNone/>
+            </a:pPr>
+            <a:r>
+              <a:rPr lang="en-US" sz="850" dirty="0">
+                <a:solidFill>
+                  <a:srgbClr val="595959"/>
+                </a:solidFill>
+                <a:latin typeface="Arial" pitchFamily="34" charset="0"/>
+                <a:ea typeface="Arial" pitchFamily="34" charset="-122"/>
+                <a:cs typeface="Arial" pitchFamily="34" charset="-120"/>
+              </a:rPr>
+              <a:t>Fed funds upper bound: hikes 2022–23, cuts 2024–25, a hike again on 16 Sep 2026 (median dot 4.1% for end-2026).</a:t>
+            </a:r>
+            <a:endParaRPr lang="en-US" sz="850" dirty="0"/>
+          </a:p>
+        </p:txBody>
+      </p:sp>
+      <p:sp>
+        <p:nvSpPr>
+          <p:cNvPr id="14" name="Shape 11"/>
+          <p:cNvSpPr/>
+          <p:nvPr/>
+        </p:nvSpPr>
+        <p:spPr>
+          <a:xfrm>
+            <a:off x="4370832" y="1325880"/>
+            <a:ext cx="3730752" cy="292608"/>
+          </a:xfrm>
+          <a:prstGeom prst="rect">
+            <a:avLst/>
+          </a:prstGeom>
+          <a:solidFill>
+            <a:srgbClr val="2C5F82"/>
+          </a:solidFill>
+          <a:ln w="12700">
+            <a:solidFill>
+              <a:srgbClr val="2C5F82"/>
+            </a:solidFill>
+            <a:prstDash val="solid"/>
+          </a:ln>
+        </p:spPr>
+      </p:sp>
+      <p:sp>
+        <p:nvSpPr>
+          <p:cNvPr id="15" name="Text 12"/>
+          <p:cNvSpPr txBox="1"/>
+          <p:nvPr/>
+        </p:nvSpPr>
+        <p:spPr>
+          <a:xfrm>
+            <a:off x="4370832" y="1325880"/>
+            <a:ext cx="3730752" cy="292608"/>
+          </a:xfrm>
+          <a:prstGeom prst="rect">
+            <a:avLst/>
+          </a:prstGeom>
+          <a:noFill/>
+          <a:ln/>
+        </p:spPr>
+        <p:txBody>
+          <a:bodyPr wrap="square" lIns="0" tIns="0" rIns="0" bIns="0" rtlCol="0" anchor="ctr"/>
+          <a:lstStyle/>
+          <a:p>
+            <a:pPr algn="ctr" indent="0" marL="0">
+              <a:buNone/>
+            </a:pPr>
+            <a:r>
+              <a:rPr lang="en-US" sz="1050" b="1" dirty="0">
+                <a:solidFill>
+                  <a:srgbClr val="FFFFFF"/>
+                </a:solidFill>
+                <a:latin typeface="Arial" pitchFamily="34" charset="0"/>
+                <a:ea typeface="Arial" pitchFamily="34" charset="-122"/>
+                <a:cs typeface="Arial" pitchFamily="34" charset="-120"/>
+              </a:rPr>
+              <a:t>Equity paths are violent</a:t>
+            </a:r>
+            <a:endParaRPr lang="en-US" sz="1050" dirty="0"/>
+          </a:p>
+        </p:txBody>
+      </p:sp>
+      <p:graphicFrame>
+        <p:nvGraphicFramePr>
+          <p:cNvPr id="16" name="Chart 1" descr=""/>
+          <p:cNvGraphicFramePr/>
+          <p:nvPr/>
+        </p:nvGraphicFramePr>
+        <p:xfrm>
+          <a:off x="4370832" y="1655064"/>
+          <a:ext cx="3730752" cy="1261872"/>
+        </p:xfrm>
+        <a:graphic xmlns:a="http://schemas.openxmlformats.org/drawingml/2006/main">
+          <a:graphicData uri="http://schemas.openxmlformats.org/drawingml/2006/chart">
+            <c:chart xmlns:c="http://schemas.openxmlformats.org/drawingml/2006/chart" r:id="rId2"/>
+          </a:graphicData>
+        </a:graphic>
+      </p:graphicFrame>
+      <p:sp>
+        <p:nvSpPr>
+          <p:cNvPr id="17" name="Text 13"/>
+          <p:cNvSpPr txBox="1"/>
+          <p:nvPr/>
+        </p:nvSpPr>
+        <p:spPr>
+          <a:xfrm>
+            <a:off x="4370832" y="2953512"/>
+            <a:ext cx="3730752" cy="365760"/>
+          </a:xfrm>
+          <a:prstGeom prst="rect">
+            <a:avLst/>
+          </a:prstGeom>
+          <a:noFill/>
+          <a:ln/>
+        </p:spPr>
+        <p:txBody>
+          <a:bodyPr wrap="square" lIns="0" tIns="0" rIns="0" bIns="0" rtlCol="0" anchor="t"/>
+          <a:lstStyle/>
+          <a:p>
+            <a:pPr indent="0" marL="0">
+              <a:buNone/>
+            </a:pPr>
+            <a:r>
+              <a:rPr lang="en-US" sz="850" dirty="0">
+                <a:solidFill>
+                  <a:srgbClr val="595959"/>
+                </a:solidFill>
+                <a:latin typeface="Arial" pitchFamily="34" charset="0"/>
+                <a:ea typeface="Arial" pitchFamily="34" charset="-122"/>
+                <a:cs typeface="Arial" pitchFamily="34" charset="-120"/>
+              </a:rPr>
+              <a:t>Index levels, end-2021 = 100: −10–25% in 2022, then 2–3×. KOSPI fell ~25% from June to late August 2026.</a:t>
+            </a:r>
+            <a:endParaRPr lang="en-US" sz="850" dirty="0"/>
+          </a:p>
+        </p:txBody>
+      </p:sp>
+      <p:sp>
+        <p:nvSpPr>
+          <p:cNvPr id="18" name="Shape 14"/>
+          <p:cNvSpPr/>
+          <p:nvPr/>
+        </p:nvSpPr>
+        <p:spPr>
+          <a:xfrm>
+            <a:off x="457200" y="3383280"/>
+            <a:ext cx="3730752" cy="292608"/>
+          </a:xfrm>
+          <a:prstGeom prst="rect">
+            <a:avLst/>
+          </a:prstGeom>
+          <a:solidFill>
+            <a:srgbClr val="2C5F82"/>
+          </a:solidFill>
+          <a:ln w="12700">
+            <a:solidFill>
+              <a:srgbClr val="2C5F82"/>
+            </a:solidFill>
+            <a:prstDash val="solid"/>
+          </a:ln>
+        </p:spPr>
+      </p:sp>
+      <p:sp>
+        <p:nvSpPr>
+          <p:cNvPr id="19" name="Text 15"/>
+          <p:cNvSpPr txBox="1"/>
+          <p:nvPr/>
+        </p:nvSpPr>
+        <p:spPr>
+          <a:xfrm>
+            <a:off x="457200" y="3383280"/>
+            <a:ext cx="3730752" cy="292608"/>
+          </a:xfrm>
+          <a:prstGeom prst="rect">
+            <a:avLst/>
+          </a:prstGeom>
+          <a:noFill/>
+          <a:ln/>
+        </p:spPr>
+        <p:txBody>
+          <a:bodyPr wrap="square" lIns="0" tIns="0" rIns="0" bIns="0" rtlCol="0" anchor="ctr"/>
+          <a:lstStyle/>
+          <a:p>
+            <a:pPr algn="ctr" indent="0" marL="0">
+              <a:buNone/>
+            </a:pPr>
+            <a:r>
+              <a:rPr lang="en-US" sz="1050" b="1" dirty="0">
+                <a:solidFill>
+                  <a:srgbClr val="FFFFFF"/>
+                </a:solidFill>
+                <a:latin typeface="Arial" pitchFamily="34" charset="0"/>
+                <a:ea typeface="Arial" pitchFamily="34" charset="-122"/>
+                <a:cs typeface="Arial" pitchFamily="34" charset="-120"/>
+              </a:rPr>
+              <a:t>Long bonds carry rate risk</a:t>
+            </a:r>
+            <a:endParaRPr lang="en-US" sz="1050" dirty="0"/>
+          </a:p>
+        </p:txBody>
+      </p:sp>
+      <p:graphicFrame>
+        <p:nvGraphicFramePr>
+          <p:cNvPr id="20" name="Chart 2" descr=""/>
+          <p:cNvGraphicFramePr/>
+          <p:nvPr/>
+        </p:nvGraphicFramePr>
+        <p:xfrm>
+          <a:off x="457200" y="3712464"/>
+          <a:ext cx="3730752" cy="1261872"/>
+        </p:xfrm>
+        <a:graphic xmlns:a="http://schemas.openxmlformats.org/drawingml/2006/main">
+          <a:graphicData uri="http://schemas.openxmlformats.org/drawingml/2006/chart">
+            <c:chart xmlns:c="http://schemas.openxmlformats.org/drawingml/2006/chart" r:id="rId3"/>
+          </a:graphicData>
+        </a:graphic>
+      </p:graphicFrame>
+      <p:sp>
+        <p:nvSpPr>
+          <p:cNvPr id="21" name="Text 16"/>
+          <p:cNvSpPr txBox="1"/>
+          <p:nvPr/>
+        </p:nvSpPr>
+        <p:spPr>
+          <a:xfrm>
+            <a:off x="457200" y="5010912"/>
+            <a:ext cx="3730752" cy="365760"/>
+          </a:xfrm>
+          <a:prstGeom prst="rect">
+            <a:avLst/>
+          </a:prstGeom>
+          <a:noFill/>
+          <a:ln/>
+        </p:spPr>
+        <p:txBody>
+          <a:bodyPr wrap="square" lIns="0" tIns="0" rIns="0" bIns="0" rtlCol="0" anchor="t"/>
+          <a:lstStyle/>
+          <a:p>
+            <a:pPr indent="0" marL="0">
+              <a:buNone/>
+            </a:pPr>
+            <a:r>
+              <a:rPr lang="en-US" sz="850" dirty="0">
+                <a:solidFill>
+                  <a:srgbClr val="595959"/>
+                </a:solidFill>
+                <a:latin typeface="Arial" pitchFamily="34" charset="0"/>
+                <a:ea typeface="Arial" pitchFamily="34" charset="-122"/>
+                <a:cs typeface="Arial" pitchFamily="34" charset="-120"/>
+              </a:rPr>
+              <a:t>Value change of a 5-year USD bond (5.69% coupon) for parallel rate moves of −2% to +2%.</a:t>
+            </a:r>
+            <a:endParaRPr lang="en-US" sz="850" dirty="0"/>
+          </a:p>
+        </p:txBody>
+      </p:sp>
+      <p:sp>
+        <p:nvSpPr>
+          <p:cNvPr id="22" name="Shape 17"/>
+          <p:cNvSpPr/>
+          <p:nvPr/>
+        </p:nvSpPr>
+        <p:spPr>
+          <a:xfrm>
+            <a:off x="4370832" y="3383280"/>
+            <a:ext cx="3730752" cy="292608"/>
+          </a:xfrm>
+          <a:prstGeom prst="rect">
+            <a:avLst/>
+          </a:prstGeom>
+          <a:solidFill>
+            <a:srgbClr val="2C5F82"/>
+          </a:solidFill>
+          <a:ln w="12700">
+            <a:solidFill>
+              <a:srgbClr val="2C5F82"/>
+            </a:solidFill>
+            <a:prstDash val="solid"/>
+          </a:ln>
+        </p:spPr>
+      </p:sp>
+      <p:sp>
+        <p:nvSpPr>
+          <p:cNvPr id="23" name="Text 18"/>
+          <p:cNvSpPr txBox="1"/>
+          <p:nvPr/>
+        </p:nvSpPr>
+        <p:spPr>
+          <a:xfrm>
+            <a:off x="4370832" y="3383280"/>
+            <a:ext cx="3730752" cy="292608"/>
+          </a:xfrm>
+          <a:prstGeom prst="rect">
+            <a:avLst/>
+          </a:prstGeom>
+          <a:noFill/>
+          <a:ln/>
+        </p:spPr>
+        <p:txBody>
+          <a:bodyPr wrap="square" lIns="0" tIns="0" rIns="0" bIns="0" rtlCol="0" anchor="ctr"/>
+          <a:lstStyle/>
+          <a:p>
+            <a:pPr algn="ctr" indent="0" marL="0">
+              <a:buNone/>
+            </a:pPr>
+            <a:r>
+              <a:rPr lang="en-US" sz="1050" b="1" dirty="0">
+                <a:solidFill>
+                  <a:srgbClr val="FFFFFF"/>
+                </a:solidFill>
+                <a:latin typeface="Arial" pitchFamily="34" charset="0"/>
+                <a:ea typeface="Arial" pitchFamily="34" charset="-122"/>
+                <a:cs typeface="Arial" pitchFamily="34" charset="-120"/>
+              </a:rPr>
+              <a:t>Valuations already price in a lot</a:t>
+            </a:r>
+            <a:endParaRPr lang="en-US" sz="1050" dirty="0"/>
+          </a:p>
+        </p:txBody>
+      </p:sp>
+      <p:graphicFrame>
+        <p:nvGraphicFramePr>
+          <p:cNvPr id="24" name="Chart 3" descr=""/>
+          <p:cNvGraphicFramePr/>
+          <p:nvPr/>
+        </p:nvGraphicFramePr>
+        <p:xfrm>
+          <a:off x="4370832" y="3712464"/>
+          <a:ext cx="3730752" cy="1261872"/>
+        </p:xfrm>
+        <a:graphic xmlns:a="http://schemas.openxmlformats.org/drawingml/2006/main">
+          <a:graphicData uri="http://schemas.openxmlformats.org/drawingml/2006/chart">
+            <c:chart xmlns:c="http://schemas.openxmlformats.org/drawingml/2006/chart" r:id="rId4"/>
+          </a:graphicData>
+        </a:graphic>
+      </p:graphicFrame>
+      <p:sp>
+        <p:nvSpPr>
+          <p:cNvPr id="25" name="Text 19"/>
+          <p:cNvSpPr txBox="1"/>
+          <p:nvPr/>
+        </p:nvSpPr>
+        <p:spPr>
+          <a:xfrm>
+            <a:off x="4370832" y="5010912"/>
+            <a:ext cx="3730752" cy="365760"/>
+          </a:xfrm>
+          <a:prstGeom prst="rect">
+            <a:avLst/>
+          </a:prstGeom>
+          <a:noFill/>
+          <a:ln/>
+        </p:spPr>
+        <p:txBody>
+          <a:bodyPr wrap="square" lIns="0" tIns="0" rIns="0" bIns="0" rtlCol="0" anchor="t"/>
+          <a:lstStyle/>
+          <a:p>
+            <a:pPr indent="0" marL="0">
+              <a:buNone/>
+            </a:pPr>
+            <a:r>
+              <a:rPr lang="en-US" sz="850" dirty="0">
+                <a:solidFill>
+                  <a:srgbClr val="595959"/>
+                </a:solidFill>
+                <a:latin typeface="Arial" pitchFamily="34" charset="0"/>
+                <a:ea typeface="Arial" pitchFamily="34" charset="-122"/>
+                <a:cs typeface="Arial" pitchFamily="34" charset="-120"/>
+              </a:rPr>
+              <a:t>Siblis Research, 1 Jul 2026. Korea's gap assumes earnings roughly triple; Nikkei CAPE 38.6×; Taiwan among the most expensive markets.</a:t>
+            </a:r>
+            <a:endParaRPr lang="en-US" sz="850" dirty="0"/>
+          </a:p>
+        </p:txBody>
+      </p:sp>
+      <p:sp>
+        <p:nvSpPr>
+          <p:cNvPr id="26" name="Text 20"/>
+          <p:cNvSpPr txBox="1"/>
+          <p:nvPr/>
+        </p:nvSpPr>
+        <p:spPr>
+          <a:xfrm>
+            <a:off x="8211312" y="1280160"/>
+            <a:ext cx="3520440" cy="320040"/>
+          </a:xfrm>
+          <a:prstGeom prst="rect">
+            <a:avLst/>
+          </a:prstGeom>
+          <a:noFill/>
+          <a:ln/>
+        </p:spPr>
+        <p:txBody>
+          <a:bodyPr wrap="square" lIns="0" tIns="0" rIns="0" bIns="0" rtlCol="0" anchor="t"/>
+          <a:lstStyle/>
+          <a:p>
+            <a:pPr algn="ctr" indent="0" marL="0">
+              <a:buNone/>
+            </a:pPr>
+            <a:r>
+              <a:rPr lang="en-US" sz="1500" b="1" dirty="0">
+                <a:solidFill>
+                  <a:srgbClr val="262626"/>
+                </a:solidFill>
+                <a:latin typeface="Arial" pitchFamily="34" charset="0"/>
+                <a:ea typeface="Arial" pitchFamily="34" charset="-122"/>
+                <a:cs typeface="Arial" pitchFamily="34" charset="-120"/>
+              </a:rPr>
+              <a:t>Implications</a:t>
+            </a:r>
+            <a:endParaRPr lang="en-US" sz="1500" dirty="0"/>
+          </a:p>
+        </p:txBody>
+      </p:sp>
+      <p:sp>
+        <p:nvSpPr>
+          <p:cNvPr id="27" name="Shape 21"/>
+          <p:cNvSpPr/>
+          <p:nvPr/>
+        </p:nvSpPr>
+        <p:spPr>
+          <a:xfrm>
+            <a:off x="8485632" y="1627632"/>
+            <a:ext cx="2971800" cy="0"/>
+          </a:xfrm>
+          <a:prstGeom prst="line">
+            <a:avLst/>
+          </a:prstGeom>
+          <a:noFill/>
+          <a:ln w="9525">
+            <a:solidFill>
+              <a:srgbClr val="2C5F82"/>
+            </a:solidFill>
+            <a:prstDash val="solid"/>
+          </a:ln>
+        </p:spPr>
+      </p:sp>
+      <p:sp>
+        <p:nvSpPr>
+          <p:cNvPr id="28" name="Text 22"/>
+          <p:cNvSpPr txBox="1"/>
+          <p:nvPr/>
+        </p:nvSpPr>
+        <p:spPr>
+          <a:xfrm>
+            <a:off x="8211312" y="1645920"/>
+            <a:ext cx="3520440" cy="274320"/>
+          </a:xfrm>
+          <a:prstGeom prst="rect">
+            <a:avLst/>
+          </a:prstGeom>
+          <a:noFill/>
+          <a:ln/>
+        </p:spPr>
+        <p:txBody>
+          <a:bodyPr wrap="square" lIns="0" tIns="0" rIns="0" bIns="0" rtlCol="0" anchor="t"/>
+          <a:lstStyle/>
+          <a:p>
+            <a:pPr algn="ctr" indent="0" marL="0">
+              <a:buNone/>
+            </a:pPr>
+            <a:r>
+              <a:rPr lang="en-US" sz="800" i="1" dirty="0">
+                <a:solidFill>
+                  <a:srgbClr val="595959"/>
+                </a:solidFill>
+                <a:latin typeface="Arial" pitchFamily="34" charset="0"/>
+                <a:ea typeface="Arial" pitchFamily="34" charset="-122"/>
+                <a:cs typeface="Arial" pitchFamily="34" charset="-120"/>
+              </a:rPr>
+              <a:t>Market proof: Taiwan structured-note issuance +81% in 2025, snowball autocalls the favourite payoff (SRP)</a:t>
+            </a:r>
+            <a:endParaRPr lang="en-US" sz="800" dirty="0"/>
+          </a:p>
+        </p:txBody>
+      </p:sp>
+      <p:sp>
+        <p:nvSpPr>
+          <p:cNvPr id="29" name="Shape 23"/>
+          <p:cNvSpPr/>
+          <p:nvPr/>
+        </p:nvSpPr>
+        <p:spPr>
+          <a:xfrm>
+            <a:off x="8211312" y="1938528"/>
+            <a:ext cx="3520440" cy="621792"/>
+          </a:xfrm>
+          <a:prstGeom prst="rect">
+            <a:avLst/>
+          </a:prstGeom>
+          <a:solidFill>
+            <a:srgbClr val="FFFFFF"/>
+          </a:solidFill>
+          <a:ln w="12700">
+            <a:solidFill>
+              <a:srgbClr val="2C5F82"/>
+            </a:solidFill>
+            <a:prstDash val="solid"/>
+          </a:ln>
+        </p:spPr>
+      </p:sp>
+      <p:sp>
+        <p:nvSpPr>
+          <p:cNvPr id="30" name="Text 24"/>
+          <p:cNvSpPr txBox="1"/>
+          <p:nvPr/>
+        </p:nvSpPr>
+        <p:spPr>
+          <a:xfrm>
+            <a:off x="8257032" y="1938528"/>
+            <a:ext cx="411480" cy="621792"/>
+          </a:xfrm>
+          <a:prstGeom prst="rect">
+            <a:avLst/>
+          </a:prstGeom>
+          <a:noFill/>
+          <a:ln/>
+        </p:spPr>
+        <p:txBody>
+          <a:bodyPr wrap="square" lIns="0" tIns="0" rIns="0" bIns="0" rtlCol="0" anchor="ctr"/>
+          <a:lstStyle/>
+          <a:p>
+            <a:pPr algn="ctr" indent="0" marL="0">
+              <a:buNone/>
+            </a:pPr>
+            <a:r>
+              <a:rPr lang="en-US" sz="2200" b="1" i="1" dirty="0">
+                <a:solidFill>
+                  <a:srgbClr val="2C5F82"/>
+                </a:solidFill>
+                <a:latin typeface="Arial" pitchFamily="34" charset="0"/>
+                <a:ea typeface="Arial" pitchFamily="34" charset="-122"/>
+                <a:cs typeface="Arial" pitchFamily="34" charset="-120"/>
+              </a:rPr>
+              <a:t>1</a:t>
+            </a:r>
+            <a:endParaRPr lang="en-US" sz="2200" dirty="0"/>
+          </a:p>
+        </p:txBody>
+      </p:sp>
+      <p:sp>
+        <p:nvSpPr>
+          <p:cNvPr id="31" name="Text 25"/>
+          <p:cNvSpPr txBox="1"/>
+          <p:nvPr/>
+        </p:nvSpPr>
+        <p:spPr>
+          <a:xfrm>
+            <a:off x="8714232" y="1956816"/>
+            <a:ext cx="2926080" cy="585216"/>
+          </a:xfrm>
+          <a:prstGeom prst="rect">
+            <a:avLst/>
+          </a:prstGeom>
+          <a:noFill/>
+          <a:ln/>
+        </p:spPr>
+        <p:txBody>
+          <a:bodyPr wrap="square" lIns="0" tIns="0" rIns="0" bIns="0" rtlCol="0" anchor="ctr"/>
+          <a:lstStyle/>
+          <a:p>
+            <a:pPr indent="0" marL="0">
+              <a:buNone/>
+            </a:pPr>
+            <a:r>
+              <a:rPr lang="en-US" sz="880" b="1" dirty="0">
+                <a:solidFill>
+                  <a:srgbClr val="262626"/>
+                </a:solidFill>
+                <a:latin typeface="Arial" pitchFamily="34" charset="0"/>
+                <a:ea typeface="Arial" pitchFamily="34" charset="-122"/>
+                <a:cs typeface="Arial" pitchFamily="34" charset="-120"/>
+              </a:rPr>
+              <a:t>Early exit beats duration: </a:t>
+            </a:r>
+            <a:pPr indent="0" marL="0">
+              <a:buNone/>
+            </a:pPr>
+            <a:r>
+              <a:rPr lang="en-US" sz="880" dirty="0">
+                <a:solidFill>
+                  <a:srgbClr val="595959"/>
+                </a:solidFill>
+                <a:latin typeface="Arial" pitchFamily="34" charset="0"/>
+                <a:ea typeface="Arial" pitchFamily="34" charset="-122"/>
+                <a:cs typeface="Arial" pitchFamily="34" charset="-120"/>
+              </a:rPr>
+              <a:t>Bonds lose ~4.0% per 1% rate rise; autocalls can redeem from year 1</a:t>
+            </a:r>
+            <a:endParaRPr lang="en-US" sz="880" dirty="0"/>
+          </a:p>
+        </p:txBody>
+      </p:sp>
+      <p:sp>
+        <p:nvSpPr>
+          <p:cNvPr id="32" name="Shape 26"/>
+          <p:cNvSpPr/>
+          <p:nvPr/>
+        </p:nvSpPr>
+        <p:spPr>
+          <a:xfrm>
+            <a:off x="8211312" y="2633472"/>
+            <a:ext cx="3520440" cy="621792"/>
+          </a:xfrm>
+          <a:prstGeom prst="rect">
+            <a:avLst/>
+          </a:prstGeom>
+          <a:solidFill>
+            <a:srgbClr val="FFFFFF"/>
+          </a:solidFill>
+          <a:ln w="12700">
+            <a:solidFill>
+              <a:srgbClr val="2C5F82"/>
+            </a:solidFill>
+            <a:prstDash val="solid"/>
+          </a:ln>
+        </p:spPr>
+      </p:sp>
+      <p:sp>
+        <p:nvSpPr>
+          <p:cNvPr id="33" name="Text 27"/>
+          <p:cNvSpPr txBox="1"/>
+          <p:nvPr/>
+        </p:nvSpPr>
+        <p:spPr>
+          <a:xfrm>
+            <a:off x="8257032" y="2633472"/>
+            <a:ext cx="411480" cy="621792"/>
+          </a:xfrm>
+          <a:prstGeom prst="rect">
+            <a:avLst/>
+          </a:prstGeom>
+          <a:noFill/>
+          <a:ln/>
+        </p:spPr>
+        <p:txBody>
+          <a:bodyPr wrap="square" lIns="0" tIns="0" rIns="0" bIns="0" rtlCol="0" anchor="ctr"/>
+          <a:lstStyle/>
+          <a:p>
+            <a:pPr algn="ctr" indent="0" marL="0">
+              <a:buNone/>
+            </a:pPr>
+            <a:r>
+              <a:rPr lang="en-US" sz="2200" b="1" i="1" dirty="0">
+                <a:solidFill>
+                  <a:srgbClr val="2C5F82"/>
+                </a:solidFill>
+                <a:latin typeface="Arial" pitchFamily="34" charset="0"/>
+                <a:ea typeface="Arial" pitchFamily="34" charset="-122"/>
+                <a:cs typeface="Arial" pitchFamily="34" charset="-120"/>
+              </a:rPr>
+              <a:t>2</a:t>
+            </a:r>
+            <a:endParaRPr lang="en-US" sz="2200" dirty="0"/>
+          </a:p>
+        </p:txBody>
+      </p:sp>
+      <p:sp>
+        <p:nvSpPr>
+          <p:cNvPr id="34" name="Text 28"/>
+          <p:cNvSpPr txBox="1"/>
+          <p:nvPr/>
+        </p:nvSpPr>
+        <p:spPr>
+          <a:xfrm>
+            <a:off x="8714232" y="2651760"/>
+            <a:ext cx="2926080" cy="585216"/>
+          </a:xfrm>
+          <a:prstGeom prst="rect">
+            <a:avLst/>
+          </a:prstGeom>
+          <a:noFill/>
+          <a:ln/>
+        </p:spPr>
+        <p:txBody>
+          <a:bodyPr wrap="square" lIns="0" tIns="0" rIns="0" bIns="0" rtlCol="0" anchor="ctr"/>
+          <a:lstStyle/>
+          <a:p>
+            <a:pPr indent="0" marL="0">
+              <a:buNone/>
+            </a:pPr>
+            <a:r>
+              <a:rPr lang="en-US" sz="880" b="1" dirty="0">
+                <a:solidFill>
+                  <a:srgbClr val="262626"/>
+                </a:solidFill>
+                <a:latin typeface="Arial" pitchFamily="34" charset="0"/>
+                <a:ea typeface="Arial" pitchFamily="34" charset="-122"/>
+                <a:cs typeface="Arial" pitchFamily="34" charset="-120"/>
+              </a:rPr>
+              <a:t>Paid on recovery, not timing: </a:t>
+            </a:r>
+            <a:pPr indent="0" marL="0">
+              <a:buNone/>
+            </a:pPr>
+            <a:r>
+              <a:rPr lang="en-US" sz="880" dirty="0">
+                <a:solidFill>
+                  <a:srgbClr val="595959"/>
+                </a:solidFill>
+                <a:latin typeface="Arial" pitchFamily="34" charset="0"/>
+                <a:ea typeface="Arial" pitchFamily="34" charset="-122"/>
+                <a:cs typeface="Arial" pitchFamily="34" charset="-120"/>
+              </a:rPr>
+              <a:t>−25% in ten weeks (KOSPI 2026): autocall coupons pay once the basket is back at its start</a:t>
+            </a:r>
+            <a:endParaRPr lang="en-US" sz="880" dirty="0"/>
+          </a:p>
+        </p:txBody>
+      </p:sp>
+      <p:sp>
+        <p:nvSpPr>
+          <p:cNvPr id="35" name="Shape 29"/>
+          <p:cNvSpPr/>
+          <p:nvPr/>
+        </p:nvSpPr>
+        <p:spPr>
+          <a:xfrm>
+            <a:off x="8211312" y="3328416"/>
+            <a:ext cx="3520440" cy="621792"/>
+          </a:xfrm>
+          <a:prstGeom prst="rect">
+            <a:avLst/>
+          </a:prstGeom>
+          <a:solidFill>
+            <a:srgbClr val="FFFFFF"/>
+          </a:solidFill>
+          <a:ln w="12700">
+            <a:solidFill>
+              <a:srgbClr val="2C5F82"/>
+            </a:solidFill>
+            <a:prstDash val="solid"/>
+          </a:ln>
+        </p:spPr>
+      </p:sp>
+      <p:sp>
+        <p:nvSpPr>
+          <p:cNvPr id="36" name="Text 30"/>
+          <p:cNvSpPr txBox="1"/>
+          <p:nvPr/>
+        </p:nvSpPr>
+        <p:spPr>
+          <a:xfrm>
+            <a:off x="8257032" y="3328416"/>
+            <a:ext cx="411480" cy="621792"/>
+          </a:xfrm>
+          <a:prstGeom prst="rect">
+            <a:avLst/>
+          </a:prstGeom>
+          <a:noFill/>
+          <a:ln/>
+        </p:spPr>
+        <p:txBody>
+          <a:bodyPr wrap="square" lIns="0" tIns="0" rIns="0" bIns="0" rtlCol="0" anchor="ctr"/>
+          <a:lstStyle/>
+          <a:p>
+            <a:pPr algn="ctr" indent="0" marL="0">
+              <a:buNone/>
+            </a:pPr>
+            <a:r>
+              <a:rPr lang="en-US" sz="2200" b="1" i="1" dirty="0">
+                <a:solidFill>
+                  <a:srgbClr val="2C5F82"/>
+                </a:solidFill>
+                <a:latin typeface="Arial" pitchFamily="34" charset="0"/>
+                <a:ea typeface="Arial" pitchFamily="34" charset="-122"/>
+                <a:cs typeface="Arial" pitchFamily="34" charset="-120"/>
+              </a:rPr>
+              <a:t>3</a:t>
+            </a:r>
+            <a:endParaRPr lang="en-US" sz="2200" dirty="0"/>
+          </a:p>
+        </p:txBody>
+      </p:sp>
+      <p:sp>
+        <p:nvSpPr>
+          <p:cNvPr id="37" name="Text 31"/>
+          <p:cNvSpPr txBox="1"/>
+          <p:nvPr/>
+        </p:nvSpPr>
+        <p:spPr>
+          <a:xfrm>
+            <a:off x="8714232" y="3346704"/>
+            <a:ext cx="2926080" cy="585216"/>
+          </a:xfrm>
+          <a:prstGeom prst="rect">
+            <a:avLst/>
+          </a:prstGeom>
+          <a:noFill/>
+          <a:ln/>
+        </p:spPr>
+        <p:txBody>
+          <a:bodyPr wrap="square" lIns="0" tIns="0" rIns="0" bIns="0" rtlCol="0" anchor="ctr"/>
+          <a:lstStyle/>
+          <a:p>
+            <a:pPr indent="0" marL="0">
+              <a:buNone/>
+            </a:pPr>
+            <a:r>
+              <a:rPr lang="en-US" sz="880" b="1" dirty="0">
+                <a:solidFill>
+                  <a:srgbClr val="262626"/>
+                </a:solidFill>
+                <a:latin typeface="Arial" pitchFamily="34" charset="0"/>
+                <a:ea typeface="Arial" pitchFamily="34" charset="-122"/>
+                <a:cs typeface="Arial" pitchFamily="34" charset="-120"/>
+              </a:rPr>
+              <a:t>Diversify the basket: </a:t>
+            </a:r>
+            <a:pPr indent="0" marL="0">
+              <a:buNone/>
+            </a:pPr>
+            <a:r>
+              <a:rPr lang="en-US" sz="880" dirty="0">
+                <a:solidFill>
+                  <a:srgbClr val="595959"/>
+                </a:solidFill>
+                <a:latin typeface="Arial" pitchFamily="34" charset="0"/>
+                <a:ea typeface="Arial" pitchFamily="34" charset="-122"/>
+                <a:cs typeface="Arial" pitchFamily="34" charset="-120"/>
+              </a:rPr>
+              <a:t>TSMC &gt;40% of TAIEX, ~92% of advanced chips from Taiwan: use a diversified ETF basket, not worst-of</a:t>
+            </a:r>
+            <a:endParaRPr lang="en-US" sz="880" dirty="0"/>
+          </a:p>
+        </p:txBody>
+      </p:sp>
+      <p:sp>
+        <p:nvSpPr>
+          <p:cNvPr id="38" name="Shape 32"/>
+          <p:cNvSpPr/>
+          <p:nvPr/>
+        </p:nvSpPr>
+        <p:spPr>
+          <a:xfrm>
+            <a:off x="8211312" y="4023360"/>
+            <a:ext cx="3520440" cy="621792"/>
+          </a:xfrm>
+          <a:prstGeom prst="rect">
+            <a:avLst/>
+          </a:prstGeom>
+          <a:solidFill>
+            <a:srgbClr val="FFFFFF"/>
+          </a:solidFill>
+          <a:ln w="12700">
+            <a:solidFill>
+              <a:srgbClr val="2C5F82"/>
+            </a:solidFill>
+            <a:prstDash val="solid"/>
+          </a:ln>
+        </p:spPr>
+      </p:sp>
+      <p:sp>
+        <p:nvSpPr>
+          <p:cNvPr id="39" name="Text 33"/>
+          <p:cNvSpPr txBox="1"/>
+          <p:nvPr/>
+        </p:nvSpPr>
+        <p:spPr>
+          <a:xfrm>
+            <a:off x="8257032" y="4023360"/>
+            <a:ext cx="411480" cy="621792"/>
+          </a:xfrm>
+          <a:prstGeom prst="rect">
+            <a:avLst/>
+          </a:prstGeom>
+          <a:noFill/>
+          <a:ln/>
+        </p:spPr>
+        <p:txBody>
+          <a:bodyPr wrap="square" lIns="0" tIns="0" rIns="0" bIns="0" rtlCol="0" anchor="ctr"/>
+          <a:lstStyle/>
+          <a:p>
+            <a:pPr algn="ctr" indent="0" marL="0">
+              <a:buNone/>
+            </a:pPr>
+            <a:r>
+              <a:rPr lang="en-US" sz="2200" b="1" i="1" dirty="0">
+                <a:solidFill>
+                  <a:srgbClr val="2C5F82"/>
+                </a:solidFill>
+                <a:latin typeface="Arial" pitchFamily="34" charset="0"/>
+                <a:ea typeface="Arial" pitchFamily="34" charset="-122"/>
+                <a:cs typeface="Arial" pitchFamily="34" charset="-120"/>
+              </a:rPr>
+              <a:t>4</a:t>
+            </a:r>
+            <a:endParaRPr lang="en-US" sz="2200" dirty="0"/>
+          </a:p>
+        </p:txBody>
+      </p:sp>
+      <p:sp>
+        <p:nvSpPr>
+          <p:cNvPr id="40" name="Text 34"/>
+          <p:cNvSpPr txBox="1"/>
+          <p:nvPr/>
+        </p:nvSpPr>
+        <p:spPr>
+          <a:xfrm>
+            <a:off x="8714232" y="4041648"/>
+            <a:ext cx="2926080" cy="585216"/>
+          </a:xfrm>
+          <a:prstGeom prst="rect">
+            <a:avLst/>
+          </a:prstGeom>
+          <a:noFill/>
+          <a:ln/>
+        </p:spPr>
+        <p:txBody>
+          <a:bodyPr wrap="square" lIns="0" tIns="0" rIns="0" bIns="0" rtlCol="0" anchor="ctr"/>
+          <a:lstStyle/>
+          <a:p>
+            <a:pPr indent="0" marL="0">
+              <a:buNone/>
+            </a:pPr>
+            <a:r>
+              <a:rPr lang="en-US" sz="880" b="1" dirty="0">
+                <a:solidFill>
+                  <a:srgbClr val="262626"/>
+                </a:solidFill>
+                <a:latin typeface="Arial" pitchFamily="34" charset="0"/>
+                <a:ea typeface="Arial" pitchFamily="34" charset="-122"/>
+                <a:cs typeface="Arial" pitchFamily="34" charset="-120"/>
+              </a:rPr>
+              <a:t>Volatility funds the coupon: </a:t>
+            </a:r>
+            <a:pPr indent="0" marL="0">
+              <a:buNone/>
+            </a:pPr>
+            <a:r>
+              <a:rPr lang="en-US" sz="880" dirty="0">
+                <a:solidFill>
+                  <a:srgbClr val="595959"/>
+                </a:solidFill>
+                <a:latin typeface="Arial" pitchFamily="34" charset="0"/>
+                <a:ea typeface="Arial" pitchFamily="34" charset="-122"/>
+                <a:cs typeface="Arial" pitchFamily="34" charset="-120"/>
+              </a:rPr>
+              <a:t>VKOSPI at a record 91.2: richer option premium means higher autocall coupons</a:t>
+            </a:r>
+            <a:endParaRPr lang="en-US" sz="880" dirty="0"/>
+          </a:p>
+        </p:txBody>
+      </p:sp>
+      <p:sp>
+        <p:nvSpPr>
+          <p:cNvPr id="41" name="Shape 35"/>
+          <p:cNvSpPr/>
+          <p:nvPr/>
+        </p:nvSpPr>
+        <p:spPr>
+          <a:xfrm>
+            <a:off x="8211312" y="4718304"/>
+            <a:ext cx="3520440" cy="621792"/>
+          </a:xfrm>
+          <a:prstGeom prst="rect">
+            <a:avLst/>
+          </a:prstGeom>
+          <a:solidFill>
+            <a:srgbClr val="FFFFFF"/>
+          </a:solidFill>
+          <a:ln w="12700">
+            <a:solidFill>
+              <a:srgbClr val="2C5F82"/>
+            </a:solidFill>
+            <a:prstDash val="solid"/>
+          </a:ln>
+        </p:spPr>
+      </p:sp>
+      <p:sp>
+        <p:nvSpPr>
+          <p:cNvPr id="42" name="Text 36"/>
+          <p:cNvSpPr txBox="1"/>
+          <p:nvPr/>
+        </p:nvSpPr>
+        <p:spPr>
+          <a:xfrm>
+            <a:off x="8257032" y="4718304"/>
+            <a:ext cx="411480" cy="621792"/>
+          </a:xfrm>
+          <a:prstGeom prst="rect">
+            <a:avLst/>
+          </a:prstGeom>
+          <a:noFill/>
+          <a:ln/>
+        </p:spPr>
+        <p:txBody>
+          <a:bodyPr wrap="square" lIns="0" tIns="0" rIns="0" bIns="0" rtlCol="0" anchor="ctr"/>
+          <a:lstStyle/>
+          <a:p>
+            <a:pPr algn="ctr" indent="0" marL="0">
+              <a:buNone/>
+            </a:pPr>
+            <a:r>
+              <a:rPr lang="en-US" sz="2200" b="1" i="1" dirty="0">
+                <a:solidFill>
+                  <a:srgbClr val="2C5F82"/>
+                </a:solidFill>
+                <a:latin typeface="Arial" pitchFamily="34" charset="0"/>
+                <a:ea typeface="Arial" pitchFamily="34" charset="-122"/>
+                <a:cs typeface="Arial" pitchFamily="34" charset="-120"/>
+              </a:rPr>
+              <a:t>5</a:t>
+            </a:r>
+            <a:endParaRPr lang="en-US" sz="2200" dirty="0"/>
+          </a:p>
+        </p:txBody>
+      </p:sp>
+      <p:sp>
+        <p:nvSpPr>
+          <p:cNvPr id="43" name="Text 37"/>
+          <p:cNvSpPr txBox="1"/>
+          <p:nvPr/>
+        </p:nvSpPr>
+        <p:spPr>
+          <a:xfrm>
+            <a:off x="8714232" y="4736592"/>
+            <a:ext cx="2926080" cy="585216"/>
+          </a:xfrm>
+          <a:prstGeom prst="rect">
+            <a:avLst/>
+          </a:prstGeom>
+          <a:noFill/>
+          <a:ln/>
+        </p:spPr>
+        <p:txBody>
+          <a:bodyPr wrap="square" lIns="0" tIns="0" rIns="0" bIns="0" rtlCol="0" anchor="ctr"/>
+          <a:lstStyle/>
+          <a:p>
+            <a:pPr indent="0" marL="0">
+              <a:buNone/>
+            </a:pPr>
+            <a:r>
+              <a:rPr lang="en-US" sz="880" b="1" dirty="0">
+                <a:solidFill>
+                  <a:srgbClr val="262626"/>
+                </a:solidFill>
+                <a:latin typeface="Arial" pitchFamily="34" charset="0"/>
+                <a:ea typeface="Arial" pitchFamily="34" charset="-122"/>
+                <a:cs typeface="Arial" pitchFamily="34" charset="-120"/>
+              </a:rPr>
+              <a:t>Protection is affordable: </a:t>
+            </a:r>
+            <a:pPr indent="0" marL="0">
+              <a:buNone/>
+            </a:pPr>
+            <a:r>
+              <a:rPr lang="en-US" sz="880" dirty="0">
+                <a:solidFill>
+                  <a:srgbClr val="595959"/>
+                </a:solidFill>
+                <a:latin typeface="Arial" pitchFamily="34" charset="0"/>
+                <a:ea typeface="Arial" pitchFamily="34" charset="-122"/>
+                <a:cs typeface="Arial" pitchFamily="34" charset="-120"/>
+              </a:rPr>
+              <a:t>USD 100 in 5 years costs USD 75.8 at 5.69%: a buffer and a 70% floor fit inside an autocall</a:t>
+            </a:r>
+            <a:endParaRPr lang="en-US" sz="880" dirty="0"/>
+          </a:p>
+        </p:txBody>
+      </p:sp>
+      <p:sp>
+        <p:nvSpPr>
+          <p:cNvPr id="44" name="Shape 38"/>
+          <p:cNvSpPr/>
+          <p:nvPr/>
+        </p:nvSpPr>
+        <p:spPr>
+          <a:xfrm>
+            <a:off x="457200" y="5486400"/>
+            <a:ext cx="11274552" cy="438912"/>
+          </a:xfrm>
+          <a:prstGeom prst="rect">
+            <a:avLst/>
+          </a:prstGeom>
+          <a:solidFill>
+            <a:srgbClr val="2C5F82"/>
+          </a:solidFill>
+          <a:ln w="12700">
+            <a:solidFill>
+              <a:srgbClr val="2C5F82"/>
+            </a:solidFill>
+            <a:prstDash val="solid"/>
+          </a:ln>
+        </p:spPr>
+      </p:sp>
+      <p:sp>
+        <p:nvSpPr>
+          <p:cNvPr id="45" name="Text 39"/>
+          <p:cNvSpPr txBox="1"/>
+          <p:nvPr/>
+        </p:nvSpPr>
+        <p:spPr>
+          <a:xfrm>
+            <a:off x="594360" y="5486400"/>
+            <a:ext cx="11000232" cy="438912"/>
+          </a:xfrm>
+          <a:prstGeom prst="rect">
+            <a:avLst/>
+          </a:prstGeom>
+          <a:noFill/>
+          <a:ln/>
+        </p:spPr>
+        <p:txBody>
+          <a:bodyPr wrap="square" lIns="0" tIns="0" rIns="0" bIns="0" rtlCol="0" anchor="ctr"/>
+          <a:lstStyle/>
+          <a:p>
+            <a:pPr algn="ctr" indent="0" marL="0">
+              <a:buNone/>
+            </a:pPr>
+            <a:r>
+              <a:rPr lang="en-US" sz="1200" b="1" dirty="0">
+                <a:solidFill>
+                  <a:srgbClr val="FFFFFF"/>
+                </a:solidFill>
+                <a:latin typeface="Arial" pitchFamily="34" charset="0"/>
+                <a:ea typeface="Arial" pitchFamily="34" charset="-122"/>
+                <a:cs typeface="Arial" pitchFamily="34" charset="-120"/>
+              </a:rPr>
+              <a:t>Plain bonds and equities leave investors exposed; a buffered autocall with a 70% floor keeps the theme and manages the risks.</a:t>
+            </a:r>
+            <a:endParaRPr lang="en-US" sz="1200" dirty="0"/>
+          </a:p>
+        </p:txBody>
+      </p:sp>
+      <p:sp>
+        <p:nvSpPr>
+          <p:cNvPr id="46" name="Text 40"/>
+          <p:cNvSpPr txBox="1"/>
+          <p:nvPr/>
+        </p:nvSpPr>
+        <p:spPr>
+          <a:xfrm>
+            <a:off x="457200" y="5998464"/>
+            <a:ext cx="11274552" cy="274320"/>
+          </a:xfrm>
+          <a:prstGeom prst="rect">
+            <a:avLst/>
+          </a:prstGeom>
+          <a:noFill/>
+          <a:ln/>
+        </p:spPr>
+        <p:txBody>
+          <a:bodyPr wrap="square" lIns="0" tIns="0" rIns="0" bIns="0" rtlCol="0" anchor="t"/>
+          <a:lstStyle/>
+          <a:p>
+            <a:pPr indent="0" marL="0">
+              <a:buNone/>
+            </a:pPr>
+            <a:r>
+              <a:rPr lang="en-US" sz="800" i="1" dirty="0">
+                <a:solidFill>
+                  <a:srgbClr val="595959"/>
+                </a:solidFill>
+                <a:latin typeface="Arial" pitchFamily="34" charset="0"/>
+                <a:ea typeface="Arial" pitchFamily="34" charset="-122"/>
+                <a:cs typeface="Arial" pitchFamily="34" charset="-120"/>
+              </a:rPr>
+              <a:t>Sources: Federal Reserve via Advisor Perspectives; TWSE, KRX/press, Nikkei (index levels); Siblis Research (P/E); Herald / SBS (VKOSPI); TrendForce; J.P. Morgan 2026 Outlook; StructuredRetailProducts.com; case funding grid with standard bond maths.</a:t>
+            </a:r>
+            <a:endParaRPr lang="en-US" sz="800" dirty="0"/>
+          </a:p>
+        </p:txBody>
+      </p:sp>
+    </p:spTree>
+  </p:cSld>
+  <p:clrMapOvr>
+    <a:masterClrMapping/>
+  </p:clrMapOvr>
+</p:sld>
+</file>
+
+<file path=ppt/slides/slide6.xml><?xml version="1.0" encoding="utf-8"?>
+<p:sld xmlns:a="http://schemas.openxmlformats.org/drawingml/2006/main" xmlns:r="http://schemas.openxmlformats.org/officeDocument/2006/relationships" xmlns:p="http://schemas.openxmlformats.org/presentationml/2006/main">
+  <p:cSld name="Slide 6">
+    <p:bg>
+      <p:bgPr>
+        <a:solidFill>
+          <a:srgbClr val="FFFFFF"/>
+        </a:solidFill>
+      </p:bgPr>
+    </p:bg>
+    <p:spTree>
+      <p:nvGrpSpPr>
+        <p:cNvPr id="1" name=""/>
+        <p:cNvGrpSpPr/>
+        <p:nvPr/>
+      </p:nvGrpSpPr>
+      <p:grpSpPr>
+        <a:xfrm>
+          <a:off x="0" y="0"/>
+          <a:ext cx="0" cy="0"/>
+          <a:chOff x="0" y="0"/>
+          <a:chExt cx="0" cy="0"/>
+        </a:xfrm>
+      </p:grpSpPr>
+      <p:sp>
+        <p:nvSpPr>
+          <p:cNvPr id="2" name="Text 0"/>
+          <p:cNvSpPr txBox="1"/>
+          <p:nvPr/>
+        </p:nvSpPr>
+        <p:spPr>
+          <a:xfrm>
+            <a:off x="457200" y="274320"/>
+            <a:ext cx="11247120" cy="548640"/>
+          </a:xfrm>
+          <a:prstGeom prst="rect">
+            <a:avLst/>
+          </a:prstGeom>
+          <a:noFill/>
+          <a:ln/>
+        </p:spPr>
+        <p:txBody>
+          <a:bodyPr wrap="square" lIns="0" tIns="0" rIns="0" bIns="0" rtlCol="0" anchor="ctr"/>
+          <a:lstStyle/>
+          <a:p>
+            <a:pPr indent="0" marL="0">
+              <a:buNone/>
+            </a:pPr>
+            <a:r>
+              <a:rPr lang="en-US" sz="2400" dirty="0">
+                <a:solidFill>
+                  <a:srgbClr val="262626"/>
+                </a:solidFill>
+                <a:latin typeface="Arial" pitchFamily="34" charset="0"/>
+                <a:ea typeface="Arial" pitchFamily="34" charset="-122"/>
+                <a:cs typeface="Arial" pitchFamily="34" charset="-120"/>
+              </a:rPr>
+              <a:t>Appendix: sources for the investment thesis</a:t>
+            </a:r>
+            <a:endParaRPr lang="en-US" sz="2400" dirty="0"/>
+          </a:p>
+        </p:txBody>
+      </p:sp>
+      <p:sp>
+        <p:nvSpPr>
+          <p:cNvPr id="3" name="Shape 1"/>
+          <p:cNvSpPr/>
+          <p:nvPr/>
+        </p:nvSpPr>
+        <p:spPr>
+          <a:xfrm>
+            <a:off x="457200" y="896112"/>
+            <a:ext cx="11274552" cy="0"/>
+          </a:xfrm>
+          <a:prstGeom prst="line">
+            <a:avLst/>
+          </a:prstGeom>
+          <a:noFill/>
+          <a:ln w="12700">
+            <a:solidFill>
+              <a:srgbClr val="2C5F82"/>
+            </a:solidFill>
+            <a:prstDash val="solid"/>
+          </a:ln>
+        </p:spPr>
+      </p:sp>
+      <p:sp>
+        <p:nvSpPr>
+          <p:cNvPr id="4" name="Shape 2"/>
+          <p:cNvSpPr/>
+          <p:nvPr/>
+        </p:nvSpPr>
+        <p:spPr>
+          <a:xfrm>
+            <a:off x="457200" y="6382512"/>
+            <a:ext cx="11274552" cy="0"/>
+          </a:xfrm>
+          <a:prstGeom prst="line">
+            <a:avLst/>
+          </a:prstGeom>
+          <a:noFill/>
+          <a:ln w="9525">
+            <a:solidFill>
+              <a:srgbClr val="BFBFBF"/>
+            </a:solidFill>
+            <a:prstDash val="solid"/>
+          </a:ln>
+        </p:spPr>
+      </p:sp>
+      <p:sp>
+        <p:nvSpPr>
+          <p:cNvPr id="5" name="Text 3"/>
+          <p:cNvSpPr txBox="1"/>
+          <p:nvPr/>
+        </p:nvSpPr>
+        <p:spPr>
+          <a:xfrm>
+            <a:off x="457200" y="6446520"/>
+            <a:ext cx="3611880" cy="274320"/>
+          </a:xfrm>
+          <a:prstGeom prst="rect">
+            <a:avLst/>
+          </a:prstGeom>
+          <a:noFill/>
+          <a:ln/>
+        </p:spPr>
+        <p:txBody>
+          <a:bodyPr wrap="square" lIns="0" tIns="0" rIns="0" bIns="0" rtlCol="0" anchor="t"/>
+          <a:lstStyle/>
+          <a:p>
+            <a:pPr algn="ctr" indent="0" marL="0">
+              <a:buNone/>
+            </a:pPr>
+            <a:r>
+              <a:rPr lang="en-US" sz="1200" spc="100" kern="0" dirty="0">
+                <a:solidFill>
+                  <a:srgbClr val="595959"/>
+                </a:solidFill>
+                <a:latin typeface="Arial" pitchFamily="34" charset="0"/>
+                <a:ea typeface="Arial" pitchFamily="34" charset="-122"/>
+                <a:cs typeface="Arial" pitchFamily="34" charset="-120"/>
+              </a:rPr>
+              <a:t>ANALYSIS</a:t>
+            </a:r>
+            <a:endParaRPr lang="en-US" sz="1200" dirty="0"/>
+          </a:p>
+        </p:txBody>
+      </p:sp>
+      <p:sp>
+        <p:nvSpPr>
+          <p:cNvPr id="6" name="Text 4"/>
+          <p:cNvSpPr txBox="1"/>
+          <p:nvPr/>
+        </p:nvSpPr>
+        <p:spPr>
+          <a:xfrm>
+            <a:off x="4288536" y="6446520"/>
+            <a:ext cx="3611880" cy="274320"/>
+          </a:xfrm>
+          <a:prstGeom prst="rect">
+            <a:avLst/>
+          </a:prstGeom>
+          <a:noFill/>
+          <a:ln/>
+        </p:spPr>
+        <p:txBody>
+          <a:bodyPr wrap="square" lIns="0" tIns="0" rIns="0" bIns="0" rtlCol="0" anchor="t"/>
+          <a:lstStyle/>
+          <a:p>
+            <a:pPr algn="ctr" indent="0" marL="0">
+              <a:buNone/>
+            </a:pPr>
+            <a:r>
+              <a:rPr lang="en-US" sz="1200" spc="100" kern="0" dirty="0">
+                <a:solidFill>
+                  <a:srgbClr val="595959"/>
+                </a:solidFill>
+                <a:latin typeface="Arial" pitchFamily="34" charset="0"/>
+                <a:ea typeface="Arial" pitchFamily="34" charset="-122"/>
+                <a:cs typeface="Arial" pitchFamily="34" charset="-120"/>
+              </a:rPr>
+              <a:t>STRATEGY</a:t>
+            </a:r>
+            <a:endParaRPr lang="en-US" sz="1200" dirty="0"/>
+          </a:p>
+        </p:txBody>
+      </p:sp>
+      <p:sp>
+        <p:nvSpPr>
+          <p:cNvPr id="7" name="Shape 5"/>
+          <p:cNvSpPr/>
+          <p:nvPr/>
+        </p:nvSpPr>
+        <p:spPr>
+          <a:xfrm>
+            <a:off x="8677656" y="6364224"/>
+            <a:ext cx="2514600" cy="45720"/>
+          </a:xfrm>
+          <a:prstGeom prst="rect">
+            <a:avLst/>
+          </a:prstGeom>
+          <a:solidFill>
+            <a:srgbClr val="2C5F82"/>
+          </a:solidFill>
+          <a:ln w="12700">
+            <a:solidFill>
+              <a:srgbClr val="2C5F82"/>
+            </a:solidFill>
+            <a:prstDash val="solid"/>
+          </a:ln>
+        </p:spPr>
+      </p:sp>
+      <p:sp>
+        <p:nvSpPr>
+          <p:cNvPr id="8" name="Text 6"/>
+          <p:cNvSpPr txBox="1"/>
+          <p:nvPr/>
+        </p:nvSpPr>
+        <p:spPr>
+          <a:xfrm>
+            <a:off x="8129016" y="6446520"/>
+            <a:ext cx="3611880" cy="274320"/>
+          </a:xfrm>
+          <a:prstGeom prst="rect">
+            <a:avLst/>
+          </a:prstGeom>
+          <a:noFill/>
+          <a:ln/>
+        </p:spPr>
+        <p:txBody>
+          <a:bodyPr wrap="square" lIns="0" tIns="0" rIns="0" bIns="0" rtlCol="0" anchor="t"/>
+          <a:lstStyle/>
+          <a:p>
+            <a:pPr algn="ctr" indent="0" marL="0">
+              <a:buNone/>
+            </a:pPr>
+            <a:r>
+              <a:rPr lang="en-US" sz="1200" b="1" spc="100" kern="0" dirty="0">
+                <a:solidFill>
+                  <a:srgbClr val="2C5F82"/>
+                </a:solidFill>
+                <a:latin typeface="Arial" pitchFamily="34" charset="0"/>
+                <a:ea typeface="Arial" pitchFamily="34" charset="-122"/>
+                <a:cs typeface="Arial" pitchFamily="34" charset="-120"/>
+              </a:rPr>
+              <a:t>APPENDIX</a:t>
+            </a:r>
+            <a:endParaRPr lang="en-US" sz="1200" dirty="0"/>
+          </a:p>
+        </p:txBody>
+      </p:sp>
+      <p:graphicFrame>
+        <p:nvGraphicFramePr>
+          <p:cNvPr id="7" name="Table 0"/>
           <p:cNvGraphicFramePr>
             <a:graphicFrameLocks noGrp="1"/>
           </p:cNvGraphicFramePr>
@@ -11829,7 +12915,7 @@
                 <a:gridCol w="6583680"/>
                 <a:gridCol w="4690872"/>
               </a:tblGrid>
-              <a:tr h="256032">
+              <a:tr h="246888">
                 <a:tc>
                   <a:txBody>
                     <a:bodyPr/>
@@ -11967,7 +13053,7 @@
                   </a:tcPr>
                 </a:tc>
               </a:tr>
-              <a:tr h="256032">
+              <a:tr h="246888">
                 <a:tc>
                   <a:txBody>
                     <a:bodyPr/>
@@ -12105,7 +13191,7 @@
                   </a:tcPr>
                 </a:tc>
               </a:tr>
-              <a:tr h="256032">
+              <a:tr h="246888">
                 <a:tc>
                   <a:txBody>
                     <a:bodyPr/>
@@ -12243,7 +13329,7 @@
                   </a:tcPr>
                 </a:tc>
               </a:tr>
-              <a:tr h="256032">
+              <a:tr h="246888">
                 <a:tc>
                   <a:txBody>
                     <a:bodyPr/>
@@ -12381,7 +13467,7 @@
                   </a:tcPr>
                 </a:tc>
               </a:tr>
-              <a:tr h="256032">
+              <a:tr h="246888">
                 <a:tc>
                   <a:txBody>
                     <a:bodyPr/>
@@ -12519,7 +13605,7 @@
                   </a:tcPr>
                 </a:tc>
               </a:tr>
-              <a:tr h="256032">
+              <a:tr h="246888">
                 <a:tc>
                   <a:txBody>
                     <a:bodyPr/>
@@ -12657,7 +13743,7 @@
                   </a:tcPr>
                 </a:tc>
               </a:tr>
-              <a:tr h="256032">
+              <a:tr h="246888">
                 <a:tc>
                   <a:txBody>
                     <a:bodyPr/>
@@ -12795,7 +13881,7 @@
                   </a:tcPr>
                 </a:tc>
               </a:tr>
-              <a:tr h="256032">
+              <a:tr h="246888">
                 <a:tc>
                   <a:txBody>
                     <a:bodyPr/>
@@ -12933,7 +14019,7 @@
                   </a:tcPr>
                 </a:tc>
               </a:tr>
-              <a:tr h="256032">
+              <a:tr h="246888">
                 <a:tc>
                   <a:txBody>
                     <a:bodyPr/>
@@ -13071,7 +14157,7 @@
                   </a:tcPr>
                 </a:tc>
               </a:tr>
-              <a:tr h="256032">
+              <a:tr h="246888">
                 <a:tc>
                   <a:txBody>
                     <a:bodyPr/>
@@ -13209,7 +14295,7 @@
                   </a:tcPr>
                 </a:tc>
               </a:tr>
-              <a:tr h="256032">
+              <a:tr h="246888">
                 <a:tc>
                   <a:txBody>
                     <a:bodyPr/>
@@ -13347,7 +14433,145 @@
                   </a:tcPr>
                 </a:tc>
               </a:tr>
-              <a:tr h="256032">
+              <a:tr h="246888">
+                <a:tc>
+                  <a:txBody>
+                    <a:bodyPr/>
+                    <a:lstStyle/>
+                    <a:p>
+                      <a:pPr indent="0" marL="0">
+                        <a:buNone/>
+                      </a:pPr>
+                      <a:r>
+                        <a:rPr lang="en-US" sz="850" dirty="0">
+                          <a:solidFill>
+                            <a:srgbClr val="262626"/>
+                          </a:solidFill>
+                          <a:latin typeface="Arial" pitchFamily="34" charset="0"/>
+                          <a:ea typeface="Arial" pitchFamily="34" charset="-122"/>
+                          <a:cs typeface="Arial" pitchFamily="34" charset="-120"/>
+                        </a:rPr>
+                        <a:t>FOMC dot plot: medians 4.125% (2026), 4.125% (2027), 3.875% (2028), 3.625% (2029), 3.25% longer run</a:t>
+                      </a:r>
+                      <a:endParaRPr lang="en-US" sz="850" dirty="0">
+                        <a:latin typeface="Arial" charset="0"/>
+                        <a:ea typeface="Arial" charset="0"/>
+                        <a:cs typeface="Arial" charset="0"/>
+                      </a:endParaRPr>
+                    </a:p>
+                  </a:txBody>
+                  <a:tcPr marL="63500" marR="63500" marT="12700" marB="12700" anchor="ctr">
+                    <a:lnL w="6350" cap="flat" cmpd="sng" algn="ctr">
+                      <a:solidFill>
+                        <a:srgbClr val="BFBFBF"/>
+                      </a:solidFill>
+                      <a:prstDash val="solid"/>
+                      <a:round/>
+                      <a:headEnd type="none" w="med" len="med"/>
+                      <a:tailEnd type="none" w="med" len="med"/>
+                    </a:lnL>
+                    <a:lnR w="6350" cap="flat" cmpd="sng" algn="ctr">
+                      <a:solidFill>
+                        <a:srgbClr val="BFBFBF"/>
+                      </a:solidFill>
+                      <a:prstDash val="solid"/>
+                      <a:round/>
+                      <a:headEnd type="none" w="med" len="med"/>
+                      <a:tailEnd type="none" w="med" len="med"/>
+                    </a:lnR>
+                    <a:lnT w="6350" cap="flat" cmpd="sng" algn="ctr">
+                      <a:solidFill>
+                        <a:srgbClr val="BFBFBF"/>
+                      </a:solidFill>
+                      <a:prstDash val="solid"/>
+                      <a:round/>
+                      <a:headEnd type="none" w="med" len="med"/>
+                      <a:tailEnd type="none" w="med" len="med"/>
+                    </a:lnT>
+                    <a:lnB w="6350" cap="flat" cmpd="sng" algn="ctr">
+                      <a:solidFill>
+                        <a:srgbClr val="BFBFBF"/>
+                      </a:solidFill>
+                      <a:prstDash val="solid"/>
+                      <a:round/>
+                      <a:headEnd type="none" w="med" len="med"/>
+                      <a:tailEnd type="none" w="med" len="med"/>
+                    </a:lnB>
+                    <a:solidFill>
+                      <a:srgbClr val="FFFFFF"/>
+                    </a:solidFill>
+                  </a:tcPr>
+                </a:tc>
+                <a:tc>
+                  <a:txBody>
+                    <a:bodyPr/>
+                    <a:lstStyle/>
+                    <a:p>
+                      <a:pPr indent="0" marL="0">
+                        <a:buNone/>
+                      </a:pPr>
+                      <a:r>
+                        <a:rPr lang="en-US" sz="850" dirty="0">
+                          <a:solidFill>
+                            <a:srgbClr val="262626"/>
+                          </a:solidFill>
+                          <a:latin typeface="Arial" pitchFamily="34" charset="0"/>
+                          <a:ea typeface="Arial" pitchFamily="34" charset="-122"/>
+                          <a:cs typeface="Arial" pitchFamily="34" charset="-120"/>
+                        </a:rPr>
+                        <a:t>Federal Reserve, Summary of Economic Projections, Figure 2 (16 Sep 2026)</a:t>
+                      </a:r>
+                      <a:endParaRPr lang="en-US" sz="850" dirty="0">
+                        <a:latin typeface="Arial" charset="0"/>
+                        <a:ea typeface="Arial" charset="0"/>
+                        <a:cs typeface="Arial" charset="0"/>
+                      </a:endParaRPr>
+                    </a:p>
+                  </a:txBody>
+                  <a:tcPr marL="63500" marR="63500" marT="12700" marB="12700" anchor="ctr">
+                    <a:lnL w="6350" cap="flat" cmpd="sng" algn="ctr">
+                      <a:solidFill>
+                        <a:srgbClr val="BFBFBF"/>
+                      </a:solidFill>
+                      <a:prstDash val="solid"/>
+                      <a:round/>
+                      <a:headEnd type="none" w="med" len="med"/>
+                      <a:tailEnd type="none" w="med" len="med"/>
+                    </a:lnL>
+                    <a:lnR w="6350" cap="flat" cmpd="sng" algn="ctr">
+                      <a:solidFill>
+                        <a:srgbClr val="BFBFBF"/>
+                      </a:solidFill>
+                      <a:prstDash val="solid"/>
+                      <a:round/>
+                      <a:headEnd type="none" w="med" len="med"/>
+                      <a:tailEnd type="none" w="med" len="med"/>
+                    </a:lnR>
+                    <a:lnT w="6350" cap="flat" cmpd="sng" algn="ctr">
+                      <a:solidFill>
+                        <a:srgbClr val="BFBFBF"/>
+                      </a:solidFill>
+                      <a:prstDash val="solid"/>
+                      <a:round/>
+                      <a:headEnd type="none" w="med" len="med"/>
+                      <a:tailEnd type="none" w="med" len="med"/>
+                    </a:lnT>
+                    <a:lnB w="6350" cap="flat" cmpd="sng" algn="ctr">
+                      <a:solidFill>
+                        <a:srgbClr val="BFBFBF"/>
+                      </a:solidFill>
+                      <a:prstDash val="solid"/>
+                      <a:round/>
+                      <a:headEnd type="none" w="med" len="med"/>
+                      <a:tailEnd type="none" w="med" len="med"/>
+                    </a:lnB>
+                    <a:solidFill>
+                      <a:srgbClr val="FFFFFF"/>
+                    </a:solidFill>
+                  </a:tcPr>
+                </a:tc>
+              </a:tr>
+              <a:tr h="246888">
                 <a:tc>
                   <a:txBody>
                     <a:bodyPr/>
@@ -13485,7 +14709,7 @@
                   </a:tcPr>
                 </a:tc>
               </a:tr>
-              <a:tr h="256032">
+              <a:tr h="246888">
                 <a:tc>
                   <a:txBody>
                     <a:bodyPr/>
@@ -13623,7 +14847,7 @@
                   </a:tcPr>
                 </a:tc>
               </a:tr>
-              <a:tr h="256032">
+              <a:tr h="246888">
                 <a:tc>
                   <a:txBody>
                     <a:bodyPr/>
@@ -13761,7 +14985,7 @@
                   </a:tcPr>
                 </a:tc>
               </a:tr>
-              <a:tr h="256032">
+              <a:tr h="246888">
                 <a:tc>
                   <a:txBody>
                     <a:bodyPr/>
@@ -13899,7 +15123,7 @@
                   </a:tcPr>
                 </a:tc>
               </a:tr>
-              <a:tr h="256032">
+              <a:tr h="246888">
                 <a:tc>
                   <a:txBody>
                     <a:bodyPr/>
@@ -14037,7 +15261,7 @@
                   </a:tcPr>
                 </a:tc>
               </a:tr>
-              <a:tr h="256032">
+              <a:tr h="246888">
                 <a:tc>
                   <a:txBody>
                     <a:bodyPr/>
@@ -14175,7 +15399,7 @@
                   </a:tcPr>
                 </a:tc>
               </a:tr>
-              <a:tr h="256032">
+              <a:tr h="246888">
                 <a:tc>
                   <a:txBody>
                     <a:bodyPr/>
@@ -14325,8 +15549,8 @@
         </p:nvSpPr>
         <p:spPr>
           <a:xfrm>
-            <a:off x="457200" y="5806440"/>
-            <a:ext cx="11274552" cy="274320"/>
+            <a:off x="457200" y="6089904"/>
+            <a:ext cx="11274552" cy="237744"/>
           </a:xfrm>
           <a:prstGeom prst="rect">
             <a:avLst/>
@@ -14342,7 +15566,7 @@
               <a:buNone/>
             </a:pPr>
             <a:r>
-              <a:rPr lang="en-US" sz="900" i="1" dirty="0">
+              <a:rPr lang="en-US" sz="800" i="1" dirty="0">
                 <a:solidFill>
                   <a:srgbClr val="595959"/>
                 </a:solidFill>
@@ -14352,7 +15576,7 @@
               </a:rPr>
               <a:t>Several figures are forecasts or third-party estimates; numbers marked 'verify' come from a single secondary source. Full URLs: deck/thesis_sources.md.</a:t>
             </a:r>
-            <a:endParaRPr lang="en-US" sz="900" dirty="0"/>
+            <a:endParaRPr lang="en-US" sz="800" dirty="0"/>
           </a:p>
         </p:txBody>
       </p:sp>

</xml_diff>

<commit_message>
Thesis: merge the dot-plot slide into the one-slide thesis 2
The FOMC dot plot replaces the Fed funds history panel; implications 1 and 5 now cite it.

Co-Authored-By: Claude Opus 5.5 <noreply@anthropic.com>
Claude-Session: https://claude.ai/code/session_01Rwoh8cFDQqLD8JWT3mee6y
</commit_message>
<xml_diff>
--- a/deck/Investment-Thesis-Slides.pptx
+++ b/deck/Investment-Thesis-Slides.pptx
@@ -10,10 +10,9 @@
     <p:sldId id="258" r:id="rId4"/>
     <p:sldId id="259" r:id="rId5"/>
     <p:sldId id="260" r:id="rId6"/>
-    <p:sldId id="261" r:id="rId7"/>
   </p:sldIdLst>
   <p:notesMasterIdLst>
-    <p:notesMasterId r:id="rId8"/>
+    <p:notesMasterId r:id="rId7"/>
   </p:notesMasterIdLst>
   <p:sldSz cx="12192000" cy="6858000"/>
   <p:notesSz cx="6858000" cy="12192000"/>
@@ -423,285 +422,6 @@
 </file>
 
 <file path=ppt/charts/chart10.xml><?xml version="1.0" encoding="utf-8"?>
-<c:chartSpace xmlns:c="http://schemas.openxmlformats.org/drawingml/2006/chart" xmlns:a="http://schemas.openxmlformats.org/drawingml/2006/main" xmlns:r="http://schemas.openxmlformats.org/officeDocument/2006/relationships">
-  <c:date1904 val="0"/>
-  <c:roundedCorners val="1"/>
-  <c:chart>
-    <c:autoTitleDeleted val="1"/>
-    <c:plotArea>
-      <c:layout/>
-      <c:barChart>
-        <c:barDir val="col"/>
-        <c:grouping val="clustered"/>
-        <c:varyColors val="0"/>
-        <c:ser>
-          <c:idx val="0"/>
-          <c:order val="0"/>
-          <c:tx>
-            <c:strRef>
-              <c:f>Sheet1!$B$1</c:f>
-              <c:strCache>
-                <c:ptCount val="1"/>
-                <c:pt idx="0">
-                  <c:v>5Y USD bond</c:v>
-                </c:pt>
-              </c:strCache>
-            </c:strRef>
-          </c:tx>
-          <c:spPr>
-            <a:solidFill>
-              <a:srgbClr val="404040"/>
-            </a:solidFill>
-            <a:effectLst/>
-          </c:spPr>
-          <c:invertIfNegative val="0"/>
-          <c:dLbls>
-            <c:numFmt formatCode="0.0" sourceLinked="0"/>
-            <c:txPr>
-              <a:bodyPr/>
-              <a:lstStyle/>
-              <a:p>
-                <a:pPr>
-                  <a:defRPr b="0" i="0" strike="noStrike" sz="700" u="none">
-                    <a:solidFill>
-                      <a:srgbClr val="262626"/>
-                    </a:solidFill>
-                    <a:latin typeface="Arial"/>
-                  </a:defRPr>
-                </a:pPr>
-              </a:p>
-            </c:txPr>
-            <c:showLegendKey val="0"/>
-            <c:showVal val="1"/>
-            <c:showCatName val="0"/>
-            <c:showSerName val="0"/>
-            <c:showPercent val="0"/>
-            <c:showBubbleSize val="0"/>
-            <c:showLeaderLines val="0"/>
-          </c:dLbls>
-          <c:cat>
-            <c:multiLvlStrRef>
-              <c:f>Sheet1!$A$2:$A$10</c:f>
-              <c:multiLvlStrCache>
-                <c:ptCount val="9"/>
-                <c:lvl>
-                  <c:pt idx="0">
-                    <c:v>-2.0%</c:v>
-                  </c:pt>
-                  <c:pt idx="1">
-                    <c:v>-1.5%</c:v>
-                  </c:pt>
-                  <c:pt idx="2">
-                    <c:v>-1.0%</c:v>
-                  </c:pt>
-                  <c:pt idx="3">
-                    <c:v>-0.5%</c:v>
-                  </c:pt>
-                  <c:pt idx="4">
-                    <c:v>0</c:v>
-                  </c:pt>
-                  <c:pt idx="5">
-                    <c:v>+0.5%</c:v>
-                  </c:pt>
-                  <c:pt idx="6">
-                    <c:v>+1.0%</c:v>
-                  </c:pt>
-                  <c:pt idx="7">
-                    <c:v>+1.5%</c:v>
-                  </c:pt>
-                  <c:pt idx="8">
-                    <c:v>+2.0%</c:v>
-                  </c:pt>
-                </c:lvl>
-              </c:multiLvlStrCache>
-            </c:multiLvlStrRef>
-          </c:cat>
-          <c:val>
-            <c:numRef>
-              <c:f>Sheet1!$B$2:$B$10</c:f>
-              <c:numCache>
-                <c:formatCode>General</c:formatCode>
-                <c:ptCount val="9"/>
-                <c:pt idx="0">
-                  <c:v>9.1</c:v>
-                </c:pt>
-                <c:pt idx="1">
-                  <c:v>6.8</c:v>
-                </c:pt>
-                <c:pt idx="2">
-                  <c:v>4.5</c:v>
-                </c:pt>
-                <c:pt idx="3">
-                  <c:v>2.3</c:v>
-                </c:pt>
-                <c:pt idx="4">
-                  <c:v>0</c:v>
-                </c:pt>
-                <c:pt idx="5">
-                  <c:v>-2</c:v>
-                </c:pt>
-                <c:pt idx="6">
-                  <c:v>-4</c:v>
-                </c:pt>
-                <c:pt idx="7">
-                  <c:v>-6</c:v>
-                </c:pt>
-                <c:pt idx="8">
-                  <c:v>-7.9</c:v>
-                </c:pt>
-              </c:numCache>
-            </c:numRef>
-          </c:val>
-        </c:ser>
-        <c:dLbls>
-          <c:numFmt formatCode="0.0" sourceLinked="0"/>
-          <c:txPr>
-            <a:bodyPr/>
-            <a:lstStyle/>
-            <a:p>
-              <a:pPr>
-                <a:defRPr b="0" i="0" strike="noStrike" sz="700" u="none">
-                  <a:solidFill>
-                    <a:srgbClr val="262626"/>
-                  </a:solidFill>
-                  <a:latin typeface="Arial"/>
-                </a:defRPr>
-              </a:pPr>
-            </a:p>
-          </c:txPr>
-          <c:showLegendKey val="0"/>
-          <c:showVal val="1"/>
-          <c:showCatName val="0"/>
-          <c:showSerName val="0"/>
-          <c:showPercent val="0"/>
-          <c:showBubbleSize val="0"/>
-          <c:showLeaderLines val="0"/>
-        </c:dLbls>
-        <c:gapWidth val="150"/>
-        <c:overlap val="0"/>
-        <c:axId val="2094734554"/>
-        <c:axId val="2094734552"/>
-        <c:axId val="2094734556"/>
-      </c:barChart>
-      <c:catAx>
-        <c:axId val="2094734554"/>
-        <c:scaling>
-          <c:orientation val="minMax"/>
-        </c:scaling>
-        <c:delete val="0"/>
-        <c:axPos val="b"/>
-        <c:numFmt formatCode="General" sourceLinked="1"/>
-        <c:majorTickMark val="out"/>
-        <c:minorTickMark val="none"/>
-        <c:tickLblPos val="low"/>
-        <c:spPr>
-          <a:ln w="12700" cap="flat">
-            <a:solidFill>
-              <a:srgbClr val="BFBFBF"/>
-            </a:solidFill>
-            <a:prstDash val="solid"/>
-            <a:round/>
-          </a:ln>
-        </c:spPr>
-        <c:txPr>
-          <a:bodyPr/>
-          <a:lstStyle/>
-          <a:p>
-            <a:pPr>
-              <a:defRPr sz="750" b="0" i="0" u="none" strike="noStrike">
-                <a:solidFill>
-                  <a:srgbClr val="595959"/>
-                </a:solidFill>
-                <a:latin typeface="Arial"/>
-              </a:defRPr>
-            </a:pPr>
-            <a:endParaRPr lang="en-US"/>
-          </a:p>
-        </c:txPr>
-        <c:crossAx val="2094734552"/>
-        <c:crosses val="autoZero"/>
-        <c:auto val="1"/>
-        <c:lblAlgn val="ctr"/>
-        <c:noMultiLvlLbl val="1"/>
-      </c:catAx>
-      <c:valAx>
-        <c:axId val="2094734552"/>
-        <c:scaling>
-          <c:orientation val="minMax"/>
-          <c:max val="12"/>
-          <c:min val="-12"/>
-        </c:scaling>
-        <c:delete val="0"/>
-        <c:axPos val="l"/>
-        <c:majorGridlines>
-          <c:spPr>
-            <a:ln w="6350" cap="flat">
-              <a:solidFill>
-                <a:srgbClr val="E3E3E3"/>
-              </a:solidFill>
-              <a:prstDash val="solid"/>
-              <a:round/>
-            </a:ln>
-          </c:spPr>
-        </c:majorGridlines>
-        <c:numFmt formatCode="0&quot;%&quot;" sourceLinked="0"/>
-        <c:majorTickMark val="out"/>
-        <c:minorTickMark val="none"/>
-        <c:tickLblPos val="nextTo"/>
-        <c:spPr>
-          <a:ln w="12700" cap="flat">
-            <a:solidFill>
-              <a:srgbClr val="888888"/>
-            </a:solidFill>
-            <a:prstDash val="solid"/>
-            <a:round/>
-          </a:ln>
-        </c:spPr>
-        <c:txPr>
-          <a:bodyPr/>
-          <a:lstStyle/>
-          <a:p>
-            <a:pPr>
-              <a:defRPr sz="800" b="0" i="0" u="none" strike="noStrike">
-                <a:solidFill>
-                  <a:srgbClr val="595959"/>
-                </a:solidFill>
-                <a:latin typeface="Arial"/>
-              </a:defRPr>
-            </a:pPr>
-            <a:endParaRPr lang="en-US"/>
-          </a:p>
-        </c:txPr>
-        <c:crossAx val="2094734554"/>
-        <c:crosses val="autoZero"/>
-        <c:crossBetween val="between"/>
-        <c:majorUnit val="4"/>
-      </c:valAx>
-      <c:spPr>
-        <a:noFill/>
-        <a:ln>
-          <a:noFill/>
-        </a:ln>
-        <a:effectLst/>
-      </c:spPr>
-    </c:plotArea>
-    <c:plotVisOnly val="1"/>
-    <c:dispBlanksAs val="span"/>
-  </c:chart>
-  <c:spPr>
-    <a:noFill/>
-    <a:ln>
-      <a:noFill/>
-    </a:ln>
-    <a:effectLst/>
-  </c:spPr>
-  <c:externalData r:id="rId1">
-    <c:autoUpdate val="0"/>
-  </c:externalData>
-</c:chartSpace>
-</file>
-
-<file path=ppt/charts/chart11.xml><?xml version="1.0" encoding="utf-8"?>
 <c:chartSpace xmlns:c="http://schemas.openxmlformats.org/drawingml/2006/chart" xmlns:a="http://schemas.openxmlformats.org/drawingml/2006/main" xmlns:r="http://schemas.openxmlformats.org/officeDocument/2006/relationships">
   <c:date1904 val="0"/>
   <c:roundedCorners val="1"/>
@@ -3337,367 +3057,6 @@
               <c:strCache>
                 <c:ptCount val="1"/>
                 <c:pt idx="0">
-                  <c:v>Fed funds (upper bound)</c:v>
-                </c:pt>
-              </c:strCache>
-            </c:strRef>
-          </c:tx>
-          <c:spPr>
-            <a:solidFill>
-              <a:srgbClr val="2C5F82"/>
-            </a:solidFill>
-            <a:ln w="28575" cap="flat">
-              <a:solidFill>
-                <a:srgbClr val="2C5F82"/>
-              </a:solidFill>
-              <a:prstDash val="solid"/>
-              <a:round/>
-            </a:ln>
-            <a:effectLst/>
-          </c:spPr>
-          <c:invertIfNegative val="0"/>
-          <c:dLbls>
-            <c:numFmt formatCode="#,##0" sourceLinked="0"/>
-            <c:txPr>
-              <a:bodyPr/>
-              <a:lstStyle/>
-              <a:p>
-                <a:pPr>
-                  <a:defRPr b="0" i="0" strike="noStrike" sz="1200" u="none">
-                    <a:solidFill>
-                      <a:srgbClr val="000000"/>
-                    </a:solidFill>
-                    <a:latin typeface="Arial"/>
-                  </a:defRPr>
-                </a:pPr>
-              </a:p>
-            </c:txPr>
-            <c:showLegendKey val="0"/>
-            <c:showVal val="0"/>
-            <c:showCatName val="0"/>
-            <c:showSerName val="0"/>
-            <c:showPercent val="0"/>
-            <c:showBubbleSize val="0"/>
-            <c:showLeaderLines val="0"/>
-          </c:dLbls>
-          <c:marker>
-            <c:symbol val="none"/>
-            <c:size val="6"/>
-            <c:spPr>
-              <a:solidFill>
-                <a:srgbClr val="2C5F82"/>
-              </a:solidFill>
-              <a:ln w="9525" cap="flat">
-                <a:solidFill>
-                  <a:srgbClr val="2C5F82"/>
-                </a:solidFill>
-                <a:prstDash val="solid"/>
-                <a:round/>
-              </a:ln>
-              <a:effectLst/>
-            </c:spPr>
-          </c:marker>
-          <c:cat>
-            <c:multiLvlStrRef>
-              <c:f>Sheet1!$A$2:$A$20</c:f>
-              <c:multiLvlStrCache>
-                <c:ptCount val="19"/>
-                <c:lvl>
-                  <c:pt idx="0">
-                    <c:v>Q1-22</c:v>
-                  </c:pt>
-                  <c:pt idx="1">
-                    <c:v>Q2-22</c:v>
-                  </c:pt>
-                  <c:pt idx="2">
-                    <c:v>Q3-22</c:v>
-                  </c:pt>
-                  <c:pt idx="3">
-                    <c:v>Q4-22</c:v>
-                  </c:pt>
-                  <c:pt idx="4">
-                    <c:v>Q1-23</c:v>
-                  </c:pt>
-                  <c:pt idx="5">
-                    <c:v>Q2-23</c:v>
-                  </c:pt>
-                  <c:pt idx="6">
-                    <c:v>Q3-23</c:v>
-                  </c:pt>
-                  <c:pt idx="7">
-                    <c:v>Q4-23</c:v>
-                  </c:pt>
-                  <c:pt idx="8">
-                    <c:v>Q1-24</c:v>
-                  </c:pt>
-                  <c:pt idx="9">
-                    <c:v>Q2-24</c:v>
-                  </c:pt>
-                  <c:pt idx="10">
-                    <c:v>Q3-24</c:v>
-                  </c:pt>
-                  <c:pt idx="11">
-                    <c:v>Q4-24</c:v>
-                  </c:pt>
-                  <c:pt idx="12">
-                    <c:v>Q1-25</c:v>
-                  </c:pt>
-                  <c:pt idx="13">
-                    <c:v>Q2-25</c:v>
-                  </c:pt>
-                  <c:pt idx="14">
-                    <c:v>Q3-25</c:v>
-                  </c:pt>
-                  <c:pt idx="15">
-                    <c:v>Q4-25</c:v>
-                  </c:pt>
-                  <c:pt idx="16">
-                    <c:v>Q1-26</c:v>
-                  </c:pt>
-                  <c:pt idx="17">
-                    <c:v>Q2-26</c:v>
-                  </c:pt>
-                  <c:pt idx="18">
-                    <c:v>Q3-26</c:v>
-                  </c:pt>
-                </c:lvl>
-              </c:multiLvlStrCache>
-            </c:multiLvlStrRef>
-          </c:cat>
-          <c:val>
-            <c:numRef>
-              <c:f>Sheet1!$B$2:$B$20</c:f>
-              <c:numCache>
-                <c:formatCode>General</c:formatCode>
-                <c:ptCount val="19"/>
-                <c:pt idx="0">
-                  <c:v>0.5</c:v>
-                </c:pt>
-                <c:pt idx="1">
-                  <c:v>1.75</c:v>
-                </c:pt>
-                <c:pt idx="2">
-                  <c:v>3.25</c:v>
-                </c:pt>
-                <c:pt idx="3">
-                  <c:v>4.5</c:v>
-                </c:pt>
-                <c:pt idx="4">
-                  <c:v>5</c:v>
-                </c:pt>
-                <c:pt idx="5">
-                  <c:v>5.25</c:v>
-                </c:pt>
-                <c:pt idx="6">
-                  <c:v>5.5</c:v>
-                </c:pt>
-                <c:pt idx="7">
-                  <c:v>5.5</c:v>
-                </c:pt>
-                <c:pt idx="8">
-                  <c:v>5.5</c:v>
-                </c:pt>
-                <c:pt idx="9">
-                  <c:v>5.5</c:v>
-                </c:pt>
-                <c:pt idx="10">
-                  <c:v>5</c:v>
-                </c:pt>
-                <c:pt idx="11">
-                  <c:v>4.5</c:v>
-                </c:pt>
-                <c:pt idx="12">
-                  <c:v>4.5</c:v>
-                </c:pt>
-                <c:pt idx="13">
-                  <c:v>4.5</c:v>
-                </c:pt>
-                <c:pt idx="14">
-                  <c:v>4.25</c:v>
-                </c:pt>
-                <c:pt idx="15">
-                  <c:v>3.75</c:v>
-                </c:pt>
-                <c:pt idx="16">
-                  <c:v>3.75</c:v>
-                </c:pt>
-                <c:pt idx="17">
-                  <c:v>3.75</c:v>
-                </c:pt>
-                <c:pt idx="18">
-                  <c:v>4</c:v>
-                </c:pt>
-              </c:numCache>
-            </c:numRef>
-          </c:val>
-          <c:smooth val="0"/>
-        </c:ser>
-        <c:dLbls>
-          <c:numFmt formatCode="#,##0" sourceLinked="0"/>
-          <c:txPr>
-            <a:bodyPr/>
-            <a:lstStyle/>
-            <a:p>
-              <a:pPr>
-                <a:defRPr b="0" i="0" strike="noStrike" sz="1200" u="none">
-                  <a:solidFill>
-                    <a:srgbClr val="000000"/>
-                  </a:solidFill>
-                  <a:latin typeface="Arial"/>
-                </a:defRPr>
-              </a:pPr>
-            </a:p>
-          </c:txPr>
-          <c:showLegendKey val="0"/>
-          <c:showVal val="0"/>
-          <c:showCatName val="0"/>
-          <c:showSerName val="0"/>
-          <c:showPercent val="0"/>
-          <c:showBubbleSize val="0"/>
-          <c:showLeaderLines val="0"/>
-        </c:dLbls>
-        <c:marker val="1"/>
-        <c:axId val="2094734554"/>
-        <c:axId val="2094734552"/>
-        <c:axId val="2094734556"/>
-      </c:lineChart>
-      <c:catAx>
-        <c:axId val="2094734554"/>
-        <c:scaling>
-          <c:orientation val="minMax"/>
-        </c:scaling>
-        <c:delete val="0"/>
-        <c:axPos val="b"/>
-        <c:numFmt formatCode="General" sourceLinked="1"/>
-        <c:majorTickMark val="out"/>
-        <c:minorTickMark val="none"/>
-        <c:tickLblPos val="low"/>
-        <c:spPr>
-          <a:ln w="12700" cap="flat">
-            <a:solidFill>
-              <a:srgbClr val="BFBFBF"/>
-            </a:solidFill>
-            <a:prstDash val="solid"/>
-            <a:round/>
-          </a:ln>
-        </c:spPr>
-        <c:txPr>
-          <a:bodyPr/>
-          <a:lstStyle/>
-          <a:p>
-            <a:pPr>
-              <a:defRPr sz="650" b="0" i="0" u="none" strike="noStrike">
-                <a:solidFill>
-                  <a:srgbClr val="595959"/>
-                </a:solidFill>
-                <a:latin typeface="Arial"/>
-              </a:defRPr>
-            </a:pPr>
-            <a:endParaRPr lang="en-US"/>
-          </a:p>
-        </c:txPr>
-        <c:crossAx val="2094734552"/>
-        <c:crosses val="autoZero"/>
-        <c:auto val="1"/>
-        <c:lblAlgn val="ctr"/>
-        <c:noMultiLvlLbl val="1"/>
-      </c:catAx>
-      <c:valAx>
-        <c:axId val="2094734552"/>
-        <c:scaling>
-          <c:orientation val="minMax"/>
-          <c:max val="6"/>
-          <c:min val="0"/>
-        </c:scaling>
-        <c:delete val="0"/>
-        <c:axPos val="l"/>
-        <c:majorGridlines>
-          <c:spPr>
-            <a:ln w="6350" cap="flat">
-              <a:solidFill>
-                <a:srgbClr val="E3E3E3"/>
-              </a:solidFill>
-              <a:prstDash val="solid"/>
-              <a:round/>
-            </a:ln>
-          </c:spPr>
-        </c:majorGridlines>
-        <c:numFmt formatCode="0&quot;%&quot;" sourceLinked="0"/>
-        <c:majorTickMark val="out"/>
-        <c:minorTickMark val="none"/>
-        <c:tickLblPos val="nextTo"/>
-        <c:spPr>
-          <a:ln w="12700" cap="flat">
-            <a:solidFill>
-              <a:srgbClr val="888888"/>
-            </a:solidFill>
-            <a:prstDash val="solid"/>
-            <a:round/>
-          </a:ln>
-        </c:spPr>
-        <c:txPr>
-          <a:bodyPr/>
-          <a:lstStyle/>
-          <a:p>
-            <a:pPr>
-              <a:defRPr sz="800" b="0" i="0" u="none" strike="noStrike">
-                <a:solidFill>
-                  <a:srgbClr val="595959"/>
-                </a:solidFill>
-                <a:latin typeface="Arial"/>
-              </a:defRPr>
-            </a:pPr>
-            <a:endParaRPr lang="en-US"/>
-          </a:p>
-        </c:txPr>
-        <c:crossAx val="2094734554"/>
-        <c:crosses val="autoZero"/>
-        <c:crossBetween val="between"/>
-        <c:majorUnit val="2"/>
-      </c:valAx>
-      <c:spPr>
-        <a:noFill/>
-        <a:ln>
-          <a:noFill/>
-        </a:ln>
-        <a:effectLst/>
-      </c:spPr>
-    </c:plotArea>
-    <c:plotVisOnly val="1"/>
-    <c:dispBlanksAs val="span"/>
-  </c:chart>
-  <c:spPr>
-    <a:noFill/>
-    <a:ln>
-      <a:noFill/>
-    </a:ln>
-    <a:effectLst/>
-  </c:spPr>
-  <c:externalData r:id="rId1">
-    <c:autoUpdate val="0"/>
-  </c:externalData>
-</c:chartSpace>
-</file>
-
-<file path=ppt/charts/chart9.xml><?xml version="1.0" encoding="utf-8"?>
-<c:chartSpace xmlns:c="http://schemas.openxmlformats.org/drawingml/2006/chart" xmlns:a="http://schemas.openxmlformats.org/drawingml/2006/main" xmlns:r="http://schemas.openxmlformats.org/officeDocument/2006/relationships">
-  <c:date1904 val="0"/>
-  <c:roundedCorners val="1"/>
-  <c:chart>
-    <c:autoTitleDeleted val="1"/>
-    <c:plotArea>
-      <c:layout/>
-      <c:lineChart>
-        <c:varyColors val="0"/>
-        <c:ser>
-          <c:idx val="0"/>
-          <c:order val="0"/>
-          <c:tx>
-            <c:strRef>
-              <c:f>Sheet1!$B$1</c:f>
-              <c:strCache>
-                <c:ptCount val="1"/>
-                <c:pt idx="0">
                   <c:v>TAIEX</c:v>
                 </c:pt>
               </c:strCache>
@@ -4249,6 +3608,285 @@
 </c:chartSpace>
 </file>
 
+<file path=ppt/charts/chart9.xml><?xml version="1.0" encoding="utf-8"?>
+<c:chartSpace xmlns:c="http://schemas.openxmlformats.org/drawingml/2006/chart" xmlns:a="http://schemas.openxmlformats.org/drawingml/2006/main" xmlns:r="http://schemas.openxmlformats.org/officeDocument/2006/relationships">
+  <c:date1904 val="0"/>
+  <c:roundedCorners val="1"/>
+  <c:chart>
+    <c:autoTitleDeleted val="1"/>
+    <c:plotArea>
+      <c:layout/>
+      <c:barChart>
+        <c:barDir val="col"/>
+        <c:grouping val="clustered"/>
+        <c:varyColors val="0"/>
+        <c:ser>
+          <c:idx val="0"/>
+          <c:order val="0"/>
+          <c:tx>
+            <c:strRef>
+              <c:f>Sheet1!$B$1</c:f>
+              <c:strCache>
+                <c:ptCount val="1"/>
+                <c:pt idx="0">
+                  <c:v>5Y USD bond</c:v>
+                </c:pt>
+              </c:strCache>
+            </c:strRef>
+          </c:tx>
+          <c:spPr>
+            <a:solidFill>
+              <a:srgbClr val="404040"/>
+            </a:solidFill>
+            <a:effectLst/>
+          </c:spPr>
+          <c:invertIfNegative val="0"/>
+          <c:dLbls>
+            <c:numFmt formatCode="0.0" sourceLinked="0"/>
+            <c:txPr>
+              <a:bodyPr/>
+              <a:lstStyle/>
+              <a:p>
+                <a:pPr>
+                  <a:defRPr b="0" i="0" strike="noStrike" sz="700" u="none">
+                    <a:solidFill>
+                      <a:srgbClr val="262626"/>
+                    </a:solidFill>
+                    <a:latin typeface="Arial"/>
+                  </a:defRPr>
+                </a:pPr>
+              </a:p>
+            </c:txPr>
+            <c:showLegendKey val="0"/>
+            <c:showVal val="1"/>
+            <c:showCatName val="0"/>
+            <c:showSerName val="0"/>
+            <c:showPercent val="0"/>
+            <c:showBubbleSize val="0"/>
+            <c:showLeaderLines val="0"/>
+          </c:dLbls>
+          <c:cat>
+            <c:multiLvlStrRef>
+              <c:f>Sheet1!$A$2:$A$10</c:f>
+              <c:multiLvlStrCache>
+                <c:ptCount val="9"/>
+                <c:lvl>
+                  <c:pt idx="0">
+                    <c:v>-2.0%</c:v>
+                  </c:pt>
+                  <c:pt idx="1">
+                    <c:v>-1.5%</c:v>
+                  </c:pt>
+                  <c:pt idx="2">
+                    <c:v>-1.0%</c:v>
+                  </c:pt>
+                  <c:pt idx="3">
+                    <c:v>-0.5%</c:v>
+                  </c:pt>
+                  <c:pt idx="4">
+                    <c:v>0</c:v>
+                  </c:pt>
+                  <c:pt idx="5">
+                    <c:v>+0.5%</c:v>
+                  </c:pt>
+                  <c:pt idx="6">
+                    <c:v>+1.0%</c:v>
+                  </c:pt>
+                  <c:pt idx="7">
+                    <c:v>+1.5%</c:v>
+                  </c:pt>
+                  <c:pt idx="8">
+                    <c:v>+2.0%</c:v>
+                  </c:pt>
+                </c:lvl>
+              </c:multiLvlStrCache>
+            </c:multiLvlStrRef>
+          </c:cat>
+          <c:val>
+            <c:numRef>
+              <c:f>Sheet1!$B$2:$B$10</c:f>
+              <c:numCache>
+                <c:formatCode>General</c:formatCode>
+                <c:ptCount val="9"/>
+                <c:pt idx="0">
+                  <c:v>9.1</c:v>
+                </c:pt>
+                <c:pt idx="1">
+                  <c:v>6.8</c:v>
+                </c:pt>
+                <c:pt idx="2">
+                  <c:v>4.5</c:v>
+                </c:pt>
+                <c:pt idx="3">
+                  <c:v>2.3</c:v>
+                </c:pt>
+                <c:pt idx="4">
+                  <c:v>0</c:v>
+                </c:pt>
+                <c:pt idx="5">
+                  <c:v>-2</c:v>
+                </c:pt>
+                <c:pt idx="6">
+                  <c:v>-4</c:v>
+                </c:pt>
+                <c:pt idx="7">
+                  <c:v>-6</c:v>
+                </c:pt>
+                <c:pt idx="8">
+                  <c:v>-7.9</c:v>
+                </c:pt>
+              </c:numCache>
+            </c:numRef>
+          </c:val>
+        </c:ser>
+        <c:dLbls>
+          <c:numFmt formatCode="0.0" sourceLinked="0"/>
+          <c:txPr>
+            <a:bodyPr/>
+            <a:lstStyle/>
+            <a:p>
+              <a:pPr>
+                <a:defRPr b="0" i="0" strike="noStrike" sz="700" u="none">
+                  <a:solidFill>
+                    <a:srgbClr val="262626"/>
+                  </a:solidFill>
+                  <a:latin typeface="Arial"/>
+                </a:defRPr>
+              </a:pPr>
+            </a:p>
+          </c:txPr>
+          <c:showLegendKey val="0"/>
+          <c:showVal val="1"/>
+          <c:showCatName val="0"/>
+          <c:showSerName val="0"/>
+          <c:showPercent val="0"/>
+          <c:showBubbleSize val="0"/>
+          <c:showLeaderLines val="0"/>
+        </c:dLbls>
+        <c:gapWidth val="150"/>
+        <c:overlap val="0"/>
+        <c:axId val="2094734554"/>
+        <c:axId val="2094734552"/>
+        <c:axId val="2094734556"/>
+      </c:barChart>
+      <c:catAx>
+        <c:axId val="2094734554"/>
+        <c:scaling>
+          <c:orientation val="minMax"/>
+        </c:scaling>
+        <c:delete val="0"/>
+        <c:axPos val="b"/>
+        <c:numFmt formatCode="General" sourceLinked="1"/>
+        <c:majorTickMark val="out"/>
+        <c:minorTickMark val="none"/>
+        <c:tickLblPos val="low"/>
+        <c:spPr>
+          <a:ln w="12700" cap="flat">
+            <a:solidFill>
+              <a:srgbClr val="BFBFBF"/>
+            </a:solidFill>
+            <a:prstDash val="solid"/>
+            <a:round/>
+          </a:ln>
+        </c:spPr>
+        <c:txPr>
+          <a:bodyPr/>
+          <a:lstStyle/>
+          <a:p>
+            <a:pPr>
+              <a:defRPr sz="750" b="0" i="0" u="none" strike="noStrike">
+                <a:solidFill>
+                  <a:srgbClr val="595959"/>
+                </a:solidFill>
+                <a:latin typeface="Arial"/>
+              </a:defRPr>
+            </a:pPr>
+            <a:endParaRPr lang="en-US"/>
+          </a:p>
+        </c:txPr>
+        <c:crossAx val="2094734552"/>
+        <c:crosses val="autoZero"/>
+        <c:auto val="1"/>
+        <c:lblAlgn val="ctr"/>
+        <c:noMultiLvlLbl val="1"/>
+      </c:catAx>
+      <c:valAx>
+        <c:axId val="2094734552"/>
+        <c:scaling>
+          <c:orientation val="minMax"/>
+          <c:max val="12"/>
+          <c:min val="-12"/>
+        </c:scaling>
+        <c:delete val="0"/>
+        <c:axPos val="l"/>
+        <c:majorGridlines>
+          <c:spPr>
+            <a:ln w="6350" cap="flat">
+              <a:solidFill>
+                <a:srgbClr val="E3E3E3"/>
+              </a:solidFill>
+              <a:prstDash val="solid"/>
+              <a:round/>
+            </a:ln>
+          </c:spPr>
+        </c:majorGridlines>
+        <c:numFmt formatCode="0&quot;%&quot;" sourceLinked="0"/>
+        <c:majorTickMark val="out"/>
+        <c:minorTickMark val="none"/>
+        <c:tickLblPos val="nextTo"/>
+        <c:spPr>
+          <a:ln w="12700" cap="flat">
+            <a:solidFill>
+              <a:srgbClr val="888888"/>
+            </a:solidFill>
+            <a:prstDash val="solid"/>
+            <a:round/>
+          </a:ln>
+        </c:spPr>
+        <c:txPr>
+          <a:bodyPr/>
+          <a:lstStyle/>
+          <a:p>
+            <a:pPr>
+              <a:defRPr sz="800" b="0" i="0" u="none" strike="noStrike">
+                <a:solidFill>
+                  <a:srgbClr val="595959"/>
+                </a:solidFill>
+                <a:latin typeface="Arial"/>
+              </a:defRPr>
+            </a:pPr>
+            <a:endParaRPr lang="en-US"/>
+          </a:p>
+        </c:txPr>
+        <c:crossAx val="2094734554"/>
+        <c:crosses val="autoZero"/>
+        <c:crossBetween val="between"/>
+        <c:majorUnit val="4"/>
+      </c:valAx>
+      <c:spPr>
+        <a:noFill/>
+        <a:ln>
+          <a:noFill/>
+        </a:ln>
+        <a:effectLst/>
+      </c:spPr>
+    </c:plotArea>
+    <c:plotVisOnly val="1"/>
+    <c:dispBlanksAs val="span"/>
+  </c:chart>
+  <c:spPr>
+    <a:noFill/>
+    <a:ln>
+      <a:noFill/>
+    </a:ln>
+    <a:effectLst/>
+  </c:spPr>
+  <c:externalData r:id="rId1">
+    <c:autoUpdate val="0"/>
+  </c:externalData>
+</c:chartSpace>
+</file>
+
 <file path=ppt/notesMasters/notesMaster1.xml><?xml version="1.0" encoding="utf-8"?>
 <p:notesMaster xmlns:a="http://schemas.openxmlformats.org/drawingml/2006/main" xmlns:r="http://schemas.openxmlformats.org/officeDocument/2006/relationships" xmlns:p="http://schemas.openxmlformats.org/presentationml/2006/main">
   <p:cSld>
@@ -4908,7 +4546,7 @@
           <a:p>
             <a:r>
               <a:rPr lang="en-US" dirty="0"/>
-              <a:t>The dot plot is the Fed's own forecast. Each dot is one FOMC participant's view of the right policy rate at year-end. Three readings: (1) the median sees one more hike this year and no cuts until 2028, so USD rates stay high for most of our 5-year horizon; (2) a hawkish minority sees 4.375%, so long bonds carry real downside; (3) the dots are widely spread, so rate volatility, and with it option premium, stays high. Each reading links to why a short-dated autocall with a 70% floor fits: cheap floor, early redemption, coupon funded by volatility, and supportive easing later in the life of the note.</a:t>
+              <a:t>One-slide thesis 2, modelled on the 'traditional strategies fall short' format, using market evidence only: the Fed's 16 Sep dot plot (median 4.125% through 2027, cuts only from 2028, a hawkish minority at 4.375%, wide disagreement) and the bond duration risk it implies, violent equity paths, concentration, record volatility and a late, richly priced cycle. Implications link each market fact to why an autocallable structure fits; our specific note and its numbers come in the product section.</a:t>
             </a:r>
             <a:endParaRPr lang="en-US" dirty="0"/>
           </a:p>
@@ -4996,7 +4634,7 @@
           <a:p>
             <a:r>
               <a:rPr lang="en-US" dirty="0"/>
-              <a:t>One-slide thesis 2, modelled on the 'traditional strategies fall short' format, using market evidence only: rising rates (bond duration risk), violent equity paths, concentration, record volatility and a late, richly priced cycle. Implications link each market fact to why an autocallable structure fits; our specific note and its numbers come in the product section.</a:t>
+              <a:t/>
             </a:r>
             <a:endParaRPr lang="en-US" dirty="0"/>
           </a:p>
@@ -5020,94 +4658,6 @@
             <a:fld id="{F7021451-1387-4CA6-816F-3879F97B5CBC}" type="slidenum">
               <a:rPr lang="en-US"/>
               <a:t>5</a:t>
-            </a:fld>
-            <a:endParaRPr lang="en-US"/>
-          </a:p>
-        </p:txBody>
-      </p:sp>
-    </p:spTree>
-    <p:extLst>
-      <p:ext uri="{BB962C8B-B14F-4D97-AF65-F5344CB8AC3E}">
-        <p14:creationId xmlns:p14="http://schemas.microsoft.com/office/powerpoint/2010/main" val="1024086991"/>
-      </p:ext>
-    </p:extLst>
-  </p:cSld>
-  <p:clrMapOvr>
-    <a:masterClrMapping/>
-  </p:clrMapOvr>
-</p:notes>
-</file>
-
-<file path=ppt/notesSlides/notesSlide6.xml><?xml version="1.0" encoding="utf-8"?>
-<p:notes xmlns:a="http://schemas.openxmlformats.org/drawingml/2006/main" xmlns:r="http://schemas.openxmlformats.org/officeDocument/2006/relationships" xmlns:p="http://schemas.openxmlformats.org/presentationml/2006/main">
-  <p:cSld>
-    <p:spTree>
-      <p:nvGrpSpPr>
-        <p:cNvPr id="1" name=""/>
-        <p:cNvGrpSpPr/>
-        <p:nvPr/>
-      </p:nvGrpSpPr>
-      <p:grpSpPr>
-        <a:xfrm>
-          <a:off x="0" y="0"/>
-          <a:ext cx="0" cy="0"/>
-          <a:chOff x="0" y="0"/>
-          <a:chExt cx="0" cy="0"/>
-        </a:xfrm>
-      </p:grpSpPr>
-      <p:sp>
-        <p:nvSpPr>
-          <p:cNvPr id="2" name="Slide Image Placeholder 1"/>
-          <p:cNvSpPr>
-            <a:spLocks noGrp="1" noRot="1" noChangeAspect="1"/>
-          </p:cNvSpPr>
-          <p:nvPr>
-            <p:ph type="sldImg"/>
-          </p:nvPr>
-        </p:nvSpPr>
-        <p:spPr/>
-      </p:sp>
-      <p:sp>
-        <p:nvSpPr>
-          <p:cNvPr id="3" name="Notes Placeholder 2"/>
-          <p:cNvSpPr>
-            <a:spLocks noGrp="1"/>
-          </p:cNvSpPr>
-          <p:nvPr>
-            <p:ph type="body" idx="1"/>
-          </p:nvPr>
-        </p:nvSpPr>
-        <p:spPr/>
-        <p:txBody>
-          <a:bodyPr/>
-          <a:lstStyle/>
-          <a:p>
-            <a:r>
-              <a:rPr lang="en-US" dirty="0"/>
-              <a:t/>
-            </a:r>
-            <a:endParaRPr lang="en-US" dirty="0"/>
-          </a:p>
-        </p:txBody>
-      </p:sp>
-      <p:sp>
-        <p:nvSpPr>
-          <p:cNvPr id="4" name="Slide Number Placeholder 3"/>
-          <p:cNvSpPr>
-            <a:spLocks noGrp="1"/>
-          </p:cNvSpPr>
-          <p:nvPr>
-            <p:ph type="sldNum" sz="quarter" idx="10"/>
-          </p:nvPr>
-        </p:nvSpPr>
-        <p:spPr/>
-        <p:txBody>
-          <a:bodyPr/>
-          <a:lstStyle/>
-          <a:p>
-            <a:fld id="{F7021451-1387-4CA6-816F-3879F97B5CBC}" type="slidenum">
-              <a:rPr lang="en-US"/>
-              <a:t>6</a:t>
             </a:fld>
             <a:endParaRPr lang="en-US"/>
           </a:p>
@@ -10135,7 +9685,7 @@
                 <a:ea typeface="Arial" pitchFamily="34" charset="-122"/>
                 <a:cs typeface="Arial" pitchFamily="34" charset="-120"/>
               </a:rPr>
-              <a:t>Investment thesis 2 (rates): the Fed's dot plot says higher for longer</a:t>
+              <a:t>Investment thesis 2: Traditional strategies fall short; autocallables fit 2026</a:t>
             </a:r>
             <a:endParaRPr lang="en-US" sz="2400" dirty="0"/>
           </a:p>
@@ -10329,40 +9879,16 @@
           </a:p>
         </p:txBody>
       </p:sp>
-      <p:pic>
-        <p:nvPicPr>
-          <p:cNvPr id="9" name="Image 0" descr="/home/user/natixis-case-comp/deck/fomc_dot_plot.png">    </p:cNvPr>
-          <p:cNvPicPr>
-            <a:picLocks noChangeAspect="1"/>
-          </p:cNvPicPr>
-          <p:nvPr/>
-        </p:nvPicPr>
-        <p:blipFill>
-          <a:blip r:embed="rId1"/>
-          <a:stretch>
-            <a:fillRect/>
-          </a:stretch>
-        </p:blipFill>
-        <p:spPr>
-          <a:xfrm>
-            <a:off x="457200" y="1051560"/>
-            <a:ext cx="6583680" cy="4133939"/>
-          </a:xfrm>
-          <a:prstGeom prst="rect">
-            <a:avLst/>
-          </a:prstGeom>
-        </p:spPr>
-      </p:pic>
-      <p:sp>
-        <p:nvSpPr>
-          <p:cNvPr id="10" name="Text 7"/>
+      <p:sp>
+        <p:nvSpPr>
+          <p:cNvPr id="9" name="Text 7"/>
           <p:cNvSpPr txBox="1"/>
           <p:nvPr/>
         </p:nvSpPr>
         <p:spPr>
           <a:xfrm>
-            <a:off x="457200" y="5230368"/>
-            <a:ext cx="6583680" cy="274320"/>
+            <a:off x="457200" y="960120"/>
+            <a:ext cx="11247120" cy="274320"/>
           </a:xfrm>
           <a:prstGeom prst="rect">
             <a:avLst/>
@@ -10378,602 +9904,30 @@
               <a:buNone/>
             </a:pPr>
             <a:r>
-              <a:rPr lang="en-US" sz="850" i="1" dirty="0">
-                <a:solidFill>
-                  <a:srgbClr val="595959"/>
+              <a:rPr lang="en-US" sz="1150" b="1" i="1" dirty="0">
+                <a:solidFill>
+                  <a:srgbClr val="262626"/>
                 </a:solidFill>
                 <a:latin typeface="Arial" pitchFamily="34" charset="0"/>
                 <a:ea typeface="Arial" pitchFamily="34" charset="-122"/>
                 <a:cs typeface="Arial" pitchFamily="34" charset="-120"/>
               </a:rPr>
-              <a:t>FOMC participants' view of the appropriate fed funds rate (midpoint of target range), Summary of Economic Projections, 16 Sep 2026</a:t>
-            </a:r>
-            <a:endParaRPr lang="en-US" sz="850" dirty="0"/>
+              <a:t>The Fed sees rates high until 2028, so long bonds carry rate risk; buy-and-hold equity faces volatility, concentration and stretched valuations</a:t>
+            </a:r>
+            <a:endParaRPr lang="en-US" sz="1150" dirty="0"/>
           </a:p>
         </p:txBody>
       </p:sp>
       <p:sp>
         <p:nvSpPr>
-          <p:cNvPr id="11" name="Shape 8"/>
+          <p:cNvPr id="10" name="Shape 8"/>
           <p:cNvSpPr/>
           <p:nvPr/>
         </p:nvSpPr>
         <p:spPr>
           <a:xfrm>
-            <a:off x="7269480" y="1051560"/>
-            <a:ext cx="4462272" cy="932688"/>
-          </a:xfrm>
-          <a:prstGeom prst="rect">
-            <a:avLst/>
-          </a:prstGeom>
-          <a:solidFill>
-            <a:srgbClr val="F2F2F2"/>
-          </a:solidFill>
-          <a:ln w="12700">
-            <a:solidFill>
-              <a:srgbClr val="F2F2F2"/>
-            </a:solidFill>
-            <a:prstDash val="solid"/>
-          </a:ln>
-        </p:spPr>
-      </p:sp>
-      <p:sp>
-        <p:nvSpPr>
-          <p:cNvPr id="12" name="Text 9"/>
-          <p:cNvSpPr txBox="1"/>
-          <p:nvPr/>
-        </p:nvSpPr>
-        <p:spPr>
-          <a:xfrm>
-            <a:off x="7315200" y="1051560"/>
-            <a:ext cx="1051560" cy="932688"/>
-          </a:xfrm>
-          <a:prstGeom prst="rect">
-            <a:avLst/>
-          </a:prstGeom>
-          <a:noFill/>
-          <a:ln/>
-        </p:spPr>
-        <p:txBody>
-          <a:bodyPr wrap="square" lIns="0" tIns="0" rIns="0" bIns="0" rtlCol="0" anchor="ctr"/>
-          <a:lstStyle/>
-          <a:p>
-            <a:pPr algn="ctr" indent="0" marL="0">
-              <a:buNone/>
-            </a:pPr>
-            <a:r>
-              <a:rPr lang="en-US" sz="1600" b="1" dirty="0">
-                <a:solidFill>
-                  <a:srgbClr val="2C5F82"/>
-                </a:solidFill>
-                <a:latin typeface="Arial" pitchFamily="34" charset="0"/>
-                <a:ea typeface="Arial" pitchFamily="34" charset="-122"/>
-                <a:cs typeface="Arial" pitchFamily="34" charset="-120"/>
-              </a:rPr>
-              <a:t>4.125%</a:t>
-            </a:r>
-            <a:endParaRPr lang="en-US" sz="1600" dirty="0"/>
-          </a:p>
-        </p:txBody>
-      </p:sp>
-      <p:sp>
-        <p:nvSpPr>
-          <p:cNvPr id="13" name="Text 10"/>
-          <p:cNvSpPr txBox="1"/>
-          <p:nvPr/>
-        </p:nvSpPr>
-        <p:spPr>
-          <a:xfrm>
-            <a:off x="8412480" y="1088136"/>
-            <a:ext cx="3227832" cy="859536"/>
-          </a:xfrm>
-          <a:prstGeom prst="rect">
-            <a:avLst/>
-          </a:prstGeom>
-          <a:noFill/>
-          <a:ln/>
-        </p:spPr>
-        <p:txBody>
-          <a:bodyPr wrap="square" lIns="0" tIns="0" rIns="0" bIns="0" rtlCol="0" anchor="ctr"/>
-          <a:lstStyle/>
-          <a:p>
-            <a:pPr indent="0" marL="0">
-              <a:spcAft>
-                <a:spcPts val="100"/>
-              </a:spcAft>
-              <a:buNone/>
-            </a:pPr>
-            <a:r>
-              <a:rPr lang="en-US" sz="880" b="1" dirty="0">
-                <a:solidFill>
-                  <a:srgbClr val="262626"/>
-                </a:solidFill>
-                <a:latin typeface="Arial" pitchFamily="34" charset="0"/>
-                <a:ea typeface="Arial" pitchFamily="34" charset="-122"/>
-                <a:cs typeface="Arial" pitchFamily="34" charset="-120"/>
-              </a:rPr>
-              <a:t>Rates stay high through 2027: </a:t>
-            </a:r>
-            <a:pPr indent="0" marL="0">
-              <a:spcAft>
-                <a:spcPts val="100"/>
-              </a:spcAft>
-              <a:buNone/>
-            </a:pPr>
-            <a:r>
-              <a:rPr lang="en-US" sz="880" dirty="0">
-                <a:solidFill>
-                  <a:srgbClr val="595959"/>
-                </a:solidFill>
-                <a:latin typeface="Arial" pitchFamily="34" charset="0"/>
-                <a:ea typeface="Arial" pitchFamily="34" charset="-122"/>
-                <a:cs typeface="Arial" pitchFamily="34" charset="-120"/>
-              </a:rPr>
-              <a:t>Median 4.125% at end-2026 and 4.125% at end-2027 (one more hike from 3.75–4.00%); cuts only from 2028.</a:t>
-            </a:r>
-            <a:endParaRPr lang="en-US" sz="880" dirty="0"/>
-          </a:p>
-          <a:p>
-            <a:pPr indent="0" marL="0">
-              <a:spcAft>
-                <a:spcPts val="100"/>
-              </a:spcAft>
-              <a:buNone/>
-            </a:pPr>
-            <a:r>
-              <a:rPr lang="en-US" sz="880" b="1" dirty="0">
-                <a:solidFill>
-                  <a:srgbClr val="2C5F82"/>
-                </a:solidFill>
-                <a:latin typeface="Arial" pitchFamily="34" charset="0"/>
-                <a:ea typeface="Arial" pitchFamily="34" charset="-122"/>
-                <a:cs typeface="Arial" pitchFamily="34" charset="-120"/>
-              </a:rPr>
-              <a:t>→ USD funding stays high for most of a 5-year note: the principal and a 70% floor are cheap to build</a:t>
-            </a:r>
-            <a:endParaRPr lang="en-US" sz="880" dirty="0"/>
-          </a:p>
-        </p:txBody>
-      </p:sp>
-      <p:sp>
-        <p:nvSpPr>
-          <p:cNvPr id="14" name="Shape 11"/>
-          <p:cNvSpPr/>
-          <p:nvPr/>
-        </p:nvSpPr>
-        <p:spPr>
-          <a:xfrm>
-            <a:off x="7269480" y="2075688"/>
-            <a:ext cx="4462272" cy="932688"/>
-          </a:xfrm>
-          <a:prstGeom prst="rect">
-            <a:avLst/>
-          </a:prstGeom>
-          <a:solidFill>
-            <a:srgbClr val="FFFFFF"/>
-          </a:solidFill>
-          <a:ln w="12700">
-            <a:solidFill>
-              <a:srgbClr val="F2F2F2"/>
-            </a:solidFill>
-            <a:prstDash val="solid"/>
-          </a:ln>
-        </p:spPr>
-      </p:sp>
-      <p:sp>
-        <p:nvSpPr>
-          <p:cNvPr id="15" name="Text 12"/>
-          <p:cNvSpPr txBox="1"/>
-          <p:nvPr/>
-        </p:nvSpPr>
-        <p:spPr>
-          <a:xfrm>
-            <a:off x="7315200" y="2075688"/>
-            <a:ext cx="1051560" cy="932688"/>
-          </a:xfrm>
-          <a:prstGeom prst="rect">
-            <a:avLst/>
-          </a:prstGeom>
-          <a:noFill/>
-          <a:ln/>
-        </p:spPr>
-        <p:txBody>
-          <a:bodyPr wrap="square" lIns="0" tIns="0" rIns="0" bIns="0" rtlCol="0" anchor="ctr"/>
-          <a:lstStyle/>
-          <a:p>
-            <a:pPr algn="ctr" indent="0" marL="0">
-              <a:buNone/>
-            </a:pPr>
-            <a:r>
-              <a:rPr lang="en-US" sz="1600" b="1" dirty="0">
-                <a:solidFill>
-                  <a:srgbClr val="2C5F82"/>
-                </a:solidFill>
-                <a:latin typeface="Arial" pitchFamily="34" charset="0"/>
-                <a:ea typeface="Arial" pitchFamily="34" charset="-122"/>
-                <a:cs typeface="Arial" pitchFamily="34" charset="-120"/>
-              </a:rPr>
-              <a:t>12 dots</a:t>
-            </a:r>
-            <a:endParaRPr lang="en-US" sz="1600" dirty="0"/>
-          </a:p>
-        </p:txBody>
-      </p:sp>
-      <p:sp>
-        <p:nvSpPr>
-          <p:cNvPr id="16" name="Text 13"/>
-          <p:cNvSpPr txBox="1"/>
-          <p:nvPr/>
-        </p:nvSpPr>
-        <p:spPr>
-          <a:xfrm>
-            <a:off x="8412480" y="2112264"/>
-            <a:ext cx="3227832" cy="859536"/>
-          </a:xfrm>
-          <a:prstGeom prst="rect">
-            <a:avLst/>
-          </a:prstGeom>
-          <a:noFill/>
-          <a:ln/>
-        </p:spPr>
-        <p:txBody>
-          <a:bodyPr wrap="square" lIns="0" tIns="0" rIns="0" bIns="0" rtlCol="0" anchor="ctr"/>
-          <a:lstStyle/>
-          <a:p>
-            <a:pPr indent="0" marL="0">
-              <a:spcAft>
-                <a:spcPts val="100"/>
-              </a:spcAft>
-              <a:buNone/>
-            </a:pPr>
-            <a:r>
-              <a:rPr lang="en-US" sz="880" b="1" dirty="0">
-                <a:solidFill>
-                  <a:srgbClr val="262626"/>
-                </a:solidFill>
-                <a:latin typeface="Arial" pitchFamily="34" charset="0"/>
-                <a:ea typeface="Arial" pitchFamily="34" charset="-122"/>
-                <a:cs typeface="Arial" pitchFamily="34" charset="-120"/>
-              </a:rPr>
-              <a:t>Risk of more hikes: </a:t>
-            </a:r>
-            <a:pPr indent="0" marL="0">
-              <a:spcAft>
-                <a:spcPts val="100"/>
-              </a:spcAft>
-              <a:buNone/>
-            </a:pPr>
-            <a:r>
-              <a:rPr lang="en-US" sz="880" dirty="0">
-                <a:solidFill>
-                  <a:srgbClr val="595959"/>
-                </a:solidFill>
-                <a:latin typeface="Arial" pitchFamily="34" charset="0"/>
-                <a:ea typeface="Arial" pitchFamily="34" charset="-122"/>
-                <a:cs typeface="Arial" pitchFamily="34" charset="-120"/>
-              </a:rPr>
-              <a:t>4 participants see 4.375% this year and 8 in 2027, above the median.</a:t>
-            </a:r>
-            <a:endParaRPr lang="en-US" sz="880" dirty="0"/>
-          </a:p>
-          <a:p>
-            <a:pPr indent="0" marL="0">
-              <a:spcAft>
-                <a:spcPts val="100"/>
-              </a:spcAft>
-              <a:buNone/>
-            </a:pPr>
-            <a:r>
-              <a:rPr lang="en-US" sz="880" b="1" dirty="0">
-                <a:solidFill>
-                  <a:srgbClr val="2C5F82"/>
-                </a:solidFill>
-                <a:latin typeface="Arial" pitchFamily="34" charset="0"/>
-                <a:ea typeface="Arial" pitchFamily="34" charset="-122"/>
-                <a:cs typeface="Arial" pitchFamily="34" charset="-120"/>
-              </a:rPr>
-              <a:t>→ A 5-year bond loses if rates rise further; an autocall can redeem from year 1 (expected life ~2 years)</a:t>
-            </a:r>
-            <a:endParaRPr lang="en-US" sz="880" dirty="0"/>
-          </a:p>
-        </p:txBody>
-      </p:sp>
-      <p:sp>
-        <p:nvSpPr>
-          <p:cNvPr id="17" name="Shape 14"/>
-          <p:cNvSpPr/>
-          <p:nvPr/>
-        </p:nvSpPr>
-        <p:spPr>
-          <a:xfrm>
-            <a:off x="7269480" y="3099816"/>
-            <a:ext cx="4462272" cy="932688"/>
-          </a:xfrm>
-          <a:prstGeom prst="rect">
-            <a:avLst/>
-          </a:prstGeom>
-          <a:solidFill>
-            <a:srgbClr val="F2F2F2"/>
-          </a:solidFill>
-          <a:ln w="12700">
-            <a:solidFill>
-              <a:srgbClr val="F2F2F2"/>
-            </a:solidFill>
-            <a:prstDash val="solid"/>
-          </a:ln>
-        </p:spPr>
-      </p:sp>
-      <p:sp>
-        <p:nvSpPr>
-          <p:cNvPr id="18" name="Text 15"/>
-          <p:cNvSpPr txBox="1"/>
-          <p:nvPr/>
-        </p:nvSpPr>
-        <p:spPr>
-          <a:xfrm>
-            <a:off x="7315200" y="3099816"/>
-            <a:ext cx="1051560" cy="932688"/>
-          </a:xfrm>
-          <a:prstGeom prst="rect">
-            <a:avLst/>
-          </a:prstGeom>
-          <a:noFill/>
-          <a:ln/>
-        </p:spPr>
-        <p:txBody>
-          <a:bodyPr wrap="square" lIns="0" tIns="0" rIns="0" bIns="0" rtlCol="0" anchor="ctr"/>
-          <a:lstStyle/>
-          <a:p>
-            <a:pPr algn="ctr" indent="0" marL="0">
-              <a:buNone/>
-            </a:pPr>
-            <a:r>
-              <a:rPr lang="en-US" sz="1600" b="1" dirty="0">
-                <a:solidFill>
-                  <a:srgbClr val="2C5F82"/>
-                </a:solidFill>
-                <a:latin typeface="Arial" pitchFamily="34" charset="0"/>
-                <a:ea typeface="Arial" pitchFamily="34" charset="-122"/>
-                <a:cs typeface="Arial" pitchFamily="34" charset="-120"/>
-              </a:rPr>
-              <a:t>125bp</a:t>
-            </a:r>
-            <a:endParaRPr lang="en-US" sz="1600" dirty="0"/>
-          </a:p>
-        </p:txBody>
-      </p:sp>
-      <p:sp>
-        <p:nvSpPr>
-          <p:cNvPr id="19" name="Text 16"/>
-          <p:cNvSpPr txBox="1"/>
-          <p:nvPr/>
-        </p:nvSpPr>
-        <p:spPr>
-          <a:xfrm>
-            <a:off x="8412480" y="3136392"/>
-            <a:ext cx="3227832" cy="859536"/>
-          </a:xfrm>
-          <a:prstGeom prst="rect">
-            <a:avLst/>
-          </a:prstGeom>
-          <a:noFill/>
-          <a:ln/>
-        </p:spPr>
-        <p:txBody>
-          <a:bodyPr wrap="square" lIns="0" tIns="0" rIns="0" bIns="0" rtlCol="0" anchor="ctr"/>
-          <a:lstStyle/>
-          <a:p>
-            <a:pPr indent="0" marL="0">
-              <a:spcAft>
-                <a:spcPts val="100"/>
-              </a:spcAft>
-              <a:buNone/>
-            </a:pPr>
-            <a:r>
-              <a:rPr lang="en-US" sz="880" b="1" dirty="0">
-                <a:solidFill>
-                  <a:srgbClr val="262626"/>
-                </a:solidFill>
-                <a:latin typeface="Arial" pitchFamily="34" charset="0"/>
-                <a:ea typeface="Arial" pitchFamily="34" charset="-122"/>
-                <a:cs typeface="Arial" pitchFamily="34" charset="-120"/>
-              </a:rPr>
-              <a:t>Wide disagreement: </a:t>
-            </a:r>
-            <a:pPr indent="0" marL="0">
-              <a:spcAft>
-                <a:spcPts val="100"/>
-              </a:spcAft>
-              <a:buNone/>
-            </a:pPr>
-            <a:r>
-              <a:rPr lang="en-US" sz="880" dirty="0">
-                <a:solidFill>
-                  <a:srgbClr val="595959"/>
-                </a:solidFill>
-                <a:latin typeface="Arial" pitchFamily="34" charset="0"/>
-                <a:ea typeface="Arial" pitchFamily="34" charset="-122"/>
-                <a:cs typeface="Arial" pitchFamily="34" charset="-120"/>
-              </a:rPr>
-              <a:t>2027 dots span 3.125%–4.375%; longer run 2.875%–3.875%. The rate path is uncertain.</a:t>
-            </a:r>
-            <a:endParaRPr lang="en-US" sz="880" dirty="0"/>
-          </a:p>
-          <a:p>
-            <a:pPr indent="0" marL="0">
-              <a:spcAft>
-                <a:spcPts val="100"/>
-              </a:spcAft>
-              <a:buNone/>
-            </a:pPr>
-            <a:r>
-              <a:rPr lang="en-US" sz="880" b="1" dirty="0">
-                <a:solidFill>
-                  <a:srgbClr val="2C5F82"/>
-                </a:solidFill>
-                <a:latin typeface="Arial" pitchFamily="34" charset="0"/>
-                <a:ea typeface="Arial" pitchFamily="34" charset="-122"/>
-                <a:cs typeface="Arial" pitchFamily="34" charset="-120"/>
-              </a:rPr>
-              <a:t>→ Rate uncertainty keeps volatility high, and richer option premium funds the coupon</a:t>
-            </a:r>
-            <a:endParaRPr lang="en-US" sz="880" dirty="0"/>
-          </a:p>
-        </p:txBody>
-      </p:sp>
-      <p:sp>
-        <p:nvSpPr>
-          <p:cNvPr id="20" name="Shape 17"/>
-          <p:cNvSpPr/>
-          <p:nvPr/>
-        </p:nvSpPr>
-        <p:spPr>
-          <a:xfrm>
-            <a:off x="7269480" y="4123944"/>
-            <a:ext cx="4462272" cy="932688"/>
-          </a:xfrm>
-          <a:prstGeom prst="rect">
-            <a:avLst/>
-          </a:prstGeom>
-          <a:solidFill>
-            <a:srgbClr val="FFFFFF"/>
-          </a:solidFill>
-          <a:ln w="12700">
-            <a:solidFill>
-              <a:srgbClr val="F2F2F2"/>
-            </a:solidFill>
-            <a:prstDash val="solid"/>
-          </a:ln>
-        </p:spPr>
-      </p:sp>
-      <p:sp>
-        <p:nvSpPr>
-          <p:cNvPr id="21" name="Text 18"/>
-          <p:cNvSpPr txBox="1"/>
-          <p:nvPr/>
-        </p:nvSpPr>
-        <p:spPr>
-          <a:xfrm>
-            <a:off x="7315200" y="4123944"/>
-            <a:ext cx="1051560" cy="932688"/>
-          </a:xfrm>
-          <a:prstGeom prst="rect">
-            <a:avLst/>
-          </a:prstGeom>
-          <a:noFill/>
-          <a:ln/>
-        </p:spPr>
-        <p:txBody>
-          <a:bodyPr wrap="square" lIns="0" tIns="0" rIns="0" bIns="0" rtlCol="0" anchor="ctr"/>
-          <a:lstStyle/>
-          <a:p>
-            <a:pPr algn="ctr" indent="0" marL="0">
-              <a:buNone/>
-            </a:pPr>
-            <a:r>
-              <a:rPr lang="en-US" sz="1600" b="1" dirty="0">
-                <a:solidFill>
-                  <a:srgbClr val="2C5F82"/>
-                </a:solidFill>
-                <a:latin typeface="Arial" pitchFamily="34" charset="0"/>
-                <a:ea typeface="Arial" pitchFamily="34" charset="-122"/>
-                <a:cs typeface="Arial" pitchFamily="34" charset="-120"/>
-              </a:rPr>
-              <a:t>3.25%</a:t>
-            </a:r>
-            <a:endParaRPr lang="en-US" sz="1600" dirty="0"/>
-          </a:p>
-        </p:txBody>
-      </p:sp>
-      <p:sp>
-        <p:nvSpPr>
-          <p:cNvPr id="22" name="Text 19"/>
-          <p:cNvSpPr txBox="1"/>
-          <p:nvPr/>
-        </p:nvSpPr>
-        <p:spPr>
-          <a:xfrm>
-            <a:off x="8412480" y="4160520"/>
-            <a:ext cx="3227832" cy="859536"/>
-          </a:xfrm>
-          <a:prstGeom prst="rect">
-            <a:avLst/>
-          </a:prstGeom>
-          <a:noFill/>
-          <a:ln/>
-        </p:spPr>
-        <p:txBody>
-          <a:bodyPr wrap="square" lIns="0" tIns="0" rIns="0" bIns="0" rtlCol="0" anchor="ctr"/>
-          <a:lstStyle/>
-          <a:p>
-            <a:pPr indent="0" marL="0">
-              <a:spcAft>
-                <a:spcPts val="100"/>
-              </a:spcAft>
-              <a:buNone/>
-            </a:pPr>
-            <a:r>
-              <a:rPr lang="en-US" sz="880" b="1" dirty="0">
-                <a:solidFill>
-                  <a:srgbClr val="262626"/>
-                </a:solidFill>
-                <a:latin typeface="Arial" pitchFamily="34" charset="0"/>
-                <a:ea typeface="Arial" pitchFamily="34" charset="-122"/>
-                <a:cs typeface="Arial" pitchFamily="34" charset="-120"/>
-              </a:rPr>
-              <a:t>Slow easing later: </a:t>
-            </a:r>
-            <a:pPr indent="0" marL="0">
-              <a:spcAft>
-                <a:spcPts val="100"/>
-              </a:spcAft>
-              <a:buNone/>
-            </a:pPr>
-            <a:r>
-              <a:rPr lang="en-US" sz="880" dirty="0">
-                <a:solidFill>
-                  <a:srgbClr val="595959"/>
-                </a:solidFill>
-                <a:latin typeface="Arial" pitchFamily="34" charset="0"/>
-                <a:ea typeface="Arial" pitchFamily="34" charset="-122"/>
-                <a:cs typeface="Arial" pitchFamily="34" charset="-120"/>
-              </a:rPr>
-              <a:t>Median falls to 3.875% in 2028 and 3.625% in 2029, towards 3.25% in the long run.</a:t>
-            </a:r>
-            <a:endParaRPr lang="en-US" sz="880" dirty="0"/>
-          </a:p>
-          <a:p>
-            <a:pPr indent="0" marL="0">
-              <a:spcAft>
-                <a:spcPts val="100"/>
-              </a:spcAft>
-              <a:buNone/>
-            </a:pPr>
-            <a:r>
-              <a:rPr lang="en-US" sz="880" b="1" dirty="0">
-                <a:solidFill>
-                  <a:srgbClr val="2C5F82"/>
-                </a:solidFill>
-                <a:latin typeface="Arial" pitchFamily="34" charset="0"/>
-                <a:ea typeface="Arial" pitchFamily="34" charset="-122"/>
-                <a:cs typeface="Arial" pitchFamily="34" charset="-120"/>
-              </a:rPr>
-              <a:t>→ Lower USD rates late in the note's life support Asian equities, helping the basket back to 100% (autocall)</a:t>
-            </a:r>
-            <a:endParaRPr lang="en-US" sz="880" dirty="0"/>
-          </a:p>
-        </p:txBody>
-      </p:sp>
-      <p:sp>
-        <p:nvSpPr>
-          <p:cNvPr id="23" name="Shape 20"/>
-          <p:cNvSpPr/>
-          <p:nvPr/>
-        </p:nvSpPr>
-        <p:spPr>
-          <a:xfrm>
-            <a:off x="457200" y="5559552"/>
-            <a:ext cx="11274552" cy="438912"/>
+            <a:off x="457200" y="1325880"/>
+            <a:ext cx="3730752" cy="292608"/>
           </a:xfrm>
           <a:prstGeom prst="rect">
             <a:avLst/>
@@ -10991,14 +9945,14 @@
       </p:sp>
       <p:sp>
         <p:nvSpPr>
-          <p:cNvPr id="24" name="Text 21"/>
+          <p:cNvPr id="11" name="Text 9"/>
           <p:cNvSpPr txBox="1"/>
           <p:nvPr/>
         </p:nvSpPr>
         <p:spPr>
           <a:xfrm>
-            <a:off x="594360" y="5559552"/>
-            <a:ext cx="11000232" cy="438912"/>
+            <a:off x="457200" y="1325880"/>
+            <a:ext cx="3730752" cy="292608"/>
           </a:xfrm>
           <a:prstGeom prst="rect">
             <a:avLst/>
@@ -11014,7 +9968,7 @@
               <a:buNone/>
             </a:pPr>
             <a:r>
-              <a:rPr lang="en-US" sz="1200" b="1" dirty="0">
+              <a:rPr lang="en-US" sz="1050" b="1" dirty="0">
                 <a:solidFill>
                   <a:srgbClr val="FFFFFF"/>
                 </a:solidFill>
@@ -11022,22 +9976,46 @@
                 <a:ea typeface="Arial" pitchFamily="34" charset="-122"/>
                 <a:cs typeface="Arial" pitchFamily="34" charset="-120"/>
               </a:rPr>
-              <a:t>Higher-for-longer USD rates make a capital floor cheap and long bonds risky: the setting suits a short-dated, buffered autocall.</a:t>
-            </a:r>
-            <a:endParaRPr lang="en-US" sz="1200" dirty="0"/>
+              <a:t>The Fed: rates stay high until 2028</a:t>
+            </a:r>
+            <a:endParaRPr lang="en-US" sz="1050" dirty="0"/>
           </a:p>
         </p:txBody>
       </p:sp>
-      <p:sp>
-        <p:nvSpPr>
-          <p:cNvPr id="25" name="Text 22"/>
+      <p:pic>
+        <p:nvPicPr>
+          <p:cNvPr id="12" name="Image 0" descr="/home/user/natixis-case-comp/deck/fomc_dot_plot_compact.png">    </p:cNvPr>
+          <p:cNvPicPr>
+            <a:picLocks noChangeAspect="1"/>
+          </p:cNvPicPr>
+          <p:nvPr/>
+        </p:nvPicPr>
+        <p:blipFill>
+          <a:blip r:embed="rId1"/>
+          <a:stretch>
+            <a:fillRect/>
+          </a:stretch>
+        </p:blipFill>
+        <p:spPr>
+          <a:xfrm>
+            <a:off x="539496" y="1655064"/>
+            <a:ext cx="3566160" cy="1261203"/>
+          </a:xfrm>
+          <a:prstGeom prst="rect">
+            <a:avLst/>
+          </a:prstGeom>
+        </p:spPr>
+      </p:pic>
+      <p:sp>
+        <p:nvSpPr>
+          <p:cNvPr id="13" name="Text 10"/>
           <p:cNvSpPr txBox="1"/>
           <p:nvPr/>
         </p:nvSpPr>
         <p:spPr>
           <a:xfrm>
-            <a:off x="457200" y="6053328"/>
-            <a:ext cx="11274552" cy="274320"/>
+            <a:off x="457200" y="2953512"/>
+            <a:ext cx="3730752" cy="365760"/>
           </a:xfrm>
           <a:prstGeom prst="rect">
             <a:avLst/>
@@ -11053,7 +10031,7 @@
               <a:buNone/>
             </a:pPr>
             <a:r>
-              <a:rPr lang="en-US" sz="800" i="1" dirty="0">
+              <a:rPr lang="en-US" sz="850" dirty="0">
                 <a:solidFill>
                   <a:srgbClr val="595959"/>
                 </a:solidFill>
@@ -11061,7 +10039,1153 @@
                 <a:ea typeface="Arial" pitchFamily="34" charset="-122"/>
                 <a:cs typeface="Arial" pitchFamily="34" charset="-120"/>
               </a:rPr>
-              <a:t>Source: Federal Reserve, Summary of Economic Projections, Figure 2 (16 Sep 2026). Dot counts read from the chart (18 participants for 2026–27 and the longer run, 17 for 2028–29): verify against the SEP table.</a:t>
+              <a:t>FOMC dot plot, 16 Sep 2026 (one dot per participant; shaded = today's 3.75–4.00%). 12 dots at 4.375% for 2026–27; long run 3.25%.</a:t>
+            </a:r>
+            <a:endParaRPr lang="en-US" sz="850" dirty="0"/>
+          </a:p>
+        </p:txBody>
+      </p:sp>
+      <p:sp>
+        <p:nvSpPr>
+          <p:cNvPr id="14" name="Shape 11"/>
+          <p:cNvSpPr/>
+          <p:nvPr/>
+        </p:nvSpPr>
+        <p:spPr>
+          <a:xfrm>
+            <a:off x="4370832" y="1325880"/>
+            <a:ext cx="3730752" cy="292608"/>
+          </a:xfrm>
+          <a:prstGeom prst="rect">
+            <a:avLst/>
+          </a:prstGeom>
+          <a:solidFill>
+            <a:srgbClr val="2C5F82"/>
+          </a:solidFill>
+          <a:ln w="12700">
+            <a:solidFill>
+              <a:srgbClr val="2C5F82"/>
+            </a:solidFill>
+            <a:prstDash val="solid"/>
+          </a:ln>
+        </p:spPr>
+      </p:sp>
+      <p:sp>
+        <p:nvSpPr>
+          <p:cNvPr id="15" name="Text 12"/>
+          <p:cNvSpPr txBox="1"/>
+          <p:nvPr/>
+        </p:nvSpPr>
+        <p:spPr>
+          <a:xfrm>
+            <a:off x="4370832" y="1325880"/>
+            <a:ext cx="3730752" cy="292608"/>
+          </a:xfrm>
+          <a:prstGeom prst="rect">
+            <a:avLst/>
+          </a:prstGeom>
+          <a:noFill/>
+          <a:ln/>
+        </p:spPr>
+        <p:txBody>
+          <a:bodyPr wrap="square" lIns="0" tIns="0" rIns="0" bIns="0" rtlCol="0" anchor="ctr"/>
+          <a:lstStyle/>
+          <a:p>
+            <a:pPr algn="ctr" indent="0" marL="0">
+              <a:buNone/>
+            </a:pPr>
+            <a:r>
+              <a:rPr lang="en-US" sz="1050" b="1" dirty="0">
+                <a:solidFill>
+                  <a:srgbClr val="FFFFFF"/>
+                </a:solidFill>
+                <a:latin typeface="Arial" pitchFamily="34" charset="0"/>
+                <a:ea typeface="Arial" pitchFamily="34" charset="-122"/>
+                <a:cs typeface="Arial" pitchFamily="34" charset="-120"/>
+              </a:rPr>
+              <a:t>Equity paths are violent</a:t>
+            </a:r>
+            <a:endParaRPr lang="en-US" sz="1050" dirty="0"/>
+          </a:p>
+        </p:txBody>
+      </p:sp>
+      <p:graphicFrame>
+        <p:nvGraphicFramePr>
+          <p:cNvPr id="16" name="Chart 0" descr=""/>
+          <p:cNvGraphicFramePr/>
+          <p:nvPr/>
+        </p:nvGraphicFramePr>
+        <p:xfrm>
+          <a:off x="4370832" y="1655064"/>
+          <a:ext cx="3730752" cy="1261872"/>
+        </p:xfrm>
+        <a:graphic xmlns:a="http://schemas.openxmlformats.org/drawingml/2006/main">
+          <a:graphicData uri="http://schemas.openxmlformats.org/drawingml/2006/chart">
+            <c:chart xmlns:c="http://schemas.openxmlformats.org/drawingml/2006/chart" r:id="rId2"/>
+          </a:graphicData>
+        </a:graphic>
+      </p:graphicFrame>
+      <p:sp>
+        <p:nvSpPr>
+          <p:cNvPr id="17" name="Text 13"/>
+          <p:cNvSpPr txBox="1"/>
+          <p:nvPr/>
+        </p:nvSpPr>
+        <p:spPr>
+          <a:xfrm>
+            <a:off x="4370832" y="2953512"/>
+            <a:ext cx="3730752" cy="365760"/>
+          </a:xfrm>
+          <a:prstGeom prst="rect">
+            <a:avLst/>
+          </a:prstGeom>
+          <a:noFill/>
+          <a:ln/>
+        </p:spPr>
+        <p:txBody>
+          <a:bodyPr wrap="square" lIns="0" tIns="0" rIns="0" bIns="0" rtlCol="0" anchor="t"/>
+          <a:lstStyle/>
+          <a:p>
+            <a:pPr indent="0" marL="0">
+              <a:buNone/>
+            </a:pPr>
+            <a:r>
+              <a:rPr lang="en-US" sz="850" dirty="0">
+                <a:solidFill>
+                  <a:srgbClr val="595959"/>
+                </a:solidFill>
+                <a:latin typeface="Arial" pitchFamily="34" charset="0"/>
+                <a:ea typeface="Arial" pitchFamily="34" charset="-122"/>
+                <a:cs typeface="Arial" pitchFamily="34" charset="-120"/>
+              </a:rPr>
+              <a:t>Index levels, end-2021 = 100: −10–25% in 2022, then 2–3×. KOSPI fell ~25% from June to late August 2026.</a:t>
+            </a:r>
+            <a:endParaRPr lang="en-US" sz="850" dirty="0"/>
+          </a:p>
+        </p:txBody>
+      </p:sp>
+      <p:sp>
+        <p:nvSpPr>
+          <p:cNvPr id="18" name="Shape 14"/>
+          <p:cNvSpPr/>
+          <p:nvPr/>
+        </p:nvSpPr>
+        <p:spPr>
+          <a:xfrm>
+            <a:off x="457200" y="3383280"/>
+            <a:ext cx="3730752" cy="292608"/>
+          </a:xfrm>
+          <a:prstGeom prst="rect">
+            <a:avLst/>
+          </a:prstGeom>
+          <a:solidFill>
+            <a:srgbClr val="2C5F82"/>
+          </a:solidFill>
+          <a:ln w="12700">
+            <a:solidFill>
+              <a:srgbClr val="2C5F82"/>
+            </a:solidFill>
+            <a:prstDash val="solid"/>
+          </a:ln>
+        </p:spPr>
+      </p:sp>
+      <p:sp>
+        <p:nvSpPr>
+          <p:cNvPr id="19" name="Text 15"/>
+          <p:cNvSpPr txBox="1"/>
+          <p:nvPr/>
+        </p:nvSpPr>
+        <p:spPr>
+          <a:xfrm>
+            <a:off x="457200" y="3383280"/>
+            <a:ext cx="3730752" cy="292608"/>
+          </a:xfrm>
+          <a:prstGeom prst="rect">
+            <a:avLst/>
+          </a:prstGeom>
+          <a:noFill/>
+          <a:ln/>
+        </p:spPr>
+        <p:txBody>
+          <a:bodyPr wrap="square" lIns="0" tIns="0" rIns="0" bIns="0" rtlCol="0" anchor="ctr"/>
+          <a:lstStyle/>
+          <a:p>
+            <a:pPr algn="ctr" indent="0" marL="0">
+              <a:buNone/>
+            </a:pPr>
+            <a:r>
+              <a:rPr lang="en-US" sz="1050" b="1" dirty="0">
+                <a:solidFill>
+                  <a:srgbClr val="FFFFFF"/>
+                </a:solidFill>
+                <a:latin typeface="Arial" pitchFamily="34" charset="0"/>
+                <a:ea typeface="Arial" pitchFamily="34" charset="-122"/>
+                <a:cs typeface="Arial" pitchFamily="34" charset="-120"/>
+              </a:rPr>
+              <a:t>Long bonds carry rate risk</a:t>
+            </a:r>
+            <a:endParaRPr lang="en-US" sz="1050" dirty="0"/>
+          </a:p>
+        </p:txBody>
+      </p:sp>
+      <p:graphicFrame>
+        <p:nvGraphicFramePr>
+          <p:cNvPr id="20" name="Chart 1" descr=""/>
+          <p:cNvGraphicFramePr/>
+          <p:nvPr/>
+        </p:nvGraphicFramePr>
+        <p:xfrm>
+          <a:off x="457200" y="3712464"/>
+          <a:ext cx="3730752" cy="1261872"/>
+        </p:xfrm>
+        <a:graphic xmlns:a="http://schemas.openxmlformats.org/drawingml/2006/main">
+          <a:graphicData uri="http://schemas.openxmlformats.org/drawingml/2006/chart">
+            <c:chart xmlns:c="http://schemas.openxmlformats.org/drawingml/2006/chart" r:id="rId3"/>
+          </a:graphicData>
+        </a:graphic>
+      </p:graphicFrame>
+      <p:sp>
+        <p:nvSpPr>
+          <p:cNvPr id="21" name="Text 16"/>
+          <p:cNvSpPr txBox="1"/>
+          <p:nvPr/>
+        </p:nvSpPr>
+        <p:spPr>
+          <a:xfrm>
+            <a:off x="457200" y="5010912"/>
+            <a:ext cx="3730752" cy="365760"/>
+          </a:xfrm>
+          <a:prstGeom prst="rect">
+            <a:avLst/>
+          </a:prstGeom>
+          <a:noFill/>
+          <a:ln/>
+        </p:spPr>
+        <p:txBody>
+          <a:bodyPr wrap="square" lIns="0" tIns="0" rIns="0" bIns="0" rtlCol="0" anchor="t"/>
+          <a:lstStyle/>
+          <a:p>
+            <a:pPr indent="0" marL="0">
+              <a:buNone/>
+            </a:pPr>
+            <a:r>
+              <a:rPr lang="en-US" sz="850" dirty="0">
+                <a:solidFill>
+                  <a:srgbClr val="595959"/>
+                </a:solidFill>
+                <a:latin typeface="Arial" pitchFamily="34" charset="0"/>
+                <a:ea typeface="Arial" pitchFamily="34" charset="-122"/>
+                <a:cs typeface="Arial" pitchFamily="34" charset="-120"/>
+              </a:rPr>
+              <a:t>Value change of a 5-year USD bond (5.69% coupon) for parallel rate moves of −2% to +2%.</a:t>
+            </a:r>
+            <a:endParaRPr lang="en-US" sz="850" dirty="0"/>
+          </a:p>
+        </p:txBody>
+      </p:sp>
+      <p:sp>
+        <p:nvSpPr>
+          <p:cNvPr id="22" name="Shape 17"/>
+          <p:cNvSpPr/>
+          <p:nvPr/>
+        </p:nvSpPr>
+        <p:spPr>
+          <a:xfrm>
+            <a:off x="4370832" y="3383280"/>
+            <a:ext cx="3730752" cy="292608"/>
+          </a:xfrm>
+          <a:prstGeom prst="rect">
+            <a:avLst/>
+          </a:prstGeom>
+          <a:solidFill>
+            <a:srgbClr val="2C5F82"/>
+          </a:solidFill>
+          <a:ln w="12700">
+            <a:solidFill>
+              <a:srgbClr val="2C5F82"/>
+            </a:solidFill>
+            <a:prstDash val="solid"/>
+          </a:ln>
+        </p:spPr>
+      </p:sp>
+      <p:sp>
+        <p:nvSpPr>
+          <p:cNvPr id="23" name="Text 18"/>
+          <p:cNvSpPr txBox="1"/>
+          <p:nvPr/>
+        </p:nvSpPr>
+        <p:spPr>
+          <a:xfrm>
+            <a:off x="4370832" y="3383280"/>
+            <a:ext cx="3730752" cy="292608"/>
+          </a:xfrm>
+          <a:prstGeom prst="rect">
+            <a:avLst/>
+          </a:prstGeom>
+          <a:noFill/>
+          <a:ln/>
+        </p:spPr>
+        <p:txBody>
+          <a:bodyPr wrap="square" lIns="0" tIns="0" rIns="0" bIns="0" rtlCol="0" anchor="ctr"/>
+          <a:lstStyle/>
+          <a:p>
+            <a:pPr algn="ctr" indent="0" marL="0">
+              <a:buNone/>
+            </a:pPr>
+            <a:r>
+              <a:rPr lang="en-US" sz="1050" b="1" dirty="0">
+                <a:solidFill>
+                  <a:srgbClr val="FFFFFF"/>
+                </a:solidFill>
+                <a:latin typeface="Arial" pitchFamily="34" charset="0"/>
+                <a:ea typeface="Arial" pitchFamily="34" charset="-122"/>
+                <a:cs typeface="Arial" pitchFamily="34" charset="-120"/>
+              </a:rPr>
+              <a:t>Valuations already price in a lot</a:t>
+            </a:r>
+            <a:endParaRPr lang="en-US" sz="1050" dirty="0"/>
+          </a:p>
+        </p:txBody>
+      </p:sp>
+      <p:graphicFrame>
+        <p:nvGraphicFramePr>
+          <p:cNvPr id="24" name="Chart 2" descr=""/>
+          <p:cNvGraphicFramePr/>
+          <p:nvPr/>
+        </p:nvGraphicFramePr>
+        <p:xfrm>
+          <a:off x="4370832" y="3712464"/>
+          <a:ext cx="3730752" cy="1261872"/>
+        </p:xfrm>
+        <a:graphic xmlns:a="http://schemas.openxmlformats.org/drawingml/2006/main">
+          <a:graphicData uri="http://schemas.openxmlformats.org/drawingml/2006/chart">
+            <c:chart xmlns:c="http://schemas.openxmlformats.org/drawingml/2006/chart" r:id="rId4"/>
+          </a:graphicData>
+        </a:graphic>
+      </p:graphicFrame>
+      <p:sp>
+        <p:nvSpPr>
+          <p:cNvPr id="25" name="Text 19"/>
+          <p:cNvSpPr txBox="1"/>
+          <p:nvPr/>
+        </p:nvSpPr>
+        <p:spPr>
+          <a:xfrm>
+            <a:off x="4370832" y="5010912"/>
+            <a:ext cx="3730752" cy="365760"/>
+          </a:xfrm>
+          <a:prstGeom prst="rect">
+            <a:avLst/>
+          </a:prstGeom>
+          <a:noFill/>
+          <a:ln/>
+        </p:spPr>
+        <p:txBody>
+          <a:bodyPr wrap="square" lIns="0" tIns="0" rIns="0" bIns="0" rtlCol="0" anchor="t"/>
+          <a:lstStyle/>
+          <a:p>
+            <a:pPr indent="0" marL="0">
+              <a:buNone/>
+            </a:pPr>
+            <a:r>
+              <a:rPr lang="en-US" sz="850" dirty="0">
+                <a:solidFill>
+                  <a:srgbClr val="595959"/>
+                </a:solidFill>
+                <a:latin typeface="Arial" pitchFamily="34" charset="0"/>
+                <a:ea typeface="Arial" pitchFamily="34" charset="-122"/>
+                <a:cs typeface="Arial" pitchFamily="34" charset="-120"/>
+              </a:rPr>
+              <a:t>Siblis Research, 1 Jul 2026. Korea's gap assumes earnings roughly triple; Nikkei CAPE 38.6×; Taiwan among the most expensive markets.</a:t>
+            </a:r>
+            <a:endParaRPr lang="en-US" sz="850" dirty="0"/>
+          </a:p>
+        </p:txBody>
+      </p:sp>
+      <p:sp>
+        <p:nvSpPr>
+          <p:cNvPr id="26" name="Text 20"/>
+          <p:cNvSpPr txBox="1"/>
+          <p:nvPr/>
+        </p:nvSpPr>
+        <p:spPr>
+          <a:xfrm>
+            <a:off x="8211312" y="1280160"/>
+            <a:ext cx="3520440" cy="320040"/>
+          </a:xfrm>
+          <a:prstGeom prst="rect">
+            <a:avLst/>
+          </a:prstGeom>
+          <a:noFill/>
+          <a:ln/>
+        </p:spPr>
+        <p:txBody>
+          <a:bodyPr wrap="square" lIns="0" tIns="0" rIns="0" bIns="0" rtlCol="0" anchor="t"/>
+          <a:lstStyle/>
+          <a:p>
+            <a:pPr algn="ctr" indent="0" marL="0">
+              <a:buNone/>
+            </a:pPr>
+            <a:r>
+              <a:rPr lang="en-US" sz="1500" b="1" dirty="0">
+                <a:solidFill>
+                  <a:srgbClr val="262626"/>
+                </a:solidFill>
+                <a:latin typeface="Arial" pitchFamily="34" charset="0"/>
+                <a:ea typeface="Arial" pitchFamily="34" charset="-122"/>
+                <a:cs typeface="Arial" pitchFamily="34" charset="-120"/>
+              </a:rPr>
+              <a:t>Implications</a:t>
+            </a:r>
+            <a:endParaRPr lang="en-US" sz="1500" dirty="0"/>
+          </a:p>
+        </p:txBody>
+      </p:sp>
+      <p:sp>
+        <p:nvSpPr>
+          <p:cNvPr id="27" name="Shape 21"/>
+          <p:cNvSpPr/>
+          <p:nvPr/>
+        </p:nvSpPr>
+        <p:spPr>
+          <a:xfrm>
+            <a:off x="8485632" y="1627632"/>
+            <a:ext cx="2971800" cy="0"/>
+          </a:xfrm>
+          <a:prstGeom prst="line">
+            <a:avLst/>
+          </a:prstGeom>
+          <a:noFill/>
+          <a:ln w="9525">
+            <a:solidFill>
+              <a:srgbClr val="2C5F82"/>
+            </a:solidFill>
+            <a:prstDash val="solid"/>
+          </a:ln>
+        </p:spPr>
+      </p:sp>
+      <p:sp>
+        <p:nvSpPr>
+          <p:cNvPr id="28" name="Text 22"/>
+          <p:cNvSpPr txBox="1"/>
+          <p:nvPr/>
+        </p:nvSpPr>
+        <p:spPr>
+          <a:xfrm>
+            <a:off x="8211312" y="1645920"/>
+            <a:ext cx="3520440" cy="274320"/>
+          </a:xfrm>
+          <a:prstGeom prst="rect">
+            <a:avLst/>
+          </a:prstGeom>
+          <a:noFill/>
+          <a:ln/>
+        </p:spPr>
+        <p:txBody>
+          <a:bodyPr wrap="square" lIns="0" tIns="0" rIns="0" bIns="0" rtlCol="0" anchor="t"/>
+          <a:lstStyle/>
+          <a:p>
+            <a:pPr algn="ctr" indent="0" marL="0">
+              <a:buNone/>
+            </a:pPr>
+            <a:r>
+              <a:rPr lang="en-US" sz="800" i="1" dirty="0">
+                <a:solidFill>
+                  <a:srgbClr val="595959"/>
+                </a:solidFill>
+                <a:latin typeface="Arial" pitchFamily="34" charset="0"/>
+                <a:ea typeface="Arial" pitchFamily="34" charset="-122"/>
+                <a:cs typeface="Arial" pitchFamily="34" charset="-120"/>
+              </a:rPr>
+              <a:t>Market proof: Taiwan structured-note issuance +81% in 2025, snowball autocalls the favourite payoff (SRP)</a:t>
+            </a:r>
+            <a:endParaRPr lang="en-US" sz="800" dirty="0"/>
+          </a:p>
+        </p:txBody>
+      </p:sp>
+      <p:sp>
+        <p:nvSpPr>
+          <p:cNvPr id="29" name="Shape 23"/>
+          <p:cNvSpPr/>
+          <p:nvPr/>
+        </p:nvSpPr>
+        <p:spPr>
+          <a:xfrm>
+            <a:off x="8211312" y="1938528"/>
+            <a:ext cx="3520440" cy="621792"/>
+          </a:xfrm>
+          <a:prstGeom prst="rect">
+            <a:avLst/>
+          </a:prstGeom>
+          <a:solidFill>
+            <a:srgbClr val="FFFFFF"/>
+          </a:solidFill>
+          <a:ln w="12700">
+            <a:solidFill>
+              <a:srgbClr val="2C5F82"/>
+            </a:solidFill>
+            <a:prstDash val="solid"/>
+          </a:ln>
+        </p:spPr>
+      </p:sp>
+      <p:sp>
+        <p:nvSpPr>
+          <p:cNvPr id="30" name="Text 24"/>
+          <p:cNvSpPr txBox="1"/>
+          <p:nvPr/>
+        </p:nvSpPr>
+        <p:spPr>
+          <a:xfrm>
+            <a:off x="8257032" y="1938528"/>
+            <a:ext cx="411480" cy="621792"/>
+          </a:xfrm>
+          <a:prstGeom prst="rect">
+            <a:avLst/>
+          </a:prstGeom>
+          <a:noFill/>
+          <a:ln/>
+        </p:spPr>
+        <p:txBody>
+          <a:bodyPr wrap="square" lIns="0" tIns="0" rIns="0" bIns="0" rtlCol="0" anchor="ctr"/>
+          <a:lstStyle/>
+          <a:p>
+            <a:pPr algn="ctr" indent="0" marL="0">
+              <a:buNone/>
+            </a:pPr>
+            <a:r>
+              <a:rPr lang="en-US" sz="2200" b="1" i="1" dirty="0">
+                <a:solidFill>
+                  <a:srgbClr val="2C5F82"/>
+                </a:solidFill>
+                <a:latin typeface="Arial" pitchFamily="34" charset="0"/>
+                <a:ea typeface="Arial" pitchFamily="34" charset="-122"/>
+                <a:cs typeface="Arial" pitchFamily="34" charset="-120"/>
+              </a:rPr>
+              <a:t>1</a:t>
+            </a:r>
+            <a:endParaRPr lang="en-US" sz="2200" dirty="0"/>
+          </a:p>
+        </p:txBody>
+      </p:sp>
+      <p:sp>
+        <p:nvSpPr>
+          <p:cNvPr id="31" name="Text 25"/>
+          <p:cNvSpPr txBox="1"/>
+          <p:nvPr/>
+        </p:nvSpPr>
+        <p:spPr>
+          <a:xfrm>
+            <a:off x="8714232" y="1956816"/>
+            <a:ext cx="2926080" cy="585216"/>
+          </a:xfrm>
+          <a:prstGeom prst="rect">
+            <a:avLst/>
+          </a:prstGeom>
+          <a:noFill/>
+          <a:ln/>
+        </p:spPr>
+        <p:txBody>
+          <a:bodyPr wrap="square" lIns="0" tIns="0" rIns="0" bIns="0" rtlCol="0" anchor="ctr"/>
+          <a:lstStyle/>
+          <a:p>
+            <a:pPr indent="0" marL="0">
+              <a:buNone/>
+            </a:pPr>
+            <a:r>
+              <a:rPr lang="en-US" sz="880" b="1" dirty="0">
+                <a:solidFill>
+                  <a:srgbClr val="262626"/>
+                </a:solidFill>
+                <a:latin typeface="Arial" pitchFamily="34" charset="0"/>
+                <a:ea typeface="Arial" pitchFamily="34" charset="-122"/>
+                <a:cs typeface="Arial" pitchFamily="34" charset="-120"/>
+              </a:rPr>
+              <a:t>Early exit beats duration: </a:t>
+            </a:r>
+            <a:pPr indent="0" marL="0">
+              <a:buNone/>
+            </a:pPr>
+            <a:r>
+              <a:rPr lang="en-US" sz="880" dirty="0">
+                <a:solidFill>
+                  <a:srgbClr val="595959"/>
+                </a:solidFill>
+                <a:latin typeface="Arial" pitchFamily="34" charset="0"/>
+                <a:ea typeface="Arial" pitchFamily="34" charset="-122"/>
+                <a:cs typeface="Arial" pitchFamily="34" charset="-120"/>
+              </a:rPr>
+              <a:t>Fed median 4.125% to end-2027, some see more hikes: bonds lose ~4.0% per 1% rise; autocalls can redeem from year 1</a:t>
+            </a:r>
+            <a:endParaRPr lang="en-US" sz="880" dirty="0"/>
+          </a:p>
+        </p:txBody>
+      </p:sp>
+      <p:sp>
+        <p:nvSpPr>
+          <p:cNvPr id="32" name="Shape 26"/>
+          <p:cNvSpPr/>
+          <p:nvPr/>
+        </p:nvSpPr>
+        <p:spPr>
+          <a:xfrm>
+            <a:off x="8211312" y="2633472"/>
+            <a:ext cx="3520440" cy="621792"/>
+          </a:xfrm>
+          <a:prstGeom prst="rect">
+            <a:avLst/>
+          </a:prstGeom>
+          <a:solidFill>
+            <a:srgbClr val="FFFFFF"/>
+          </a:solidFill>
+          <a:ln w="12700">
+            <a:solidFill>
+              <a:srgbClr val="2C5F82"/>
+            </a:solidFill>
+            <a:prstDash val="solid"/>
+          </a:ln>
+        </p:spPr>
+      </p:sp>
+      <p:sp>
+        <p:nvSpPr>
+          <p:cNvPr id="33" name="Text 27"/>
+          <p:cNvSpPr txBox="1"/>
+          <p:nvPr/>
+        </p:nvSpPr>
+        <p:spPr>
+          <a:xfrm>
+            <a:off x="8257032" y="2633472"/>
+            <a:ext cx="411480" cy="621792"/>
+          </a:xfrm>
+          <a:prstGeom prst="rect">
+            <a:avLst/>
+          </a:prstGeom>
+          <a:noFill/>
+          <a:ln/>
+        </p:spPr>
+        <p:txBody>
+          <a:bodyPr wrap="square" lIns="0" tIns="0" rIns="0" bIns="0" rtlCol="0" anchor="ctr"/>
+          <a:lstStyle/>
+          <a:p>
+            <a:pPr algn="ctr" indent="0" marL="0">
+              <a:buNone/>
+            </a:pPr>
+            <a:r>
+              <a:rPr lang="en-US" sz="2200" b="1" i="1" dirty="0">
+                <a:solidFill>
+                  <a:srgbClr val="2C5F82"/>
+                </a:solidFill>
+                <a:latin typeface="Arial" pitchFamily="34" charset="0"/>
+                <a:ea typeface="Arial" pitchFamily="34" charset="-122"/>
+                <a:cs typeface="Arial" pitchFamily="34" charset="-120"/>
+              </a:rPr>
+              <a:t>2</a:t>
+            </a:r>
+            <a:endParaRPr lang="en-US" sz="2200" dirty="0"/>
+          </a:p>
+        </p:txBody>
+      </p:sp>
+      <p:sp>
+        <p:nvSpPr>
+          <p:cNvPr id="34" name="Text 28"/>
+          <p:cNvSpPr txBox="1"/>
+          <p:nvPr/>
+        </p:nvSpPr>
+        <p:spPr>
+          <a:xfrm>
+            <a:off x="8714232" y="2651760"/>
+            <a:ext cx="2926080" cy="585216"/>
+          </a:xfrm>
+          <a:prstGeom prst="rect">
+            <a:avLst/>
+          </a:prstGeom>
+          <a:noFill/>
+          <a:ln/>
+        </p:spPr>
+        <p:txBody>
+          <a:bodyPr wrap="square" lIns="0" tIns="0" rIns="0" bIns="0" rtlCol="0" anchor="ctr"/>
+          <a:lstStyle/>
+          <a:p>
+            <a:pPr indent="0" marL="0">
+              <a:buNone/>
+            </a:pPr>
+            <a:r>
+              <a:rPr lang="en-US" sz="880" b="1" dirty="0">
+                <a:solidFill>
+                  <a:srgbClr val="262626"/>
+                </a:solidFill>
+                <a:latin typeface="Arial" pitchFamily="34" charset="0"/>
+                <a:ea typeface="Arial" pitchFamily="34" charset="-122"/>
+                <a:cs typeface="Arial" pitchFamily="34" charset="-120"/>
+              </a:rPr>
+              <a:t>Paid on recovery, not timing: </a:t>
+            </a:r>
+            <a:pPr indent="0" marL="0">
+              <a:buNone/>
+            </a:pPr>
+            <a:r>
+              <a:rPr lang="en-US" sz="880" dirty="0">
+                <a:solidFill>
+                  <a:srgbClr val="595959"/>
+                </a:solidFill>
+                <a:latin typeface="Arial" pitchFamily="34" charset="0"/>
+                <a:ea typeface="Arial" pitchFamily="34" charset="-122"/>
+                <a:cs typeface="Arial" pitchFamily="34" charset="-120"/>
+              </a:rPr>
+              <a:t>−25% in ten weeks (KOSPI 2026): autocall coupons pay once the basket is back at its start</a:t>
+            </a:r>
+            <a:endParaRPr lang="en-US" sz="880" dirty="0"/>
+          </a:p>
+        </p:txBody>
+      </p:sp>
+      <p:sp>
+        <p:nvSpPr>
+          <p:cNvPr id="35" name="Shape 29"/>
+          <p:cNvSpPr/>
+          <p:nvPr/>
+        </p:nvSpPr>
+        <p:spPr>
+          <a:xfrm>
+            <a:off x="8211312" y="3328416"/>
+            <a:ext cx="3520440" cy="621792"/>
+          </a:xfrm>
+          <a:prstGeom prst="rect">
+            <a:avLst/>
+          </a:prstGeom>
+          <a:solidFill>
+            <a:srgbClr val="FFFFFF"/>
+          </a:solidFill>
+          <a:ln w="12700">
+            <a:solidFill>
+              <a:srgbClr val="2C5F82"/>
+            </a:solidFill>
+            <a:prstDash val="solid"/>
+          </a:ln>
+        </p:spPr>
+      </p:sp>
+      <p:sp>
+        <p:nvSpPr>
+          <p:cNvPr id="36" name="Text 30"/>
+          <p:cNvSpPr txBox="1"/>
+          <p:nvPr/>
+        </p:nvSpPr>
+        <p:spPr>
+          <a:xfrm>
+            <a:off x="8257032" y="3328416"/>
+            <a:ext cx="411480" cy="621792"/>
+          </a:xfrm>
+          <a:prstGeom prst="rect">
+            <a:avLst/>
+          </a:prstGeom>
+          <a:noFill/>
+          <a:ln/>
+        </p:spPr>
+        <p:txBody>
+          <a:bodyPr wrap="square" lIns="0" tIns="0" rIns="0" bIns="0" rtlCol="0" anchor="ctr"/>
+          <a:lstStyle/>
+          <a:p>
+            <a:pPr algn="ctr" indent="0" marL="0">
+              <a:buNone/>
+            </a:pPr>
+            <a:r>
+              <a:rPr lang="en-US" sz="2200" b="1" i="1" dirty="0">
+                <a:solidFill>
+                  <a:srgbClr val="2C5F82"/>
+                </a:solidFill>
+                <a:latin typeface="Arial" pitchFamily="34" charset="0"/>
+                <a:ea typeface="Arial" pitchFamily="34" charset="-122"/>
+                <a:cs typeface="Arial" pitchFamily="34" charset="-120"/>
+              </a:rPr>
+              <a:t>3</a:t>
+            </a:r>
+            <a:endParaRPr lang="en-US" sz="2200" dirty="0"/>
+          </a:p>
+        </p:txBody>
+      </p:sp>
+      <p:sp>
+        <p:nvSpPr>
+          <p:cNvPr id="37" name="Text 31"/>
+          <p:cNvSpPr txBox="1"/>
+          <p:nvPr/>
+        </p:nvSpPr>
+        <p:spPr>
+          <a:xfrm>
+            <a:off x="8714232" y="3346704"/>
+            <a:ext cx="2926080" cy="585216"/>
+          </a:xfrm>
+          <a:prstGeom prst="rect">
+            <a:avLst/>
+          </a:prstGeom>
+          <a:noFill/>
+          <a:ln/>
+        </p:spPr>
+        <p:txBody>
+          <a:bodyPr wrap="square" lIns="0" tIns="0" rIns="0" bIns="0" rtlCol="0" anchor="ctr"/>
+          <a:lstStyle/>
+          <a:p>
+            <a:pPr indent="0" marL="0">
+              <a:buNone/>
+            </a:pPr>
+            <a:r>
+              <a:rPr lang="en-US" sz="880" b="1" dirty="0">
+                <a:solidFill>
+                  <a:srgbClr val="262626"/>
+                </a:solidFill>
+                <a:latin typeface="Arial" pitchFamily="34" charset="0"/>
+                <a:ea typeface="Arial" pitchFamily="34" charset="-122"/>
+                <a:cs typeface="Arial" pitchFamily="34" charset="-120"/>
+              </a:rPr>
+              <a:t>Diversify the basket: </a:t>
+            </a:r>
+            <a:pPr indent="0" marL="0">
+              <a:buNone/>
+            </a:pPr>
+            <a:r>
+              <a:rPr lang="en-US" sz="880" dirty="0">
+                <a:solidFill>
+                  <a:srgbClr val="595959"/>
+                </a:solidFill>
+                <a:latin typeface="Arial" pitchFamily="34" charset="0"/>
+                <a:ea typeface="Arial" pitchFamily="34" charset="-122"/>
+                <a:cs typeface="Arial" pitchFamily="34" charset="-120"/>
+              </a:rPr>
+              <a:t>TSMC &gt;40% of TAIEX, ~92% of advanced chips from Taiwan: use a diversified ETF basket, not worst-of</a:t>
+            </a:r>
+            <a:endParaRPr lang="en-US" sz="880" dirty="0"/>
+          </a:p>
+        </p:txBody>
+      </p:sp>
+      <p:sp>
+        <p:nvSpPr>
+          <p:cNvPr id="38" name="Shape 32"/>
+          <p:cNvSpPr/>
+          <p:nvPr/>
+        </p:nvSpPr>
+        <p:spPr>
+          <a:xfrm>
+            <a:off x="8211312" y="4023360"/>
+            <a:ext cx="3520440" cy="621792"/>
+          </a:xfrm>
+          <a:prstGeom prst="rect">
+            <a:avLst/>
+          </a:prstGeom>
+          <a:solidFill>
+            <a:srgbClr val="FFFFFF"/>
+          </a:solidFill>
+          <a:ln w="12700">
+            <a:solidFill>
+              <a:srgbClr val="2C5F82"/>
+            </a:solidFill>
+            <a:prstDash val="solid"/>
+          </a:ln>
+        </p:spPr>
+      </p:sp>
+      <p:sp>
+        <p:nvSpPr>
+          <p:cNvPr id="39" name="Text 33"/>
+          <p:cNvSpPr txBox="1"/>
+          <p:nvPr/>
+        </p:nvSpPr>
+        <p:spPr>
+          <a:xfrm>
+            <a:off x="8257032" y="4023360"/>
+            <a:ext cx="411480" cy="621792"/>
+          </a:xfrm>
+          <a:prstGeom prst="rect">
+            <a:avLst/>
+          </a:prstGeom>
+          <a:noFill/>
+          <a:ln/>
+        </p:spPr>
+        <p:txBody>
+          <a:bodyPr wrap="square" lIns="0" tIns="0" rIns="0" bIns="0" rtlCol="0" anchor="ctr"/>
+          <a:lstStyle/>
+          <a:p>
+            <a:pPr algn="ctr" indent="0" marL="0">
+              <a:buNone/>
+            </a:pPr>
+            <a:r>
+              <a:rPr lang="en-US" sz="2200" b="1" i="1" dirty="0">
+                <a:solidFill>
+                  <a:srgbClr val="2C5F82"/>
+                </a:solidFill>
+                <a:latin typeface="Arial" pitchFamily="34" charset="0"/>
+                <a:ea typeface="Arial" pitchFamily="34" charset="-122"/>
+                <a:cs typeface="Arial" pitchFamily="34" charset="-120"/>
+              </a:rPr>
+              <a:t>4</a:t>
+            </a:r>
+            <a:endParaRPr lang="en-US" sz="2200" dirty="0"/>
+          </a:p>
+        </p:txBody>
+      </p:sp>
+      <p:sp>
+        <p:nvSpPr>
+          <p:cNvPr id="40" name="Text 34"/>
+          <p:cNvSpPr txBox="1"/>
+          <p:nvPr/>
+        </p:nvSpPr>
+        <p:spPr>
+          <a:xfrm>
+            <a:off x="8714232" y="4041648"/>
+            <a:ext cx="2926080" cy="585216"/>
+          </a:xfrm>
+          <a:prstGeom prst="rect">
+            <a:avLst/>
+          </a:prstGeom>
+          <a:noFill/>
+          <a:ln/>
+        </p:spPr>
+        <p:txBody>
+          <a:bodyPr wrap="square" lIns="0" tIns="0" rIns="0" bIns="0" rtlCol="0" anchor="ctr"/>
+          <a:lstStyle/>
+          <a:p>
+            <a:pPr indent="0" marL="0">
+              <a:buNone/>
+            </a:pPr>
+            <a:r>
+              <a:rPr lang="en-US" sz="880" b="1" dirty="0">
+                <a:solidFill>
+                  <a:srgbClr val="262626"/>
+                </a:solidFill>
+                <a:latin typeface="Arial" pitchFamily="34" charset="0"/>
+                <a:ea typeface="Arial" pitchFamily="34" charset="-122"/>
+                <a:cs typeface="Arial" pitchFamily="34" charset="-120"/>
+              </a:rPr>
+              <a:t>Volatility funds the coupon: </a:t>
+            </a:r>
+            <a:pPr indent="0" marL="0">
+              <a:buNone/>
+            </a:pPr>
+            <a:r>
+              <a:rPr lang="en-US" sz="880" dirty="0">
+                <a:solidFill>
+                  <a:srgbClr val="595959"/>
+                </a:solidFill>
+                <a:latin typeface="Arial" pitchFamily="34" charset="0"/>
+                <a:ea typeface="Arial" pitchFamily="34" charset="-122"/>
+                <a:cs typeface="Arial" pitchFamily="34" charset="-120"/>
+              </a:rPr>
+              <a:t>VKOSPI at a record 91.2: richer option premium means higher autocall coupons</a:t>
+            </a:r>
+            <a:endParaRPr lang="en-US" sz="880" dirty="0"/>
+          </a:p>
+        </p:txBody>
+      </p:sp>
+      <p:sp>
+        <p:nvSpPr>
+          <p:cNvPr id="41" name="Shape 35"/>
+          <p:cNvSpPr/>
+          <p:nvPr/>
+        </p:nvSpPr>
+        <p:spPr>
+          <a:xfrm>
+            <a:off x="8211312" y="4718304"/>
+            <a:ext cx="3520440" cy="621792"/>
+          </a:xfrm>
+          <a:prstGeom prst="rect">
+            <a:avLst/>
+          </a:prstGeom>
+          <a:solidFill>
+            <a:srgbClr val="FFFFFF"/>
+          </a:solidFill>
+          <a:ln w="12700">
+            <a:solidFill>
+              <a:srgbClr val="2C5F82"/>
+            </a:solidFill>
+            <a:prstDash val="solid"/>
+          </a:ln>
+        </p:spPr>
+      </p:sp>
+      <p:sp>
+        <p:nvSpPr>
+          <p:cNvPr id="42" name="Text 36"/>
+          <p:cNvSpPr txBox="1"/>
+          <p:nvPr/>
+        </p:nvSpPr>
+        <p:spPr>
+          <a:xfrm>
+            <a:off x="8257032" y="4718304"/>
+            <a:ext cx="411480" cy="621792"/>
+          </a:xfrm>
+          <a:prstGeom prst="rect">
+            <a:avLst/>
+          </a:prstGeom>
+          <a:noFill/>
+          <a:ln/>
+        </p:spPr>
+        <p:txBody>
+          <a:bodyPr wrap="square" lIns="0" tIns="0" rIns="0" bIns="0" rtlCol="0" anchor="ctr"/>
+          <a:lstStyle/>
+          <a:p>
+            <a:pPr algn="ctr" indent="0" marL="0">
+              <a:buNone/>
+            </a:pPr>
+            <a:r>
+              <a:rPr lang="en-US" sz="2200" b="1" i="1" dirty="0">
+                <a:solidFill>
+                  <a:srgbClr val="2C5F82"/>
+                </a:solidFill>
+                <a:latin typeface="Arial" pitchFamily="34" charset="0"/>
+                <a:ea typeface="Arial" pitchFamily="34" charset="-122"/>
+                <a:cs typeface="Arial" pitchFamily="34" charset="-120"/>
+              </a:rPr>
+              <a:t>5</a:t>
+            </a:r>
+            <a:endParaRPr lang="en-US" sz="2200" dirty="0"/>
+          </a:p>
+        </p:txBody>
+      </p:sp>
+      <p:sp>
+        <p:nvSpPr>
+          <p:cNvPr id="43" name="Text 37"/>
+          <p:cNvSpPr txBox="1"/>
+          <p:nvPr/>
+        </p:nvSpPr>
+        <p:spPr>
+          <a:xfrm>
+            <a:off x="8714232" y="4736592"/>
+            <a:ext cx="2926080" cy="585216"/>
+          </a:xfrm>
+          <a:prstGeom prst="rect">
+            <a:avLst/>
+          </a:prstGeom>
+          <a:noFill/>
+          <a:ln/>
+        </p:spPr>
+        <p:txBody>
+          <a:bodyPr wrap="square" lIns="0" tIns="0" rIns="0" bIns="0" rtlCol="0" anchor="ctr"/>
+          <a:lstStyle/>
+          <a:p>
+            <a:pPr indent="0" marL="0">
+              <a:buNone/>
+            </a:pPr>
+            <a:r>
+              <a:rPr lang="en-US" sz="880" b="1" dirty="0">
+                <a:solidFill>
+                  <a:srgbClr val="262626"/>
+                </a:solidFill>
+                <a:latin typeface="Arial" pitchFamily="34" charset="0"/>
+                <a:ea typeface="Arial" pitchFamily="34" charset="-122"/>
+                <a:cs typeface="Arial" pitchFamily="34" charset="-120"/>
+              </a:rPr>
+              <a:t>Protection is affordable: </a:t>
+            </a:r>
+            <a:pPr indent="0" marL="0">
+              <a:buNone/>
+            </a:pPr>
+            <a:r>
+              <a:rPr lang="en-US" sz="880" dirty="0">
+                <a:solidFill>
+                  <a:srgbClr val="595959"/>
+                </a:solidFill>
+                <a:latin typeface="Arial" pitchFamily="34" charset="0"/>
+                <a:ea typeface="Arial" pitchFamily="34" charset="-122"/>
+                <a:cs typeface="Arial" pitchFamily="34" charset="-120"/>
+              </a:rPr>
+              <a:t>Rates high until 2028: USD 100 in 5 years costs USD 75.8 at 5.69%, so a 70% floor fits inside an autocall</a:t>
+            </a:r>
+            <a:endParaRPr lang="en-US" sz="880" dirty="0"/>
+          </a:p>
+        </p:txBody>
+      </p:sp>
+      <p:sp>
+        <p:nvSpPr>
+          <p:cNvPr id="44" name="Shape 38"/>
+          <p:cNvSpPr/>
+          <p:nvPr/>
+        </p:nvSpPr>
+        <p:spPr>
+          <a:xfrm>
+            <a:off x="457200" y="5486400"/>
+            <a:ext cx="11274552" cy="438912"/>
+          </a:xfrm>
+          <a:prstGeom prst="rect">
+            <a:avLst/>
+          </a:prstGeom>
+          <a:solidFill>
+            <a:srgbClr val="2C5F82"/>
+          </a:solidFill>
+          <a:ln w="12700">
+            <a:solidFill>
+              <a:srgbClr val="2C5F82"/>
+            </a:solidFill>
+            <a:prstDash val="solid"/>
+          </a:ln>
+        </p:spPr>
+      </p:sp>
+      <p:sp>
+        <p:nvSpPr>
+          <p:cNvPr id="45" name="Text 39"/>
+          <p:cNvSpPr txBox="1"/>
+          <p:nvPr/>
+        </p:nvSpPr>
+        <p:spPr>
+          <a:xfrm>
+            <a:off x="594360" y="5486400"/>
+            <a:ext cx="11000232" cy="438912"/>
+          </a:xfrm>
+          <a:prstGeom prst="rect">
+            <a:avLst/>
+          </a:prstGeom>
+          <a:noFill/>
+          <a:ln/>
+        </p:spPr>
+        <p:txBody>
+          <a:bodyPr wrap="square" lIns="0" tIns="0" rIns="0" bIns="0" rtlCol="0" anchor="ctr"/>
+          <a:lstStyle/>
+          <a:p>
+            <a:pPr algn="ctr" indent="0" marL="0">
+              <a:buNone/>
+            </a:pPr>
+            <a:r>
+              <a:rPr lang="en-US" sz="1200" b="1" dirty="0">
+                <a:solidFill>
+                  <a:srgbClr val="FFFFFF"/>
+                </a:solidFill>
+                <a:latin typeface="Arial" pitchFamily="34" charset="0"/>
+                <a:ea typeface="Arial" pitchFamily="34" charset="-122"/>
+                <a:cs typeface="Arial" pitchFamily="34" charset="-120"/>
+              </a:rPr>
+              <a:t>Plain bonds and equities leave investors exposed; a buffered autocall with a 70% floor keeps the theme and manages the risks.</a:t>
+            </a:r>
+            <a:endParaRPr lang="en-US" sz="1200" dirty="0"/>
+          </a:p>
+        </p:txBody>
+      </p:sp>
+      <p:sp>
+        <p:nvSpPr>
+          <p:cNvPr id="46" name="Text 40"/>
+          <p:cNvSpPr txBox="1"/>
+          <p:nvPr/>
+        </p:nvSpPr>
+        <p:spPr>
+          <a:xfrm>
+            <a:off x="457200" y="5998464"/>
+            <a:ext cx="11274552" cy="274320"/>
+          </a:xfrm>
+          <a:prstGeom prst="rect">
+            <a:avLst/>
+          </a:prstGeom>
+          <a:noFill/>
+          <a:ln/>
+        </p:spPr>
+        <p:txBody>
+          <a:bodyPr wrap="square" lIns="0" tIns="0" rIns="0" bIns="0" rtlCol="0" anchor="t"/>
+          <a:lstStyle/>
+          <a:p>
+            <a:pPr indent="0" marL="0">
+              <a:buNone/>
+            </a:pPr>
+            <a:r>
+              <a:rPr lang="en-US" sz="800" i="1" dirty="0">
+                <a:solidFill>
+                  <a:srgbClr val="595959"/>
+                </a:solidFill>
+                <a:latin typeface="Arial" pitchFamily="34" charset="0"/>
+                <a:ea typeface="Arial" pitchFamily="34" charset="-122"/>
+                <a:cs typeface="Arial" pitchFamily="34" charset="-120"/>
+              </a:rPr>
+              <a:t>Sources: Federal Reserve, Summary of Economic Projections (16 Sep 2026; dot counts read from Figure 2, verify); TWSE, KRX/press, Nikkei (index levels); Siblis Research (P/E); Herald / SBS (VKOSPI); TrendForce; J.P. Morgan 2026 Outlook; StructuredRetailProducts.com; case funding grid with standard bond maths.</a:t>
             </a:r>
             <a:endParaRPr lang="en-US" sz="800" dirty="0"/>
           </a:p>
@@ -11132,7 +11256,7 @@
                 <a:ea typeface="Arial" pitchFamily="34" charset="-122"/>
                 <a:cs typeface="Arial" pitchFamily="34" charset="-120"/>
               </a:rPr>
-              <a:t>Investment thesis 2: Traditional strategies fall short; autocallables fit 2026</a:t>
+              <a:t>Appendix: sources for the investment thesis</a:t>
             </a:r>
             <a:endParaRPr lang="en-US" sz="2400" dirty="0"/>
           </a:p>
@@ -11186,13 +11310,91 @@
       </p:sp>
       <p:sp>
         <p:nvSpPr>
-          <p:cNvPr id="5" name="Shape 3"/>
+          <p:cNvPr id="5" name="Text 3"/>
+          <p:cNvSpPr txBox="1"/>
+          <p:nvPr/>
+        </p:nvSpPr>
+        <p:spPr>
+          <a:xfrm>
+            <a:off x="457200" y="6446520"/>
+            <a:ext cx="3611880" cy="274320"/>
+          </a:xfrm>
+          <a:prstGeom prst="rect">
+            <a:avLst/>
+          </a:prstGeom>
+          <a:noFill/>
+          <a:ln/>
+        </p:spPr>
+        <p:txBody>
+          <a:bodyPr wrap="square" lIns="0" tIns="0" rIns="0" bIns="0" rtlCol="0" anchor="t"/>
+          <a:lstStyle/>
+          <a:p>
+            <a:pPr algn="ctr" indent="0" marL="0">
+              <a:buNone/>
+            </a:pPr>
+            <a:r>
+              <a:rPr lang="en-US" sz="1200" spc="100" kern="0" dirty="0">
+                <a:solidFill>
+                  <a:srgbClr val="595959"/>
+                </a:solidFill>
+                <a:latin typeface="Arial" pitchFamily="34" charset="0"/>
+                <a:ea typeface="Arial" pitchFamily="34" charset="-122"/>
+                <a:cs typeface="Arial" pitchFamily="34" charset="-120"/>
+              </a:rPr>
+              <a:t>ANALYSIS</a:t>
+            </a:r>
+            <a:endParaRPr lang="en-US" sz="1200" dirty="0"/>
+          </a:p>
+        </p:txBody>
+      </p:sp>
+      <p:sp>
+        <p:nvSpPr>
+          <p:cNvPr id="6" name="Text 4"/>
+          <p:cNvSpPr txBox="1"/>
+          <p:nvPr/>
+        </p:nvSpPr>
+        <p:spPr>
+          <a:xfrm>
+            <a:off x="4288536" y="6446520"/>
+            <a:ext cx="3611880" cy="274320"/>
+          </a:xfrm>
+          <a:prstGeom prst="rect">
+            <a:avLst/>
+          </a:prstGeom>
+          <a:noFill/>
+          <a:ln/>
+        </p:spPr>
+        <p:txBody>
+          <a:bodyPr wrap="square" lIns="0" tIns="0" rIns="0" bIns="0" rtlCol="0" anchor="t"/>
+          <a:lstStyle/>
+          <a:p>
+            <a:pPr algn="ctr" indent="0" marL="0">
+              <a:buNone/>
+            </a:pPr>
+            <a:r>
+              <a:rPr lang="en-US" sz="1200" spc="100" kern="0" dirty="0">
+                <a:solidFill>
+                  <a:srgbClr val="595959"/>
+                </a:solidFill>
+                <a:latin typeface="Arial" pitchFamily="34" charset="0"/>
+                <a:ea typeface="Arial" pitchFamily="34" charset="-122"/>
+                <a:cs typeface="Arial" pitchFamily="34" charset="-120"/>
+              </a:rPr>
+              <a:t>STRATEGY</a:t>
+            </a:r>
+            <a:endParaRPr lang="en-US" sz="1200" dirty="0"/>
+          </a:p>
+        </p:txBody>
+      </p:sp>
+      <p:sp>
+        <p:nvSpPr>
+          <p:cNvPr id="7" name="Shape 5"/>
           <p:cNvSpPr/>
           <p:nvPr/>
         </p:nvSpPr>
         <p:spPr>
           <a:xfrm>
-            <a:off x="1005840" y="6364224"/>
+            <a:off x="8677656" y="6364224"/>
             <a:ext cx="2514600" cy="45720"/>
           </a:xfrm>
           <a:prstGeom prst="rect">
@@ -11211,13 +11413,13 @@
       </p:sp>
       <p:sp>
         <p:nvSpPr>
-          <p:cNvPr id="6" name="Text 4"/>
+          <p:cNvPr id="8" name="Text 6"/>
           <p:cNvSpPr txBox="1"/>
           <p:nvPr/>
         </p:nvSpPr>
         <p:spPr>
           <a:xfrm>
-            <a:off x="457200" y="6446520"/>
+            <a:off x="8129016" y="6446520"/>
             <a:ext cx="3611880" cy="274320"/>
           </a:xfrm>
           <a:prstGeom prst="rect">
@@ -11237,84 +11439,6 @@
               <a:rPr lang="en-US" sz="1200" b="1" spc="100" kern="0" dirty="0">
                 <a:solidFill>
                   <a:srgbClr val="2C5F82"/>
-                </a:solidFill>
-                <a:latin typeface="Arial" pitchFamily="34" charset="0"/>
-                <a:ea typeface="Arial" pitchFamily="34" charset="-122"/>
-                <a:cs typeface="Arial" pitchFamily="34" charset="-120"/>
-              </a:rPr>
-              <a:t>ANALYSIS</a:t>
-            </a:r>
-            <a:endParaRPr lang="en-US" sz="1200" dirty="0"/>
-          </a:p>
-        </p:txBody>
-      </p:sp>
-      <p:sp>
-        <p:nvSpPr>
-          <p:cNvPr id="7" name="Text 5"/>
-          <p:cNvSpPr txBox="1"/>
-          <p:nvPr/>
-        </p:nvSpPr>
-        <p:spPr>
-          <a:xfrm>
-            <a:off x="4288536" y="6446520"/>
-            <a:ext cx="3611880" cy="274320"/>
-          </a:xfrm>
-          <a:prstGeom prst="rect">
-            <a:avLst/>
-          </a:prstGeom>
-          <a:noFill/>
-          <a:ln/>
-        </p:spPr>
-        <p:txBody>
-          <a:bodyPr wrap="square" lIns="0" tIns="0" rIns="0" bIns="0" rtlCol="0" anchor="t"/>
-          <a:lstStyle/>
-          <a:p>
-            <a:pPr algn="ctr" indent="0" marL="0">
-              <a:buNone/>
-            </a:pPr>
-            <a:r>
-              <a:rPr lang="en-US" sz="1200" spc="100" kern="0" dirty="0">
-                <a:solidFill>
-                  <a:srgbClr val="595959"/>
-                </a:solidFill>
-                <a:latin typeface="Arial" pitchFamily="34" charset="0"/>
-                <a:ea typeface="Arial" pitchFamily="34" charset="-122"/>
-                <a:cs typeface="Arial" pitchFamily="34" charset="-120"/>
-              </a:rPr>
-              <a:t>STRATEGY</a:t>
-            </a:r>
-            <a:endParaRPr lang="en-US" sz="1200" dirty="0"/>
-          </a:p>
-        </p:txBody>
-      </p:sp>
-      <p:sp>
-        <p:nvSpPr>
-          <p:cNvPr id="8" name="Text 6"/>
-          <p:cNvSpPr txBox="1"/>
-          <p:nvPr/>
-        </p:nvSpPr>
-        <p:spPr>
-          <a:xfrm>
-            <a:off x="8129016" y="6446520"/>
-            <a:ext cx="3611880" cy="274320"/>
-          </a:xfrm>
-          <a:prstGeom prst="rect">
-            <a:avLst/>
-          </a:prstGeom>
-          <a:noFill/>
-          <a:ln/>
-        </p:spPr>
-        <p:txBody>
-          <a:bodyPr wrap="square" lIns="0" tIns="0" rIns="0" bIns="0" rtlCol="0" anchor="t"/>
-          <a:lstStyle/>
-          <a:p>
-            <a:pPr algn="ctr" indent="0" marL="0">
-              <a:buNone/>
-            </a:pPr>
-            <a:r>
-              <a:rPr lang="en-US" sz="1200" spc="100" kern="0" dirty="0">
-                <a:solidFill>
-                  <a:srgbClr val="595959"/>
                 </a:solidFill>
                 <a:latin typeface="Arial" pitchFamily="34" charset="0"/>
                 <a:ea typeface="Arial" pitchFamily="34" charset="-122"/>
@@ -11326,1572 +11450,9 @@
           </a:p>
         </p:txBody>
       </p:sp>
-      <p:sp>
-        <p:nvSpPr>
-          <p:cNvPr id="9" name="Text 7"/>
-          <p:cNvSpPr txBox="1"/>
-          <p:nvPr/>
-        </p:nvSpPr>
-        <p:spPr>
-          <a:xfrm>
-            <a:off x="457200" y="960120"/>
-            <a:ext cx="11247120" cy="274320"/>
-          </a:xfrm>
-          <a:prstGeom prst="rect">
-            <a:avLst/>
-          </a:prstGeom>
-          <a:noFill/>
-          <a:ln/>
-        </p:spPr>
-        <p:txBody>
-          <a:bodyPr wrap="square" lIns="0" tIns="0" rIns="0" bIns="0" rtlCol="0" anchor="t"/>
-          <a:lstStyle/>
-          <a:p>
-            <a:pPr indent="0" marL="0">
-              <a:buNone/>
-            </a:pPr>
-            <a:r>
-              <a:rPr lang="en-US" sz="1150" b="1" i="1" dirty="0">
-                <a:solidFill>
-                  <a:srgbClr val="262626"/>
-                </a:solidFill>
-                <a:latin typeface="Arial" pitchFamily="34" charset="0"/>
-                <a:ea typeface="Arial" pitchFamily="34" charset="-122"/>
-                <a:cs typeface="Arial" pitchFamily="34" charset="-120"/>
-              </a:rPr>
-              <a:t>Long bonds face rising rates; buy-and-hold equity faces record volatility, concentration and stretched valuations</a:t>
-            </a:r>
-            <a:endParaRPr lang="en-US" sz="1150" dirty="0"/>
-          </a:p>
-        </p:txBody>
-      </p:sp>
-      <p:sp>
-        <p:nvSpPr>
-          <p:cNvPr id="10" name="Shape 8"/>
-          <p:cNvSpPr/>
-          <p:nvPr/>
-        </p:nvSpPr>
-        <p:spPr>
-          <a:xfrm>
-            <a:off x="457200" y="1325880"/>
-            <a:ext cx="3730752" cy="292608"/>
-          </a:xfrm>
-          <a:prstGeom prst="rect">
-            <a:avLst/>
-          </a:prstGeom>
-          <a:solidFill>
-            <a:srgbClr val="2C5F82"/>
-          </a:solidFill>
-          <a:ln w="12700">
-            <a:solidFill>
-              <a:srgbClr val="2C5F82"/>
-            </a:solidFill>
-            <a:prstDash val="solid"/>
-          </a:ln>
-        </p:spPr>
-      </p:sp>
-      <p:sp>
-        <p:nvSpPr>
-          <p:cNvPr id="11" name="Text 9"/>
-          <p:cNvSpPr txBox="1"/>
-          <p:nvPr/>
-        </p:nvSpPr>
-        <p:spPr>
-          <a:xfrm>
-            <a:off x="457200" y="1325880"/>
-            <a:ext cx="3730752" cy="292608"/>
-          </a:xfrm>
-          <a:prstGeom prst="rect">
-            <a:avLst/>
-          </a:prstGeom>
-          <a:noFill/>
-          <a:ln/>
-        </p:spPr>
-        <p:txBody>
-          <a:bodyPr wrap="square" lIns="0" tIns="0" rIns="0" bIns="0" rtlCol="0" anchor="ctr"/>
-          <a:lstStyle/>
-          <a:p>
-            <a:pPr algn="ctr" indent="0" marL="0">
-              <a:buNone/>
-            </a:pPr>
-            <a:r>
-              <a:rPr lang="en-US" sz="1050" b="1" dirty="0">
-                <a:solidFill>
-                  <a:srgbClr val="FFFFFF"/>
-                </a:solidFill>
-                <a:latin typeface="Arial" pitchFamily="34" charset="0"/>
-                <a:ea typeface="Arial" pitchFamily="34" charset="-122"/>
-                <a:cs typeface="Arial" pitchFamily="34" charset="-120"/>
-              </a:rPr>
-              <a:t>Rates are rising again</a:t>
-            </a:r>
-            <a:endParaRPr lang="en-US" sz="1050" dirty="0"/>
-          </a:p>
-        </p:txBody>
-      </p:sp>
       <p:graphicFrame>
         <p:nvGraphicFramePr>
-          <p:cNvPr id="12" name="Chart 0" descr=""/>
-          <p:cNvGraphicFramePr/>
-          <p:nvPr/>
-        </p:nvGraphicFramePr>
-        <p:xfrm>
-          <a:off x="457200" y="1655064"/>
-          <a:ext cx="3730752" cy="1261872"/>
-        </p:xfrm>
-        <a:graphic xmlns:a="http://schemas.openxmlformats.org/drawingml/2006/main">
-          <a:graphicData uri="http://schemas.openxmlformats.org/drawingml/2006/chart">
-            <c:chart xmlns:c="http://schemas.openxmlformats.org/drawingml/2006/chart" r:id="rId1"/>
-          </a:graphicData>
-        </a:graphic>
-      </p:graphicFrame>
-      <p:sp>
-        <p:nvSpPr>
-          <p:cNvPr id="13" name="Text 10"/>
-          <p:cNvSpPr txBox="1"/>
-          <p:nvPr/>
-        </p:nvSpPr>
-        <p:spPr>
-          <a:xfrm>
-            <a:off x="457200" y="2953512"/>
-            <a:ext cx="3730752" cy="365760"/>
-          </a:xfrm>
-          <a:prstGeom prst="rect">
-            <a:avLst/>
-          </a:prstGeom>
-          <a:noFill/>
-          <a:ln/>
-        </p:spPr>
-        <p:txBody>
-          <a:bodyPr wrap="square" lIns="0" tIns="0" rIns="0" bIns="0" rtlCol="0" anchor="t"/>
-          <a:lstStyle/>
-          <a:p>
-            <a:pPr indent="0" marL="0">
-              <a:buNone/>
-            </a:pPr>
-            <a:r>
-              <a:rPr lang="en-US" sz="850" dirty="0">
-                <a:solidFill>
-                  <a:srgbClr val="595959"/>
-                </a:solidFill>
-                <a:latin typeface="Arial" pitchFamily="34" charset="0"/>
-                <a:ea typeface="Arial" pitchFamily="34" charset="-122"/>
-                <a:cs typeface="Arial" pitchFamily="34" charset="-120"/>
-              </a:rPr>
-              <a:t>Fed funds upper bound: hikes 2022–23, cuts 2024–25, a hike again on 16 Sep 2026 (median dot 4.1% for end-2026).</a:t>
-            </a:r>
-            <a:endParaRPr lang="en-US" sz="850" dirty="0"/>
-          </a:p>
-        </p:txBody>
-      </p:sp>
-      <p:sp>
-        <p:nvSpPr>
-          <p:cNvPr id="14" name="Shape 11"/>
-          <p:cNvSpPr/>
-          <p:nvPr/>
-        </p:nvSpPr>
-        <p:spPr>
-          <a:xfrm>
-            <a:off x="4370832" y="1325880"/>
-            <a:ext cx="3730752" cy="292608"/>
-          </a:xfrm>
-          <a:prstGeom prst="rect">
-            <a:avLst/>
-          </a:prstGeom>
-          <a:solidFill>
-            <a:srgbClr val="2C5F82"/>
-          </a:solidFill>
-          <a:ln w="12700">
-            <a:solidFill>
-              <a:srgbClr val="2C5F82"/>
-            </a:solidFill>
-            <a:prstDash val="solid"/>
-          </a:ln>
-        </p:spPr>
-      </p:sp>
-      <p:sp>
-        <p:nvSpPr>
-          <p:cNvPr id="15" name="Text 12"/>
-          <p:cNvSpPr txBox="1"/>
-          <p:nvPr/>
-        </p:nvSpPr>
-        <p:spPr>
-          <a:xfrm>
-            <a:off x="4370832" y="1325880"/>
-            <a:ext cx="3730752" cy="292608"/>
-          </a:xfrm>
-          <a:prstGeom prst="rect">
-            <a:avLst/>
-          </a:prstGeom>
-          <a:noFill/>
-          <a:ln/>
-        </p:spPr>
-        <p:txBody>
-          <a:bodyPr wrap="square" lIns="0" tIns="0" rIns="0" bIns="0" rtlCol="0" anchor="ctr"/>
-          <a:lstStyle/>
-          <a:p>
-            <a:pPr algn="ctr" indent="0" marL="0">
-              <a:buNone/>
-            </a:pPr>
-            <a:r>
-              <a:rPr lang="en-US" sz="1050" b="1" dirty="0">
-                <a:solidFill>
-                  <a:srgbClr val="FFFFFF"/>
-                </a:solidFill>
-                <a:latin typeface="Arial" pitchFamily="34" charset="0"/>
-                <a:ea typeface="Arial" pitchFamily="34" charset="-122"/>
-                <a:cs typeface="Arial" pitchFamily="34" charset="-120"/>
-              </a:rPr>
-              <a:t>Equity paths are violent</a:t>
-            </a:r>
-            <a:endParaRPr lang="en-US" sz="1050" dirty="0"/>
-          </a:p>
-        </p:txBody>
-      </p:sp>
-      <p:graphicFrame>
-        <p:nvGraphicFramePr>
-          <p:cNvPr id="16" name="Chart 1" descr=""/>
-          <p:cNvGraphicFramePr/>
-          <p:nvPr/>
-        </p:nvGraphicFramePr>
-        <p:xfrm>
-          <a:off x="4370832" y="1655064"/>
-          <a:ext cx="3730752" cy="1261872"/>
-        </p:xfrm>
-        <a:graphic xmlns:a="http://schemas.openxmlformats.org/drawingml/2006/main">
-          <a:graphicData uri="http://schemas.openxmlformats.org/drawingml/2006/chart">
-            <c:chart xmlns:c="http://schemas.openxmlformats.org/drawingml/2006/chart" r:id="rId2"/>
-          </a:graphicData>
-        </a:graphic>
-      </p:graphicFrame>
-      <p:sp>
-        <p:nvSpPr>
-          <p:cNvPr id="17" name="Text 13"/>
-          <p:cNvSpPr txBox="1"/>
-          <p:nvPr/>
-        </p:nvSpPr>
-        <p:spPr>
-          <a:xfrm>
-            <a:off x="4370832" y="2953512"/>
-            <a:ext cx="3730752" cy="365760"/>
-          </a:xfrm>
-          <a:prstGeom prst="rect">
-            <a:avLst/>
-          </a:prstGeom>
-          <a:noFill/>
-          <a:ln/>
-        </p:spPr>
-        <p:txBody>
-          <a:bodyPr wrap="square" lIns="0" tIns="0" rIns="0" bIns="0" rtlCol="0" anchor="t"/>
-          <a:lstStyle/>
-          <a:p>
-            <a:pPr indent="0" marL="0">
-              <a:buNone/>
-            </a:pPr>
-            <a:r>
-              <a:rPr lang="en-US" sz="850" dirty="0">
-                <a:solidFill>
-                  <a:srgbClr val="595959"/>
-                </a:solidFill>
-                <a:latin typeface="Arial" pitchFamily="34" charset="0"/>
-                <a:ea typeface="Arial" pitchFamily="34" charset="-122"/>
-                <a:cs typeface="Arial" pitchFamily="34" charset="-120"/>
-              </a:rPr>
-              <a:t>Index levels, end-2021 = 100: −10–25% in 2022, then 2–3×. KOSPI fell ~25% from June to late August 2026.</a:t>
-            </a:r>
-            <a:endParaRPr lang="en-US" sz="850" dirty="0"/>
-          </a:p>
-        </p:txBody>
-      </p:sp>
-      <p:sp>
-        <p:nvSpPr>
-          <p:cNvPr id="18" name="Shape 14"/>
-          <p:cNvSpPr/>
-          <p:nvPr/>
-        </p:nvSpPr>
-        <p:spPr>
-          <a:xfrm>
-            <a:off x="457200" y="3383280"/>
-            <a:ext cx="3730752" cy="292608"/>
-          </a:xfrm>
-          <a:prstGeom prst="rect">
-            <a:avLst/>
-          </a:prstGeom>
-          <a:solidFill>
-            <a:srgbClr val="2C5F82"/>
-          </a:solidFill>
-          <a:ln w="12700">
-            <a:solidFill>
-              <a:srgbClr val="2C5F82"/>
-            </a:solidFill>
-            <a:prstDash val="solid"/>
-          </a:ln>
-        </p:spPr>
-      </p:sp>
-      <p:sp>
-        <p:nvSpPr>
-          <p:cNvPr id="19" name="Text 15"/>
-          <p:cNvSpPr txBox="1"/>
-          <p:nvPr/>
-        </p:nvSpPr>
-        <p:spPr>
-          <a:xfrm>
-            <a:off x="457200" y="3383280"/>
-            <a:ext cx="3730752" cy="292608"/>
-          </a:xfrm>
-          <a:prstGeom prst="rect">
-            <a:avLst/>
-          </a:prstGeom>
-          <a:noFill/>
-          <a:ln/>
-        </p:spPr>
-        <p:txBody>
-          <a:bodyPr wrap="square" lIns="0" tIns="0" rIns="0" bIns="0" rtlCol="0" anchor="ctr"/>
-          <a:lstStyle/>
-          <a:p>
-            <a:pPr algn="ctr" indent="0" marL="0">
-              <a:buNone/>
-            </a:pPr>
-            <a:r>
-              <a:rPr lang="en-US" sz="1050" b="1" dirty="0">
-                <a:solidFill>
-                  <a:srgbClr val="FFFFFF"/>
-                </a:solidFill>
-                <a:latin typeface="Arial" pitchFamily="34" charset="0"/>
-                <a:ea typeface="Arial" pitchFamily="34" charset="-122"/>
-                <a:cs typeface="Arial" pitchFamily="34" charset="-120"/>
-              </a:rPr>
-              <a:t>Long bonds carry rate risk</a:t>
-            </a:r>
-            <a:endParaRPr lang="en-US" sz="1050" dirty="0"/>
-          </a:p>
-        </p:txBody>
-      </p:sp>
-      <p:graphicFrame>
-        <p:nvGraphicFramePr>
-          <p:cNvPr id="20" name="Chart 2" descr=""/>
-          <p:cNvGraphicFramePr/>
-          <p:nvPr/>
-        </p:nvGraphicFramePr>
-        <p:xfrm>
-          <a:off x="457200" y="3712464"/>
-          <a:ext cx="3730752" cy="1261872"/>
-        </p:xfrm>
-        <a:graphic xmlns:a="http://schemas.openxmlformats.org/drawingml/2006/main">
-          <a:graphicData uri="http://schemas.openxmlformats.org/drawingml/2006/chart">
-            <c:chart xmlns:c="http://schemas.openxmlformats.org/drawingml/2006/chart" r:id="rId3"/>
-          </a:graphicData>
-        </a:graphic>
-      </p:graphicFrame>
-      <p:sp>
-        <p:nvSpPr>
-          <p:cNvPr id="21" name="Text 16"/>
-          <p:cNvSpPr txBox="1"/>
-          <p:nvPr/>
-        </p:nvSpPr>
-        <p:spPr>
-          <a:xfrm>
-            <a:off x="457200" y="5010912"/>
-            <a:ext cx="3730752" cy="365760"/>
-          </a:xfrm>
-          <a:prstGeom prst="rect">
-            <a:avLst/>
-          </a:prstGeom>
-          <a:noFill/>
-          <a:ln/>
-        </p:spPr>
-        <p:txBody>
-          <a:bodyPr wrap="square" lIns="0" tIns="0" rIns="0" bIns="0" rtlCol="0" anchor="t"/>
-          <a:lstStyle/>
-          <a:p>
-            <a:pPr indent="0" marL="0">
-              <a:buNone/>
-            </a:pPr>
-            <a:r>
-              <a:rPr lang="en-US" sz="850" dirty="0">
-                <a:solidFill>
-                  <a:srgbClr val="595959"/>
-                </a:solidFill>
-                <a:latin typeface="Arial" pitchFamily="34" charset="0"/>
-                <a:ea typeface="Arial" pitchFamily="34" charset="-122"/>
-                <a:cs typeface="Arial" pitchFamily="34" charset="-120"/>
-              </a:rPr>
-              <a:t>Value change of a 5-year USD bond (5.69% coupon) for parallel rate moves of −2% to +2%.</a:t>
-            </a:r>
-            <a:endParaRPr lang="en-US" sz="850" dirty="0"/>
-          </a:p>
-        </p:txBody>
-      </p:sp>
-      <p:sp>
-        <p:nvSpPr>
-          <p:cNvPr id="22" name="Shape 17"/>
-          <p:cNvSpPr/>
-          <p:nvPr/>
-        </p:nvSpPr>
-        <p:spPr>
-          <a:xfrm>
-            <a:off x="4370832" y="3383280"/>
-            <a:ext cx="3730752" cy="292608"/>
-          </a:xfrm>
-          <a:prstGeom prst="rect">
-            <a:avLst/>
-          </a:prstGeom>
-          <a:solidFill>
-            <a:srgbClr val="2C5F82"/>
-          </a:solidFill>
-          <a:ln w="12700">
-            <a:solidFill>
-              <a:srgbClr val="2C5F82"/>
-            </a:solidFill>
-            <a:prstDash val="solid"/>
-          </a:ln>
-        </p:spPr>
-      </p:sp>
-      <p:sp>
-        <p:nvSpPr>
-          <p:cNvPr id="23" name="Text 18"/>
-          <p:cNvSpPr txBox="1"/>
-          <p:nvPr/>
-        </p:nvSpPr>
-        <p:spPr>
-          <a:xfrm>
-            <a:off x="4370832" y="3383280"/>
-            <a:ext cx="3730752" cy="292608"/>
-          </a:xfrm>
-          <a:prstGeom prst="rect">
-            <a:avLst/>
-          </a:prstGeom>
-          <a:noFill/>
-          <a:ln/>
-        </p:spPr>
-        <p:txBody>
-          <a:bodyPr wrap="square" lIns="0" tIns="0" rIns="0" bIns="0" rtlCol="0" anchor="ctr"/>
-          <a:lstStyle/>
-          <a:p>
-            <a:pPr algn="ctr" indent="0" marL="0">
-              <a:buNone/>
-            </a:pPr>
-            <a:r>
-              <a:rPr lang="en-US" sz="1050" b="1" dirty="0">
-                <a:solidFill>
-                  <a:srgbClr val="FFFFFF"/>
-                </a:solidFill>
-                <a:latin typeface="Arial" pitchFamily="34" charset="0"/>
-                <a:ea typeface="Arial" pitchFamily="34" charset="-122"/>
-                <a:cs typeface="Arial" pitchFamily="34" charset="-120"/>
-              </a:rPr>
-              <a:t>Valuations already price in a lot</a:t>
-            </a:r>
-            <a:endParaRPr lang="en-US" sz="1050" dirty="0"/>
-          </a:p>
-        </p:txBody>
-      </p:sp>
-      <p:graphicFrame>
-        <p:nvGraphicFramePr>
-          <p:cNvPr id="24" name="Chart 3" descr=""/>
-          <p:cNvGraphicFramePr/>
-          <p:nvPr/>
-        </p:nvGraphicFramePr>
-        <p:xfrm>
-          <a:off x="4370832" y="3712464"/>
-          <a:ext cx="3730752" cy="1261872"/>
-        </p:xfrm>
-        <a:graphic xmlns:a="http://schemas.openxmlformats.org/drawingml/2006/main">
-          <a:graphicData uri="http://schemas.openxmlformats.org/drawingml/2006/chart">
-            <c:chart xmlns:c="http://schemas.openxmlformats.org/drawingml/2006/chart" r:id="rId4"/>
-          </a:graphicData>
-        </a:graphic>
-      </p:graphicFrame>
-      <p:sp>
-        <p:nvSpPr>
-          <p:cNvPr id="25" name="Text 19"/>
-          <p:cNvSpPr txBox="1"/>
-          <p:nvPr/>
-        </p:nvSpPr>
-        <p:spPr>
-          <a:xfrm>
-            <a:off x="4370832" y="5010912"/>
-            <a:ext cx="3730752" cy="365760"/>
-          </a:xfrm>
-          <a:prstGeom prst="rect">
-            <a:avLst/>
-          </a:prstGeom>
-          <a:noFill/>
-          <a:ln/>
-        </p:spPr>
-        <p:txBody>
-          <a:bodyPr wrap="square" lIns="0" tIns="0" rIns="0" bIns="0" rtlCol="0" anchor="t"/>
-          <a:lstStyle/>
-          <a:p>
-            <a:pPr indent="0" marL="0">
-              <a:buNone/>
-            </a:pPr>
-            <a:r>
-              <a:rPr lang="en-US" sz="850" dirty="0">
-                <a:solidFill>
-                  <a:srgbClr val="595959"/>
-                </a:solidFill>
-                <a:latin typeface="Arial" pitchFamily="34" charset="0"/>
-                <a:ea typeface="Arial" pitchFamily="34" charset="-122"/>
-                <a:cs typeface="Arial" pitchFamily="34" charset="-120"/>
-              </a:rPr>
-              <a:t>Siblis Research, 1 Jul 2026. Korea's gap assumes earnings roughly triple; Nikkei CAPE 38.6×; Taiwan among the most expensive markets.</a:t>
-            </a:r>
-            <a:endParaRPr lang="en-US" sz="850" dirty="0"/>
-          </a:p>
-        </p:txBody>
-      </p:sp>
-      <p:sp>
-        <p:nvSpPr>
-          <p:cNvPr id="26" name="Text 20"/>
-          <p:cNvSpPr txBox="1"/>
-          <p:nvPr/>
-        </p:nvSpPr>
-        <p:spPr>
-          <a:xfrm>
-            <a:off x="8211312" y="1280160"/>
-            <a:ext cx="3520440" cy="320040"/>
-          </a:xfrm>
-          <a:prstGeom prst="rect">
-            <a:avLst/>
-          </a:prstGeom>
-          <a:noFill/>
-          <a:ln/>
-        </p:spPr>
-        <p:txBody>
-          <a:bodyPr wrap="square" lIns="0" tIns="0" rIns="0" bIns="0" rtlCol="0" anchor="t"/>
-          <a:lstStyle/>
-          <a:p>
-            <a:pPr algn="ctr" indent="0" marL="0">
-              <a:buNone/>
-            </a:pPr>
-            <a:r>
-              <a:rPr lang="en-US" sz="1500" b="1" dirty="0">
-                <a:solidFill>
-                  <a:srgbClr val="262626"/>
-                </a:solidFill>
-                <a:latin typeface="Arial" pitchFamily="34" charset="0"/>
-                <a:ea typeface="Arial" pitchFamily="34" charset="-122"/>
-                <a:cs typeface="Arial" pitchFamily="34" charset="-120"/>
-              </a:rPr>
-              <a:t>Implications</a:t>
-            </a:r>
-            <a:endParaRPr lang="en-US" sz="1500" dirty="0"/>
-          </a:p>
-        </p:txBody>
-      </p:sp>
-      <p:sp>
-        <p:nvSpPr>
-          <p:cNvPr id="27" name="Shape 21"/>
-          <p:cNvSpPr/>
-          <p:nvPr/>
-        </p:nvSpPr>
-        <p:spPr>
-          <a:xfrm>
-            <a:off x="8485632" y="1627632"/>
-            <a:ext cx="2971800" cy="0"/>
-          </a:xfrm>
-          <a:prstGeom prst="line">
-            <a:avLst/>
-          </a:prstGeom>
-          <a:noFill/>
-          <a:ln w="9525">
-            <a:solidFill>
-              <a:srgbClr val="2C5F82"/>
-            </a:solidFill>
-            <a:prstDash val="solid"/>
-          </a:ln>
-        </p:spPr>
-      </p:sp>
-      <p:sp>
-        <p:nvSpPr>
-          <p:cNvPr id="28" name="Text 22"/>
-          <p:cNvSpPr txBox="1"/>
-          <p:nvPr/>
-        </p:nvSpPr>
-        <p:spPr>
-          <a:xfrm>
-            <a:off x="8211312" y="1645920"/>
-            <a:ext cx="3520440" cy="274320"/>
-          </a:xfrm>
-          <a:prstGeom prst="rect">
-            <a:avLst/>
-          </a:prstGeom>
-          <a:noFill/>
-          <a:ln/>
-        </p:spPr>
-        <p:txBody>
-          <a:bodyPr wrap="square" lIns="0" tIns="0" rIns="0" bIns="0" rtlCol="0" anchor="t"/>
-          <a:lstStyle/>
-          <a:p>
-            <a:pPr algn="ctr" indent="0" marL="0">
-              <a:buNone/>
-            </a:pPr>
-            <a:r>
-              <a:rPr lang="en-US" sz="800" i="1" dirty="0">
-                <a:solidFill>
-                  <a:srgbClr val="595959"/>
-                </a:solidFill>
-                <a:latin typeface="Arial" pitchFamily="34" charset="0"/>
-                <a:ea typeface="Arial" pitchFamily="34" charset="-122"/>
-                <a:cs typeface="Arial" pitchFamily="34" charset="-120"/>
-              </a:rPr>
-              <a:t>Market proof: Taiwan structured-note issuance +81% in 2025, snowball autocalls the favourite payoff (SRP)</a:t>
-            </a:r>
-            <a:endParaRPr lang="en-US" sz="800" dirty="0"/>
-          </a:p>
-        </p:txBody>
-      </p:sp>
-      <p:sp>
-        <p:nvSpPr>
-          <p:cNvPr id="29" name="Shape 23"/>
-          <p:cNvSpPr/>
-          <p:nvPr/>
-        </p:nvSpPr>
-        <p:spPr>
-          <a:xfrm>
-            <a:off x="8211312" y="1938528"/>
-            <a:ext cx="3520440" cy="621792"/>
-          </a:xfrm>
-          <a:prstGeom prst="rect">
-            <a:avLst/>
-          </a:prstGeom>
-          <a:solidFill>
-            <a:srgbClr val="FFFFFF"/>
-          </a:solidFill>
-          <a:ln w="12700">
-            <a:solidFill>
-              <a:srgbClr val="2C5F82"/>
-            </a:solidFill>
-            <a:prstDash val="solid"/>
-          </a:ln>
-        </p:spPr>
-      </p:sp>
-      <p:sp>
-        <p:nvSpPr>
-          <p:cNvPr id="30" name="Text 24"/>
-          <p:cNvSpPr txBox="1"/>
-          <p:nvPr/>
-        </p:nvSpPr>
-        <p:spPr>
-          <a:xfrm>
-            <a:off x="8257032" y="1938528"/>
-            <a:ext cx="411480" cy="621792"/>
-          </a:xfrm>
-          <a:prstGeom prst="rect">
-            <a:avLst/>
-          </a:prstGeom>
-          <a:noFill/>
-          <a:ln/>
-        </p:spPr>
-        <p:txBody>
-          <a:bodyPr wrap="square" lIns="0" tIns="0" rIns="0" bIns="0" rtlCol="0" anchor="ctr"/>
-          <a:lstStyle/>
-          <a:p>
-            <a:pPr algn="ctr" indent="0" marL="0">
-              <a:buNone/>
-            </a:pPr>
-            <a:r>
-              <a:rPr lang="en-US" sz="2200" b="1" i="1" dirty="0">
-                <a:solidFill>
-                  <a:srgbClr val="2C5F82"/>
-                </a:solidFill>
-                <a:latin typeface="Arial" pitchFamily="34" charset="0"/>
-                <a:ea typeface="Arial" pitchFamily="34" charset="-122"/>
-                <a:cs typeface="Arial" pitchFamily="34" charset="-120"/>
-              </a:rPr>
-              <a:t>1</a:t>
-            </a:r>
-            <a:endParaRPr lang="en-US" sz="2200" dirty="0"/>
-          </a:p>
-        </p:txBody>
-      </p:sp>
-      <p:sp>
-        <p:nvSpPr>
-          <p:cNvPr id="31" name="Text 25"/>
-          <p:cNvSpPr txBox="1"/>
-          <p:nvPr/>
-        </p:nvSpPr>
-        <p:spPr>
-          <a:xfrm>
-            <a:off x="8714232" y="1956816"/>
-            <a:ext cx="2926080" cy="585216"/>
-          </a:xfrm>
-          <a:prstGeom prst="rect">
-            <a:avLst/>
-          </a:prstGeom>
-          <a:noFill/>
-          <a:ln/>
-        </p:spPr>
-        <p:txBody>
-          <a:bodyPr wrap="square" lIns="0" tIns="0" rIns="0" bIns="0" rtlCol="0" anchor="ctr"/>
-          <a:lstStyle/>
-          <a:p>
-            <a:pPr indent="0" marL="0">
-              <a:buNone/>
-            </a:pPr>
-            <a:r>
-              <a:rPr lang="en-US" sz="880" b="1" dirty="0">
-                <a:solidFill>
-                  <a:srgbClr val="262626"/>
-                </a:solidFill>
-                <a:latin typeface="Arial" pitchFamily="34" charset="0"/>
-                <a:ea typeface="Arial" pitchFamily="34" charset="-122"/>
-                <a:cs typeface="Arial" pitchFamily="34" charset="-120"/>
-              </a:rPr>
-              <a:t>Early exit beats duration: </a:t>
-            </a:r>
-            <a:pPr indent="0" marL="0">
-              <a:buNone/>
-            </a:pPr>
-            <a:r>
-              <a:rPr lang="en-US" sz="880" dirty="0">
-                <a:solidFill>
-                  <a:srgbClr val="595959"/>
-                </a:solidFill>
-                <a:latin typeface="Arial" pitchFamily="34" charset="0"/>
-                <a:ea typeface="Arial" pitchFamily="34" charset="-122"/>
-                <a:cs typeface="Arial" pitchFamily="34" charset="-120"/>
-              </a:rPr>
-              <a:t>Bonds lose ~4.0% per 1% rate rise; autocalls can redeem from year 1</a:t>
-            </a:r>
-            <a:endParaRPr lang="en-US" sz="880" dirty="0"/>
-          </a:p>
-        </p:txBody>
-      </p:sp>
-      <p:sp>
-        <p:nvSpPr>
-          <p:cNvPr id="32" name="Shape 26"/>
-          <p:cNvSpPr/>
-          <p:nvPr/>
-        </p:nvSpPr>
-        <p:spPr>
-          <a:xfrm>
-            <a:off x="8211312" y="2633472"/>
-            <a:ext cx="3520440" cy="621792"/>
-          </a:xfrm>
-          <a:prstGeom prst="rect">
-            <a:avLst/>
-          </a:prstGeom>
-          <a:solidFill>
-            <a:srgbClr val="FFFFFF"/>
-          </a:solidFill>
-          <a:ln w="12700">
-            <a:solidFill>
-              <a:srgbClr val="2C5F82"/>
-            </a:solidFill>
-            <a:prstDash val="solid"/>
-          </a:ln>
-        </p:spPr>
-      </p:sp>
-      <p:sp>
-        <p:nvSpPr>
-          <p:cNvPr id="33" name="Text 27"/>
-          <p:cNvSpPr txBox="1"/>
-          <p:nvPr/>
-        </p:nvSpPr>
-        <p:spPr>
-          <a:xfrm>
-            <a:off x="8257032" y="2633472"/>
-            <a:ext cx="411480" cy="621792"/>
-          </a:xfrm>
-          <a:prstGeom prst="rect">
-            <a:avLst/>
-          </a:prstGeom>
-          <a:noFill/>
-          <a:ln/>
-        </p:spPr>
-        <p:txBody>
-          <a:bodyPr wrap="square" lIns="0" tIns="0" rIns="0" bIns="0" rtlCol="0" anchor="ctr"/>
-          <a:lstStyle/>
-          <a:p>
-            <a:pPr algn="ctr" indent="0" marL="0">
-              <a:buNone/>
-            </a:pPr>
-            <a:r>
-              <a:rPr lang="en-US" sz="2200" b="1" i="1" dirty="0">
-                <a:solidFill>
-                  <a:srgbClr val="2C5F82"/>
-                </a:solidFill>
-                <a:latin typeface="Arial" pitchFamily="34" charset="0"/>
-                <a:ea typeface="Arial" pitchFamily="34" charset="-122"/>
-                <a:cs typeface="Arial" pitchFamily="34" charset="-120"/>
-              </a:rPr>
-              <a:t>2</a:t>
-            </a:r>
-            <a:endParaRPr lang="en-US" sz="2200" dirty="0"/>
-          </a:p>
-        </p:txBody>
-      </p:sp>
-      <p:sp>
-        <p:nvSpPr>
-          <p:cNvPr id="34" name="Text 28"/>
-          <p:cNvSpPr txBox="1"/>
-          <p:nvPr/>
-        </p:nvSpPr>
-        <p:spPr>
-          <a:xfrm>
-            <a:off x="8714232" y="2651760"/>
-            <a:ext cx="2926080" cy="585216"/>
-          </a:xfrm>
-          <a:prstGeom prst="rect">
-            <a:avLst/>
-          </a:prstGeom>
-          <a:noFill/>
-          <a:ln/>
-        </p:spPr>
-        <p:txBody>
-          <a:bodyPr wrap="square" lIns="0" tIns="0" rIns="0" bIns="0" rtlCol="0" anchor="ctr"/>
-          <a:lstStyle/>
-          <a:p>
-            <a:pPr indent="0" marL="0">
-              <a:buNone/>
-            </a:pPr>
-            <a:r>
-              <a:rPr lang="en-US" sz="880" b="1" dirty="0">
-                <a:solidFill>
-                  <a:srgbClr val="262626"/>
-                </a:solidFill>
-                <a:latin typeface="Arial" pitchFamily="34" charset="0"/>
-                <a:ea typeface="Arial" pitchFamily="34" charset="-122"/>
-                <a:cs typeface="Arial" pitchFamily="34" charset="-120"/>
-              </a:rPr>
-              <a:t>Paid on recovery, not timing: </a:t>
-            </a:r>
-            <a:pPr indent="0" marL="0">
-              <a:buNone/>
-            </a:pPr>
-            <a:r>
-              <a:rPr lang="en-US" sz="880" dirty="0">
-                <a:solidFill>
-                  <a:srgbClr val="595959"/>
-                </a:solidFill>
-                <a:latin typeface="Arial" pitchFamily="34" charset="0"/>
-                <a:ea typeface="Arial" pitchFamily="34" charset="-122"/>
-                <a:cs typeface="Arial" pitchFamily="34" charset="-120"/>
-              </a:rPr>
-              <a:t>−25% in ten weeks (KOSPI 2026): autocall coupons pay once the basket is back at its start</a:t>
-            </a:r>
-            <a:endParaRPr lang="en-US" sz="880" dirty="0"/>
-          </a:p>
-        </p:txBody>
-      </p:sp>
-      <p:sp>
-        <p:nvSpPr>
-          <p:cNvPr id="35" name="Shape 29"/>
-          <p:cNvSpPr/>
-          <p:nvPr/>
-        </p:nvSpPr>
-        <p:spPr>
-          <a:xfrm>
-            <a:off x="8211312" y="3328416"/>
-            <a:ext cx="3520440" cy="621792"/>
-          </a:xfrm>
-          <a:prstGeom prst="rect">
-            <a:avLst/>
-          </a:prstGeom>
-          <a:solidFill>
-            <a:srgbClr val="FFFFFF"/>
-          </a:solidFill>
-          <a:ln w="12700">
-            <a:solidFill>
-              <a:srgbClr val="2C5F82"/>
-            </a:solidFill>
-            <a:prstDash val="solid"/>
-          </a:ln>
-        </p:spPr>
-      </p:sp>
-      <p:sp>
-        <p:nvSpPr>
-          <p:cNvPr id="36" name="Text 30"/>
-          <p:cNvSpPr txBox="1"/>
-          <p:nvPr/>
-        </p:nvSpPr>
-        <p:spPr>
-          <a:xfrm>
-            <a:off x="8257032" y="3328416"/>
-            <a:ext cx="411480" cy="621792"/>
-          </a:xfrm>
-          <a:prstGeom prst="rect">
-            <a:avLst/>
-          </a:prstGeom>
-          <a:noFill/>
-          <a:ln/>
-        </p:spPr>
-        <p:txBody>
-          <a:bodyPr wrap="square" lIns="0" tIns="0" rIns="0" bIns="0" rtlCol="0" anchor="ctr"/>
-          <a:lstStyle/>
-          <a:p>
-            <a:pPr algn="ctr" indent="0" marL="0">
-              <a:buNone/>
-            </a:pPr>
-            <a:r>
-              <a:rPr lang="en-US" sz="2200" b="1" i="1" dirty="0">
-                <a:solidFill>
-                  <a:srgbClr val="2C5F82"/>
-                </a:solidFill>
-                <a:latin typeface="Arial" pitchFamily="34" charset="0"/>
-                <a:ea typeface="Arial" pitchFamily="34" charset="-122"/>
-                <a:cs typeface="Arial" pitchFamily="34" charset="-120"/>
-              </a:rPr>
-              <a:t>3</a:t>
-            </a:r>
-            <a:endParaRPr lang="en-US" sz="2200" dirty="0"/>
-          </a:p>
-        </p:txBody>
-      </p:sp>
-      <p:sp>
-        <p:nvSpPr>
-          <p:cNvPr id="37" name="Text 31"/>
-          <p:cNvSpPr txBox="1"/>
-          <p:nvPr/>
-        </p:nvSpPr>
-        <p:spPr>
-          <a:xfrm>
-            <a:off x="8714232" y="3346704"/>
-            <a:ext cx="2926080" cy="585216"/>
-          </a:xfrm>
-          <a:prstGeom prst="rect">
-            <a:avLst/>
-          </a:prstGeom>
-          <a:noFill/>
-          <a:ln/>
-        </p:spPr>
-        <p:txBody>
-          <a:bodyPr wrap="square" lIns="0" tIns="0" rIns="0" bIns="0" rtlCol="0" anchor="ctr"/>
-          <a:lstStyle/>
-          <a:p>
-            <a:pPr indent="0" marL="0">
-              <a:buNone/>
-            </a:pPr>
-            <a:r>
-              <a:rPr lang="en-US" sz="880" b="1" dirty="0">
-                <a:solidFill>
-                  <a:srgbClr val="262626"/>
-                </a:solidFill>
-                <a:latin typeface="Arial" pitchFamily="34" charset="0"/>
-                <a:ea typeface="Arial" pitchFamily="34" charset="-122"/>
-                <a:cs typeface="Arial" pitchFamily="34" charset="-120"/>
-              </a:rPr>
-              <a:t>Diversify the basket: </a:t>
-            </a:r>
-            <a:pPr indent="0" marL="0">
-              <a:buNone/>
-            </a:pPr>
-            <a:r>
-              <a:rPr lang="en-US" sz="880" dirty="0">
-                <a:solidFill>
-                  <a:srgbClr val="595959"/>
-                </a:solidFill>
-                <a:latin typeface="Arial" pitchFamily="34" charset="0"/>
-                <a:ea typeface="Arial" pitchFamily="34" charset="-122"/>
-                <a:cs typeface="Arial" pitchFamily="34" charset="-120"/>
-              </a:rPr>
-              <a:t>TSMC &gt;40% of TAIEX, ~92% of advanced chips from Taiwan: use a diversified ETF basket, not worst-of</a:t>
-            </a:r>
-            <a:endParaRPr lang="en-US" sz="880" dirty="0"/>
-          </a:p>
-        </p:txBody>
-      </p:sp>
-      <p:sp>
-        <p:nvSpPr>
-          <p:cNvPr id="38" name="Shape 32"/>
-          <p:cNvSpPr/>
-          <p:nvPr/>
-        </p:nvSpPr>
-        <p:spPr>
-          <a:xfrm>
-            <a:off x="8211312" y="4023360"/>
-            <a:ext cx="3520440" cy="621792"/>
-          </a:xfrm>
-          <a:prstGeom prst="rect">
-            <a:avLst/>
-          </a:prstGeom>
-          <a:solidFill>
-            <a:srgbClr val="FFFFFF"/>
-          </a:solidFill>
-          <a:ln w="12700">
-            <a:solidFill>
-              <a:srgbClr val="2C5F82"/>
-            </a:solidFill>
-            <a:prstDash val="solid"/>
-          </a:ln>
-        </p:spPr>
-      </p:sp>
-      <p:sp>
-        <p:nvSpPr>
-          <p:cNvPr id="39" name="Text 33"/>
-          <p:cNvSpPr txBox="1"/>
-          <p:nvPr/>
-        </p:nvSpPr>
-        <p:spPr>
-          <a:xfrm>
-            <a:off x="8257032" y="4023360"/>
-            <a:ext cx="411480" cy="621792"/>
-          </a:xfrm>
-          <a:prstGeom prst="rect">
-            <a:avLst/>
-          </a:prstGeom>
-          <a:noFill/>
-          <a:ln/>
-        </p:spPr>
-        <p:txBody>
-          <a:bodyPr wrap="square" lIns="0" tIns="0" rIns="0" bIns="0" rtlCol="0" anchor="ctr"/>
-          <a:lstStyle/>
-          <a:p>
-            <a:pPr algn="ctr" indent="0" marL="0">
-              <a:buNone/>
-            </a:pPr>
-            <a:r>
-              <a:rPr lang="en-US" sz="2200" b="1" i="1" dirty="0">
-                <a:solidFill>
-                  <a:srgbClr val="2C5F82"/>
-                </a:solidFill>
-                <a:latin typeface="Arial" pitchFamily="34" charset="0"/>
-                <a:ea typeface="Arial" pitchFamily="34" charset="-122"/>
-                <a:cs typeface="Arial" pitchFamily="34" charset="-120"/>
-              </a:rPr>
-              <a:t>4</a:t>
-            </a:r>
-            <a:endParaRPr lang="en-US" sz="2200" dirty="0"/>
-          </a:p>
-        </p:txBody>
-      </p:sp>
-      <p:sp>
-        <p:nvSpPr>
-          <p:cNvPr id="40" name="Text 34"/>
-          <p:cNvSpPr txBox="1"/>
-          <p:nvPr/>
-        </p:nvSpPr>
-        <p:spPr>
-          <a:xfrm>
-            <a:off x="8714232" y="4041648"/>
-            <a:ext cx="2926080" cy="585216"/>
-          </a:xfrm>
-          <a:prstGeom prst="rect">
-            <a:avLst/>
-          </a:prstGeom>
-          <a:noFill/>
-          <a:ln/>
-        </p:spPr>
-        <p:txBody>
-          <a:bodyPr wrap="square" lIns="0" tIns="0" rIns="0" bIns="0" rtlCol="0" anchor="ctr"/>
-          <a:lstStyle/>
-          <a:p>
-            <a:pPr indent="0" marL="0">
-              <a:buNone/>
-            </a:pPr>
-            <a:r>
-              <a:rPr lang="en-US" sz="880" b="1" dirty="0">
-                <a:solidFill>
-                  <a:srgbClr val="262626"/>
-                </a:solidFill>
-                <a:latin typeface="Arial" pitchFamily="34" charset="0"/>
-                <a:ea typeface="Arial" pitchFamily="34" charset="-122"/>
-                <a:cs typeface="Arial" pitchFamily="34" charset="-120"/>
-              </a:rPr>
-              <a:t>Volatility funds the coupon: </a:t>
-            </a:r>
-            <a:pPr indent="0" marL="0">
-              <a:buNone/>
-            </a:pPr>
-            <a:r>
-              <a:rPr lang="en-US" sz="880" dirty="0">
-                <a:solidFill>
-                  <a:srgbClr val="595959"/>
-                </a:solidFill>
-                <a:latin typeface="Arial" pitchFamily="34" charset="0"/>
-                <a:ea typeface="Arial" pitchFamily="34" charset="-122"/>
-                <a:cs typeface="Arial" pitchFamily="34" charset="-120"/>
-              </a:rPr>
-              <a:t>VKOSPI at a record 91.2: richer option premium means higher autocall coupons</a:t>
-            </a:r>
-            <a:endParaRPr lang="en-US" sz="880" dirty="0"/>
-          </a:p>
-        </p:txBody>
-      </p:sp>
-      <p:sp>
-        <p:nvSpPr>
-          <p:cNvPr id="41" name="Shape 35"/>
-          <p:cNvSpPr/>
-          <p:nvPr/>
-        </p:nvSpPr>
-        <p:spPr>
-          <a:xfrm>
-            <a:off x="8211312" y="4718304"/>
-            <a:ext cx="3520440" cy="621792"/>
-          </a:xfrm>
-          <a:prstGeom prst="rect">
-            <a:avLst/>
-          </a:prstGeom>
-          <a:solidFill>
-            <a:srgbClr val="FFFFFF"/>
-          </a:solidFill>
-          <a:ln w="12700">
-            <a:solidFill>
-              <a:srgbClr val="2C5F82"/>
-            </a:solidFill>
-            <a:prstDash val="solid"/>
-          </a:ln>
-        </p:spPr>
-      </p:sp>
-      <p:sp>
-        <p:nvSpPr>
-          <p:cNvPr id="42" name="Text 36"/>
-          <p:cNvSpPr txBox="1"/>
-          <p:nvPr/>
-        </p:nvSpPr>
-        <p:spPr>
-          <a:xfrm>
-            <a:off x="8257032" y="4718304"/>
-            <a:ext cx="411480" cy="621792"/>
-          </a:xfrm>
-          <a:prstGeom prst="rect">
-            <a:avLst/>
-          </a:prstGeom>
-          <a:noFill/>
-          <a:ln/>
-        </p:spPr>
-        <p:txBody>
-          <a:bodyPr wrap="square" lIns="0" tIns="0" rIns="0" bIns="0" rtlCol="0" anchor="ctr"/>
-          <a:lstStyle/>
-          <a:p>
-            <a:pPr algn="ctr" indent="0" marL="0">
-              <a:buNone/>
-            </a:pPr>
-            <a:r>
-              <a:rPr lang="en-US" sz="2200" b="1" i="1" dirty="0">
-                <a:solidFill>
-                  <a:srgbClr val="2C5F82"/>
-                </a:solidFill>
-                <a:latin typeface="Arial" pitchFamily="34" charset="0"/>
-                <a:ea typeface="Arial" pitchFamily="34" charset="-122"/>
-                <a:cs typeface="Arial" pitchFamily="34" charset="-120"/>
-              </a:rPr>
-              <a:t>5</a:t>
-            </a:r>
-            <a:endParaRPr lang="en-US" sz="2200" dirty="0"/>
-          </a:p>
-        </p:txBody>
-      </p:sp>
-      <p:sp>
-        <p:nvSpPr>
-          <p:cNvPr id="43" name="Text 37"/>
-          <p:cNvSpPr txBox="1"/>
-          <p:nvPr/>
-        </p:nvSpPr>
-        <p:spPr>
-          <a:xfrm>
-            <a:off x="8714232" y="4736592"/>
-            <a:ext cx="2926080" cy="585216"/>
-          </a:xfrm>
-          <a:prstGeom prst="rect">
-            <a:avLst/>
-          </a:prstGeom>
-          <a:noFill/>
-          <a:ln/>
-        </p:spPr>
-        <p:txBody>
-          <a:bodyPr wrap="square" lIns="0" tIns="0" rIns="0" bIns="0" rtlCol="0" anchor="ctr"/>
-          <a:lstStyle/>
-          <a:p>
-            <a:pPr indent="0" marL="0">
-              <a:buNone/>
-            </a:pPr>
-            <a:r>
-              <a:rPr lang="en-US" sz="880" b="1" dirty="0">
-                <a:solidFill>
-                  <a:srgbClr val="262626"/>
-                </a:solidFill>
-                <a:latin typeface="Arial" pitchFamily="34" charset="0"/>
-                <a:ea typeface="Arial" pitchFamily="34" charset="-122"/>
-                <a:cs typeface="Arial" pitchFamily="34" charset="-120"/>
-              </a:rPr>
-              <a:t>Protection is affordable: </a:t>
-            </a:r>
-            <a:pPr indent="0" marL="0">
-              <a:buNone/>
-            </a:pPr>
-            <a:r>
-              <a:rPr lang="en-US" sz="880" dirty="0">
-                <a:solidFill>
-                  <a:srgbClr val="595959"/>
-                </a:solidFill>
-                <a:latin typeface="Arial" pitchFamily="34" charset="0"/>
-                <a:ea typeface="Arial" pitchFamily="34" charset="-122"/>
-                <a:cs typeface="Arial" pitchFamily="34" charset="-120"/>
-              </a:rPr>
-              <a:t>USD 100 in 5 years costs USD 75.8 at 5.69%: a buffer and a 70% floor fit inside an autocall</a:t>
-            </a:r>
-            <a:endParaRPr lang="en-US" sz="880" dirty="0"/>
-          </a:p>
-        </p:txBody>
-      </p:sp>
-      <p:sp>
-        <p:nvSpPr>
-          <p:cNvPr id="44" name="Shape 38"/>
-          <p:cNvSpPr/>
-          <p:nvPr/>
-        </p:nvSpPr>
-        <p:spPr>
-          <a:xfrm>
-            <a:off x="457200" y="5486400"/>
-            <a:ext cx="11274552" cy="438912"/>
-          </a:xfrm>
-          <a:prstGeom prst="rect">
-            <a:avLst/>
-          </a:prstGeom>
-          <a:solidFill>
-            <a:srgbClr val="2C5F82"/>
-          </a:solidFill>
-          <a:ln w="12700">
-            <a:solidFill>
-              <a:srgbClr val="2C5F82"/>
-            </a:solidFill>
-            <a:prstDash val="solid"/>
-          </a:ln>
-        </p:spPr>
-      </p:sp>
-      <p:sp>
-        <p:nvSpPr>
-          <p:cNvPr id="45" name="Text 39"/>
-          <p:cNvSpPr txBox="1"/>
-          <p:nvPr/>
-        </p:nvSpPr>
-        <p:spPr>
-          <a:xfrm>
-            <a:off x="594360" y="5486400"/>
-            <a:ext cx="11000232" cy="438912"/>
-          </a:xfrm>
-          <a:prstGeom prst="rect">
-            <a:avLst/>
-          </a:prstGeom>
-          <a:noFill/>
-          <a:ln/>
-        </p:spPr>
-        <p:txBody>
-          <a:bodyPr wrap="square" lIns="0" tIns="0" rIns="0" bIns="0" rtlCol="0" anchor="ctr"/>
-          <a:lstStyle/>
-          <a:p>
-            <a:pPr algn="ctr" indent="0" marL="0">
-              <a:buNone/>
-            </a:pPr>
-            <a:r>
-              <a:rPr lang="en-US" sz="1200" b="1" dirty="0">
-                <a:solidFill>
-                  <a:srgbClr val="FFFFFF"/>
-                </a:solidFill>
-                <a:latin typeface="Arial" pitchFamily="34" charset="0"/>
-                <a:ea typeface="Arial" pitchFamily="34" charset="-122"/>
-                <a:cs typeface="Arial" pitchFamily="34" charset="-120"/>
-              </a:rPr>
-              <a:t>Plain bonds and equities leave investors exposed; a buffered autocall with a 70% floor keeps the theme and manages the risks.</a:t>
-            </a:r>
-            <a:endParaRPr lang="en-US" sz="1200" dirty="0"/>
-          </a:p>
-        </p:txBody>
-      </p:sp>
-      <p:sp>
-        <p:nvSpPr>
-          <p:cNvPr id="46" name="Text 40"/>
-          <p:cNvSpPr txBox="1"/>
-          <p:nvPr/>
-        </p:nvSpPr>
-        <p:spPr>
-          <a:xfrm>
-            <a:off x="457200" y="5998464"/>
-            <a:ext cx="11274552" cy="274320"/>
-          </a:xfrm>
-          <a:prstGeom prst="rect">
-            <a:avLst/>
-          </a:prstGeom>
-          <a:noFill/>
-          <a:ln/>
-        </p:spPr>
-        <p:txBody>
-          <a:bodyPr wrap="square" lIns="0" tIns="0" rIns="0" bIns="0" rtlCol="0" anchor="t"/>
-          <a:lstStyle/>
-          <a:p>
-            <a:pPr indent="0" marL="0">
-              <a:buNone/>
-            </a:pPr>
-            <a:r>
-              <a:rPr lang="en-US" sz="800" i="1" dirty="0">
-                <a:solidFill>
-                  <a:srgbClr val="595959"/>
-                </a:solidFill>
-                <a:latin typeface="Arial" pitchFamily="34" charset="0"/>
-                <a:ea typeface="Arial" pitchFamily="34" charset="-122"/>
-                <a:cs typeface="Arial" pitchFamily="34" charset="-120"/>
-              </a:rPr>
-              <a:t>Sources: Federal Reserve via Advisor Perspectives; TWSE, KRX/press, Nikkei (index levels); Siblis Research (P/E); Herald / SBS (VKOSPI); TrendForce; J.P. Morgan 2026 Outlook; StructuredRetailProducts.com; case funding grid with standard bond maths.</a:t>
-            </a:r>
-            <a:endParaRPr lang="en-US" sz="800" dirty="0"/>
-          </a:p>
-        </p:txBody>
-      </p:sp>
-    </p:spTree>
-  </p:cSld>
-  <p:clrMapOvr>
-    <a:masterClrMapping/>
-  </p:clrMapOvr>
-</p:sld>
-</file>
-
-<file path=ppt/slides/slide6.xml><?xml version="1.0" encoding="utf-8"?>
-<p:sld xmlns:a="http://schemas.openxmlformats.org/drawingml/2006/main" xmlns:r="http://schemas.openxmlformats.org/officeDocument/2006/relationships" xmlns:p="http://schemas.openxmlformats.org/presentationml/2006/main">
-  <p:cSld name="Slide 6">
-    <p:bg>
-      <p:bgPr>
-        <a:solidFill>
-          <a:srgbClr val="FFFFFF"/>
-        </a:solidFill>
-      </p:bgPr>
-    </p:bg>
-    <p:spTree>
-      <p:nvGrpSpPr>
-        <p:cNvPr id="1" name=""/>
-        <p:cNvGrpSpPr/>
-        <p:nvPr/>
-      </p:nvGrpSpPr>
-      <p:grpSpPr>
-        <a:xfrm>
-          <a:off x="0" y="0"/>
-          <a:ext cx="0" cy="0"/>
-          <a:chOff x="0" y="0"/>
-          <a:chExt cx="0" cy="0"/>
-        </a:xfrm>
-      </p:grpSpPr>
-      <p:sp>
-        <p:nvSpPr>
-          <p:cNvPr id="2" name="Text 0"/>
-          <p:cNvSpPr txBox="1"/>
-          <p:nvPr/>
-        </p:nvSpPr>
-        <p:spPr>
-          <a:xfrm>
-            <a:off x="457200" y="274320"/>
-            <a:ext cx="11247120" cy="548640"/>
-          </a:xfrm>
-          <a:prstGeom prst="rect">
-            <a:avLst/>
-          </a:prstGeom>
-          <a:noFill/>
-          <a:ln/>
-        </p:spPr>
-        <p:txBody>
-          <a:bodyPr wrap="square" lIns="0" tIns="0" rIns="0" bIns="0" rtlCol="0" anchor="ctr"/>
-          <a:lstStyle/>
-          <a:p>
-            <a:pPr indent="0" marL="0">
-              <a:buNone/>
-            </a:pPr>
-            <a:r>
-              <a:rPr lang="en-US" sz="2400" dirty="0">
-                <a:solidFill>
-                  <a:srgbClr val="262626"/>
-                </a:solidFill>
-                <a:latin typeface="Arial" pitchFamily="34" charset="0"/>
-                <a:ea typeface="Arial" pitchFamily="34" charset="-122"/>
-                <a:cs typeface="Arial" pitchFamily="34" charset="-120"/>
-              </a:rPr>
-              <a:t>Appendix: sources for the investment thesis</a:t>
-            </a:r>
-            <a:endParaRPr lang="en-US" sz="2400" dirty="0"/>
-          </a:p>
-        </p:txBody>
-      </p:sp>
-      <p:sp>
-        <p:nvSpPr>
-          <p:cNvPr id="3" name="Shape 1"/>
-          <p:cNvSpPr/>
-          <p:nvPr/>
-        </p:nvSpPr>
-        <p:spPr>
-          <a:xfrm>
-            <a:off x="457200" y="896112"/>
-            <a:ext cx="11274552" cy="0"/>
-          </a:xfrm>
-          <a:prstGeom prst="line">
-            <a:avLst/>
-          </a:prstGeom>
-          <a:noFill/>
-          <a:ln w="12700">
-            <a:solidFill>
-              <a:srgbClr val="2C5F82"/>
-            </a:solidFill>
-            <a:prstDash val="solid"/>
-          </a:ln>
-        </p:spPr>
-      </p:sp>
-      <p:sp>
-        <p:nvSpPr>
-          <p:cNvPr id="4" name="Shape 2"/>
-          <p:cNvSpPr/>
-          <p:nvPr/>
-        </p:nvSpPr>
-        <p:spPr>
-          <a:xfrm>
-            <a:off x="457200" y="6382512"/>
-            <a:ext cx="11274552" cy="0"/>
-          </a:xfrm>
-          <a:prstGeom prst="line">
-            <a:avLst/>
-          </a:prstGeom>
-          <a:noFill/>
-          <a:ln w="9525">
-            <a:solidFill>
-              <a:srgbClr val="BFBFBF"/>
-            </a:solidFill>
-            <a:prstDash val="solid"/>
-          </a:ln>
-        </p:spPr>
-      </p:sp>
-      <p:sp>
-        <p:nvSpPr>
-          <p:cNvPr id="5" name="Text 3"/>
-          <p:cNvSpPr txBox="1"/>
-          <p:nvPr/>
-        </p:nvSpPr>
-        <p:spPr>
-          <a:xfrm>
-            <a:off x="457200" y="6446520"/>
-            <a:ext cx="3611880" cy="274320"/>
-          </a:xfrm>
-          <a:prstGeom prst="rect">
-            <a:avLst/>
-          </a:prstGeom>
-          <a:noFill/>
-          <a:ln/>
-        </p:spPr>
-        <p:txBody>
-          <a:bodyPr wrap="square" lIns="0" tIns="0" rIns="0" bIns="0" rtlCol="0" anchor="t"/>
-          <a:lstStyle/>
-          <a:p>
-            <a:pPr algn="ctr" indent="0" marL="0">
-              <a:buNone/>
-            </a:pPr>
-            <a:r>
-              <a:rPr lang="en-US" sz="1200" spc="100" kern="0" dirty="0">
-                <a:solidFill>
-                  <a:srgbClr val="595959"/>
-                </a:solidFill>
-                <a:latin typeface="Arial" pitchFamily="34" charset="0"/>
-                <a:ea typeface="Arial" pitchFamily="34" charset="-122"/>
-                <a:cs typeface="Arial" pitchFamily="34" charset="-120"/>
-              </a:rPr>
-              <a:t>ANALYSIS</a:t>
-            </a:r>
-            <a:endParaRPr lang="en-US" sz="1200" dirty="0"/>
-          </a:p>
-        </p:txBody>
-      </p:sp>
-      <p:sp>
-        <p:nvSpPr>
-          <p:cNvPr id="6" name="Text 4"/>
-          <p:cNvSpPr txBox="1"/>
-          <p:nvPr/>
-        </p:nvSpPr>
-        <p:spPr>
-          <a:xfrm>
-            <a:off x="4288536" y="6446520"/>
-            <a:ext cx="3611880" cy="274320"/>
-          </a:xfrm>
-          <a:prstGeom prst="rect">
-            <a:avLst/>
-          </a:prstGeom>
-          <a:noFill/>
-          <a:ln/>
-        </p:spPr>
-        <p:txBody>
-          <a:bodyPr wrap="square" lIns="0" tIns="0" rIns="0" bIns="0" rtlCol="0" anchor="t"/>
-          <a:lstStyle/>
-          <a:p>
-            <a:pPr algn="ctr" indent="0" marL="0">
-              <a:buNone/>
-            </a:pPr>
-            <a:r>
-              <a:rPr lang="en-US" sz="1200" spc="100" kern="0" dirty="0">
-                <a:solidFill>
-                  <a:srgbClr val="595959"/>
-                </a:solidFill>
-                <a:latin typeface="Arial" pitchFamily="34" charset="0"/>
-                <a:ea typeface="Arial" pitchFamily="34" charset="-122"/>
-                <a:cs typeface="Arial" pitchFamily="34" charset="-120"/>
-              </a:rPr>
-              <a:t>STRATEGY</a:t>
-            </a:r>
-            <a:endParaRPr lang="en-US" sz="1200" dirty="0"/>
-          </a:p>
-        </p:txBody>
-      </p:sp>
-      <p:sp>
-        <p:nvSpPr>
-          <p:cNvPr id="7" name="Shape 5"/>
-          <p:cNvSpPr/>
-          <p:nvPr/>
-        </p:nvSpPr>
-        <p:spPr>
-          <a:xfrm>
-            <a:off x="8677656" y="6364224"/>
-            <a:ext cx="2514600" cy="45720"/>
-          </a:xfrm>
-          <a:prstGeom prst="rect">
-            <a:avLst/>
-          </a:prstGeom>
-          <a:solidFill>
-            <a:srgbClr val="2C5F82"/>
-          </a:solidFill>
-          <a:ln w="12700">
-            <a:solidFill>
-              <a:srgbClr val="2C5F82"/>
-            </a:solidFill>
-            <a:prstDash val="solid"/>
-          </a:ln>
-        </p:spPr>
-      </p:sp>
-      <p:sp>
-        <p:nvSpPr>
-          <p:cNvPr id="8" name="Text 6"/>
-          <p:cNvSpPr txBox="1"/>
-          <p:nvPr/>
-        </p:nvSpPr>
-        <p:spPr>
-          <a:xfrm>
-            <a:off x="8129016" y="6446520"/>
-            <a:ext cx="3611880" cy="274320"/>
-          </a:xfrm>
-          <a:prstGeom prst="rect">
-            <a:avLst/>
-          </a:prstGeom>
-          <a:noFill/>
-          <a:ln/>
-        </p:spPr>
-        <p:txBody>
-          <a:bodyPr wrap="square" lIns="0" tIns="0" rIns="0" bIns="0" rtlCol="0" anchor="t"/>
-          <a:lstStyle/>
-          <a:p>
-            <a:pPr algn="ctr" indent="0" marL="0">
-              <a:buNone/>
-            </a:pPr>
-            <a:r>
-              <a:rPr lang="en-US" sz="1200" b="1" spc="100" kern="0" dirty="0">
-                <a:solidFill>
-                  <a:srgbClr val="2C5F82"/>
-                </a:solidFill>
-                <a:latin typeface="Arial" pitchFamily="34" charset="0"/>
-                <a:ea typeface="Arial" pitchFamily="34" charset="-122"/>
-                <a:cs typeface="Arial" pitchFamily="34" charset="-120"/>
-              </a:rPr>
-              <a:t>APPENDIX</a:t>
-            </a:r>
-            <a:endParaRPr lang="en-US" sz="1200" dirty="0"/>
-          </a:p>
-        </p:txBody>
-      </p:sp>
-      <p:graphicFrame>
-        <p:nvGraphicFramePr>
-          <p:cNvPr id="7" name="Table 0"/>
+          <p:cNvPr id="6" name="Table 0"/>
           <p:cNvGraphicFramePr>
             <a:graphicFrameLocks noGrp="1"/>
           </p:cNvGraphicFramePr>

</xml_diff>

<commit_message>
Thesis 2 one-slide: new matrix layout (market reality / traditional / autocall answer)
Replaces the 2x2-panels-plus-numbered-implications format that echoed last year's sample.

Co-Authored-By: Claude Opus 5.5 <noreply@anthropic.com>
Claude-Session: https://claude.ai/code/session_01Rwoh8cFDQqLD8JWT3mee6y
</commit_message>
<xml_diff>
--- a/deck/Investment-Thesis-Slides.pptx
+++ b/deck/Investment-Thesis-Slides.pptx
@@ -430,7 +430,7 @@
     <c:plotArea>
       <c:layout/>
       <c:barChart>
-        <c:barDir val="col"/>
+        <c:barDir val="bar"/>
         <c:grouping val="clustered"/>
         <c:varyColors val="0"/>
         <c:ser>
@@ -623,11 +623,11 @@
           <c:orientation val="minMax"/>
         </c:scaling>
         <c:delete val="0"/>
-        <c:axPos val="b"/>
+        <c:axPos val="l"/>
         <c:numFmt formatCode="General" sourceLinked="1"/>
         <c:majorTickMark val="out"/>
         <c:minorTickMark val="none"/>
-        <c:tickLblPos val="low"/>
+        <c:tickLblPos val="nextTo"/>
         <c:spPr>
           <a:ln w="12700" cap="flat">
             <a:solidFill>
@@ -662,15 +662,15 @@
         <c:axId val="2094734552"/>
         <c:scaling>
           <c:orientation val="minMax"/>
-          <c:max val="28"/>
+          <c:max val="27"/>
           <c:min val="0"/>
         </c:scaling>
         <c:delete val="1"/>
-        <c:axPos val="l"/>
+        <c:axPos val="b"/>
         <c:numFmt formatCode="General" sourceLinked="0"/>
         <c:majorTickMark val="out"/>
         <c:minorTickMark val="none"/>
-        <c:tickLblPos val="nextTo"/>
+        <c:tickLblPos val="low"/>
         <c:spPr>
           <a:ln w="12700" cap="flat">
             <a:solidFill>
@@ -715,7 +715,7 @@
         <a:lstStyle/>
         <a:p>
           <a:pPr>
-            <a:defRPr sz="800">
+            <a:defRPr sz="750">
               <a:latin typeface="Arial"/>
               <a:cs typeface="Arial"/>
             </a:defRPr>
@@ -3046,6 +3046,285 @@
     <c:autoTitleDeleted val="1"/>
     <c:plotArea>
       <c:layout/>
+      <c:barChart>
+        <c:barDir val="col"/>
+        <c:grouping val="clustered"/>
+        <c:varyColors val="0"/>
+        <c:ser>
+          <c:idx val="0"/>
+          <c:order val="0"/>
+          <c:tx>
+            <c:strRef>
+              <c:f>Sheet1!$B$1</c:f>
+              <c:strCache>
+                <c:ptCount val="1"/>
+                <c:pt idx="0">
+                  <c:v>5Y USD bond</c:v>
+                </c:pt>
+              </c:strCache>
+            </c:strRef>
+          </c:tx>
+          <c:spPr>
+            <a:solidFill>
+              <a:srgbClr val="7F7F7F"/>
+            </a:solidFill>
+            <a:effectLst/>
+          </c:spPr>
+          <c:invertIfNegative val="0"/>
+          <c:dLbls>
+            <c:numFmt formatCode="#,##0" sourceLinked="0"/>
+            <c:txPr>
+              <a:bodyPr/>
+              <a:lstStyle/>
+              <a:p>
+                <a:pPr>
+                  <a:defRPr b="0" i="0" strike="noStrike" sz="1200" u="none">
+                    <a:solidFill>
+                      <a:srgbClr val="000000"/>
+                    </a:solidFill>
+                    <a:latin typeface="Arial"/>
+                  </a:defRPr>
+                </a:pPr>
+              </a:p>
+            </c:txPr>
+            <c:showLegendKey val="0"/>
+            <c:showVal val="0"/>
+            <c:showCatName val="0"/>
+            <c:showSerName val="0"/>
+            <c:showPercent val="0"/>
+            <c:showBubbleSize val="0"/>
+            <c:showLeaderLines val="0"/>
+          </c:dLbls>
+          <c:cat>
+            <c:multiLvlStrRef>
+              <c:f>Sheet1!$A$2:$A$10</c:f>
+              <c:multiLvlStrCache>
+                <c:ptCount val="9"/>
+                <c:lvl>
+                  <c:pt idx="0">
+                    <c:v>-2.0</c:v>
+                  </c:pt>
+                  <c:pt idx="1">
+                    <c:v>-1.5</c:v>
+                  </c:pt>
+                  <c:pt idx="2">
+                    <c:v>-1.0</c:v>
+                  </c:pt>
+                  <c:pt idx="3">
+                    <c:v>-0.5</c:v>
+                  </c:pt>
+                  <c:pt idx="4">
+                    <c:v>0</c:v>
+                  </c:pt>
+                  <c:pt idx="5">
+                    <c:v>+0.5</c:v>
+                  </c:pt>
+                  <c:pt idx="6">
+                    <c:v>+1.0</c:v>
+                  </c:pt>
+                  <c:pt idx="7">
+                    <c:v>+1.5</c:v>
+                  </c:pt>
+                  <c:pt idx="8">
+                    <c:v>+2.0</c:v>
+                  </c:pt>
+                </c:lvl>
+              </c:multiLvlStrCache>
+            </c:multiLvlStrRef>
+          </c:cat>
+          <c:val>
+            <c:numRef>
+              <c:f>Sheet1!$B$2:$B$10</c:f>
+              <c:numCache>
+                <c:formatCode>General</c:formatCode>
+                <c:ptCount val="9"/>
+                <c:pt idx="0">
+                  <c:v>9.1</c:v>
+                </c:pt>
+                <c:pt idx="1">
+                  <c:v>6.8</c:v>
+                </c:pt>
+                <c:pt idx="2">
+                  <c:v>4.5</c:v>
+                </c:pt>
+                <c:pt idx="3">
+                  <c:v>2.3</c:v>
+                </c:pt>
+                <c:pt idx="4">
+                  <c:v>0</c:v>
+                </c:pt>
+                <c:pt idx="5">
+                  <c:v>-2</c:v>
+                </c:pt>
+                <c:pt idx="6">
+                  <c:v>-4</c:v>
+                </c:pt>
+                <c:pt idx="7">
+                  <c:v>-6</c:v>
+                </c:pt>
+                <c:pt idx="8">
+                  <c:v>-7.9</c:v>
+                </c:pt>
+              </c:numCache>
+            </c:numRef>
+          </c:val>
+        </c:ser>
+        <c:dLbls>
+          <c:numFmt formatCode="#,##0" sourceLinked="0"/>
+          <c:txPr>
+            <a:bodyPr/>
+            <a:lstStyle/>
+            <a:p>
+              <a:pPr>
+                <a:defRPr b="0" i="0" strike="noStrike" sz="1200" u="none">
+                  <a:solidFill>
+                    <a:srgbClr val="000000"/>
+                  </a:solidFill>
+                  <a:latin typeface="Arial"/>
+                </a:defRPr>
+              </a:pPr>
+            </a:p>
+          </c:txPr>
+          <c:showLegendKey val="0"/>
+          <c:showVal val="0"/>
+          <c:showCatName val="0"/>
+          <c:showSerName val="0"/>
+          <c:showPercent val="0"/>
+          <c:showBubbleSize val="0"/>
+          <c:showLeaderLines val="0"/>
+        </c:dLbls>
+        <c:gapWidth val="150"/>
+        <c:overlap val="0"/>
+        <c:axId val="2094734554"/>
+        <c:axId val="2094734552"/>
+        <c:axId val="2094734556"/>
+      </c:barChart>
+      <c:catAx>
+        <c:axId val="2094734554"/>
+        <c:scaling>
+          <c:orientation val="minMax"/>
+        </c:scaling>
+        <c:delete val="0"/>
+        <c:axPos val="b"/>
+        <c:numFmt formatCode="General" sourceLinked="1"/>
+        <c:majorTickMark val="out"/>
+        <c:minorTickMark val="none"/>
+        <c:tickLblPos val="low"/>
+        <c:spPr>
+          <a:ln w="12700" cap="flat">
+            <a:solidFill>
+              <a:srgbClr val="BFBFBF"/>
+            </a:solidFill>
+            <a:prstDash val="solid"/>
+            <a:round/>
+          </a:ln>
+        </c:spPr>
+        <c:txPr>
+          <a:bodyPr/>
+          <a:lstStyle/>
+          <a:p>
+            <a:pPr>
+              <a:defRPr sz="650" b="0" i="0" u="none" strike="noStrike">
+                <a:solidFill>
+                  <a:srgbClr val="595959"/>
+                </a:solidFill>
+                <a:latin typeface="Arial"/>
+              </a:defRPr>
+            </a:pPr>
+            <a:endParaRPr lang="en-US"/>
+          </a:p>
+        </c:txPr>
+        <c:crossAx val="2094734552"/>
+        <c:crosses val="autoZero"/>
+        <c:auto val="1"/>
+        <c:lblAlgn val="ctr"/>
+        <c:noMultiLvlLbl val="1"/>
+      </c:catAx>
+      <c:valAx>
+        <c:axId val="2094734552"/>
+        <c:scaling>
+          <c:orientation val="minMax"/>
+          <c:max val="10"/>
+          <c:min val="-10"/>
+        </c:scaling>
+        <c:delete val="0"/>
+        <c:axPos val="l"/>
+        <c:majorGridlines>
+          <c:spPr>
+            <a:ln w="6350" cap="flat">
+              <a:solidFill>
+                <a:srgbClr val="E3E3E3"/>
+              </a:solidFill>
+              <a:prstDash val="solid"/>
+              <a:round/>
+            </a:ln>
+          </c:spPr>
+        </c:majorGridlines>
+        <c:numFmt formatCode="0&quot;%&quot;" sourceLinked="0"/>
+        <c:majorTickMark val="out"/>
+        <c:minorTickMark val="none"/>
+        <c:tickLblPos val="nextTo"/>
+        <c:spPr>
+          <a:ln w="12700" cap="flat">
+            <a:solidFill>
+              <a:srgbClr val="888888"/>
+            </a:solidFill>
+            <a:prstDash val="solid"/>
+            <a:round/>
+          </a:ln>
+        </c:spPr>
+        <c:txPr>
+          <a:bodyPr/>
+          <a:lstStyle/>
+          <a:p>
+            <a:pPr>
+              <a:defRPr sz="700" b="0" i="0" u="none" strike="noStrike">
+                <a:solidFill>
+                  <a:srgbClr val="595959"/>
+                </a:solidFill>
+                <a:latin typeface="Arial"/>
+              </a:defRPr>
+            </a:pPr>
+            <a:endParaRPr lang="en-US"/>
+          </a:p>
+        </c:txPr>
+        <c:crossAx val="2094734554"/>
+        <c:crosses val="autoZero"/>
+        <c:crossBetween val="between"/>
+        <c:majorUnit val="5"/>
+      </c:valAx>
+      <c:spPr>
+        <a:noFill/>
+        <a:ln>
+          <a:noFill/>
+        </a:ln>
+        <a:effectLst/>
+      </c:spPr>
+    </c:plotArea>
+    <c:plotVisOnly val="1"/>
+    <c:dispBlanksAs val="span"/>
+  </c:chart>
+  <c:spPr>
+    <a:noFill/>
+    <a:ln>
+      <a:noFill/>
+    </a:ln>
+    <a:effectLst/>
+  </c:spPr>
+  <c:externalData r:id="rId1">
+    <c:autoUpdate val="0"/>
+  </c:externalData>
+</c:chartSpace>
+</file>
+
+<file path=ppt/charts/chart9.xml><?xml version="1.0" encoding="utf-8"?>
+<c:chartSpace xmlns:c="http://schemas.openxmlformats.org/drawingml/2006/chart" xmlns:a="http://schemas.openxmlformats.org/drawingml/2006/main" xmlns:r="http://schemas.openxmlformats.org/officeDocument/2006/relationships">
+  <c:date1904 val="0"/>
+  <c:roundedCorners val="1"/>
+  <c:chart>
+    <c:autoTitleDeleted val="1"/>
+    <c:plotArea>
+      <c:layout/>
       <c:lineChart>
         <c:varyColors val="0"/>
         <c:ser>
@@ -3101,8 +3380,8 @@
             <c:showLeaderLines val="0"/>
           </c:dLbls>
           <c:marker>
-            <c:symbol val="circle"/>
-            <c:size val="3"/>
+            <c:symbol val="none"/>
+            <c:size val="6"/>
             <c:spPr>
               <a:solidFill>
                 <a:srgbClr val="2C5F82"/>
@@ -3233,8 +3512,8 @@
             <c:showLeaderLines val="0"/>
           </c:dLbls>
           <c:marker>
-            <c:symbol val="circle"/>
-            <c:size val="3"/>
+            <c:symbol val="none"/>
+            <c:size val="6"/>
             <c:spPr>
               <a:solidFill>
                 <a:srgbClr val="B23B3B"/>
@@ -3365,8 +3644,8 @@
             <c:showLeaderLines val="0"/>
           </c:dLbls>
           <c:marker>
-            <c:symbol val="circle"/>
-            <c:size val="3"/>
+            <c:symbol val="none"/>
+            <c:size val="6"/>
             <c:spPr>
               <a:solidFill>
                 <a:srgbClr val="A6A6A6"/>
@@ -3498,7 +3777,7 @@
           <a:lstStyle/>
           <a:p>
             <a:pPr>
-              <a:defRPr sz="650" b="0" i="0" u="none" strike="noStrike">
+              <a:defRPr sz="700" b="0" i="0" u="none" strike="noStrike">
                 <a:solidFill>
                   <a:srgbClr val="595959"/>
                 </a:solidFill>
@@ -3552,7 +3831,7 @@
           <a:lstStyle/>
           <a:p>
             <a:pPr>
-              <a:defRPr sz="800" b="0" i="0" u="none" strike="noStrike">
+              <a:defRPr sz="700" b="0" i="0" u="none" strike="noStrike">
                 <a:solidFill>
                   <a:srgbClr val="595959"/>
                 </a:solidFill>
@@ -3592,285 +3871,6 @@
         </a:p>
       </c:txPr>
     </c:legend>
-    <c:plotVisOnly val="1"/>
-    <c:dispBlanksAs val="span"/>
-  </c:chart>
-  <c:spPr>
-    <a:noFill/>
-    <a:ln>
-      <a:noFill/>
-    </a:ln>
-    <a:effectLst/>
-  </c:spPr>
-  <c:externalData r:id="rId1">
-    <c:autoUpdate val="0"/>
-  </c:externalData>
-</c:chartSpace>
-</file>
-
-<file path=ppt/charts/chart9.xml><?xml version="1.0" encoding="utf-8"?>
-<c:chartSpace xmlns:c="http://schemas.openxmlformats.org/drawingml/2006/chart" xmlns:a="http://schemas.openxmlformats.org/drawingml/2006/main" xmlns:r="http://schemas.openxmlformats.org/officeDocument/2006/relationships">
-  <c:date1904 val="0"/>
-  <c:roundedCorners val="1"/>
-  <c:chart>
-    <c:autoTitleDeleted val="1"/>
-    <c:plotArea>
-      <c:layout/>
-      <c:barChart>
-        <c:barDir val="col"/>
-        <c:grouping val="clustered"/>
-        <c:varyColors val="0"/>
-        <c:ser>
-          <c:idx val="0"/>
-          <c:order val="0"/>
-          <c:tx>
-            <c:strRef>
-              <c:f>Sheet1!$B$1</c:f>
-              <c:strCache>
-                <c:ptCount val="1"/>
-                <c:pt idx="0">
-                  <c:v>5Y USD bond</c:v>
-                </c:pt>
-              </c:strCache>
-            </c:strRef>
-          </c:tx>
-          <c:spPr>
-            <a:solidFill>
-              <a:srgbClr val="404040"/>
-            </a:solidFill>
-            <a:effectLst/>
-          </c:spPr>
-          <c:invertIfNegative val="0"/>
-          <c:dLbls>
-            <c:numFmt formatCode="0.0" sourceLinked="0"/>
-            <c:txPr>
-              <a:bodyPr/>
-              <a:lstStyle/>
-              <a:p>
-                <a:pPr>
-                  <a:defRPr b="0" i="0" strike="noStrike" sz="700" u="none">
-                    <a:solidFill>
-                      <a:srgbClr val="262626"/>
-                    </a:solidFill>
-                    <a:latin typeface="Arial"/>
-                  </a:defRPr>
-                </a:pPr>
-              </a:p>
-            </c:txPr>
-            <c:showLegendKey val="0"/>
-            <c:showVal val="1"/>
-            <c:showCatName val="0"/>
-            <c:showSerName val="0"/>
-            <c:showPercent val="0"/>
-            <c:showBubbleSize val="0"/>
-            <c:showLeaderLines val="0"/>
-          </c:dLbls>
-          <c:cat>
-            <c:multiLvlStrRef>
-              <c:f>Sheet1!$A$2:$A$10</c:f>
-              <c:multiLvlStrCache>
-                <c:ptCount val="9"/>
-                <c:lvl>
-                  <c:pt idx="0">
-                    <c:v>-2.0%</c:v>
-                  </c:pt>
-                  <c:pt idx="1">
-                    <c:v>-1.5%</c:v>
-                  </c:pt>
-                  <c:pt idx="2">
-                    <c:v>-1.0%</c:v>
-                  </c:pt>
-                  <c:pt idx="3">
-                    <c:v>-0.5%</c:v>
-                  </c:pt>
-                  <c:pt idx="4">
-                    <c:v>0</c:v>
-                  </c:pt>
-                  <c:pt idx="5">
-                    <c:v>+0.5%</c:v>
-                  </c:pt>
-                  <c:pt idx="6">
-                    <c:v>+1.0%</c:v>
-                  </c:pt>
-                  <c:pt idx="7">
-                    <c:v>+1.5%</c:v>
-                  </c:pt>
-                  <c:pt idx="8">
-                    <c:v>+2.0%</c:v>
-                  </c:pt>
-                </c:lvl>
-              </c:multiLvlStrCache>
-            </c:multiLvlStrRef>
-          </c:cat>
-          <c:val>
-            <c:numRef>
-              <c:f>Sheet1!$B$2:$B$10</c:f>
-              <c:numCache>
-                <c:formatCode>General</c:formatCode>
-                <c:ptCount val="9"/>
-                <c:pt idx="0">
-                  <c:v>9.1</c:v>
-                </c:pt>
-                <c:pt idx="1">
-                  <c:v>6.8</c:v>
-                </c:pt>
-                <c:pt idx="2">
-                  <c:v>4.5</c:v>
-                </c:pt>
-                <c:pt idx="3">
-                  <c:v>2.3</c:v>
-                </c:pt>
-                <c:pt idx="4">
-                  <c:v>0</c:v>
-                </c:pt>
-                <c:pt idx="5">
-                  <c:v>-2</c:v>
-                </c:pt>
-                <c:pt idx="6">
-                  <c:v>-4</c:v>
-                </c:pt>
-                <c:pt idx="7">
-                  <c:v>-6</c:v>
-                </c:pt>
-                <c:pt idx="8">
-                  <c:v>-7.9</c:v>
-                </c:pt>
-              </c:numCache>
-            </c:numRef>
-          </c:val>
-        </c:ser>
-        <c:dLbls>
-          <c:numFmt formatCode="0.0" sourceLinked="0"/>
-          <c:txPr>
-            <a:bodyPr/>
-            <a:lstStyle/>
-            <a:p>
-              <a:pPr>
-                <a:defRPr b="0" i="0" strike="noStrike" sz="700" u="none">
-                  <a:solidFill>
-                    <a:srgbClr val="262626"/>
-                  </a:solidFill>
-                  <a:latin typeface="Arial"/>
-                </a:defRPr>
-              </a:pPr>
-            </a:p>
-          </c:txPr>
-          <c:showLegendKey val="0"/>
-          <c:showVal val="1"/>
-          <c:showCatName val="0"/>
-          <c:showSerName val="0"/>
-          <c:showPercent val="0"/>
-          <c:showBubbleSize val="0"/>
-          <c:showLeaderLines val="0"/>
-        </c:dLbls>
-        <c:gapWidth val="150"/>
-        <c:overlap val="0"/>
-        <c:axId val="2094734554"/>
-        <c:axId val="2094734552"/>
-        <c:axId val="2094734556"/>
-      </c:barChart>
-      <c:catAx>
-        <c:axId val="2094734554"/>
-        <c:scaling>
-          <c:orientation val="minMax"/>
-        </c:scaling>
-        <c:delete val="0"/>
-        <c:axPos val="b"/>
-        <c:numFmt formatCode="General" sourceLinked="1"/>
-        <c:majorTickMark val="out"/>
-        <c:minorTickMark val="none"/>
-        <c:tickLblPos val="low"/>
-        <c:spPr>
-          <a:ln w="12700" cap="flat">
-            <a:solidFill>
-              <a:srgbClr val="BFBFBF"/>
-            </a:solidFill>
-            <a:prstDash val="solid"/>
-            <a:round/>
-          </a:ln>
-        </c:spPr>
-        <c:txPr>
-          <a:bodyPr/>
-          <a:lstStyle/>
-          <a:p>
-            <a:pPr>
-              <a:defRPr sz="750" b="0" i="0" u="none" strike="noStrike">
-                <a:solidFill>
-                  <a:srgbClr val="595959"/>
-                </a:solidFill>
-                <a:latin typeface="Arial"/>
-              </a:defRPr>
-            </a:pPr>
-            <a:endParaRPr lang="en-US"/>
-          </a:p>
-        </c:txPr>
-        <c:crossAx val="2094734552"/>
-        <c:crosses val="autoZero"/>
-        <c:auto val="1"/>
-        <c:lblAlgn val="ctr"/>
-        <c:noMultiLvlLbl val="1"/>
-      </c:catAx>
-      <c:valAx>
-        <c:axId val="2094734552"/>
-        <c:scaling>
-          <c:orientation val="minMax"/>
-          <c:max val="12"/>
-          <c:min val="-12"/>
-        </c:scaling>
-        <c:delete val="0"/>
-        <c:axPos val="l"/>
-        <c:majorGridlines>
-          <c:spPr>
-            <a:ln w="6350" cap="flat">
-              <a:solidFill>
-                <a:srgbClr val="E3E3E3"/>
-              </a:solidFill>
-              <a:prstDash val="solid"/>
-              <a:round/>
-            </a:ln>
-          </c:spPr>
-        </c:majorGridlines>
-        <c:numFmt formatCode="0&quot;%&quot;" sourceLinked="0"/>
-        <c:majorTickMark val="out"/>
-        <c:minorTickMark val="none"/>
-        <c:tickLblPos val="nextTo"/>
-        <c:spPr>
-          <a:ln w="12700" cap="flat">
-            <a:solidFill>
-              <a:srgbClr val="888888"/>
-            </a:solidFill>
-            <a:prstDash val="solid"/>
-            <a:round/>
-          </a:ln>
-        </c:spPr>
-        <c:txPr>
-          <a:bodyPr/>
-          <a:lstStyle/>
-          <a:p>
-            <a:pPr>
-              <a:defRPr sz="800" b="0" i="0" u="none" strike="noStrike">
-                <a:solidFill>
-                  <a:srgbClr val="595959"/>
-                </a:solidFill>
-                <a:latin typeface="Arial"/>
-              </a:defRPr>
-            </a:pPr>
-            <a:endParaRPr lang="en-US"/>
-          </a:p>
-        </c:txPr>
-        <c:crossAx val="2094734554"/>
-        <c:crosses val="autoZero"/>
-        <c:crossBetween val="between"/>
-        <c:majorUnit val="4"/>
-      </c:valAx>
-      <c:spPr>
-        <a:noFill/>
-        <a:ln>
-          <a:noFill/>
-        </a:ln>
-        <a:effectLst/>
-      </c:spPr>
-    </c:plotArea>
     <c:plotVisOnly val="1"/>
     <c:dispBlanksAs val="span"/>
   </c:chart>
@@ -4546,7 +4546,7 @@
           <a:p>
             <a:r>
               <a:rPr lang="en-US" dirty="0"/>
-              <a:t>One-slide thesis 2, modelled on the 'traditional strategies fall short' format, using market evidence only: the Fed's 16 Sep dot plot (median 4.125% through 2027, cuts only from 2028, a hawkish minority at 4.375%, wide disagreement) and the bond duration risk it implies, violent equity paths, concentration, record volatility and a late, richly priced cycle. Implications link each market fact to why an autocallable structure fits; our specific note and its numbers come in the product section.</a:t>
+              <a:t>Read across each row: what the 2026 market looks like, what that does to plain bonds or buy-and-hold equity, and how an autocallable answers it. Rates: the Fed's dot plot keeps rates high until 2028 with a hawkish minority, so long bonds carry rate risk, while high rates make a capital floor cheap and an autocall can redeem from year 1. Volatility: violent round trips punish buy-and-hold timing; autocall coupons pay on recovery and record volatility funds them. Valuation: concentration and full prices make upside less valuable, so capping it at the coupon costs little, and a diversified ETF basket avoids single-name risk. Our specific note and its numbers come in the product section.</a:t>
             </a:r>
             <a:endParaRPr lang="en-US" dirty="0"/>
           </a:p>
@@ -9887,8 +9887,8 @@
         </p:nvSpPr>
         <p:spPr>
           <a:xfrm>
-            <a:off x="457200" y="960120"/>
-            <a:ext cx="11247120" cy="274320"/>
+            <a:off x="2011680" y="1024128"/>
+            <a:ext cx="5212080" cy="274320"/>
           </a:xfrm>
           <a:prstGeom prst="rect">
             <a:avLst/>
@@ -9900,11 +9900,11 @@
           <a:bodyPr wrap="square" lIns="0" tIns="0" rIns="0" bIns="0" rtlCol="0" anchor="t"/>
           <a:lstStyle/>
           <a:p>
-            <a:pPr indent="0" marL="0">
+            <a:pPr algn="l" indent="0" marL="0">
               <a:buNone/>
             </a:pPr>
             <a:r>
-              <a:rPr lang="en-US" sz="1150" b="1" i="1" dirty="0">
+              <a:rPr lang="en-US" sz="1100" b="1" dirty="0">
                 <a:solidFill>
                   <a:srgbClr val="262626"/>
                 </a:solidFill>
@@ -9912,9 +9912,9 @@
                 <a:ea typeface="Arial" pitchFamily="34" charset="-122"/>
                 <a:cs typeface="Arial" pitchFamily="34" charset="-120"/>
               </a:rPr>
-              <a:t>The Fed sees rates high until 2028, so long bonds carry rate risk; buy-and-hold equity faces volatility, concentration and stretched valuations</a:t>
-            </a:r>
-            <a:endParaRPr lang="en-US" sz="1150" dirty="0"/>
+              <a:t>Market reality in 2026 (evidence)</a:t>
+            </a:r>
+            <a:endParaRPr lang="en-US" sz="1100" dirty="0"/>
           </a:p>
         </p:txBody>
       </p:sp>
@@ -9926,8 +9926,155 @@
         </p:nvSpPr>
         <p:spPr>
           <a:xfrm>
-            <a:off x="457200" y="1325880"/>
-            <a:ext cx="3730752" cy="292608"/>
+            <a:off x="2011680" y="1316736"/>
+            <a:ext cx="5212080" cy="0"/>
+          </a:xfrm>
+          <a:prstGeom prst="line">
+            <a:avLst/>
+          </a:prstGeom>
+          <a:noFill/>
+          <a:ln w="9525">
+            <a:solidFill>
+              <a:srgbClr val="BFBFBF"/>
+            </a:solidFill>
+            <a:prstDash val="solid"/>
+          </a:ln>
+        </p:spPr>
+      </p:sp>
+      <p:sp>
+        <p:nvSpPr>
+          <p:cNvPr id="11" name="Text 9"/>
+          <p:cNvSpPr txBox="1"/>
+          <p:nvPr/>
+        </p:nvSpPr>
+        <p:spPr>
+          <a:xfrm>
+            <a:off x="7315200" y="1024128"/>
+            <a:ext cx="2148840" cy="274320"/>
+          </a:xfrm>
+          <a:prstGeom prst="rect">
+            <a:avLst/>
+          </a:prstGeom>
+          <a:noFill/>
+          <a:ln/>
+        </p:spPr>
+        <p:txBody>
+          <a:bodyPr wrap="square" lIns="0" tIns="0" rIns="0" bIns="0" rtlCol="0" anchor="t"/>
+          <a:lstStyle/>
+          <a:p>
+            <a:pPr algn="ctr" indent="0" marL="0">
+              <a:buNone/>
+            </a:pPr>
+            <a:r>
+              <a:rPr lang="en-US" sz="1100" b="1" dirty="0">
+                <a:solidFill>
+                  <a:srgbClr val="B23B3B"/>
+                </a:solidFill>
+                <a:latin typeface="Arial" pitchFamily="34" charset="0"/>
+                <a:ea typeface="Arial" pitchFamily="34" charset="-122"/>
+                <a:cs typeface="Arial" pitchFamily="34" charset="-120"/>
+              </a:rPr>
+              <a:t>Plain bonds / buy-and-hold</a:t>
+            </a:r>
+            <a:endParaRPr lang="en-US" sz="1100" dirty="0"/>
+          </a:p>
+        </p:txBody>
+      </p:sp>
+      <p:sp>
+        <p:nvSpPr>
+          <p:cNvPr id="12" name="Shape 10"/>
+          <p:cNvSpPr/>
+          <p:nvPr/>
+        </p:nvSpPr>
+        <p:spPr>
+          <a:xfrm>
+            <a:off x="7315200" y="1316736"/>
+            <a:ext cx="2148840" cy="0"/>
+          </a:xfrm>
+          <a:prstGeom prst="line">
+            <a:avLst/>
+          </a:prstGeom>
+          <a:noFill/>
+          <a:ln w="25400">
+            <a:solidFill>
+              <a:srgbClr val="B23B3B"/>
+            </a:solidFill>
+            <a:prstDash val="solid"/>
+          </a:ln>
+        </p:spPr>
+      </p:sp>
+      <p:sp>
+        <p:nvSpPr>
+          <p:cNvPr id="13" name="Text 11"/>
+          <p:cNvSpPr txBox="1"/>
+          <p:nvPr/>
+        </p:nvSpPr>
+        <p:spPr>
+          <a:xfrm>
+            <a:off x="9555480" y="1024128"/>
+            <a:ext cx="2176272" cy="274320"/>
+          </a:xfrm>
+          <a:prstGeom prst="rect">
+            <a:avLst/>
+          </a:prstGeom>
+          <a:noFill/>
+          <a:ln/>
+        </p:spPr>
+        <p:txBody>
+          <a:bodyPr wrap="square" lIns="0" tIns="0" rIns="0" bIns="0" rtlCol="0" anchor="t"/>
+          <a:lstStyle/>
+          <a:p>
+            <a:pPr algn="ctr" indent="0" marL="0">
+              <a:buNone/>
+            </a:pPr>
+            <a:r>
+              <a:rPr lang="en-US" sz="1100" b="1" dirty="0">
+                <a:solidFill>
+                  <a:srgbClr val="2C5F82"/>
+                </a:solidFill>
+                <a:latin typeface="Arial" pitchFamily="34" charset="0"/>
+                <a:ea typeface="Arial" pitchFamily="34" charset="-122"/>
+                <a:cs typeface="Arial" pitchFamily="34" charset="-120"/>
+              </a:rPr>
+              <a:t>Autocallable answer</a:t>
+            </a:r>
+            <a:endParaRPr lang="en-US" sz="1100" dirty="0"/>
+          </a:p>
+        </p:txBody>
+      </p:sp>
+      <p:sp>
+        <p:nvSpPr>
+          <p:cNvPr id="14" name="Shape 12"/>
+          <p:cNvSpPr/>
+          <p:nvPr/>
+        </p:nvSpPr>
+        <p:spPr>
+          <a:xfrm>
+            <a:off x="9555480" y="1316736"/>
+            <a:ext cx="2176272" cy="0"/>
+          </a:xfrm>
+          <a:prstGeom prst="line">
+            <a:avLst/>
+          </a:prstGeom>
+          <a:noFill/>
+          <a:ln w="25400">
+            <a:solidFill>
+              <a:srgbClr val="2C5F82"/>
+            </a:solidFill>
+            <a:prstDash val="solid"/>
+          </a:ln>
+        </p:spPr>
+      </p:sp>
+      <p:sp>
+        <p:nvSpPr>
+          <p:cNvPr id="15" name="Shape 13"/>
+          <p:cNvSpPr/>
+          <p:nvPr/>
+        </p:nvSpPr>
+        <p:spPr>
+          <a:xfrm>
+            <a:off x="457200" y="1417320"/>
+            <a:ext cx="1463040" cy="1307592"/>
           </a:xfrm>
           <a:prstGeom prst="rect">
             <a:avLst/>
@@ -9945,14 +10092,14 @@
       </p:sp>
       <p:sp>
         <p:nvSpPr>
-          <p:cNvPr id="11" name="Text 9"/>
+          <p:cNvPr id="16" name="Text 14"/>
           <p:cNvSpPr txBox="1"/>
           <p:nvPr/>
         </p:nvSpPr>
         <p:spPr>
           <a:xfrm>
-            <a:off x="457200" y="1325880"/>
-            <a:ext cx="3730752" cy="292608"/>
+            <a:off x="548640" y="1554480"/>
+            <a:ext cx="1280160" cy="457200"/>
           </a:xfrm>
           <a:prstGeom prst="rect">
             <a:avLst/>
@@ -9961,14 +10108,14 @@
           <a:ln/>
         </p:spPr>
         <p:txBody>
-          <a:bodyPr wrap="square" lIns="0" tIns="0" rIns="0" bIns="0" rtlCol="0" anchor="ctr"/>
+          <a:bodyPr wrap="square" lIns="0" tIns="0" rIns="0" bIns="0" rtlCol="0" anchor="t"/>
           <a:lstStyle/>
           <a:p>
-            <a:pPr algn="ctr" indent="0" marL="0">
+            <a:pPr indent="0" marL="0">
               <a:buNone/>
             </a:pPr>
             <a:r>
-              <a:rPr lang="en-US" sz="1050" b="1" dirty="0">
+              <a:rPr lang="en-US" sz="1500" b="1" dirty="0">
                 <a:solidFill>
                   <a:srgbClr val="FFFFFF"/>
                 </a:solidFill>
@@ -9976,15 +10123,259 @@
                 <a:ea typeface="Arial" pitchFamily="34" charset="-122"/>
                 <a:cs typeface="Arial" pitchFamily="34" charset="-120"/>
               </a:rPr>
-              <a:t>The Fed: rates stay high until 2028</a:t>
-            </a:r>
-            <a:endParaRPr lang="en-US" sz="1050" dirty="0"/>
+              <a:t>Rates</a:t>
+            </a:r>
+            <a:endParaRPr lang="en-US" sz="1500" dirty="0"/>
+          </a:p>
+        </p:txBody>
+      </p:sp>
+      <p:sp>
+        <p:nvSpPr>
+          <p:cNvPr id="17" name="Text 15"/>
+          <p:cNvSpPr txBox="1"/>
+          <p:nvPr/>
+        </p:nvSpPr>
+        <p:spPr>
+          <a:xfrm>
+            <a:off x="548640" y="2039112"/>
+            <a:ext cx="1280160" cy="640080"/>
+          </a:xfrm>
+          <a:prstGeom prst="rect">
+            <a:avLst/>
+          </a:prstGeom>
+          <a:noFill/>
+          <a:ln/>
+        </p:spPr>
+        <p:txBody>
+          <a:bodyPr wrap="square" lIns="0" tIns="0" rIns="0" bIns="0" rtlCol="0" anchor="t"/>
+          <a:lstStyle/>
+          <a:p>
+            <a:pPr indent="0" marL="0">
+              <a:buNone/>
+            </a:pPr>
+            <a:r>
+              <a:rPr lang="en-US" sz="900" dirty="0">
+                <a:solidFill>
+                  <a:srgbClr val="DCE6EE"/>
+                </a:solidFill>
+                <a:latin typeface="Arial" pitchFamily="34" charset="0"/>
+                <a:ea typeface="Arial" pitchFamily="34" charset="-122"/>
+                <a:cs typeface="Arial" pitchFamily="34" charset="-120"/>
+              </a:rPr>
+              <a:t>The Fed sees rates high until 2028</a:t>
+            </a:r>
+            <a:endParaRPr lang="en-US" sz="900" dirty="0"/>
+          </a:p>
+        </p:txBody>
+      </p:sp>
+      <p:sp>
+        <p:nvSpPr>
+          <p:cNvPr id="18" name="Shape 16"/>
+          <p:cNvSpPr/>
+          <p:nvPr/>
+        </p:nvSpPr>
+        <p:spPr>
+          <a:xfrm>
+            <a:off x="7315200" y="1417320"/>
+            <a:ext cx="2148840" cy="1307592"/>
+          </a:xfrm>
+          <a:prstGeom prst="rect">
+            <a:avLst/>
+          </a:prstGeom>
+          <a:solidFill>
+            <a:srgbClr val="F7ECEC"/>
+          </a:solidFill>
+          <a:ln w="12700">
+            <a:solidFill>
+              <a:srgbClr val="F7ECEC"/>
+            </a:solidFill>
+            <a:prstDash val="solid"/>
+          </a:ln>
+        </p:spPr>
+      </p:sp>
+      <p:sp>
+        <p:nvSpPr>
+          <p:cNvPr id="19" name="Text 17"/>
+          <p:cNvSpPr txBox="1"/>
+          <p:nvPr/>
+        </p:nvSpPr>
+        <p:spPr>
+          <a:xfrm>
+            <a:off x="7406640" y="1472184"/>
+            <a:ext cx="1965960" cy="1197864"/>
+          </a:xfrm>
+          <a:prstGeom prst="rect">
+            <a:avLst/>
+          </a:prstGeom>
+          <a:noFill/>
+          <a:ln/>
+        </p:spPr>
+        <p:txBody>
+          <a:bodyPr wrap="square" lIns="0" tIns="0" rIns="0" bIns="0" rtlCol="0" anchor="ctr"/>
+          <a:lstStyle/>
+          <a:p>
+            <a:pPr indent="0" marL="0">
+              <a:spcAft>
+                <a:spcPts val="200"/>
+              </a:spcAft>
+              <a:buNone/>
+            </a:pPr>
+            <a:r>
+              <a:rPr lang="en-US" sz="880" dirty="0">
+                <a:solidFill>
+                  <a:srgbClr val="262626"/>
+                </a:solidFill>
+                <a:latin typeface="Arial" pitchFamily="34" charset="0"/>
+                <a:ea typeface="Arial" pitchFamily="34" charset="-122"/>
+                <a:cs typeface="Arial" pitchFamily="34" charset="-120"/>
+              </a:rPr>
+              <a:t>A 5-year bond loses ~4.0% for every 1% rise in rates, </a:t>
+            </a:r>
+            <a:pPr indent="0" marL="0">
+              <a:spcAft>
+                <a:spcPts val="200"/>
+              </a:spcAft>
+              <a:buNone/>
+            </a:pPr>
+            <a:r>
+              <a:rPr lang="en-US" sz="880" dirty="0">
+                <a:solidFill>
+                  <a:srgbClr val="262626"/>
+                </a:solidFill>
+                <a:latin typeface="Arial" pitchFamily="34" charset="0"/>
+                <a:ea typeface="Arial" pitchFamily="34" charset="-122"/>
+                <a:cs typeface="Arial" pitchFamily="34" charset="-120"/>
+              </a:rPr>
+              <a:t>and 12 Fed dots sit at 4.375% for 2026–27: more hikes are possible.</a:t>
+            </a:r>
+            <a:endParaRPr lang="en-US" sz="880" dirty="0"/>
+          </a:p>
+        </p:txBody>
+      </p:sp>
+      <p:sp>
+        <p:nvSpPr>
+          <p:cNvPr id="20" name="Shape 18"/>
+          <p:cNvSpPr/>
+          <p:nvPr/>
+        </p:nvSpPr>
+        <p:spPr>
+          <a:xfrm>
+            <a:off x="9555480" y="1417320"/>
+            <a:ext cx="2176272" cy="1307592"/>
+          </a:xfrm>
+          <a:prstGeom prst="rect">
+            <a:avLst/>
+          </a:prstGeom>
+          <a:solidFill>
+            <a:srgbClr val="E8EFF5"/>
+          </a:solidFill>
+          <a:ln w="12700">
+            <a:solidFill>
+              <a:srgbClr val="E8EFF5"/>
+            </a:solidFill>
+            <a:prstDash val="solid"/>
+          </a:ln>
+        </p:spPr>
+      </p:sp>
+      <p:sp>
+        <p:nvSpPr>
+          <p:cNvPr id="21" name="Text 19"/>
+          <p:cNvSpPr txBox="1"/>
+          <p:nvPr/>
+        </p:nvSpPr>
+        <p:spPr>
+          <a:xfrm>
+            <a:off x="9646920" y="1472184"/>
+            <a:ext cx="1993392" cy="1197864"/>
+          </a:xfrm>
+          <a:prstGeom prst="rect">
+            <a:avLst/>
+          </a:prstGeom>
+          <a:noFill/>
+          <a:ln/>
+        </p:spPr>
+        <p:txBody>
+          <a:bodyPr wrap="square" lIns="0" tIns="0" rIns="0" bIns="0" rtlCol="0" anchor="ctr"/>
+          <a:lstStyle/>
+          <a:p>
+            <a:pPr indent="0" marL="0">
+              <a:spcAft>
+                <a:spcPts val="200"/>
+              </a:spcAft>
+              <a:buNone/>
+            </a:pPr>
+            <a:r>
+              <a:rPr lang="en-US" sz="880" b="1" dirty="0">
+                <a:solidFill>
+                  <a:srgbClr val="2C5F82"/>
+                </a:solidFill>
+                <a:latin typeface="Arial" pitchFamily="34" charset="0"/>
+                <a:ea typeface="Arial" pitchFamily="34" charset="-122"/>
+                <a:cs typeface="Arial" pitchFamily="34" charset="-120"/>
+              </a:rPr>
+              <a:t>Early exit: </a:t>
+            </a:r>
+            <a:pPr indent="0" marL="0">
+              <a:spcAft>
+                <a:spcPts val="200"/>
+              </a:spcAft>
+              <a:buNone/>
+            </a:pPr>
+            <a:r>
+              <a:rPr lang="en-US" sz="880" dirty="0">
+                <a:solidFill>
+                  <a:srgbClr val="262626"/>
+                </a:solidFill>
+                <a:latin typeface="Arial" pitchFamily="34" charset="0"/>
+                <a:ea typeface="Arial" pitchFamily="34" charset="-122"/>
+                <a:cs typeface="Arial" pitchFamily="34" charset="-120"/>
+              </a:rPr>
+              <a:t>can redeem from year 1, so duration is short.</a:t>
+            </a:r>
+            <a:endParaRPr lang="en-US" sz="880" dirty="0"/>
+          </a:p>
+          <a:p>
+            <a:pPr indent="0" marL="0">
+              <a:spcAft>
+                <a:spcPts val="200"/>
+              </a:spcAft>
+              <a:buNone/>
+            </a:pPr>
+            <a:r>
+              <a:rPr lang="en-US" sz="880" b="1" dirty="0">
+                <a:solidFill>
+                  <a:srgbClr val="2C5F82"/>
+                </a:solidFill>
+                <a:latin typeface="Arial" pitchFamily="34" charset="0"/>
+                <a:ea typeface="Arial" pitchFamily="34" charset="-122"/>
+                <a:cs typeface="Arial" pitchFamily="34" charset="-120"/>
+              </a:rPr>
+              <a:t>Cheap floor: </a:t>
+            </a:r>
+            <a:pPr indent="0" marL="0">
+              <a:spcAft>
+                <a:spcPts val="200"/>
+              </a:spcAft>
+              <a:buNone/>
+            </a:pPr>
+            <a:r>
+              <a:rPr lang="en-US" sz="880" dirty="0">
+                <a:solidFill>
+                  <a:srgbClr val="262626"/>
+                </a:solidFill>
+                <a:latin typeface="Arial" pitchFamily="34" charset="0"/>
+                <a:ea typeface="Arial" pitchFamily="34" charset="-122"/>
+                <a:cs typeface="Arial" pitchFamily="34" charset="-120"/>
+              </a:rPr>
+              <a:t>USD 75.8 today buys USD 100 in 5 years, so a 70% floor fits inside.</a:t>
+            </a:r>
+            <a:endParaRPr lang="en-US" sz="880" dirty="0"/>
           </a:p>
         </p:txBody>
       </p:sp>
       <p:pic>
         <p:nvPicPr>
-          <p:cNvPr id="12" name="Image 0" descr="/home/user/natixis-case-comp/deck/fomc_dot_plot_compact.png">    </p:cNvPr>
+          <p:cNvPr id="22" name="Image 0" descr="/home/user/natixis-case-comp/deck/fomc_dot_plot_compact.png">    </p:cNvPr>
           <p:cNvPicPr>
             <a:picLocks noChangeAspect="1"/>
           </p:cNvPicPr>
@@ -9998,8 +10389,8 @@
         </p:blipFill>
         <p:spPr>
           <a:xfrm>
-            <a:off x="539496" y="1655064"/>
-            <a:ext cx="3566160" cy="1261203"/>
+            <a:off x="2011680" y="1435608"/>
+            <a:ext cx="3154680" cy="1115680"/>
           </a:xfrm>
           <a:prstGeom prst="rect">
             <a:avLst/>
@@ -10008,14 +10399,14 @@
       </p:pic>
       <p:sp>
         <p:nvSpPr>
-          <p:cNvPr id="13" name="Text 10"/>
+          <p:cNvPr id="23" name="Text 20"/>
           <p:cNvSpPr txBox="1"/>
           <p:nvPr/>
         </p:nvSpPr>
         <p:spPr>
           <a:xfrm>
-            <a:off x="457200" y="2953512"/>
-            <a:ext cx="3730752" cy="365760"/>
+            <a:off x="2011680" y="2551176"/>
+            <a:ext cx="3154680" cy="182880"/>
           </a:xfrm>
           <a:prstGeom prst="rect">
             <a:avLst/>
@@ -10031,7 +10422,7 @@
               <a:buNone/>
             </a:pPr>
             <a:r>
-              <a:rPr lang="en-US" sz="850" dirty="0">
+              <a:rPr lang="en-US" sz="750" i="1" dirty="0">
                 <a:solidFill>
                   <a:srgbClr val="595959"/>
                 </a:solidFill>
@@ -10039,22 +10430,100 @@
                 <a:ea typeface="Arial" pitchFamily="34" charset="-122"/>
                 <a:cs typeface="Arial" pitchFamily="34" charset="-120"/>
               </a:rPr>
-              <a:t>FOMC dot plot, 16 Sep 2026 (one dot per participant; shaded = today's 3.75–4.00%). 12 dots at 4.375% for 2026–27; long run 3.25%.</a:t>
-            </a:r>
-            <a:endParaRPr lang="en-US" sz="850" dirty="0"/>
+              <a:t>FOMC dot plot, 16 Sep 2026 (shaded: today's 3.75–4.00%)</a:t>
+            </a:r>
+            <a:endParaRPr lang="en-US" sz="750" dirty="0"/>
           </a:p>
         </p:txBody>
       </p:sp>
-      <p:sp>
-        <p:nvSpPr>
-          <p:cNvPr id="14" name="Shape 11"/>
+      <p:graphicFrame>
+        <p:nvGraphicFramePr>
+          <p:cNvPr id="24" name="Chart 0" descr=""/>
+          <p:cNvGraphicFramePr/>
+          <p:nvPr/>
+        </p:nvGraphicFramePr>
+        <p:xfrm>
+          <a:off x="5257800" y="1417320"/>
+          <a:ext cx="1965960" cy="1133856"/>
+        </p:xfrm>
+        <a:graphic xmlns:a="http://schemas.openxmlformats.org/drawingml/2006/main">
+          <a:graphicData uri="http://schemas.openxmlformats.org/drawingml/2006/chart">
+            <c:chart xmlns:c="http://schemas.openxmlformats.org/drawingml/2006/chart" r:id="rId2"/>
+          </a:graphicData>
+        </a:graphic>
+      </p:graphicFrame>
+      <p:sp>
+        <p:nvSpPr>
+          <p:cNvPr id="25" name="Text 21"/>
+          <p:cNvSpPr txBox="1"/>
+          <p:nvPr/>
+        </p:nvSpPr>
+        <p:spPr>
+          <a:xfrm>
+            <a:off x="5303520" y="2551176"/>
+            <a:ext cx="1920240" cy="182880"/>
+          </a:xfrm>
+          <a:prstGeom prst="rect">
+            <a:avLst/>
+          </a:prstGeom>
+          <a:noFill/>
+          <a:ln/>
+        </p:spPr>
+        <p:txBody>
+          <a:bodyPr wrap="square" lIns="0" tIns="0" rIns="0" bIns="0" rtlCol="0" anchor="t"/>
+          <a:lstStyle/>
+          <a:p>
+            <a:pPr indent="0" marL="0">
+              <a:buNone/>
+            </a:pPr>
+            <a:r>
+              <a:rPr lang="en-US" sz="750" i="1" dirty="0">
+                <a:solidFill>
+                  <a:srgbClr val="595959"/>
+                </a:solidFill>
+                <a:latin typeface="Arial" pitchFamily="34" charset="0"/>
+                <a:ea typeface="Arial" pitchFamily="34" charset="-122"/>
+                <a:cs typeface="Arial" pitchFamily="34" charset="-120"/>
+              </a:rPr>
+              <a:t>5Y bond value vs rate move (%)</a:t>
+            </a:r>
+            <a:endParaRPr lang="en-US" sz="750" dirty="0"/>
+          </a:p>
+        </p:txBody>
+      </p:sp>
+      <p:sp>
+        <p:nvSpPr>
+          <p:cNvPr id="26" name="Shape 22"/>
           <p:cNvSpPr/>
           <p:nvPr/>
         </p:nvSpPr>
         <p:spPr>
           <a:xfrm>
-            <a:off x="4370832" y="1325880"/>
-            <a:ext cx="3730752" cy="292608"/>
+            <a:off x="457200" y="2761488"/>
+            <a:ext cx="11274552" cy="0"/>
+          </a:xfrm>
+          <a:prstGeom prst="line">
+            <a:avLst/>
+          </a:prstGeom>
+          <a:noFill/>
+          <a:ln w="6350">
+            <a:solidFill>
+              <a:srgbClr val="D9D9D9"/>
+            </a:solidFill>
+            <a:prstDash val="dash"/>
+          </a:ln>
+        </p:spPr>
+      </p:sp>
+      <p:sp>
+        <p:nvSpPr>
+          <p:cNvPr id="27" name="Shape 23"/>
+          <p:cNvSpPr/>
+          <p:nvPr/>
+        </p:nvSpPr>
+        <p:spPr>
+          <a:xfrm>
+            <a:off x="457200" y="2816352"/>
+            <a:ext cx="1463040" cy="1307592"/>
           </a:xfrm>
           <a:prstGeom prst="rect">
             <a:avLst/>
@@ -10072,14 +10541,14 @@
       </p:sp>
       <p:sp>
         <p:nvSpPr>
-          <p:cNvPr id="15" name="Text 12"/>
+          <p:cNvPr id="28" name="Text 24"/>
           <p:cNvSpPr txBox="1"/>
           <p:nvPr/>
         </p:nvSpPr>
         <p:spPr>
           <a:xfrm>
-            <a:off x="4370832" y="1325880"/>
-            <a:ext cx="3730752" cy="292608"/>
+            <a:off x="548640" y="2953512"/>
+            <a:ext cx="1280160" cy="457200"/>
           </a:xfrm>
           <a:prstGeom prst="rect">
             <a:avLst/>
@@ -10088,14 +10557,14 @@
           <a:ln/>
         </p:spPr>
         <p:txBody>
-          <a:bodyPr wrap="square" lIns="0" tIns="0" rIns="0" bIns="0" rtlCol="0" anchor="ctr"/>
+          <a:bodyPr wrap="square" lIns="0" tIns="0" rIns="0" bIns="0" rtlCol="0" anchor="t"/>
           <a:lstStyle/>
           <a:p>
-            <a:pPr algn="ctr" indent="0" marL="0">
+            <a:pPr indent="0" marL="0">
               <a:buNone/>
             </a:pPr>
             <a:r>
-              <a:rPr lang="en-US" sz="1050" b="1" dirty="0">
+              <a:rPr lang="en-US" sz="1500" b="1" dirty="0">
                 <a:solidFill>
                   <a:srgbClr val="FFFFFF"/>
                 </a:solidFill>
@@ -10103,38 +10572,22 @@
                 <a:ea typeface="Arial" pitchFamily="34" charset="-122"/>
                 <a:cs typeface="Arial" pitchFamily="34" charset="-120"/>
               </a:rPr>
-              <a:t>Equity paths are violent</a:t>
-            </a:r>
-            <a:endParaRPr lang="en-US" sz="1050" dirty="0"/>
+              <a:t>Volatility</a:t>
+            </a:r>
+            <a:endParaRPr lang="en-US" sz="1500" dirty="0"/>
           </a:p>
         </p:txBody>
       </p:sp>
-      <p:graphicFrame>
-        <p:nvGraphicFramePr>
-          <p:cNvPr id="16" name="Chart 0" descr=""/>
-          <p:cNvGraphicFramePr/>
-          <p:nvPr/>
-        </p:nvGraphicFramePr>
-        <p:xfrm>
-          <a:off x="4370832" y="1655064"/>
-          <a:ext cx="3730752" cy="1261872"/>
-        </p:xfrm>
-        <a:graphic xmlns:a="http://schemas.openxmlformats.org/drawingml/2006/main">
-          <a:graphicData uri="http://schemas.openxmlformats.org/drawingml/2006/chart">
-            <c:chart xmlns:c="http://schemas.openxmlformats.org/drawingml/2006/chart" r:id="rId2"/>
-          </a:graphicData>
-        </a:graphic>
-      </p:graphicFrame>
-      <p:sp>
-        <p:nvSpPr>
-          <p:cNvPr id="17" name="Text 13"/>
+      <p:sp>
+        <p:nvSpPr>
+          <p:cNvPr id="29" name="Text 25"/>
           <p:cNvSpPr txBox="1"/>
           <p:nvPr/>
         </p:nvSpPr>
         <p:spPr>
           <a:xfrm>
-            <a:off x="4370832" y="2953512"/>
-            <a:ext cx="3730752" cy="365760"/>
+            <a:off x="548640" y="3438144"/>
+            <a:ext cx="1280160" cy="640080"/>
           </a:xfrm>
           <a:prstGeom prst="rect">
             <a:avLst/>
@@ -10150,30 +10603,296 @@
               <a:buNone/>
             </a:pPr>
             <a:r>
-              <a:rPr lang="en-US" sz="850" dirty="0">
-                <a:solidFill>
-                  <a:srgbClr val="595959"/>
+              <a:rPr lang="en-US" sz="900" dirty="0">
+                <a:solidFill>
+                  <a:srgbClr val="DCE6EE"/>
                 </a:solidFill>
                 <a:latin typeface="Arial" pitchFamily="34" charset="0"/>
                 <a:ea typeface="Arial" pitchFamily="34" charset="-122"/>
                 <a:cs typeface="Arial" pitchFamily="34" charset="-120"/>
               </a:rPr>
-              <a:t>Index levels, end-2021 = 100: −10–25% in 2022, then 2–3×. KOSPI fell ~25% from June to late August 2026.</a:t>
-            </a:r>
-            <a:endParaRPr lang="en-US" sz="850" dirty="0"/>
+              <a:t>Violent paths, record fear gauges</a:t>
+            </a:r>
+            <a:endParaRPr lang="en-US" sz="900" dirty="0"/>
           </a:p>
         </p:txBody>
       </p:sp>
       <p:sp>
         <p:nvSpPr>
-          <p:cNvPr id="18" name="Shape 14"/>
+          <p:cNvPr id="30" name="Shape 26"/>
           <p:cNvSpPr/>
           <p:nvPr/>
         </p:nvSpPr>
         <p:spPr>
           <a:xfrm>
-            <a:off x="457200" y="3383280"/>
-            <a:ext cx="3730752" cy="292608"/>
+            <a:off x="7315200" y="2816352"/>
+            <a:ext cx="2148840" cy="1307592"/>
+          </a:xfrm>
+          <a:prstGeom prst="rect">
+            <a:avLst/>
+          </a:prstGeom>
+          <a:solidFill>
+            <a:srgbClr val="F7ECEC"/>
+          </a:solidFill>
+          <a:ln w="12700">
+            <a:solidFill>
+              <a:srgbClr val="F7ECEC"/>
+            </a:solidFill>
+            <a:prstDash val="solid"/>
+          </a:ln>
+        </p:spPr>
+      </p:sp>
+      <p:sp>
+        <p:nvSpPr>
+          <p:cNvPr id="31" name="Text 27"/>
+          <p:cNvSpPr txBox="1"/>
+          <p:nvPr/>
+        </p:nvSpPr>
+        <p:spPr>
+          <a:xfrm>
+            <a:off x="7406640" y="2871216"/>
+            <a:ext cx="1965960" cy="1197864"/>
+          </a:xfrm>
+          <a:prstGeom prst="rect">
+            <a:avLst/>
+          </a:prstGeom>
+          <a:noFill/>
+          <a:ln/>
+        </p:spPr>
+        <p:txBody>
+          <a:bodyPr wrap="square" lIns="0" tIns="0" rIns="0" bIns="0" rtlCol="0" anchor="ctr"/>
+          <a:lstStyle/>
+          <a:p>
+            <a:pPr indent="0" marL="0">
+              <a:spcAft>
+                <a:spcPts val="200"/>
+              </a:spcAft>
+              <a:buNone/>
+            </a:pPr>
+            <a:r>
+              <a:rPr lang="en-US" sz="880" dirty="0">
+                <a:solidFill>
+                  <a:srgbClr val="262626"/>
+                </a:solidFill>
+                <a:latin typeface="Arial" pitchFamily="34" charset="0"/>
+                <a:ea typeface="Arial" pitchFamily="34" charset="-122"/>
+                <a:cs typeface="Arial" pitchFamily="34" charset="-120"/>
+              </a:rPr>
+              <a:t>Index levels fell 10–25% in 2022, then rose 2–3×; KOSPI lost ~25% from June to August 2026. Buy-and-hold must sit through it or time the bottom.</a:t>
+            </a:r>
+            <a:endParaRPr lang="en-US" sz="880" dirty="0"/>
+          </a:p>
+        </p:txBody>
+      </p:sp>
+      <p:sp>
+        <p:nvSpPr>
+          <p:cNvPr id="32" name="Shape 28"/>
+          <p:cNvSpPr/>
+          <p:nvPr/>
+        </p:nvSpPr>
+        <p:spPr>
+          <a:xfrm>
+            <a:off x="9555480" y="2816352"/>
+            <a:ext cx="2176272" cy="1307592"/>
+          </a:xfrm>
+          <a:prstGeom prst="rect">
+            <a:avLst/>
+          </a:prstGeom>
+          <a:solidFill>
+            <a:srgbClr val="E8EFF5"/>
+          </a:solidFill>
+          <a:ln w="12700">
+            <a:solidFill>
+              <a:srgbClr val="E8EFF5"/>
+            </a:solidFill>
+            <a:prstDash val="solid"/>
+          </a:ln>
+        </p:spPr>
+      </p:sp>
+      <p:sp>
+        <p:nvSpPr>
+          <p:cNvPr id="33" name="Text 29"/>
+          <p:cNvSpPr txBox="1"/>
+          <p:nvPr/>
+        </p:nvSpPr>
+        <p:spPr>
+          <a:xfrm>
+            <a:off x="9646920" y="2871216"/>
+            <a:ext cx="1993392" cy="1197864"/>
+          </a:xfrm>
+          <a:prstGeom prst="rect">
+            <a:avLst/>
+          </a:prstGeom>
+          <a:noFill/>
+          <a:ln/>
+        </p:spPr>
+        <p:txBody>
+          <a:bodyPr wrap="square" lIns="0" tIns="0" rIns="0" bIns="0" rtlCol="0" anchor="ctr"/>
+          <a:lstStyle/>
+          <a:p>
+            <a:pPr indent="0" marL="0">
+              <a:spcAft>
+                <a:spcPts val="200"/>
+              </a:spcAft>
+              <a:buNone/>
+            </a:pPr>
+            <a:r>
+              <a:rPr lang="en-US" sz="880" b="1" dirty="0">
+                <a:solidFill>
+                  <a:srgbClr val="2C5F82"/>
+                </a:solidFill>
+                <a:latin typeface="Arial" pitchFamily="34" charset="0"/>
+                <a:ea typeface="Arial" pitchFamily="34" charset="-122"/>
+                <a:cs typeface="Arial" pitchFamily="34" charset="-120"/>
+              </a:rPr>
+              <a:t>Paid on recovery: </a:t>
+            </a:r>
+            <a:pPr indent="0" marL="0">
+              <a:spcAft>
+                <a:spcPts val="200"/>
+              </a:spcAft>
+              <a:buNone/>
+            </a:pPr>
+            <a:r>
+              <a:rPr lang="en-US" sz="880" dirty="0">
+                <a:solidFill>
+                  <a:srgbClr val="262626"/>
+                </a:solidFill>
+                <a:latin typeface="Arial" pitchFamily="34" charset="0"/>
+                <a:ea typeface="Arial" pitchFamily="34" charset="-122"/>
+                <a:cs typeface="Arial" pitchFamily="34" charset="-120"/>
+              </a:rPr>
+              <a:t>coupons pay once the basket is back at its start; memory catches up missed ones.</a:t>
+            </a:r>
+            <a:endParaRPr lang="en-US" sz="880" dirty="0"/>
+          </a:p>
+          <a:p>
+            <a:pPr indent="0" marL="0">
+              <a:spcAft>
+                <a:spcPts val="200"/>
+              </a:spcAft>
+              <a:buNone/>
+            </a:pPr>
+            <a:r>
+              <a:rPr lang="en-US" sz="880" b="1" dirty="0">
+                <a:solidFill>
+                  <a:srgbClr val="2C5F82"/>
+                </a:solidFill>
+                <a:latin typeface="Arial" pitchFamily="34" charset="0"/>
+                <a:ea typeface="Arial" pitchFamily="34" charset="-122"/>
+                <a:cs typeface="Arial" pitchFamily="34" charset="-120"/>
+              </a:rPr>
+              <a:t>Vol funds the coupon: </a:t>
+            </a:r>
+            <a:pPr indent="0" marL="0">
+              <a:spcAft>
+                <a:spcPts val="200"/>
+              </a:spcAft>
+              <a:buNone/>
+            </a:pPr>
+            <a:r>
+              <a:rPr lang="en-US" sz="880" dirty="0">
+                <a:solidFill>
+                  <a:srgbClr val="262626"/>
+                </a:solidFill>
+                <a:latin typeface="Arial" pitchFamily="34" charset="0"/>
+                <a:ea typeface="Arial" pitchFamily="34" charset="-122"/>
+                <a:cs typeface="Arial" pitchFamily="34" charset="-120"/>
+              </a:rPr>
+              <a:t>VKOSPI hit a record 91.2.</a:t>
+            </a:r>
+            <a:endParaRPr lang="en-US" sz="880" dirty="0"/>
+          </a:p>
+        </p:txBody>
+      </p:sp>
+      <p:graphicFrame>
+        <p:nvGraphicFramePr>
+          <p:cNvPr id="34" name="Chart 1" descr=""/>
+          <p:cNvGraphicFramePr/>
+          <p:nvPr/>
+        </p:nvGraphicFramePr>
+        <p:xfrm>
+          <a:off x="2011680" y="2816352"/>
+          <a:ext cx="5212080" cy="1133856"/>
+        </p:xfrm>
+        <a:graphic xmlns:a="http://schemas.openxmlformats.org/drawingml/2006/main">
+          <a:graphicData uri="http://schemas.openxmlformats.org/drawingml/2006/chart">
+            <c:chart xmlns:c="http://schemas.openxmlformats.org/drawingml/2006/chart" r:id="rId3"/>
+          </a:graphicData>
+        </a:graphic>
+      </p:graphicFrame>
+      <p:sp>
+        <p:nvSpPr>
+          <p:cNvPr id="35" name="Text 30"/>
+          <p:cNvSpPr txBox="1"/>
+          <p:nvPr/>
+        </p:nvSpPr>
+        <p:spPr>
+          <a:xfrm>
+            <a:off x="2011680" y="3950208"/>
+            <a:ext cx="5212080" cy="182880"/>
+          </a:xfrm>
+          <a:prstGeom prst="rect">
+            <a:avLst/>
+          </a:prstGeom>
+          <a:noFill/>
+          <a:ln/>
+        </p:spPr>
+        <p:txBody>
+          <a:bodyPr wrap="square" lIns="0" tIns="0" rIns="0" bIns="0" rtlCol="0" anchor="t"/>
+          <a:lstStyle/>
+          <a:p>
+            <a:pPr indent="0" marL="0">
+              <a:buNone/>
+            </a:pPr>
+            <a:r>
+              <a:rPr lang="en-US" sz="750" i="1" dirty="0">
+                <a:solidFill>
+                  <a:srgbClr val="595959"/>
+                </a:solidFill>
+                <a:latin typeface="Arial" pitchFamily="34" charset="0"/>
+                <a:ea typeface="Arial" pitchFamily="34" charset="-122"/>
+                <a:cs typeface="Arial" pitchFamily="34" charset="-120"/>
+              </a:rPr>
+              <a:t>TAIEX, KOSPI, Nikkei 225 (end-2021 = 100)</a:t>
+            </a:r>
+            <a:endParaRPr lang="en-US" sz="750" dirty="0"/>
+          </a:p>
+        </p:txBody>
+      </p:sp>
+      <p:sp>
+        <p:nvSpPr>
+          <p:cNvPr id="36" name="Shape 31"/>
+          <p:cNvSpPr/>
+          <p:nvPr/>
+        </p:nvSpPr>
+        <p:spPr>
+          <a:xfrm>
+            <a:off x="457200" y="4160520"/>
+            <a:ext cx="11274552" cy="0"/>
+          </a:xfrm>
+          <a:prstGeom prst="line">
+            <a:avLst/>
+          </a:prstGeom>
+          <a:noFill/>
+          <a:ln w="6350">
+            <a:solidFill>
+              <a:srgbClr val="D9D9D9"/>
+            </a:solidFill>
+            <a:prstDash val="dash"/>
+          </a:ln>
+        </p:spPr>
+      </p:sp>
+      <p:sp>
+        <p:nvSpPr>
+          <p:cNvPr id="37" name="Shape 32"/>
+          <p:cNvSpPr/>
+          <p:nvPr/>
+        </p:nvSpPr>
+        <p:spPr>
+          <a:xfrm>
+            <a:off x="457200" y="4215384"/>
+            <a:ext cx="1463040" cy="1307592"/>
           </a:xfrm>
           <a:prstGeom prst="rect">
             <a:avLst/>
@@ -10191,14 +10910,14 @@
       </p:sp>
       <p:sp>
         <p:nvSpPr>
-          <p:cNvPr id="19" name="Text 15"/>
+          <p:cNvPr id="38" name="Text 33"/>
           <p:cNvSpPr txBox="1"/>
           <p:nvPr/>
         </p:nvSpPr>
         <p:spPr>
           <a:xfrm>
-            <a:off x="457200" y="3383280"/>
-            <a:ext cx="3730752" cy="292608"/>
+            <a:off x="548640" y="4352544"/>
+            <a:ext cx="1280160" cy="457200"/>
           </a:xfrm>
           <a:prstGeom prst="rect">
             <a:avLst/>
@@ -10207,14 +10926,14 @@
           <a:ln/>
         </p:spPr>
         <p:txBody>
-          <a:bodyPr wrap="square" lIns="0" tIns="0" rIns="0" bIns="0" rtlCol="0" anchor="ctr"/>
+          <a:bodyPr wrap="square" lIns="0" tIns="0" rIns="0" bIns="0" rtlCol="0" anchor="t"/>
           <a:lstStyle/>
           <a:p>
-            <a:pPr algn="ctr" indent="0" marL="0">
+            <a:pPr indent="0" marL="0">
               <a:buNone/>
             </a:pPr>
             <a:r>
-              <a:rPr lang="en-US" sz="1050" b="1" dirty="0">
+              <a:rPr lang="en-US" sz="1500" b="1" dirty="0">
                 <a:solidFill>
                   <a:srgbClr val="FFFFFF"/>
                 </a:solidFill>
@@ -10222,38 +10941,22 @@
                 <a:ea typeface="Arial" pitchFamily="34" charset="-122"/>
                 <a:cs typeface="Arial" pitchFamily="34" charset="-120"/>
               </a:rPr>
-              <a:t>Long bonds carry rate risk</a:t>
-            </a:r>
-            <a:endParaRPr lang="en-US" sz="1050" dirty="0"/>
+              <a:t>Valuation</a:t>
+            </a:r>
+            <a:endParaRPr lang="en-US" sz="1500" dirty="0"/>
           </a:p>
         </p:txBody>
       </p:sp>
-      <p:graphicFrame>
-        <p:nvGraphicFramePr>
-          <p:cNvPr id="20" name="Chart 1" descr=""/>
-          <p:cNvGraphicFramePr/>
-          <p:nvPr/>
-        </p:nvGraphicFramePr>
-        <p:xfrm>
-          <a:off x="457200" y="3712464"/>
-          <a:ext cx="3730752" cy="1261872"/>
-        </p:xfrm>
-        <a:graphic xmlns:a="http://schemas.openxmlformats.org/drawingml/2006/main">
-          <a:graphicData uri="http://schemas.openxmlformats.org/drawingml/2006/chart">
-            <c:chart xmlns:c="http://schemas.openxmlformats.org/drawingml/2006/chart" r:id="rId3"/>
-          </a:graphicData>
-        </a:graphic>
-      </p:graphicFrame>
-      <p:sp>
-        <p:nvSpPr>
-          <p:cNvPr id="21" name="Text 16"/>
+      <p:sp>
+        <p:nvSpPr>
+          <p:cNvPr id="39" name="Text 34"/>
           <p:cNvSpPr txBox="1"/>
           <p:nvPr/>
         </p:nvSpPr>
         <p:spPr>
           <a:xfrm>
-            <a:off x="457200" y="5010912"/>
-            <a:ext cx="3730752" cy="365760"/>
+            <a:off x="548640" y="4837176"/>
+            <a:ext cx="1280160" cy="640080"/>
           </a:xfrm>
           <a:prstGeom prst="rect">
             <a:avLst/>
@@ -10269,40 +10972,40 @@
               <a:buNone/>
             </a:pPr>
             <a:r>
-              <a:rPr lang="en-US" sz="850" dirty="0">
-                <a:solidFill>
-                  <a:srgbClr val="595959"/>
+              <a:rPr lang="en-US" sz="900" dirty="0">
+                <a:solidFill>
+                  <a:srgbClr val="DCE6EE"/>
                 </a:solidFill>
                 <a:latin typeface="Arial" pitchFamily="34" charset="0"/>
                 <a:ea typeface="Arial" pitchFamily="34" charset="-122"/>
                 <a:cs typeface="Arial" pitchFamily="34" charset="-120"/>
               </a:rPr>
-              <a:t>Value change of a 5-year USD bond (5.69% coupon) for parallel rate moves of −2% to +2%.</a:t>
-            </a:r>
-            <a:endParaRPr lang="en-US" sz="850" dirty="0"/>
+              <a:t>Much good news is priced, in a few names</a:t>
+            </a:r>
+            <a:endParaRPr lang="en-US" sz="900" dirty="0"/>
           </a:p>
         </p:txBody>
       </p:sp>
       <p:sp>
         <p:nvSpPr>
-          <p:cNvPr id="22" name="Shape 17"/>
+          <p:cNvPr id="40" name="Shape 35"/>
           <p:cNvSpPr/>
           <p:nvPr/>
         </p:nvSpPr>
         <p:spPr>
           <a:xfrm>
-            <a:off x="4370832" y="3383280"/>
-            <a:ext cx="3730752" cy="292608"/>
+            <a:off x="7315200" y="4215384"/>
+            <a:ext cx="2148840" cy="1307592"/>
           </a:xfrm>
           <a:prstGeom prst="rect">
             <a:avLst/>
           </a:prstGeom>
           <a:solidFill>
-            <a:srgbClr val="2C5F82"/>
+            <a:srgbClr val="F7ECEC"/>
           </a:solidFill>
           <a:ln w="12700">
             <a:solidFill>
-              <a:srgbClr val="2C5F82"/>
+              <a:srgbClr val="F7ECEC"/>
             </a:solidFill>
             <a:prstDash val="solid"/>
           </a:ln>
@@ -10310,14 +11013,14 @@
       </p:sp>
       <p:sp>
         <p:nvSpPr>
-          <p:cNvPr id="23" name="Text 18"/>
+          <p:cNvPr id="41" name="Text 36"/>
           <p:cNvSpPr txBox="1"/>
           <p:nvPr/>
         </p:nvSpPr>
         <p:spPr>
           <a:xfrm>
-            <a:off x="4370832" y="3383280"/>
-            <a:ext cx="3730752" cy="292608"/>
+            <a:off x="7406640" y="4270248"/>
+            <a:ext cx="1965960" cy="1197864"/>
           </a:xfrm>
           <a:prstGeom prst="rect">
             <a:avLst/>
@@ -10329,33 +11032,157 @@
           <a:bodyPr wrap="square" lIns="0" tIns="0" rIns="0" bIns="0" rtlCol="0" anchor="ctr"/>
           <a:lstStyle/>
           <a:p>
-            <a:pPr algn="ctr" indent="0" marL="0">
+            <a:pPr indent="0" marL="0">
+              <a:spcAft>
+                <a:spcPts val="200"/>
+              </a:spcAft>
               <a:buNone/>
             </a:pPr>
             <a:r>
-              <a:rPr lang="en-US" sz="1050" b="1" dirty="0">
-                <a:solidFill>
-                  <a:srgbClr val="FFFFFF"/>
+              <a:rPr lang="en-US" sz="880" dirty="0">
+                <a:solidFill>
+                  <a:srgbClr val="262626"/>
                 </a:solidFill>
                 <a:latin typeface="Arial" pitchFamily="34" charset="0"/>
                 <a:ea typeface="Arial" pitchFamily="34" charset="-122"/>
                 <a:cs typeface="Arial" pitchFamily="34" charset="-120"/>
               </a:rPr>
-              <a:t>Valuations already price in a lot</a:t>
-            </a:r>
-            <a:endParaRPr lang="en-US" sz="1050" dirty="0"/>
+              <a:t>KOSPI trades at 23× trailing earnings; Nikkei CAPE 38.6×; TSMC is &gt;40% of TAIEX and Taiwan makes ~92% of advanced chips. Upside is concentrated and partly priced.</a:t>
+            </a:r>
+            <a:endParaRPr lang="en-US" sz="880" dirty="0"/>
+          </a:p>
+        </p:txBody>
+      </p:sp>
+      <p:sp>
+        <p:nvSpPr>
+          <p:cNvPr id="42" name="Shape 37"/>
+          <p:cNvSpPr/>
+          <p:nvPr/>
+        </p:nvSpPr>
+        <p:spPr>
+          <a:xfrm>
+            <a:off x="9555480" y="4215384"/>
+            <a:ext cx="2176272" cy="1307592"/>
+          </a:xfrm>
+          <a:prstGeom prst="rect">
+            <a:avLst/>
+          </a:prstGeom>
+          <a:solidFill>
+            <a:srgbClr val="E8EFF5"/>
+          </a:solidFill>
+          <a:ln w="12700">
+            <a:solidFill>
+              <a:srgbClr val="E8EFF5"/>
+            </a:solidFill>
+            <a:prstDash val="solid"/>
+          </a:ln>
+        </p:spPr>
+      </p:sp>
+      <p:sp>
+        <p:nvSpPr>
+          <p:cNvPr id="43" name="Text 38"/>
+          <p:cNvSpPr txBox="1"/>
+          <p:nvPr/>
+        </p:nvSpPr>
+        <p:spPr>
+          <a:xfrm>
+            <a:off x="9646920" y="4270248"/>
+            <a:ext cx="1993392" cy="1197864"/>
+          </a:xfrm>
+          <a:prstGeom prst="rect">
+            <a:avLst/>
+          </a:prstGeom>
+          <a:noFill/>
+          <a:ln/>
+        </p:spPr>
+        <p:txBody>
+          <a:bodyPr wrap="square" lIns="0" tIns="0" rIns="0" bIns="0" rtlCol="0" anchor="ctr"/>
+          <a:lstStyle/>
+          <a:p>
+            <a:pPr indent="0" marL="0">
+              <a:spcAft>
+                <a:spcPts val="200"/>
+              </a:spcAft>
+              <a:buNone/>
+            </a:pPr>
+            <a:r>
+              <a:rPr lang="en-US" sz="880" b="1" dirty="0">
+                <a:solidFill>
+                  <a:srgbClr val="2C5F82"/>
+                </a:solidFill>
+                <a:latin typeface="Arial" pitchFamily="34" charset="0"/>
+                <a:ea typeface="Arial" pitchFamily="34" charset="-122"/>
+                <a:cs typeface="Arial" pitchFamily="34" charset="-120"/>
+              </a:rPr>
+              <a:t>Diversify: </a:t>
+            </a:r>
+            <a:pPr indent="0" marL="0">
+              <a:spcAft>
+                <a:spcPts val="200"/>
+              </a:spcAft>
+              <a:buNone/>
+            </a:pPr>
+            <a:r>
+              <a:rPr lang="en-US" sz="880" dirty="0">
+                <a:solidFill>
+                  <a:srgbClr val="262626"/>
+                </a:solidFill>
+                <a:latin typeface="Arial" pitchFamily="34" charset="0"/>
+                <a:ea typeface="Arial" pitchFamily="34" charset="-122"/>
+                <a:cs typeface="Arial" pitchFamily="34" charset="-120"/>
+              </a:rPr>
+              <a:t>five-ETF basket, not a worst-of on single names.</a:t>
+            </a:r>
+            <a:endParaRPr lang="en-US" sz="880" dirty="0"/>
+          </a:p>
+          <a:p>
+            <a:pPr indent="0" marL="0">
+              <a:spcAft>
+                <a:spcPts val="200"/>
+              </a:spcAft>
+              <a:buNone/>
+            </a:pPr>
+            <a:r>
+              <a:rPr lang="en-US" sz="880" b="1" dirty="0">
+                <a:solidFill>
+                  <a:srgbClr val="2C5F82"/>
+                </a:solidFill>
+                <a:latin typeface="Arial" pitchFamily="34" charset="0"/>
+                <a:ea typeface="Arial" pitchFamily="34" charset="-122"/>
+                <a:cs typeface="Arial" pitchFamily="34" charset="-120"/>
+              </a:rPr>
+              <a:t>Cap costs little: </a:t>
+            </a:r>
+            <a:pPr indent="0" marL="0">
+              <a:spcAft>
+                <a:spcPts val="200"/>
+              </a:spcAft>
+              <a:buNone/>
+            </a:pPr>
+            <a:r>
+              <a:rPr lang="en-US" sz="880" dirty="0">
+                <a:solidFill>
+                  <a:srgbClr val="262626"/>
+                </a:solidFill>
+                <a:latin typeface="Arial" pitchFamily="34" charset="0"/>
+                <a:ea typeface="Arial" pitchFamily="34" charset="-122"/>
+                <a:cs typeface="Arial" pitchFamily="34" charset="-120"/>
+              </a:rPr>
+              <a:t>giving up upside beyond the coupon matters less when it is already priced.</a:t>
+            </a:r>
+            <a:endParaRPr lang="en-US" sz="880" dirty="0"/>
           </a:p>
         </p:txBody>
       </p:sp>
       <p:graphicFrame>
         <p:nvGraphicFramePr>
-          <p:cNvPr id="24" name="Chart 2" descr=""/>
+          <p:cNvPr id="44" name="Chart 2" descr=""/>
           <p:cNvGraphicFramePr/>
           <p:nvPr/>
         </p:nvGraphicFramePr>
         <p:xfrm>
-          <a:off x="4370832" y="3712464"/>
-          <a:ext cx="3730752" cy="1261872"/>
+          <a:off x="2011680" y="4215384"/>
+          <a:ext cx="5212080" cy="1133856"/>
         </p:xfrm>
         <a:graphic xmlns:a="http://schemas.openxmlformats.org/drawingml/2006/main">
           <a:graphicData uri="http://schemas.openxmlformats.org/drawingml/2006/chart">
@@ -10365,14 +11192,14 @@
       </p:graphicFrame>
       <p:sp>
         <p:nvSpPr>
-          <p:cNvPr id="25" name="Text 19"/>
+          <p:cNvPr id="45" name="Text 39"/>
           <p:cNvSpPr txBox="1"/>
           <p:nvPr/>
         </p:nvSpPr>
         <p:spPr>
           <a:xfrm>
-            <a:off x="4370832" y="5010912"/>
-            <a:ext cx="3730752" cy="365760"/>
+            <a:off x="2011680" y="5349240"/>
+            <a:ext cx="5212080" cy="182880"/>
           </a:xfrm>
           <a:prstGeom prst="rect">
             <a:avLst/>
@@ -10388,7 +11215,7 @@
               <a:buNone/>
             </a:pPr>
             <a:r>
-              <a:rPr lang="en-US" sz="850" dirty="0">
+              <a:rPr lang="en-US" sz="750" i="1" dirty="0">
                 <a:solidFill>
                   <a:srgbClr val="595959"/>
                 </a:solidFill>
@@ -10396,22 +11223,22 @@
                 <a:ea typeface="Arial" pitchFamily="34" charset="-122"/>
                 <a:cs typeface="Arial" pitchFamily="34" charset="-120"/>
               </a:rPr>
-              <a:t>Siblis Research, 1 Jul 2026. Korea's gap assumes earnings roughly triple; Nikkei CAPE 38.6×; Taiwan among the most expensive markets.</a:t>
-            </a:r>
-            <a:endParaRPr lang="en-US" sz="850" dirty="0"/>
+              <a:t>Price/earnings, 1 Jul 2026 (Siblis Research)</a:t>
+            </a:r>
+            <a:endParaRPr lang="en-US" sz="750" dirty="0"/>
           </a:p>
         </p:txBody>
       </p:sp>
       <p:sp>
         <p:nvSpPr>
-          <p:cNvPr id="26" name="Text 20"/>
+          <p:cNvPr id="46" name="Text 40"/>
           <p:cNvSpPr txBox="1"/>
           <p:nvPr/>
         </p:nvSpPr>
         <p:spPr>
           <a:xfrm>
-            <a:off x="8211312" y="1280160"/>
-            <a:ext cx="3520440" cy="320040"/>
+            <a:off x="457200" y="5669280"/>
+            <a:ext cx="11274552" cy="274320"/>
           </a:xfrm>
           <a:prstGeom prst="rect">
             <a:avLst/>
@@ -10423,121 +11250,48 @@
           <a:bodyPr wrap="square" lIns="0" tIns="0" rIns="0" bIns="0" rtlCol="0" anchor="t"/>
           <a:lstStyle/>
           <a:p>
-            <a:pPr algn="ctr" indent="0" marL="0">
+            <a:pPr indent="0" marL="0">
               <a:buNone/>
             </a:pPr>
             <a:r>
-              <a:rPr lang="en-US" sz="1500" b="1" dirty="0">
-                <a:solidFill>
-                  <a:srgbClr val="262626"/>
+              <a:rPr lang="en-US" sz="1000" b="1" dirty="0">
+                <a:solidFill>
+                  <a:srgbClr val="2C5F82"/>
                 </a:solidFill>
                 <a:latin typeface="Arial" pitchFamily="34" charset="0"/>
                 <a:ea typeface="Arial" pitchFamily="34" charset="-122"/>
                 <a:cs typeface="Arial" pitchFamily="34" charset="-120"/>
               </a:rPr>
-              <a:t>Implications</a:t>
-            </a:r>
-            <a:endParaRPr lang="en-US" sz="1500" dirty="0"/>
-          </a:p>
-        </p:txBody>
-      </p:sp>
-      <p:sp>
-        <p:nvSpPr>
-          <p:cNvPr id="27" name="Shape 21"/>
-          <p:cNvSpPr/>
-          <p:nvPr/>
-        </p:nvSpPr>
-        <p:spPr>
-          <a:xfrm>
-            <a:off x="8485632" y="1627632"/>
-            <a:ext cx="2971800" cy="0"/>
-          </a:xfrm>
-          <a:prstGeom prst="line">
-            <a:avLst/>
-          </a:prstGeom>
-          <a:noFill/>
-          <a:ln w="9525">
-            <a:solidFill>
-              <a:srgbClr val="2C5F82"/>
-            </a:solidFill>
-            <a:prstDash val="solid"/>
-          </a:ln>
-        </p:spPr>
-      </p:sp>
-      <p:sp>
-        <p:nvSpPr>
-          <p:cNvPr id="28" name="Text 22"/>
-          <p:cNvSpPr txBox="1"/>
-          <p:nvPr/>
-        </p:nvSpPr>
-        <p:spPr>
-          <a:xfrm>
-            <a:off x="8211312" y="1645920"/>
-            <a:ext cx="3520440" cy="274320"/>
-          </a:xfrm>
-          <a:prstGeom prst="rect">
-            <a:avLst/>
-          </a:prstGeom>
-          <a:noFill/>
-          <a:ln/>
-        </p:spPr>
-        <p:txBody>
-          <a:bodyPr wrap="square" lIns="0" tIns="0" rIns="0" bIns="0" rtlCol="0" anchor="t"/>
-          <a:lstStyle/>
-          <a:p>
-            <a:pPr algn="ctr" indent="0" marL="0">
+              <a:t>Market proof: </a:t>
+            </a:r>
+            <a:pPr indent="0" marL="0">
               <a:buNone/>
             </a:pPr>
             <a:r>
-              <a:rPr lang="en-US" sz="800" i="1" dirty="0">
-                <a:solidFill>
-                  <a:srgbClr val="595959"/>
+              <a:rPr lang="en-US" sz="1000" dirty="0">
+                <a:solidFill>
+                  <a:srgbClr val="262626"/>
                 </a:solidFill>
                 <a:latin typeface="Arial" pitchFamily="34" charset="0"/>
                 <a:ea typeface="Arial" pitchFamily="34" charset="-122"/>
                 <a:cs typeface="Arial" pitchFamily="34" charset="-120"/>
               </a:rPr>
-              <a:t>Market proof: Taiwan structured-note issuance +81% in 2025, snowball autocalls the favourite payoff (SRP)</a:t>
-            </a:r>
-            <a:endParaRPr lang="en-US" sz="800" dirty="0"/>
+              <a:t>Taiwan structured-note issuance rose 81% in 2025, with autocalls the favourite payoff (SRP). Investors facing the same market are already choosing this answer.</a:t>
+            </a:r>
+            <a:endParaRPr lang="en-US" sz="1000" dirty="0"/>
           </a:p>
         </p:txBody>
       </p:sp>
       <p:sp>
         <p:nvSpPr>
-          <p:cNvPr id="29" name="Shape 23"/>
-          <p:cNvSpPr/>
-          <p:nvPr/>
-        </p:nvSpPr>
-        <p:spPr>
-          <a:xfrm>
-            <a:off x="8211312" y="1938528"/>
-            <a:ext cx="3520440" cy="621792"/>
-          </a:xfrm>
-          <a:prstGeom prst="rect">
-            <a:avLst/>
-          </a:prstGeom>
-          <a:solidFill>
-            <a:srgbClr val="FFFFFF"/>
-          </a:solidFill>
-          <a:ln w="12700">
-            <a:solidFill>
-              <a:srgbClr val="2C5F82"/>
-            </a:solidFill>
-            <a:prstDash val="solid"/>
-          </a:ln>
-        </p:spPr>
-      </p:sp>
-      <p:sp>
-        <p:nvSpPr>
-          <p:cNvPr id="30" name="Text 24"/>
+          <p:cNvPr id="47" name="Text 41"/>
           <p:cNvSpPr txBox="1"/>
           <p:nvPr/>
         </p:nvSpPr>
         <p:spPr>
           <a:xfrm>
-            <a:off x="8257032" y="1938528"/>
-            <a:ext cx="411480" cy="621792"/>
+            <a:off x="457200" y="5998464"/>
+            <a:ext cx="11274552" cy="274320"/>
           </a:xfrm>
           <a:prstGeom prst="rect">
             <a:avLst/>
@@ -10546,646 +11300,22 @@
           <a:ln/>
         </p:spPr>
         <p:txBody>
-          <a:bodyPr wrap="square" lIns="0" tIns="0" rIns="0" bIns="0" rtlCol="0" anchor="ctr"/>
+          <a:bodyPr wrap="square" lIns="0" tIns="0" rIns="0" bIns="0" rtlCol="0" anchor="t"/>
           <a:lstStyle/>
           <a:p>
-            <a:pPr algn="ctr" indent="0" marL="0">
+            <a:pPr indent="0" marL="0">
               <a:buNone/>
             </a:pPr>
             <a:r>
-              <a:rPr lang="en-US" sz="2200" b="1" i="1" dirty="0">
-                <a:solidFill>
-                  <a:srgbClr val="2C5F82"/>
+              <a:rPr lang="en-US" sz="800" i="1" dirty="0">
+                <a:solidFill>
+                  <a:srgbClr val="595959"/>
                 </a:solidFill>
                 <a:latin typeface="Arial" pitchFamily="34" charset="0"/>
                 <a:ea typeface="Arial" pitchFamily="34" charset="-122"/>
                 <a:cs typeface="Arial" pitchFamily="34" charset="-120"/>
               </a:rPr>
-              <a:t>1</a:t>
-            </a:r>
-            <a:endParaRPr lang="en-US" sz="2200" dirty="0"/>
-          </a:p>
-        </p:txBody>
-      </p:sp>
-      <p:sp>
-        <p:nvSpPr>
-          <p:cNvPr id="31" name="Text 25"/>
-          <p:cNvSpPr txBox="1"/>
-          <p:nvPr/>
-        </p:nvSpPr>
-        <p:spPr>
-          <a:xfrm>
-            <a:off x="8714232" y="1956816"/>
-            <a:ext cx="2926080" cy="585216"/>
-          </a:xfrm>
-          <a:prstGeom prst="rect">
-            <a:avLst/>
-          </a:prstGeom>
-          <a:noFill/>
-          <a:ln/>
-        </p:spPr>
-        <p:txBody>
-          <a:bodyPr wrap="square" lIns="0" tIns="0" rIns="0" bIns="0" rtlCol="0" anchor="ctr"/>
-          <a:lstStyle/>
-          <a:p>
-            <a:pPr indent="0" marL="0">
-              <a:buNone/>
-            </a:pPr>
-            <a:r>
-              <a:rPr lang="en-US" sz="880" b="1" dirty="0">
-                <a:solidFill>
-                  <a:srgbClr val="262626"/>
-                </a:solidFill>
-                <a:latin typeface="Arial" pitchFamily="34" charset="0"/>
-                <a:ea typeface="Arial" pitchFamily="34" charset="-122"/>
-                <a:cs typeface="Arial" pitchFamily="34" charset="-120"/>
-              </a:rPr>
-              <a:t>Early exit beats duration: </a:t>
-            </a:r>
-            <a:pPr indent="0" marL="0">
-              <a:buNone/>
-            </a:pPr>
-            <a:r>
-              <a:rPr lang="en-US" sz="880" dirty="0">
-                <a:solidFill>
-                  <a:srgbClr val="595959"/>
-                </a:solidFill>
-                <a:latin typeface="Arial" pitchFamily="34" charset="0"/>
-                <a:ea typeface="Arial" pitchFamily="34" charset="-122"/>
-                <a:cs typeface="Arial" pitchFamily="34" charset="-120"/>
-              </a:rPr>
-              <a:t>Fed median 4.125% to end-2027, some see more hikes: bonds lose ~4.0% per 1% rise; autocalls can redeem from year 1</a:t>
-            </a:r>
-            <a:endParaRPr lang="en-US" sz="880" dirty="0"/>
-          </a:p>
-        </p:txBody>
-      </p:sp>
-      <p:sp>
-        <p:nvSpPr>
-          <p:cNvPr id="32" name="Shape 26"/>
-          <p:cNvSpPr/>
-          <p:nvPr/>
-        </p:nvSpPr>
-        <p:spPr>
-          <a:xfrm>
-            <a:off x="8211312" y="2633472"/>
-            <a:ext cx="3520440" cy="621792"/>
-          </a:xfrm>
-          <a:prstGeom prst="rect">
-            <a:avLst/>
-          </a:prstGeom>
-          <a:solidFill>
-            <a:srgbClr val="FFFFFF"/>
-          </a:solidFill>
-          <a:ln w="12700">
-            <a:solidFill>
-              <a:srgbClr val="2C5F82"/>
-            </a:solidFill>
-            <a:prstDash val="solid"/>
-          </a:ln>
-        </p:spPr>
-      </p:sp>
-      <p:sp>
-        <p:nvSpPr>
-          <p:cNvPr id="33" name="Text 27"/>
-          <p:cNvSpPr txBox="1"/>
-          <p:nvPr/>
-        </p:nvSpPr>
-        <p:spPr>
-          <a:xfrm>
-            <a:off x="8257032" y="2633472"/>
-            <a:ext cx="411480" cy="621792"/>
-          </a:xfrm>
-          <a:prstGeom prst="rect">
-            <a:avLst/>
-          </a:prstGeom>
-          <a:noFill/>
-          <a:ln/>
-        </p:spPr>
-        <p:txBody>
-          <a:bodyPr wrap="square" lIns="0" tIns="0" rIns="0" bIns="0" rtlCol="0" anchor="ctr"/>
-          <a:lstStyle/>
-          <a:p>
-            <a:pPr algn="ctr" indent="0" marL="0">
-              <a:buNone/>
-            </a:pPr>
-            <a:r>
-              <a:rPr lang="en-US" sz="2200" b="1" i="1" dirty="0">
-                <a:solidFill>
-                  <a:srgbClr val="2C5F82"/>
-                </a:solidFill>
-                <a:latin typeface="Arial" pitchFamily="34" charset="0"/>
-                <a:ea typeface="Arial" pitchFamily="34" charset="-122"/>
-                <a:cs typeface="Arial" pitchFamily="34" charset="-120"/>
-              </a:rPr>
-              <a:t>2</a:t>
-            </a:r>
-            <a:endParaRPr lang="en-US" sz="2200" dirty="0"/>
-          </a:p>
-        </p:txBody>
-      </p:sp>
-      <p:sp>
-        <p:nvSpPr>
-          <p:cNvPr id="34" name="Text 28"/>
-          <p:cNvSpPr txBox="1"/>
-          <p:nvPr/>
-        </p:nvSpPr>
-        <p:spPr>
-          <a:xfrm>
-            <a:off x="8714232" y="2651760"/>
-            <a:ext cx="2926080" cy="585216"/>
-          </a:xfrm>
-          <a:prstGeom prst="rect">
-            <a:avLst/>
-          </a:prstGeom>
-          <a:noFill/>
-          <a:ln/>
-        </p:spPr>
-        <p:txBody>
-          <a:bodyPr wrap="square" lIns="0" tIns="0" rIns="0" bIns="0" rtlCol="0" anchor="ctr"/>
-          <a:lstStyle/>
-          <a:p>
-            <a:pPr indent="0" marL="0">
-              <a:buNone/>
-            </a:pPr>
-            <a:r>
-              <a:rPr lang="en-US" sz="880" b="1" dirty="0">
-                <a:solidFill>
-                  <a:srgbClr val="262626"/>
-                </a:solidFill>
-                <a:latin typeface="Arial" pitchFamily="34" charset="0"/>
-                <a:ea typeface="Arial" pitchFamily="34" charset="-122"/>
-                <a:cs typeface="Arial" pitchFamily="34" charset="-120"/>
-              </a:rPr>
-              <a:t>Paid on recovery, not timing: </a:t>
-            </a:r>
-            <a:pPr indent="0" marL="0">
-              <a:buNone/>
-            </a:pPr>
-            <a:r>
-              <a:rPr lang="en-US" sz="880" dirty="0">
-                <a:solidFill>
-                  <a:srgbClr val="595959"/>
-                </a:solidFill>
-                <a:latin typeface="Arial" pitchFamily="34" charset="0"/>
-                <a:ea typeface="Arial" pitchFamily="34" charset="-122"/>
-                <a:cs typeface="Arial" pitchFamily="34" charset="-120"/>
-              </a:rPr>
-              <a:t>−25% in ten weeks (KOSPI 2026): autocall coupons pay once the basket is back at its start</a:t>
-            </a:r>
-            <a:endParaRPr lang="en-US" sz="880" dirty="0"/>
-          </a:p>
-        </p:txBody>
-      </p:sp>
-      <p:sp>
-        <p:nvSpPr>
-          <p:cNvPr id="35" name="Shape 29"/>
-          <p:cNvSpPr/>
-          <p:nvPr/>
-        </p:nvSpPr>
-        <p:spPr>
-          <a:xfrm>
-            <a:off x="8211312" y="3328416"/>
-            <a:ext cx="3520440" cy="621792"/>
-          </a:xfrm>
-          <a:prstGeom prst="rect">
-            <a:avLst/>
-          </a:prstGeom>
-          <a:solidFill>
-            <a:srgbClr val="FFFFFF"/>
-          </a:solidFill>
-          <a:ln w="12700">
-            <a:solidFill>
-              <a:srgbClr val="2C5F82"/>
-            </a:solidFill>
-            <a:prstDash val="solid"/>
-          </a:ln>
-        </p:spPr>
-      </p:sp>
-      <p:sp>
-        <p:nvSpPr>
-          <p:cNvPr id="36" name="Text 30"/>
-          <p:cNvSpPr txBox="1"/>
-          <p:nvPr/>
-        </p:nvSpPr>
-        <p:spPr>
-          <a:xfrm>
-            <a:off x="8257032" y="3328416"/>
-            <a:ext cx="411480" cy="621792"/>
-          </a:xfrm>
-          <a:prstGeom prst="rect">
-            <a:avLst/>
-          </a:prstGeom>
-          <a:noFill/>
-          <a:ln/>
-        </p:spPr>
-        <p:txBody>
-          <a:bodyPr wrap="square" lIns="0" tIns="0" rIns="0" bIns="0" rtlCol="0" anchor="ctr"/>
-          <a:lstStyle/>
-          <a:p>
-            <a:pPr algn="ctr" indent="0" marL="0">
-              <a:buNone/>
-            </a:pPr>
-            <a:r>
-              <a:rPr lang="en-US" sz="2200" b="1" i="1" dirty="0">
-                <a:solidFill>
-                  <a:srgbClr val="2C5F82"/>
-                </a:solidFill>
-                <a:latin typeface="Arial" pitchFamily="34" charset="0"/>
-                <a:ea typeface="Arial" pitchFamily="34" charset="-122"/>
-                <a:cs typeface="Arial" pitchFamily="34" charset="-120"/>
-              </a:rPr>
-              <a:t>3</a:t>
-            </a:r>
-            <a:endParaRPr lang="en-US" sz="2200" dirty="0"/>
-          </a:p>
-        </p:txBody>
-      </p:sp>
-      <p:sp>
-        <p:nvSpPr>
-          <p:cNvPr id="37" name="Text 31"/>
-          <p:cNvSpPr txBox="1"/>
-          <p:nvPr/>
-        </p:nvSpPr>
-        <p:spPr>
-          <a:xfrm>
-            <a:off x="8714232" y="3346704"/>
-            <a:ext cx="2926080" cy="585216"/>
-          </a:xfrm>
-          <a:prstGeom prst="rect">
-            <a:avLst/>
-          </a:prstGeom>
-          <a:noFill/>
-          <a:ln/>
-        </p:spPr>
-        <p:txBody>
-          <a:bodyPr wrap="square" lIns="0" tIns="0" rIns="0" bIns="0" rtlCol="0" anchor="ctr"/>
-          <a:lstStyle/>
-          <a:p>
-            <a:pPr indent="0" marL="0">
-              <a:buNone/>
-            </a:pPr>
-            <a:r>
-              <a:rPr lang="en-US" sz="880" b="1" dirty="0">
-                <a:solidFill>
-                  <a:srgbClr val="262626"/>
-                </a:solidFill>
-                <a:latin typeface="Arial" pitchFamily="34" charset="0"/>
-                <a:ea typeface="Arial" pitchFamily="34" charset="-122"/>
-                <a:cs typeface="Arial" pitchFamily="34" charset="-120"/>
-              </a:rPr>
-              <a:t>Diversify the basket: </a:t>
-            </a:r>
-            <a:pPr indent="0" marL="0">
-              <a:buNone/>
-            </a:pPr>
-            <a:r>
-              <a:rPr lang="en-US" sz="880" dirty="0">
-                <a:solidFill>
-                  <a:srgbClr val="595959"/>
-                </a:solidFill>
-                <a:latin typeface="Arial" pitchFamily="34" charset="0"/>
-                <a:ea typeface="Arial" pitchFamily="34" charset="-122"/>
-                <a:cs typeface="Arial" pitchFamily="34" charset="-120"/>
-              </a:rPr>
-              <a:t>TSMC &gt;40% of TAIEX, ~92% of advanced chips from Taiwan: use a diversified ETF basket, not worst-of</a:t>
-            </a:r>
-            <a:endParaRPr lang="en-US" sz="880" dirty="0"/>
-          </a:p>
-        </p:txBody>
-      </p:sp>
-      <p:sp>
-        <p:nvSpPr>
-          <p:cNvPr id="38" name="Shape 32"/>
-          <p:cNvSpPr/>
-          <p:nvPr/>
-        </p:nvSpPr>
-        <p:spPr>
-          <a:xfrm>
-            <a:off x="8211312" y="4023360"/>
-            <a:ext cx="3520440" cy="621792"/>
-          </a:xfrm>
-          <a:prstGeom prst="rect">
-            <a:avLst/>
-          </a:prstGeom>
-          <a:solidFill>
-            <a:srgbClr val="FFFFFF"/>
-          </a:solidFill>
-          <a:ln w="12700">
-            <a:solidFill>
-              <a:srgbClr val="2C5F82"/>
-            </a:solidFill>
-            <a:prstDash val="solid"/>
-          </a:ln>
-        </p:spPr>
-      </p:sp>
-      <p:sp>
-        <p:nvSpPr>
-          <p:cNvPr id="39" name="Text 33"/>
-          <p:cNvSpPr txBox="1"/>
-          <p:nvPr/>
-        </p:nvSpPr>
-        <p:spPr>
-          <a:xfrm>
-            <a:off x="8257032" y="4023360"/>
-            <a:ext cx="411480" cy="621792"/>
-          </a:xfrm>
-          <a:prstGeom prst="rect">
-            <a:avLst/>
-          </a:prstGeom>
-          <a:noFill/>
-          <a:ln/>
-        </p:spPr>
-        <p:txBody>
-          <a:bodyPr wrap="square" lIns="0" tIns="0" rIns="0" bIns="0" rtlCol="0" anchor="ctr"/>
-          <a:lstStyle/>
-          <a:p>
-            <a:pPr algn="ctr" indent="0" marL="0">
-              <a:buNone/>
-            </a:pPr>
-            <a:r>
-              <a:rPr lang="en-US" sz="2200" b="1" i="1" dirty="0">
-                <a:solidFill>
-                  <a:srgbClr val="2C5F82"/>
-                </a:solidFill>
-                <a:latin typeface="Arial" pitchFamily="34" charset="0"/>
-                <a:ea typeface="Arial" pitchFamily="34" charset="-122"/>
-                <a:cs typeface="Arial" pitchFamily="34" charset="-120"/>
-              </a:rPr>
-              <a:t>4</a:t>
-            </a:r>
-            <a:endParaRPr lang="en-US" sz="2200" dirty="0"/>
-          </a:p>
-        </p:txBody>
-      </p:sp>
-      <p:sp>
-        <p:nvSpPr>
-          <p:cNvPr id="40" name="Text 34"/>
-          <p:cNvSpPr txBox="1"/>
-          <p:nvPr/>
-        </p:nvSpPr>
-        <p:spPr>
-          <a:xfrm>
-            <a:off x="8714232" y="4041648"/>
-            <a:ext cx="2926080" cy="585216"/>
-          </a:xfrm>
-          <a:prstGeom prst="rect">
-            <a:avLst/>
-          </a:prstGeom>
-          <a:noFill/>
-          <a:ln/>
-        </p:spPr>
-        <p:txBody>
-          <a:bodyPr wrap="square" lIns="0" tIns="0" rIns="0" bIns="0" rtlCol="0" anchor="ctr"/>
-          <a:lstStyle/>
-          <a:p>
-            <a:pPr indent="0" marL="0">
-              <a:buNone/>
-            </a:pPr>
-            <a:r>
-              <a:rPr lang="en-US" sz="880" b="1" dirty="0">
-                <a:solidFill>
-                  <a:srgbClr val="262626"/>
-                </a:solidFill>
-                <a:latin typeface="Arial" pitchFamily="34" charset="0"/>
-                <a:ea typeface="Arial" pitchFamily="34" charset="-122"/>
-                <a:cs typeface="Arial" pitchFamily="34" charset="-120"/>
-              </a:rPr>
-              <a:t>Volatility funds the coupon: </a:t>
-            </a:r>
-            <a:pPr indent="0" marL="0">
-              <a:buNone/>
-            </a:pPr>
-            <a:r>
-              <a:rPr lang="en-US" sz="880" dirty="0">
-                <a:solidFill>
-                  <a:srgbClr val="595959"/>
-                </a:solidFill>
-                <a:latin typeface="Arial" pitchFamily="34" charset="0"/>
-                <a:ea typeface="Arial" pitchFamily="34" charset="-122"/>
-                <a:cs typeface="Arial" pitchFamily="34" charset="-120"/>
-              </a:rPr>
-              <a:t>VKOSPI at a record 91.2: richer option premium means higher autocall coupons</a:t>
-            </a:r>
-            <a:endParaRPr lang="en-US" sz="880" dirty="0"/>
-          </a:p>
-        </p:txBody>
-      </p:sp>
-      <p:sp>
-        <p:nvSpPr>
-          <p:cNvPr id="41" name="Shape 35"/>
-          <p:cNvSpPr/>
-          <p:nvPr/>
-        </p:nvSpPr>
-        <p:spPr>
-          <a:xfrm>
-            <a:off x="8211312" y="4718304"/>
-            <a:ext cx="3520440" cy="621792"/>
-          </a:xfrm>
-          <a:prstGeom prst="rect">
-            <a:avLst/>
-          </a:prstGeom>
-          <a:solidFill>
-            <a:srgbClr val="FFFFFF"/>
-          </a:solidFill>
-          <a:ln w="12700">
-            <a:solidFill>
-              <a:srgbClr val="2C5F82"/>
-            </a:solidFill>
-            <a:prstDash val="solid"/>
-          </a:ln>
-        </p:spPr>
-      </p:sp>
-      <p:sp>
-        <p:nvSpPr>
-          <p:cNvPr id="42" name="Text 36"/>
-          <p:cNvSpPr txBox="1"/>
-          <p:nvPr/>
-        </p:nvSpPr>
-        <p:spPr>
-          <a:xfrm>
-            <a:off x="8257032" y="4718304"/>
-            <a:ext cx="411480" cy="621792"/>
-          </a:xfrm>
-          <a:prstGeom prst="rect">
-            <a:avLst/>
-          </a:prstGeom>
-          <a:noFill/>
-          <a:ln/>
-        </p:spPr>
-        <p:txBody>
-          <a:bodyPr wrap="square" lIns="0" tIns="0" rIns="0" bIns="0" rtlCol="0" anchor="ctr"/>
-          <a:lstStyle/>
-          <a:p>
-            <a:pPr algn="ctr" indent="0" marL="0">
-              <a:buNone/>
-            </a:pPr>
-            <a:r>
-              <a:rPr lang="en-US" sz="2200" b="1" i="1" dirty="0">
-                <a:solidFill>
-                  <a:srgbClr val="2C5F82"/>
-                </a:solidFill>
-                <a:latin typeface="Arial" pitchFamily="34" charset="0"/>
-                <a:ea typeface="Arial" pitchFamily="34" charset="-122"/>
-                <a:cs typeface="Arial" pitchFamily="34" charset="-120"/>
-              </a:rPr>
-              <a:t>5</a:t>
-            </a:r>
-            <a:endParaRPr lang="en-US" sz="2200" dirty="0"/>
-          </a:p>
-        </p:txBody>
-      </p:sp>
-      <p:sp>
-        <p:nvSpPr>
-          <p:cNvPr id="43" name="Text 37"/>
-          <p:cNvSpPr txBox="1"/>
-          <p:nvPr/>
-        </p:nvSpPr>
-        <p:spPr>
-          <a:xfrm>
-            <a:off x="8714232" y="4736592"/>
-            <a:ext cx="2926080" cy="585216"/>
-          </a:xfrm>
-          <a:prstGeom prst="rect">
-            <a:avLst/>
-          </a:prstGeom>
-          <a:noFill/>
-          <a:ln/>
-        </p:spPr>
-        <p:txBody>
-          <a:bodyPr wrap="square" lIns="0" tIns="0" rIns="0" bIns="0" rtlCol="0" anchor="ctr"/>
-          <a:lstStyle/>
-          <a:p>
-            <a:pPr indent="0" marL="0">
-              <a:buNone/>
-            </a:pPr>
-            <a:r>
-              <a:rPr lang="en-US" sz="880" b="1" dirty="0">
-                <a:solidFill>
-                  <a:srgbClr val="262626"/>
-                </a:solidFill>
-                <a:latin typeface="Arial" pitchFamily="34" charset="0"/>
-                <a:ea typeface="Arial" pitchFamily="34" charset="-122"/>
-                <a:cs typeface="Arial" pitchFamily="34" charset="-120"/>
-              </a:rPr>
-              <a:t>Protection is affordable: </a:t>
-            </a:r>
-            <a:pPr indent="0" marL="0">
-              <a:buNone/>
-            </a:pPr>
-            <a:r>
-              <a:rPr lang="en-US" sz="880" dirty="0">
-                <a:solidFill>
-                  <a:srgbClr val="595959"/>
-                </a:solidFill>
-                <a:latin typeface="Arial" pitchFamily="34" charset="0"/>
-                <a:ea typeface="Arial" pitchFamily="34" charset="-122"/>
-                <a:cs typeface="Arial" pitchFamily="34" charset="-120"/>
-              </a:rPr>
-              <a:t>Rates high until 2028: USD 100 in 5 years costs USD 75.8 at 5.69%, so a 70% floor fits inside an autocall</a:t>
-            </a:r>
-            <a:endParaRPr lang="en-US" sz="880" dirty="0"/>
-          </a:p>
-        </p:txBody>
-      </p:sp>
-      <p:sp>
-        <p:nvSpPr>
-          <p:cNvPr id="44" name="Shape 38"/>
-          <p:cNvSpPr/>
-          <p:nvPr/>
-        </p:nvSpPr>
-        <p:spPr>
-          <a:xfrm>
-            <a:off x="457200" y="5486400"/>
-            <a:ext cx="11274552" cy="438912"/>
-          </a:xfrm>
-          <a:prstGeom prst="rect">
-            <a:avLst/>
-          </a:prstGeom>
-          <a:solidFill>
-            <a:srgbClr val="2C5F82"/>
-          </a:solidFill>
-          <a:ln w="12700">
-            <a:solidFill>
-              <a:srgbClr val="2C5F82"/>
-            </a:solidFill>
-            <a:prstDash val="solid"/>
-          </a:ln>
-        </p:spPr>
-      </p:sp>
-      <p:sp>
-        <p:nvSpPr>
-          <p:cNvPr id="45" name="Text 39"/>
-          <p:cNvSpPr txBox="1"/>
-          <p:nvPr/>
-        </p:nvSpPr>
-        <p:spPr>
-          <a:xfrm>
-            <a:off x="594360" y="5486400"/>
-            <a:ext cx="11000232" cy="438912"/>
-          </a:xfrm>
-          <a:prstGeom prst="rect">
-            <a:avLst/>
-          </a:prstGeom>
-          <a:noFill/>
-          <a:ln/>
-        </p:spPr>
-        <p:txBody>
-          <a:bodyPr wrap="square" lIns="0" tIns="0" rIns="0" bIns="0" rtlCol="0" anchor="ctr"/>
-          <a:lstStyle/>
-          <a:p>
-            <a:pPr algn="ctr" indent="0" marL="0">
-              <a:buNone/>
-            </a:pPr>
-            <a:r>
-              <a:rPr lang="en-US" sz="1200" b="1" dirty="0">
-                <a:solidFill>
-                  <a:srgbClr val="FFFFFF"/>
-                </a:solidFill>
-                <a:latin typeface="Arial" pitchFamily="34" charset="0"/>
-                <a:ea typeface="Arial" pitchFamily="34" charset="-122"/>
-                <a:cs typeface="Arial" pitchFamily="34" charset="-120"/>
-              </a:rPr>
-              <a:t>Plain bonds and equities leave investors exposed; a buffered autocall with a 70% floor keeps the theme and manages the risks.</a:t>
-            </a:r>
-            <a:endParaRPr lang="en-US" sz="1200" dirty="0"/>
-          </a:p>
-        </p:txBody>
-      </p:sp>
-      <p:sp>
-        <p:nvSpPr>
-          <p:cNvPr id="46" name="Text 40"/>
-          <p:cNvSpPr txBox="1"/>
-          <p:nvPr/>
-        </p:nvSpPr>
-        <p:spPr>
-          <a:xfrm>
-            <a:off x="457200" y="5998464"/>
-            <a:ext cx="11274552" cy="274320"/>
-          </a:xfrm>
-          <a:prstGeom prst="rect">
-            <a:avLst/>
-          </a:prstGeom>
-          <a:noFill/>
-          <a:ln/>
-        </p:spPr>
-        <p:txBody>
-          <a:bodyPr wrap="square" lIns="0" tIns="0" rIns="0" bIns="0" rtlCol="0" anchor="t"/>
-          <a:lstStyle/>
-          <a:p>
-            <a:pPr indent="0" marL="0">
-              <a:buNone/>
-            </a:pPr>
-            <a:r>
-              <a:rPr lang="en-US" sz="800" i="1" dirty="0">
-                <a:solidFill>
-                  <a:srgbClr val="595959"/>
-                </a:solidFill>
-                <a:latin typeface="Arial" pitchFamily="34" charset="0"/>
-                <a:ea typeface="Arial" pitchFamily="34" charset="-122"/>
-                <a:cs typeface="Arial" pitchFamily="34" charset="-120"/>
-              </a:rPr>
-              <a:t>Sources: Federal Reserve, Summary of Economic Projections (16 Sep 2026; dot counts read from Figure 2, verify); TWSE, KRX/press, Nikkei (index levels); Siblis Research (P/E); Herald / SBS (VKOSPI); TrendForce; J.P. Morgan 2026 Outlook; StructuredRetailProducts.com; case funding grid with standard bond maths.</a:t>
+              <a:t>Sources: Federal Reserve, Summary of Economic Projections (16 Sep 2026; dot counts read from Figure 2, verify); TWSE, KRX/press, Nikkei (index levels); Siblis Research (P/E); Herald / SBS (VKOSPI); J.P. Morgan 2026 Outlook; StructuredRetailProducts.com; case funding grid with standard bond maths.</a:t>
             </a:r>
             <a:endParaRPr lang="en-US" sz="800" dirty="0"/>
           </a:p>

</xml_diff>